<commit_message>
chore(docs): update feature and process PPTX to v0.8.4
- features: add Launcher slide, scrollable form entry, 5-language support,
  v0.8.4 in title, 542 tests, updated manuals section
- prozess: 5-language label in step 5, updated manual description

Co-Authored-By: Claude Sonnet 4.6 <noreply@anthropic.com>
</commit_message>
<xml_diff>
--- a/docs/situation_report_features.pptx
+++ b/docs/situation_report_features.pptx
@@ -12,6 +12,7 @@
     <p:sldId id="260" r:id="rId11"/>
     <p:sldId id="261" r:id="rId12"/>
     <p:sldId id="262" r:id="rId13"/>
+    <p:sldId id="263" r:id="rId14"/>
   </p:sldIdLst>
   <p:sldSz cx="12188952" cy="6858000" type="screen4x3"/>
   <p:notesSz cx="6858000" cy="9144000"/>
@@ -3243,7 +3244,7 @@
                   <a:srgbClr val="ECF0F1"/>
                 </a:solidFill>
               </a:rPr>
-              <a:t>Feature-Übersicht — Stand April 2026</a:t>
+              <a:t>Feature-Übersicht — v0.8.4 | Stand April 2026</a:t>
             </a:r>
           </a:p>
         </p:txBody>
@@ -3372,7 +3373,7 @@
                   <a:srgbClr val="FFFFFF"/>
                 </a:solidFill>
               </a:rPr>
-              <a:t>transform_data</a:t>
+              <a:t>launcher — Zentraler Einstiegspunkt</a:t>
             </a:r>
           </a:p>
         </p:txBody>
@@ -3646,7 +3647,7 @@
                   <a:srgbClr val="2C3E50"/>
                 </a:solidFill>
               </a:rPr>
-              <a:t>Kern-Transformation</a:t>
+              <a:t>Modul-Grid</a:t>
             </a:r>
           </a:p>
         </p:txBody>
@@ -3680,7 +3681,7 @@
                   <a:srgbClr val="2C3E50"/>
                 </a:solidFill>
               </a:rPr>
-              <a:t>Liest Jira-JSON-Export, berechnet Verweildauer je Workflow-Stage, schreibt IssueTimes.xlsx und CFD.xlsx</a:t>
+              <a:t>Alle verfügbaren und geplanten Module als Kacheln; verfügbare Module per Klick direkt starten — öffnen sich als eigenständiger Prozess in eigenem Fenster, Launcher bleibt geöffnet</a:t>
             </a:r>
           </a:p>
         </p:txBody>
@@ -3800,7 +3801,7 @@
                   <a:srgbClr val="2C3E50"/>
                 </a:solidFill>
               </a:rPr>
-              <a:t>Workflow-Datei</a:t>
+              <a:t>5 Sprachen</a:t>
             </a:r>
           </a:p>
         </p:txBody>
@@ -3834,7 +3835,7 @@
                   <a:srgbClr val="2C3E50"/>
                 </a:solidFill>
               </a:rPr>
-              <a:t>Textdatei mit &lt;First&gt;- und &lt;Closed&gt;-Markern definiert Eintritts- und Abschluss-Stage</a:t>
+              <a:t>Vollständig lokalisiert in DE, EN, RO, PT, FR — Umschaltung per Flag-Button oben rechts; Einstellung wird persistent gespeichert und gilt für alle Module gemeinsam</a:t>
             </a:r>
           </a:p>
         </p:txBody>
@@ -3954,7 +3955,7 @@
                   <a:srgbClr val="2C3E50"/>
                 </a:solidFill>
               </a:rPr>
-              <a:t>Datumsregeln</a:t>
+              <a:t>Update-Check</a:t>
             </a:r>
           </a:p>
         </p:txBody>
@@ -3988,7 +3989,7 @@
                   <a:srgbClr val="2C3E50"/>
                 </a:solidFill>
               </a:rPr>
-              <a:t>First Date / Closed Date aus Stage-Übergängen; Fallback bei übersprungenen Stages; Closed Date wird gelöscht wenn Issue wiedereröffnet wurde</a:t>
+              <a:t>Beim Start automatische Prüfung auf neue GitHub-Releases im Hintergrund; gelbes Banner mit Download-Link erscheint bei neuerer Version — kein Fehler bei fehlendem Internet</a:t>
             </a:r>
           </a:p>
         </p:txBody>
@@ -4108,7 +4109,7 @@
                   <a:srgbClr val="2C3E50"/>
                 </a:solidFill>
               </a:rPr>
-              <a:t>Carry-Forward</a:t>
+              <a:t>Handbuch-Button</a:t>
             </a:r>
           </a:p>
         </p:txBody>
@@ -4142,7 +4143,7 @@
                   <a:srgbClr val="2C3E50"/>
                 </a:solidFill>
               </a:rPr>
-              <a:t>Verweildauer wird auf letzte bekannte Stage weitergezählt wenn eine Stage übersprungen wurde</a:t>
+              <a:t>(?)-Button öffnet sprachspezifisches PDF-Handbuch direkt auf GitHub Pages — in allen 5 Sprachen verfügbar</a:t>
             </a:r>
           </a:p>
         </p:txBody>
@@ -4262,7 +4263,7 @@
                   <a:srgbClr val="2C3E50"/>
                 </a:solidFill>
               </a:rPr>
-              <a:t>Validierung &amp; Warnungen</a:t>
+              <a:t>ALPHA-Badge</a:t>
             </a:r>
           </a:p>
         </p:txBody>
@@ -4296,7 +4297,7 @@
                   <a:srgbClr val="2C3E50"/>
                 </a:solidFill>
               </a:rPr>
-              <a:t>Warnt bei fehlenden Workflow-Markern, unmapped Statuses und Stage-Inkonsistenzen</a:t>
+              <a:t>Rotes ALPHA-Badge in der Titelleiste signalisiert Alpha-Status des Projekts</a:t>
             </a:r>
           </a:p>
         </p:txBody>
@@ -4416,7 +4417,7 @@
                   <a:srgbClr val="2C3E50"/>
                 </a:solidFill>
               </a:rPr>
-              <a:t>GUI</a:t>
+              <a:t>Portable Start</a:t>
             </a:r>
           </a:p>
         </p:txBody>
@@ -4450,7 +4451,7 @@
                   <a:srgbClr val="2C3E50"/>
                 </a:solidFill>
               </a:rPr>
-              <a:t>tkinter-Oberfläche mit Dateidialogen für JSON, Workflow-Datei und Ausgabeordner; Präfix automatisch aus Dateiname vorbelegt</a:t>
+              <a:t>SituationReport.bat (Windows) / .command (macOS) / .sh (Linux) — kein Python oder Terminal erforderlich</a:t>
             </a:r>
           </a:p>
         </p:txBody>
@@ -4458,314 +4459,6 @@
       <p:sp>
         <p:nvSpPr>
           <p:cNvPr id="32" name="Rectangle 31"/>
-          <p:cNvSpPr/>
-          <p:nvPr/>
-        </p:nvSpPr>
-        <p:spPr>
-          <a:xfrm>
-            <a:off x="274320" y="5276087"/>
-            <a:ext cx="2926080" cy="658368"/>
-          </a:xfrm>
-          <a:prstGeom prst="rect">
-            <a:avLst/>
-          </a:prstGeom>
-          <a:solidFill>
-            <a:srgbClr val="ECF0F1"/>
-          </a:solidFill>
-          <a:ln>
-            <a:noFill/>
-          </a:ln>
-        </p:spPr>
-        <p:style>
-          <a:lnRef idx="1">
-            <a:schemeClr val="accent1"/>
-          </a:lnRef>
-          <a:fillRef idx="3">
-            <a:schemeClr val="accent1"/>
-          </a:fillRef>
-          <a:effectRef idx="2">
-            <a:schemeClr val="accent1"/>
-          </a:effectRef>
-          <a:fontRef idx="minor">
-            <a:schemeClr val="lt1"/>
-          </a:fontRef>
-        </p:style>
-        <p:txBody>
-          <a:bodyPr rtlCol="0" anchor="ctr"/>
-          <a:lstStyle/>
-          <a:p>
-            <a:pPr algn="ctr"/>
-          </a:p>
-        </p:txBody>
-      </p:sp>
-      <p:sp>
-        <p:nvSpPr>
-          <p:cNvPr id="33" name="Rectangle 32"/>
-          <p:cNvSpPr/>
-          <p:nvPr/>
-        </p:nvSpPr>
-        <p:spPr>
-          <a:xfrm>
-            <a:off x="3291840" y="5276087"/>
-            <a:ext cx="8595360" cy="658368"/>
-          </a:xfrm>
-          <a:prstGeom prst="rect">
-            <a:avLst/>
-          </a:prstGeom>
-          <a:solidFill>
-            <a:srgbClr val="ECF0F1"/>
-          </a:solidFill>
-          <a:ln>
-            <a:noFill/>
-          </a:ln>
-        </p:spPr>
-        <p:style>
-          <a:lnRef idx="1">
-            <a:schemeClr val="accent1"/>
-          </a:lnRef>
-          <a:fillRef idx="3">
-            <a:schemeClr val="accent1"/>
-          </a:fillRef>
-          <a:effectRef idx="2">
-            <a:schemeClr val="accent1"/>
-          </a:effectRef>
-          <a:fontRef idx="minor">
-            <a:schemeClr val="lt1"/>
-          </a:fontRef>
-        </p:style>
-        <p:txBody>
-          <a:bodyPr rtlCol="0" anchor="ctr"/>
-          <a:lstStyle/>
-          <a:p>
-            <a:pPr algn="ctr"/>
-          </a:p>
-        </p:txBody>
-      </p:sp>
-      <p:sp>
-        <p:nvSpPr>
-          <p:cNvPr id="34" name="TextBox 33"/>
-          <p:cNvSpPr txBox="1"/>
-          <p:nvPr/>
-        </p:nvSpPr>
-        <p:spPr>
-          <a:xfrm>
-            <a:off x="347472" y="5312663"/>
-            <a:ext cx="2788920" cy="603503"/>
-          </a:xfrm>
-          <a:prstGeom prst="rect">
-            <a:avLst/>
-          </a:prstGeom>
-          <a:noFill/>
-        </p:spPr>
-        <p:txBody>
-          <a:bodyPr wrap="square">
-            <a:spAutoFit/>
-          </a:bodyPr>
-          <a:lstStyle/>
-          <a:p>
-            <a:pPr algn="l"/>
-            <a:r>
-              <a:rPr sz="900" b="1">
-                <a:solidFill>
-                  <a:srgbClr val="2C3E50"/>
-                </a:solidFill>
-              </a:rPr>
-              <a:t>Ladebalken</a:t>
-            </a:r>
-          </a:p>
-        </p:txBody>
-      </p:sp>
-      <p:sp>
-        <p:nvSpPr>
-          <p:cNvPr id="35" name="TextBox 34"/>
-          <p:cNvSpPr txBox="1"/>
-          <p:nvPr/>
-        </p:nvSpPr>
-        <p:spPr>
-          <a:xfrm>
-            <a:off x="3364992" y="5312663"/>
-            <a:ext cx="8412480" cy="603503"/>
-          </a:xfrm>
-          <a:prstGeom prst="rect">
-            <a:avLst/>
-          </a:prstGeom>
-          <a:noFill/>
-        </p:spPr>
-        <p:txBody>
-          <a:bodyPr wrap="square">
-            <a:spAutoFit/>
-          </a:bodyPr>
-          <a:lstStyle/>
-          <a:p>
-            <a:pPr algn="l"/>
-            <a:r>
-              <a:rPr sz="900" b="0">
-                <a:solidFill>
-                  <a:srgbClr val="2C3E50"/>
-                </a:solidFill>
-              </a:rPr>
-              <a:t>Erscheint nach 3 Sekunden wenn die Transformation noch läuft</a:t>
-            </a:r>
-          </a:p>
-        </p:txBody>
-      </p:sp>
-      <p:sp>
-        <p:nvSpPr>
-          <p:cNvPr id="36" name="Rectangle 35"/>
-          <p:cNvSpPr/>
-          <p:nvPr/>
-        </p:nvSpPr>
-        <p:spPr>
-          <a:xfrm>
-            <a:off x="274320" y="5934455"/>
-            <a:ext cx="2926080" cy="658368"/>
-          </a:xfrm>
-          <a:prstGeom prst="rect">
-            <a:avLst/>
-          </a:prstGeom>
-          <a:solidFill>
-            <a:srgbClr val="FFFFFF"/>
-          </a:solidFill>
-          <a:ln>
-            <a:noFill/>
-          </a:ln>
-        </p:spPr>
-        <p:style>
-          <a:lnRef idx="1">
-            <a:schemeClr val="accent1"/>
-          </a:lnRef>
-          <a:fillRef idx="3">
-            <a:schemeClr val="accent1"/>
-          </a:fillRef>
-          <a:effectRef idx="2">
-            <a:schemeClr val="accent1"/>
-          </a:effectRef>
-          <a:fontRef idx="minor">
-            <a:schemeClr val="lt1"/>
-          </a:fontRef>
-        </p:style>
-        <p:txBody>
-          <a:bodyPr rtlCol="0" anchor="ctr"/>
-          <a:lstStyle/>
-          <a:p>
-            <a:pPr algn="ctr"/>
-          </a:p>
-        </p:txBody>
-      </p:sp>
-      <p:sp>
-        <p:nvSpPr>
-          <p:cNvPr id="37" name="Rectangle 36"/>
-          <p:cNvSpPr/>
-          <p:nvPr/>
-        </p:nvSpPr>
-        <p:spPr>
-          <a:xfrm>
-            <a:off x="3291840" y="5934455"/>
-            <a:ext cx="8595360" cy="658368"/>
-          </a:xfrm>
-          <a:prstGeom prst="rect">
-            <a:avLst/>
-          </a:prstGeom>
-          <a:solidFill>
-            <a:srgbClr val="FFFFFF"/>
-          </a:solidFill>
-          <a:ln>
-            <a:noFill/>
-          </a:ln>
-        </p:spPr>
-        <p:style>
-          <a:lnRef idx="1">
-            <a:schemeClr val="accent1"/>
-          </a:lnRef>
-          <a:fillRef idx="3">
-            <a:schemeClr val="accent1"/>
-          </a:fillRef>
-          <a:effectRef idx="2">
-            <a:schemeClr val="accent1"/>
-          </a:effectRef>
-          <a:fontRef idx="minor">
-            <a:schemeClr val="lt1"/>
-          </a:fontRef>
-        </p:style>
-        <p:txBody>
-          <a:bodyPr rtlCol="0" anchor="ctr"/>
-          <a:lstStyle/>
-          <a:p>
-            <a:pPr algn="ctr"/>
-          </a:p>
-        </p:txBody>
-      </p:sp>
-      <p:sp>
-        <p:nvSpPr>
-          <p:cNvPr id="38" name="TextBox 37"/>
-          <p:cNvSpPr txBox="1"/>
-          <p:nvPr/>
-        </p:nvSpPr>
-        <p:spPr>
-          <a:xfrm>
-            <a:off x="347472" y="5971031"/>
-            <a:ext cx="2788920" cy="603503"/>
-          </a:xfrm>
-          <a:prstGeom prst="rect">
-            <a:avLst/>
-          </a:prstGeom>
-          <a:noFill/>
-        </p:spPr>
-        <p:txBody>
-          <a:bodyPr wrap="square">
-            <a:spAutoFit/>
-          </a:bodyPr>
-          <a:lstStyle/>
-          <a:p>
-            <a:pPr algn="l"/>
-            <a:r>
-              <a:rPr sz="900" b="1">
-                <a:solidFill>
-                  <a:srgbClr val="2C3E50"/>
-                </a:solidFill>
-              </a:rPr>
-              <a:t>Doppelklick-Starter</a:t>
-            </a:r>
-          </a:p>
-        </p:txBody>
-      </p:sp>
-      <p:sp>
-        <p:nvSpPr>
-          <p:cNvPr id="39" name="TextBox 38"/>
-          <p:cNvSpPr txBox="1"/>
-          <p:nvPr/>
-        </p:nvSpPr>
-        <p:spPr>
-          <a:xfrm>
-            <a:off x="3364992" y="5971031"/>
-            <a:ext cx="8412480" cy="603503"/>
-          </a:xfrm>
-          <a:prstGeom prst="rect">
-            <a:avLst/>
-          </a:prstGeom>
-          <a:noFill/>
-        </p:spPr>
-        <p:txBody>
-          <a:bodyPr wrap="square">
-            <a:spAutoFit/>
-          </a:bodyPr>
-          <a:lstStyle/>
-          <a:p>
-            <a:pPr algn="l"/>
-            <a:r>
-              <a:rPr sz="900" b="0">
-                <a:solidFill>
-                  <a:srgbClr val="2C3E50"/>
-                </a:solidFill>
-              </a:rPr>
-              <a:t>transform_data_gui.pyw startet die GUI ohne Konsolenfenster</a:t>
-            </a:r>
-          </a:p>
-        </p:txBody>
-      </p:sp>
-      <p:sp>
-        <p:nvSpPr>
-          <p:cNvPr id="40" name="Rectangle 39"/>
           <p:cNvSpPr/>
           <p:nvPr/>
         </p:nvSpPr>
@@ -4896,7 +4589,7 @@
                   <a:srgbClr val="FFFFFF"/>
                 </a:solidFill>
               </a:rPr>
-              <a:t>build_reports — Metriken</a:t>
+              <a:t>transform_data</a:t>
             </a:r>
           </a:p>
         </p:txBody>
@@ -5170,7 +4863,7 @@
                   <a:srgbClr val="2C3E50"/>
                 </a:solidFill>
               </a:rPr>
-              <a:t>Flow Time / Cycle Time</a:t>
+              <a:t>Kern-Transformation</a:t>
             </a:r>
           </a:p>
         </p:txBody>
@@ -5204,7 +4897,7 @@
                   <a:srgbClr val="2C3E50"/>
                 </a:solidFill>
               </a:rPr>
-              <a:t>Boxplot + Scatterplot; Methode A &amp; B; LOESS-Trendlinie; Perzentil-Referenzlinien; farbige Punkte; rote Ausreißer; Issue-Key als Hover-Tooltip</a:t>
+              <a:t>Liest Jira-JSON-Export, berechnet Verweildauer je Workflow-Stage, schreibt IssueTimes.xlsx und CFD.xlsx</a:t>
             </a:r>
           </a:p>
         </p:txBody>
@@ -5324,7 +5017,7 @@
                   <a:srgbClr val="2C3E50"/>
                 </a:solidFill>
               </a:rPr>
-              <a:t>Flow Velocity / Throughput</a:t>
+              <a:t>Workflow-Datei</a:t>
             </a:r>
           </a:p>
         </p:txBody>
@@ -5358,7 +5051,7 @@
                   <a:srgbClr val="2C3E50"/>
                 </a:solidFill>
               </a:rPr>
-              <a:t>Tagesfrequenz-Histogramm + Wochenverlauf-Linienchart + PI-Balkendiagramm; konfigurierbares Target CT</a:t>
+              <a:t>Textdatei mit &lt;First&gt;- und &lt;Closed&gt;-Markern definiert Eintritts- und Abschluss-Stage</a:t>
             </a:r>
           </a:p>
         </p:txBody>
@@ -5478,7 +5171,7 @@
                   <a:srgbClr val="2C3E50"/>
                 </a:solidFill>
               </a:rPr>
-              <a:t>Flow Load / WIP</a:t>
+              <a:t>Datumsregeln</a:t>
             </a:r>
           </a:p>
         </p:txBody>
@@ -5512,7 +5205,7 @@
                   <a:srgbClr val="2C3E50"/>
                 </a:solidFill>
               </a:rPr>
-              <a:t>Aging-WIP-Boxplot pro Stage; Issue-Anzahl je Stage als Annotation; Referenzlinien (Median, P85, Target CT); Legende</a:t>
+              <a:t>First Date / Closed Date aus Stage-Übergängen; Fallback bei übersprungenen Stages; Closed Date wird gelöscht wenn Issue wiedereröffnet wurde</a:t>
             </a:r>
           </a:p>
         </p:txBody>
@@ -5632,7 +5325,7 @@
                   <a:srgbClr val="2C3E50"/>
                 </a:solidFill>
               </a:rPr>
-              <a:t>CFD</a:t>
+              <a:t>Carry-Forward</a:t>
             </a:r>
           </a:p>
         </p:txBody>
@@ -5666,7 +5359,7 @@
                   <a:srgbClr val="2C3E50"/>
                 </a:solidFill>
               </a:rPr>
-              <a:t>Gestapeltes Flächendiagramm; Trendlinien an visuellen Oberkanten der &lt;First&gt;- und &lt;Closed&gt;-Stages; Monats-/KW-Achse ohne Überlappung; In/Out-Ratio im Titel</a:t>
+              <a:t>Verweildauer wird auf letzte bekannte Stage weitergezählt wenn eine Stage übersprungen wurde</a:t>
             </a:r>
           </a:p>
         </p:txBody>
@@ -5786,7 +5479,7 @@
                   <a:srgbClr val="2C3E50"/>
                 </a:solidFill>
               </a:rPr>
-              <a:t>Flow Distribution</a:t>
+              <a:t>Validierung &amp; Warnungen</a:t>
             </a:r>
           </a:p>
         </p:txBody>
@@ -5820,7 +5513,7 @@
                   <a:srgbClr val="2C3E50"/>
                 </a:solidFill>
               </a:rPr>
-              <a:t>Drei Teildiagramme: Issue-Typ-Donut, Stage-Prominence-Donut, Ø Cycle Time je Typ als Balken</a:t>
+              <a:t>Warnt bei fehlenden Workflow-Markern, unmapped Statuses und Stage-Inkonsistenzen</a:t>
             </a:r>
           </a:p>
         </p:txBody>
@@ -5828,6 +5521,468 @@
       <p:sp>
         <p:nvSpPr>
           <p:cNvPr id="28" name="Rectangle 27"/>
+          <p:cNvSpPr/>
+          <p:nvPr/>
+        </p:nvSpPr>
+        <p:spPr>
+          <a:xfrm>
+            <a:off x="274320" y="4617719"/>
+            <a:ext cx="2926080" cy="658368"/>
+          </a:xfrm>
+          <a:prstGeom prst="rect">
+            <a:avLst/>
+          </a:prstGeom>
+          <a:solidFill>
+            <a:srgbClr val="FFFFFF"/>
+          </a:solidFill>
+          <a:ln>
+            <a:noFill/>
+          </a:ln>
+        </p:spPr>
+        <p:style>
+          <a:lnRef idx="1">
+            <a:schemeClr val="accent1"/>
+          </a:lnRef>
+          <a:fillRef idx="3">
+            <a:schemeClr val="accent1"/>
+          </a:fillRef>
+          <a:effectRef idx="2">
+            <a:schemeClr val="accent1"/>
+          </a:effectRef>
+          <a:fontRef idx="minor">
+            <a:schemeClr val="lt1"/>
+          </a:fontRef>
+        </p:style>
+        <p:txBody>
+          <a:bodyPr rtlCol="0" anchor="ctr"/>
+          <a:lstStyle/>
+          <a:p>
+            <a:pPr algn="ctr"/>
+          </a:p>
+        </p:txBody>
+      </p:sp>
+      <p:sp>
+        <p:nvSpPr>
+          <p:cNvPr id="29" name="Rectangle 28"/>
+          <p:cNvSpPr/>
+          <p:nvPr/>
+        </p:nvSpPr>
+        <p:spPr>
+          <a:xfrm>
+            <a:off x="3291840" y="4617719"/>
+            <a:ext cx="8595360" cy="658368"/>
+          </a:xfrm>
+          <a:prstGeom prst="rect">
+            <a:avLst/>
+          </a:prstGeom>
+          <a:solidFill>
+            <a:srgbClr val="FFFFFF"/>
+          </a:solidFill>
+          <a:ln>
+            <a:noFill/>
+          </a:ln>
+        </p:spPr>
+        <p:style>
+          <a:lnRef idx="1">
+            <a:schemeClr val="accent1"/>
+          </a:lnRef>
+          <a:fillRef idx="3">
+            <a:schemeClr val="accent1"/>
+          </a:fillRef>
+          <a:effectRef idx="2">
+            <a:schemeClr val="accent1"/>
+          </a:effectRef>
+          <a:fontRef idx="minor">
+            <a:schemeClr val="lt1"/>
+          </a:fontRef>
+        </p:style>
+        <p:txBody>
+          <a:bodyPr rtlCol="0" anchor="ctr"/>
+          <a:lstStyle/>
+          <a:p>
+            <a:pPr algn="ctr"/>
+          </a:p>
+        </p:txBody>
+      </p:sp>
+      <p:sp>
+        <p:nvSpPr>
+          <p:cNvPr id="30" name="TextBox 29"/>
+          <p:cNvSpPr txBox="1"/>
+          <p:nvPr/>
+        </p:nvSpPr>
+        <p:spPr>
+          <a:xfrm>
+            <a:off x="347472" y="4654295"/>
+            <a:ext cx="2788920" cy="603503"/>
+          </a:xfrm>
+          <a:prstGeom prst="rect">
+            <a:avLst/>
+          </a:prstGeom>
+          <a:noFill/>
+        </p:spPr>
+        <p:txBody>
+          <a:bodyPr wrap="square">
+            <a:spAutoFit/>
+          </a:bodyPr>
+          <a:lstStyle/>
+          <a:p>
+            <a:pPr algn="l"/>
+            <a:r>
+              <a:rPr sz="900" b="1">
+                <a:solidFill>
+                  <a:srgbClr val="2C3E50"/>
+                </a:solidFill>
+              </a:rPr>
+              <a:t>GUI</a:t>
+            </a:r>
+          </a:p>
+        </p:txBody>
+      </p:sp>
+      <p:sp>
+        <p:nvSpPr>
+          <p:cNvPr id="31" name="TextBox 30"/>
+          <p:cNvSpPr txBox="1"/>
+          <p:nvPr/>
+        </p:nvSpPr>
+        <p:spPr>
+          <a:xfrm>
+            <a:off x="3364992" y="4654295"/>
+            <a:ext cx="8412480" cy="603503"/>
+          </a:xfrm>
+          <a:prstGeom prst="rect">
+            <a:avLst/>
+          </a:prstGeom>
+          <a:noFill/>
+        </p:spPr>
+        <p:txBody>
+          <a:bodyPr wrap="square">
+            <a:spAutoFit/>
+          </a:bodyPr>
+          <a:lstStyle/>
+          <a:p>
+            <a:pPr algn="l"/>
+            <a:r>
+              <a:rPr sz="900" b="0">
+                <a:solidFill>
+                  <a:srgbClr val="2C3E50"/>
+                </a:solidFill>
+              </a:rPr>
+              <a:t>tkinter-Oberfläche mit Dateidialogen für JSON, Workflow-Datei und Ausgabeordner; Präfix automatisch aus Dateiname vorbelegt</a:t>
+            </a:r>
+          </a:p>
+        </p:txBody>
+      </p:sp>
+      <p:sp>
+        <p:nvSpPr>
+          <p:cNvPr id="32" name="Rectangle 31"/>
+          <p:cNvSpPr/>
+          <p:nvPr/>
+        </p:nvSpPr>
+        <p:spPr>
+          <a:xfrm>
+            <a:off x="274320" y="5276087"/>
+            <a:ext cx="2926080" cy="658368"/>
+          </a:xfrm>
+          <a:prstGeom prst="rect">
+            <a:avLst/>
+          </a:prstGeom>
+          <a:solidFill>
+            <a:srgbClr val="ECF0F1"/>
+          </a:solidFill>
+          <a:ln>
+            <a:noFill/>
+          </a:ln>
+        </p:spPr>
+        <p:style>
+          <a:lnRef idx="1">
+            <a:schemeClr val="accent1"/>
+          </a:lnRef>
+          <a:fillRef idx="3">
+            <a:schemeClr val="accent1"/>
+          </a:fillRef>
+          <a:effectRef idx="2">
+            <a:schemeClr val="accent1"/>
+          </a:effectRef>
+          <a:fontRef idx="minor">
+            <a:schemeClr val="lt1"/>
+          </a:fontRef>
+        </p:style>
+        <p:txBody>
+          <a:bodyPr rtlCol="0" anchor="ctr"/>
+          <a:lstStyle/>
+          <a:p>
+            <a:pPr algn="ctr"/>
+          </a:p>
+        </p:txBody>
+      </p:sp>
+      <p:sp>
+        <p:nvSpPr>
+          <p:cNvPr id="33" name="Rectangle 32"/>
+          <p:cNvSpPr/>
+          <p:nvPr/>
+        </p:nvSpPr>
+        <p:spPr>
+          <a:xfrm>
+            <a:off x="3291840" y="5276087"/>
+            <a:ext cx="8595360" cy="658368"/>
+          </a:xfrm>
+          <a:prstGeom prst="rect">
+            <a:avLst/>
+          </a:prstGeom>
+          <a:solidFill>
+            <a:srgbClr val="ECF0F1"/>
+          </a:solidFill>
+          <a:ln>
+            <a:noFill/>
+          </a:ln>
+        </p:spPr>
+        <p:style>
+          <a:lnRef idx="1">
+            <a:schemeClr val="accent1"/>
+          </a:lnRef>
+          <a:fillRef idx="3">
+            <a:schemeClr val="accent1"/>
+          </a:fillRef>
+          <a:effectRef idx="2">
+            <a:schemeClr val="accent1"/>
+          </a:effectRef>
+          <a:fontRef idx="minor">
+            <a:schemeClr val="lt1"/>
+          </a:fontRef>
+        </p:style>
+        <p:txBody>
+          <a:bodyPr rtlCol="0" anchor="ctr"/>
+          <a:lstStyle/>
+          <a:p>
+            <a:pPr algn="ctr"/>
+          </a:p>
+        </p:txBody>
+      </p:sp>
+      <p:sp>
+        <p:nvSpPr>
+          <p:cNvPr id="34" name="TextBox 33"/>
+          <p:cNvSpPr txBox="1"/>
+          <p:nvPr/>
+        </p:nvSpPr>
+        <p:spPr>
+          <a:xfrm>
+            <a:off x="347472" y="5312663"/>
+            <a:ext cx="2788920" cy="603503"/>
+          </a:xfrm>
+          <a:prstGeom prst="rect">
+            <a:avLst/>
+          </a:prstGeom>
+          <a:noFill/>
+        </p:spPr>
+        <p:txBody>
+          <a:bodyPr wrap="square">
+            <a:spAutoFit/>
+          </a:bodyPr>
+          <a:lstStyle/>
+          <a:p>
+            <a:pPr algn="l"/>
+            <a:r>
+              <a:rPr sz="900" b="1">
+                <a:solidFill>
+                  <a:srgbClr val="2C3E50"/>
+                </a:solidFill>
+              </a:rPr>
+              <a:t>Ladebalken</a:t>
+            </a:r>
+          </a:p>
+        </p:txBody>
+      </p:sp>
+      <p:sp>
+        <p:nvSpPr>
+          <p:cNvPr id="35" name="TextBox 34"/>
+          <p:cNvSpPr txBox="1"/>
+          <p:nvPr/>
+        </p:nvSpPr>
+        <p:spPr>
+          <a:xfrm>
+            <a:off x="3364992" y="5312663"/>
+            <a:ext cx="8412480" cy="603503"/>
+          </a:xfrm>
+          <a:prstGeom prst="rect">
+            <a:avLst/>
+          </a:prstGeom>
+          <a:noFill/>
+        </p:spPr>
+        <p:txBody>
+          <a:bodyPr wrap="square">
+            <a:spAutoFit/>
+          </a:bodyPr>
+          <a:lstStyle/>
+          <a:p>
+            <a:pPr algn="l"/>
+            <a:r>
+              <a:rPr sz="900" b="0">
+                <a:solidFill>
+                  <a:srgbClr val="2C3E50"/>
+                </a:solidFill>
+              </a:rPr>
+              <a:t>Erscheint nach 3 Sekunden wenn die Transformation noch läuft</a:t>
+            </a:r>
+          </a:p>
+        </p:txBody>
+      </p:sp>
+      <p:sp>
+        <p:nvSpPr>
+          <p:cNvPr id="36" name="Rectangle 35"/>
+          <p:cNvSpPr/>
+          <p:nvPr/>
+        </p:nvSpPr>
+        <p:spPr>
+          <a:xfrm>
+            <a:off x="274320" y="5934455"/>
+            <a:ext cx="2926080" cy="658368"/>
+          </a:xfrm>
+          <a:prstGeom prst="rect">
+            <a:avLst/>
+          </a:prstGeom>
+          <a:solidFill>
+            <a:srgbClr val="FFFFFF"/>
+          </a:solidFill>
+          <a:ln>
+            <a:noFill/>
+          </a:ln>
+        </p:spPr>
+        <p:style>
+          <a:lnRef idx="1">
+            <a:schemeClr val="accent1"/>
+          </a:lnRef>
+          <a:fillRef idx="3">
+            <a:schemeClr val="accent1"/>
+          </a:fillRef>
+          <a:effectRef idx="2">
+            <a:schemeClr val="accent1"/>
+          </a:effectRef>
+          <a:fontRef idx="minor">
+            <a:schemeClr val="lt1"/>
+          </a:fontRef>
+        </p:style>
+        <p:txBody>
+          <a:bodyPr rtlCol="0" anchor="ctr"/>
+          <a:lstStyle/>
+          <a:p>
+            <a:pPr algn="ctr"/>
+          </a:p>
+        </p:txBody>
+      </p:sp>
+      <p:sp>
+        <p:nvSpPr>
+          <p:cNvPr id="37" name="Rectangle 36"/>
+          <p:cNvSpPr/>
+          <p:nvPr/>
+        </p:nvSpPr>
+        <p:spPr>
+          <a:xfrm>
+            <a:off x="3291840" y="5934455"/>
+            <a:ext cx="8595360" cy="658368"/>
+          </a:xfrm>
+          <a:prstGeom prst="rect">
+            <a:avLst/>
+          </a:prstGeom>
+          <a:solidFill>
+            <a:srgbClr val="FFFFFF"/>
+          </a:solidFill>
+          <a:ln>
+            <a:noFill/>
+          </a:ln>
+        </p:spPr>
+        <p:style>
+          <a:lnRef idx="1">
+            <a:schemeClr val="accent1"/>
+          </a:lnRef>
+          <a:fillRef idx="3">
+            <a:schemeClr val="accent1"/>
+          </a:fillRef>
+          <a:effectRef idx="2">
+            <a:schemeClr val="accent1"/>
+          </a:effectRef>
+          <a:fontRef idx="minor">
+            <a:schemeClr val="lt1"/>
+          </a:fontRef>
+        </p:style>
+        <p:txBody>
+          <a:bodyPr rtlCol="0" anchor="ctr"/>
+          <a:lstStyle/>
+          <a:p>
+            <a:pPr algn="ctr"/>
+          </a:p>
+        </p:txBody>
+      </p:sp>
+      <p:sp>
+        <p:nvSpPr>
+          <p:cNvPr id="38" name="TextBox 37"/>
+          <p:cNvSpPr txBox="1"/>
+          <p:nvPr/>
+        </p:nvSpPr>
+        <p:spPr>
+          <a:xfrm>
+            <a:off x="347472" y="5971031"/>
+            <a:ext cx="2788920" cy="603503"/>
+          </a:xfrm>
+          <a:prstGeom prst="rect">
+            <a:avLst/>
+          </a:prstGeom>
+          <a:noFill/>
+        </p:spPr>
+        <p:txBody>
+          <a:bodyPr wrap="square">
+            <a:spAutoFit/>
+          </a:bodyPr>
+          <a:lstStyle/>
+          <a:p>
+            <a:pPr algn="l"/>
+            <a:r>
+              <a:rPr sz="900" b="1">
+                <a:solidFill>
+                  <a:srgbClr val="2C3E50"/>
+                </a:solidFill>
+              </a:rPr>
+              <a:t>Doppelklick-Starter</a:t>
+            </a:r>
+          </a:p>
+        </p:txBody>
+      </p:sp>
+      <p:sp>
+        <p:nvSpPr>
+          <p:cNvPr id="39" name="TextBox 38"/>
+          <p:cNvSpPr txBox="1"/>
+          <p:nvPr/>
+        </p:nvSpPr>
+        <p:spPr>
+          <a:xfrm>
+            <a:off x="3364992" y="5971031"/>
+            <a:ext cx="8412480" cy="603503"/>
+          </a:xfrm>
+          <a:prstGeom prst="rect">
+            <a:avLst/>
+          </a:prstGeom>
+          <a:noFill/>
+        </p:spPr>
+        <p:txBody>
+          <a:bodyPr wrap="square">
+            <a:spAutoFit/>
+          </a:bodyPr>
+          <a:lstStyle/>
+          <a:p>
+            <a:pPr algn="l"/>
+            <a:r>
+              <a:rPr sz="900" b="0">
+                <a:solidFill>
+                  <a:srgbClr val="2C3E50"/>
+                </a:solidFill>
+              </a:rPr>
+              <a:t>transform_data_gui.pyw startet die GUI ohne Konsolenfenster</a:t>
+            </a:r>
+          </a:p>
+        </p:txBody>
+      </p:sp>
+      <p:sp>
+        <p:nvSpPr>
+          <p:cNvPr id="40" name="Rectangle 39"/>
           <p:cNvSpPr/>
           <p:nvPr/>
         </p:nvSpPr>
@@ -5958,7 +6113,7 @@
                   <a:srgbClr val="FFFFFF"/>
                 </a:solidFill>
               </a:rPr>
-              <a:t>build_reports — Filter &amp; Ausschlüsse</a:t>
+              <a:t>build_reports — Metriken</a:t>
             </a:r>
           </a:p>
         </p:txBody>
@@ -6232,7 +6387,7 @@
                   <a:srgbClr val="2C3E50"/>
                 </a:solidFill>
               </a:rPr>
-              <a:t>Datumsfilter</a:t>
+              <a:t>Flow Time / Cycle Time</a:t>
             </a:r>
           </a:p>
         </p:txBody>
@@ -6266,7 +6421,7 @@
                   <a:srgbClr val="2C3E50"/>
                 </a:solidFill>
               </a:rPr>
-              <a:t>Von/Bis mit Kalender-Picker; "Letzte 365 Tage"-Button</a:t>
+              <a:t>Boxplot + Scatterplot; Methode A &amp; B; LOESS-Trendlinie; Perzentil-Referenzlinien; farbige Punkte; rote Ausreißer; Issue-Key als Hover-Tooltip</a:t>
             </a:r>
           </a:p>
         </p:txBody>
@@ -6386,7 +6541,7 @@
                   <a:srgbClr val="2C3E50"/>
                 </a:solidFill>
               </a:rPr>
-              <a:t>Projektfilter</a:t>
+              <a:t>Flow Velocity / Throughput</a:t>
             </a:r>
           </a:p>
         </p:txBody>
@@ -6420,7 +6575,7 @@
                   <a:srgbClr val="2C3E50"/>
                 </a:solidFill>
               </a:rPr>
-              <a:t>Auswahl aus allen in IssueTimes vorhandenen Projekten</a:t>
+              <a:t>Tagesfrequenz-Histogramm + Wochenverlauf-Linienchart + PI-Balkendiagramm; konfigurierbares Target CT</a:t>
             </a:r>
           </a:p>
         </p:txBody>
@@ -6540,7 +6695,7 @@
                   <a:srgbClr val="2C3E50"/>
                 </a:solidFill>
               </a:rPr>
-              <a:t>Issuetype-Filter</a:t>
+              <a:t>Flow Load / WIP</a:t>
             </a:r>
           </a:p>
         </p:txBody>
@@ -6574,7 +6729,7 @@
                   <a:srgbClr val="2C3E50"/>
                 </a:solidFill>
               </a:rPr>
-              <a:t>Auswahl aus allen vorhandenen Issue-Typen</a:t>
+              <a:t>Aging-WIP-Boxplot pro Stage; Issue-Anzahl je Stage als Annotation; Referenzlinien (Median, P85, Target CT); Legende</a:t>
             </a:r>
           </a:p>
         </p:txBody>
@@ -6694,7 +6849,7 @@
                   <a:srgbClr val="2C3E50"/>
                 </a:solidFill>
               </a:rPr>
-              <a:t>Ausschluss Status / Resolution</a:t>
+              <a:t>CFD</a:t>
             </a:r>
           </a:p>
         </p:txBody>
@@ -6728,7 +6883,7 @@
                   <a:srgbClr val="2C3E50"/>
                 </a:solidFill>
               </a:rPr>
-              <a:t>Issues komplett aus allen Metriken entfernen</a:t>
+              <a:t>Gestapeltes Flächendiagramm; Trendlinien an visuellen Oberkanten der &lt;First&gt;- und &lt;Closed&gt;-Stages; Monats-/KW-Achse ohne Überlappung; In/Out-Ratio im Titel</a:t>
             </a:r>
           </a:p>
         </p:txBody>
@@ -6848,7 +7003,7 @@
                   <a:srgbClr val="2C3E50"/>
                 </a:solidFill>
               </a:rPr>
-              <a:t>Zero-Day-Filter</a:t>
+              <a:t>Flow Distribution</a:t>
             </a:r>
           </a:p>
         </p:txBody>
@@ -6882,7 +7037,7 @@
                   <a:srgbClr val="2C3E50"/>
                 </a:solidFill>
               </a:rPr>
-              <a:t>Konfigurierbarer Schwellwert (Standard 5 min); ausgeschlossene Issues in separater Excel dokumentiert</a:t>
+              <a:t>Drei Teildiagramme: Issue-Typ-Donut, Stage-Prominence-Donut, Ø Cycle Time je Typ als Balken</a:t>
             </a:r>
           </a:p>
         </p:txBody>
@@ -6890,160 +7045,6 @@
       <p:sp>
         <p:nvSpPr>
           <p:cNvPr id="28" name="Rectangle 27"/>
-          <p:cNvSpPr/>
-          <p:nvPr/>
-        </p:nvSpPr>
-        <p:spPr>
-          <a:xfrm>
-            <a:off x="274320" y="4617719"/>
-            <a:ext cx="2926080" cy="658368"/>
-          </a:xfrm>
-          <a:prstGeom prst="rect">
-            <a:avLst/>
-          </a:prstGeom>
-          <a:solidFill>
-            <a:srgbClr val="FFFFFF"/>
-          </a:solidFill>
-          <a:ln>
-            <a:noFill/>
-          </a:ln>
-        </p:spPr>
-        <p:style>
-          <a:lnRef idx="1">
-            <a:schemeClr val="accent1"/>
-          </a:lnRef>
-          <a:fillRef idx="3">
-            <a:schemeClr val="accent1"/>
-          </a:fillRef>
-          <a:effectRef idx="2">
-            <a:schemeClr val="accent1"/>
-          </a:effectRef>
-          <a:fontRef idx="minor">
-            <a:schemeClr val="lt1"/>
-          </a:fontRef>
-        </p:style>
-        <p:txBody>
-          <a:bodyPr rtlCol="0" anchor="ctr"/>
-          <a:lstStyle/>
-          <a:p>
-            <a:pPr algn="ctr"/>
-          </a:p>
-        </p:txBody>
-      </p:sp>
-      <p:sp>
-        <p:nvSpPr>
-          <p:cNvPr id="29" name="Rectangle 28"/>
-          <p:cNvSpPr/>
-          <p:nvPr/>
-        </p:nvSpPr>
-        <p:spPr>
-          <a:xfrm>
-            <a:off x="3291840" y="4617719"/>
-            <a:ext cx="8595360" cy="658368"/>
-          </a:xfrm>
-          <a:prstGeom prst="rect">
-            <a:avLst/>
-          </a:prstGeom>
-          <a:solidFill>
-            <a:srgbClr val="FFFFFF"/>
-          </a:solidFill>
-          <a:ln>
-            <a:noFill/>
-          </a:ln>
-        </p:spPr>
-        <p:style>
-          <a:lnRef idx="1">
-            <a:schemeClr val="accent1"/>
-          </a:lnRef>
-          <a:fillRef idx="3">
-            <a:schemeClr val="accent1"/>
-          </a:fillRef>
-          <a:effectRef idx="2">
-            <a:schemeClr val="accent1"/>
-          </a:effectRef>
-          <a:fontRef idx="minor">
-            <a:schemeClr val="lt1"/>
-          </a:fontRef>
-        </p:style>
-        <p:txBody>
-          <a:bodyPr rtlCol="0" anchor="ctr"/>
-          <a:lstStyle/>
-          <a:p>
-            <a:pPr algn="ctr"/>
-          </a:p>
-        </p:txBody>
-      </p:sp>
-      <p:sp>
-        <p:nvSpPr>
-          <p:cNvPr id="30" name="TextBox 29"/>
-          <p:cNvSpPr txBox="1"/>
-          <p:nvPr/>
-        </p:nvSpPr>
-        <p:spPr>
-          <a:xfrm>
-            <a:off x="347472" y="4654295"/>
-            <a:ext cx="2788920" cy="603503"/>
-          </a:xfrm>
-          <a:prstGeom prst="rect">
-            <a:avLst/>
-          </a:prstGeom>
-          <a:noFill/>
-        </p:spPr>
-        <p:txBody>
-          <a:bodyPr wrap="square">
-            <a:spAutoFit/>
-          </a:bodyPr>
-          <a:lstStyle/>
-          <a:p>
-            <a:pPr algn="l"/>
-            <a:r>
-              <a:rPr sz="900" b="1">
-                <a:solidFill>
-                  <a:srgbClr val="2C3E50"/>
-                </a:solidFill>
-              </a:rPr>
-              <a:t>Datumsfilter-Bugfix</a:t>
-            </a:r>
-          </a:p>
-        </p:txBody>
-      </p:sp>
-      <p:sp>
-        <p:nvSpPr>
-          <p:cNvPr id="31" name="TextBox 30"/>
-          <p:cNvSpPr txBox="1"/>
-          <p:nvPr/>
-        </p:nvSpPr>
-        <p:spPr>
-          <a:xfrm>
-            <a:off x="3364992" y="4654295"/>
-            <a:ext cx="8412480" cy="603503"/>
-          </a:xfrm>
-          <a:prstGeom prst="rect">
-            <a:avLst/>
-          </a:prstGeom>
-          <a:noFill/>
-        </p:spPr>
-        <p:txBody>
-          <a:bodyPr wrap="square">
-            <a:spAutoFit/>
-          </a:bodyPr>
-          <a:lstStyle/>
-          <a:p>
-            <a:pPr algn="l"/>
-            <a:r>
-              <a:rPr sz="900" b="0">
-                <a:solidFill>
-                  <a:srgbClr val="2C3E50"/>
-                </a:solidFill>
-              </a:rPr>
-              <a:t>Offene Issues (kein Closed Date) wurden fälschlich vom Datumsfilter ausgeschlossen — behoben</a:t>
-            </a:r>
-          </a:p>
-        </p:txBody>
-      </p:sp>
-      <p:sp>
-        <p:nvSpPr>
-          <p:cNvPr id="32" name="Rectangle 31"/>
           <p:cNvSpPr/>
           <p:nvPr/>
         </p:nvSpPr>
@@ -7174,7 +7175,7 @@
                   <a:srgbClr val="FFFFFF"/>
                 </a:solidFill>
               </a:rPr>
-              <a:t>build_reports — Export &amp; Reporting</a:t>
+              <a:t>build_reports — Filter &amp; Ausschlüsse</a:t>
             </a:r>
           </a:p>
         </p:txBody>
@@ -7448,7 +7449,7 @@
                   <a:srgbClr val="2C3E50"/>
                 </a:solidFill>
               </a:rPr>
-              <a:t>Browser-Anzeige</a:t>
+              <a:t>Datumsfilter</a:t>
             </a:r>
           </a:p>
         </p:txBody>
@@ -7482,7 +7483,7 @@
                   <a:srgbClr val="2C3E50"/>
                 </a:solidFill>
               </a:rPr>
-              <a:t>Vollständig interaktive Plotly-Diagramme im Browser</a:t>
+              <a:t>Von/Bis mit Kalender-Picker; "Letzte 365 Tage"-Button</a:t>
             </a:r>
           </a:p>
         </p:txBody>
@@ -7602,7 +7603,7 @@
                   <a:srgbClr val="2C3E50"/>
                 </a:solidFill>
               </a:rPr>
-              <a:t>PDF-Export</a:t>
+              <a:t>Projektfilter</a:t>
             </a:r>
           </a:p>
         </p:txBody>
@@ -7636,7 +7637,7 @@
                   <a:srgbClr val="2C3E50"/>
                 </a:solidFill>
               </a:rPr>
-              <a:t>Mehrseitige PDF mit allen gewählten Metriken</a:t>
+              <a:t>Auswahl aus allen in IssueTimes vorhandenen Projekten</a:t>
             </a:r>
           </a:p>
         </p:txBody>
@@ -7756,7 +7757,7 @@
                   <a:srgbClr val="2C3E50"/>
                 </a:solidFill>
               </a:rPr>
-              <a:t>Report-Excel</a:t>
+              <a:t>Issuetype-Filter</a:t>
             </a:r>
           </a:p>
         </p:txBody>
@@ -7790,7 +7791,7 @@
                   <a:srgbClr val="2C3E50"/>
                 </a:solidFill>
               </a:rPr>
-              <a:t>Wird automatisch beim PDF-Export erzeugt; enthält gefilterte Issues mit Status Group, CT Methode A und B</a:t>
+              <a:t>Auswahl aus allen vorhandenen Issue-Typen</a:t>
             </a:r>
           </a:p>
         </p:txBody>
@@ -7910,7 +7911,7 @@
                   <a:srgbClr val="2C3E50"/>
                 </a:solidFill>
               </a:rPr>
-              <a:t>PI-Konfiguration</a:t>
+              <a:t>Ausschluss Status / Resolution</a:t>
             </a:r>
           </a:p>
         </p:txBody>
@@ -7944,7 +7945,7 @@
                   <a:srgbClr val="2C3E50"/>
                 </a:solidFill>
               </a:rPr>
-              <a:t>Eigene PI-Intervalle per JSON-Datei; ohne Datei werden Kalenderquartale verwendet</a:t>
+              <a:t>Issues komplett aus allen Metriken entfernen</a:t>
             </a:r>
           </a:p>
         </p:txBody>
@@ -7952,6 +7953,314 @@
       <p:sp>
         <p:nvSpPr>
           <p:cNvPr id="24" name="Rectangle 23"/>
+          <p:cNvSpPr/>
+          <p:nvPr/>
+        </p:nvSpPr>
+        <p:spPr>
+          <a:xfrm>
+            <a:off x="274320" y="3959351"/>
+            <a:ext cx="2926080" cy="658368"/>
+          </a:xfrm>
+          <a:prstGeom prst="rect">
+            <a:avLst/>
+          </a:prstGeom>
+          <a:solidFill>
+            <a:srgbClr val="ECF0F1"/>
+          </a:solidFill>
+          <a:ln>
+            <a:noFill/>
+          </a:ln>
+        </p:spPr>
+        <p:style>
+          <a:lnRef idx="1">
+            <a:schemeClr val="accent1"/>
+          </a:lnRef>
+          <a:fillRef idx="3">
+            <a:schemeClr val="accent1"/>
+          </a:fillRef>
+          <a:effectRef idx="2">
+            <a:schemeClr val="accent1"/>
+          </a:effectRef>
+          <a:fontRef idx="minor">
+            <a:schemeClr val="lt1"/>
+          </a:fontRef>
+        </p:style>
+        <p:txBody>
+          <a:bodyPr rtlCol="0" anchor="ctr"/>
+          <a:lstStyle/>
+          <a:p>
+            <a:pPr algn="ctr"/>
+          </a:p>
+        </p:txBody>
+      </p:sp>
+      <p:sp>
+        <p:nvSpPr>
+          <p:cNvPr id="25" name="Rectangle 24"/>
+          <p:cNvSpPr/>
+          <p:nvPr/>
+        </p:nvSpPr>
+        <p:spPr>
+          <a:xfrm>
+            <a:off x="3291840" y="3959351"/>
+            <a:ext cx="8595360" cy="658368"/>
+          </a:xfrm>
+          <a:prstGeom prst="rect">
+            <a:avLst/>
+          </a:prstGeom>
+          <a:solidFill>
+            <a:srgbClr val="ECF0F1"/>
+          </a:solidFill>
+          <a:ln>
+            <a:noFill/>
+          </a:ln>
+        </p:spPr>
+        <p:style>
+          <a:lnRef idx="1">
+            <a:schemeClr val="accent1"/>
+          </a:lnRef>
+          <a:fillRef idx="3">
+            <a:schemeClr val="accent1"/>
+          </a:fillRef>
+          <a:effectRef idx="2">
+            <a:schemeClr val="accent1"/>
+          </a:effectRef>
+          <a:fontRef idx="minor">
+            <a:schemeClr val="lt1"/>
+          </a:fontRef>
+        </p:style>
+        <p:txBody>
+          <a:bodyPr rtlCol="0" anchor="ctr"/>
+          <a:lstStyle/>
+          <a:p>
+            <a:pPr algn="ctr"/>
+          </a:p>
+        </p:txBody>
+      </p:sp>
+      <p:sp>
+        <p:nvSpPr>
+          <p:cNvPr id="26" name="TextBox 25"/>
+          <p:cNvSpPr txBox="1"/>
+          <p:nvPr/>
+        </p:nvSpPr>
+        <p:spPr>
+          <a:xfrm>
+            <a:off x="347472" y="3995927"/>
+            <a:ext cx="2788920" cy="603503"/>
+          </a:xfrm>
+          <a:prstGeom prst="rect">
+            <a:avLst/>
+          </a:prstGeom>
+          <a:noFill/>
+        </p:spPr>
+        <p:txBody>
+          <a:bodyPr wrap="square">
+            <a:spAutoFit/>
+          </a:bodyPr>
+          <a:lstStyle/>
+          <a:p>
+            <a:pPr algn="l"/>
+            <a:r>
+              <a:rPr sz="900" b="1">
+                <a:solidFill>
+                  <a:srgbClr val="2C3E50"/>
+                </a:solidFill>
+              </a:rPr>
+              <a:t>Zero-Day-Filter</a:t>
+            </a:r>
+          </a:p>
+        </p:txBody>
+      </p:sp>
+      <p:sp>
+        <p:nvSpPr>
+          <p:cNvPr id="27" name="TextBox 26"/>
+          <p:cNvSpPr txBox="1"/>
+          <p:nvPr/>
+        </p:nvSpPr>
+        <p:spPr>
+          <a:xfrm>
+            <a:off x="3364992" y="3995927"/>
+            <a:ext cx="8412480" cy="603503"/>
+          </a:xfrm>
+          <a:prstGeom prst="rect">
+            <a:avLst/>
+          </a:prstGeom>
+          <a:noFill/>
+        </p:spPr>
+        <p:txBody>
+          <a:bodyPr wrap="square">
+            <a:spAutoFit/>
+          </a:bodyPr>
+          <a:lstStyle/>
+          <a:p>
+            <a:pPr algn="l"/>
+            <a:r>
+              <a:rPr sz="900" b="0">
+                <a:solidFill>
+                  <a:srgbClr val="2C3E50"/>
+                </a:solidFill>
+              </a:rPr>
+              <a:t>Konfigurierbarer Schwellwert (Standard 5 min); ausgeschlossene Issues in separater Excel dokumentiert</a:t>
+            </a:r>
+          </a:p>
+        </p:txBody>
+      </p:sp>
+      <p:sp>
+        <p:nvSpPr>
+          <p:cNvPr id="28" name="Rectangle 27"/>
+          <p:cNvSpPr/>
+          <p:nvPr/>
+        </p:nvSpPr>
+        <p:spPr>
+          <a:xfrm>
+            <a:off x="274320" y="4617719"/>
+            <a:ext cx="2926080" cy="658368"/>
+          </a:xfrm>
+          <a:prstGeom prst="rect">
+            <a:avLst/>
+          </a:prstGeom>
+          <a:solidFill>
+            <a:srgbClr val="FFFFFF"/>
+          </a:solidFill>
+          <a:ln>
+            <a:noFill/>
+          </a:ln>
+        </p:spPr>
+        <p:style>
+          <a:lnRef idx="1">
+            <a:schemeClr val="accent1"/>
+          </a:lnRef>
+          <a:fillRef idx="3">
+            <a:schemeClr val="accent1"/>
+          </a:fillRef>
+          <a:effectRef idx="2">
+            <a:schemeClr val="accent1"/>
+          </a:effectRef>
+          <a:fontRef idx="minor">
+            <a:schemeClr val="lt1"/>
+          </a:fontRef>
+        </p:style>
+        <p:txBody>
+          <a:bodyPr rtlCol="0" anchor="ctr"/>
+          <a:lstStyle/>
+          <a:p>
+            <a:pPr algn="ctr"/>
+          </a:p>
+        </p:txBody>
+      </p:sp>
+      <p:sp>
+        <p:nvSpPr>
+          <p:cNvPr id="29" name="Rectangle 28"/>
+          <p:cNvSpPr/>
+          <p:nvPr/>
+        </p:nvSpPr>
+        <p:spPr>
+          <a:xfrm>
+            <a:off x="3291840" y="4617719"/>
+            <a:ext cx="8595360" cy="658368"/>
+          </a:xfrm>
+          <a:prstGeom prst="rect">
+            <a:avLst/>
+          </a:prstGeom>
+          <a:solidFill>
+            <a:srgbClr val="FFFFFF"/>
+          </a:solidFill>
+          <a:ln>
+            <a:noFill/>
+          </a:ln>
+        </p:spPr>
+        <p:style>
+          <a:lnRef idx="1">
+            <a:schemeClr val="accent1"/>
+          </a:lnRef>
+          <a:fillRef idx="3">
+            <a:schemeClr val="accent1"/>
+          </a:fillRef>
+          <a:effectRef idx="2">
+            <a:schemeClr val="accent1"/>
+          </a:effectRef>
+          <a:fontRef idx="minor">
+            <a:schemeClr val="lt1"/>
+          </a:fontRef>
+        </p:style>
+        <p:txBody>
+          <a:bodyPr rtlCol="0" anchor="ctr"/>
+          <a:lstStyle/>
+          <a:p>
+            <a:pPr algn="ctr"/>
+          </a:p>
+        </p:txBody>
+      </p:sp>
+      <p:sp>
+        <p:nvSpPr>
+          <p:cNvPr id="30" name="TextBox 29"/>
+          <p:cNvSpPr txBox="1"/>
+          <p:nvPr/>
+        </p:nvSpPr>
+        <p:spPr>
+          <a:xfrm>
+            <a:off x="347472" y="4654295"/>
+            <a:ext cx="2788920" cy="603503"/>
+          </a:xfrm>
+          <a:prstGeom prst="rect">
+            <a:avLst/>
+          </a:prstGeom>
+          <a:noFill/>
+        </p:spPr>
+        <p:txBody>
+          <a:bodyPr wrap="square">
+            <a:spAutoFit/>
+          </a:bodyPr>
+          <a:lstStyle/>
+          <a:p>
+            <a:pPr algn="l"/>
+            <a:r>
+              <a:rPr sz="900" b="1">
+                <a:solidFill>
+                  <a:srgbClr val="2C3E50"/>
+                </a:solidFill>
+              </a:rPr>
+              <a:t>Datumsfilter-Bugfix</a:t>
+            </a:r>
+          </a:p>
+        </p:txBody>
+      </p:sp>
+      <p:sp>
+        <p:nvSpPr>
+          <p:cNvPr id="31" name="TextBox 30"/>
+          <p:cNvSpPr txBox="1"/>
+          <p:nvPr/>
+        </p:nvSpPr>
+        <p:spPr>
+          <a:xfrm>
+            <a:off x="3364992" y="4654295"/>
+            <a:ext cx="8412480" cy="603503"/>
+          </a:xfrm>
+          <a:prstGeom prst="rect">
+            <a:avLst/>
+          </a:prstGeom>
+          <a:noFill/>
+        </p:spPr>
+        <p:txBody>
+          <a:bodyPr wrap="square">
+            <a:spAutoFit/>
+          </a:bodyPr>
+          <a:lstStyle/>
+          <a:p>
+            <a:pPr algn="l"/>
+            <a:r>
+              <a:rPr sz="900" b="0">
+                <a:solidFill>
+                  <a:srgbClr val="2C3E50"/>
+                </a:solidFill>
+              </a:rPr>
+              <a:t>Offene Issues (kein Closed Date) wurden fälschlich vom Datumsfilter ausgeschlossen — behoben</a:t>
+            </a:r>
+          </a:p>
+        </p:txBody>
+      </p:sp>
+      <p:sp>
+        <p:nvSpPr>
+          <p:cNvPr id="32" name="Rectangle 31"/>
           <p:cNvSpPr/>
           <p:nvPr/>
         </p:nvSpPr>
@@ -8082,7 +8391,7 @@
                   <a:srgbClr val="FFFFFF"/>
                 </a:solidFill>
               </a:rPr>
-              <a:t>build_reports — GUI &amp; UX</a:t>
+              <a:t>build_reports — Export &amp; Reporting</a:t>
             </a:r>
           </a:p>
         </p:txBody>
@@ -8356,7 +8665,7 @@
                   <a:srgbClr val="2C3E50"/>
                 </a:solidFill>
               </a:rPr>
-              <a:t>Terminologie</a:t>
+              <a:t>Browser-Anzeige</a:t>
             </a:r>
           </a:p>
         </p:txBody>
@@ -8390,7 +8699,7 @@
                   <a:srgbClr val="2C3E50"/>
                 </a:solidFill>
               </a:rPr>
-              <a:t>Umschaltung SAFe ↔ Global (Flow Time ↔ Cycle Time etc.)</a:t>
+              <a:t>Vollständig interaktive Plotly-Diagramme im Browser</a:t>
             </a:r>
           </a:p>
         </p:txBody>
@@ -8510,7 +8819,7 @@
                   <a:srgbClr val="2C3E50"/>
                 </a:solidFill>
               </a:rPr>
-              <a:t>Templates</a:t>
+              <a:t>PDF-Export</a:t>
             </a:r>
           </a:p>
         </p:txBody>
@@ -8544,7 +8853,7 @@
                   <a:srgbClr val="2C3E50"/>
                 </a:solidFill>
               </a:rPr>
-              <a:t>Alle Einstellungen als JSON speichern/laden; Ausschlüsse als dauerhafter Standard speicherbar</a:t>
+              <a:t>Mehrseitige PDF mit allen gewählten Metriken</a:t>
             </a:r>
           </a:p>
         </p:txBody>
@@ -8664,7 +8973,7 @@
                   <a:srgbClr val="2C3E50"/>
                 </a:solidFill>
               </a:rPr>
-              <a:t>Tooltips</a:t>
+              <a:t>Report-Excel</a:t>
             </a:r>
           </a:p>
         </p:txBody>
@@ -8698,7 +9007,7 @@
                   <a:srgbClr val="2C3E50"/>
                 </a:solidFill>
               </a:rPr>
-              <a:t>Hover-Tooltips auf allen GUI-Elementen</a:t>
+              <a:t>Wird automatisch beim PDF-Export erzeugt; enthält gefilterte Issues mit Status Group, CT Methode A und B</a:t>
             </a:r>
           </a:p>
         </p:txBody>
@@ -8818,7 +9127,7 @@
                   <a:srgbClr val="2C3E50"/>
                 </a:solidFill>
               </a:rPr>
-              <a:t>Ladebalken</a:t>
+              <a:t>PI-Konfiguration</a:t>
             </a:r>
           </a:p>
         </p:txBody>
@@ -8852,7 +9161,7 @@
                   <a:srgbClr val="2C3E50"/>
                 </a:solidFill>
               </a:rPr>
-              <a:t>Erscheint nach 3 Sekunden bei laufenden Berechnungen</a:t>
+              <a:t>Eigene PI-Intervalle per JSON-Datei; ohne Datei werden Kalenderquartale verwendet</a:t>
             </a:r>
           </a:p>
         </p:txBody>
@@ -8860,468 +9169,6 @@
       <p:sp>
         <p:nvSpPr>
           <p:cNvPr id="24" name="Rectangle 23"/>
-          <p:cNvSpPr/>
-          <p:nvPr/>
-        </p:nvSpPr>
-        <p:spPr>
-          <a:xfrm>
-            <a:off x="274320" y="3959351"/>
-            <a:ext cx="2926080" cy="658368"/>
-          </a:xfrm>
-          <a:prstGeom prst="rect">
-            <a:avLst/>
-          </a:prstGeom>
-          <a:solidFill>
-            <a:srgbClr val="ECF0F1"/>
-          </a:solidFill>
-          <a:ln>
-            <a:noFill/>
-          </a:ln>
-        </p:spPr>
-        <p:style>
-          <a:lnRef idx="1">
-            <a:schemeClr val="accent1"/>
-          </a:lnRef>
-          <a:fillRef idx="3">
-            <a:schemeClr val="accent1"/>
-          </a:fillRef>
-          <a:effectRef idx="2">
-            <a:schemeClr val="accent1"/>
-          </a:effectRef>
-          <a:fontRef idx="minor">
-            <a:schemeClr val="lt1"/>
-          </a:fontRef>
-        </p:style>
-        <p:txBody>
-          <a:bodyPr rtlCol="0" anchor="ctr"/>
-          <a:lstStyle/>
-          <a:p>
-            <a:pPr algn="ctr"/>
-          </a:p>
-        </p:txBody>
-      </p:sp>
-      <p:sp>
-        <p:nvSpPr>
-          <p:cNvPr id="25" name="Rectangle 24"/>
-          <p:cNvSpPr/>
-          <p:nvPr/>
-        </p:nvSpPr>
-        <p:spPr>
-          <a:xfrm>
-            <a:off x="3291840" y="3959351"/>
-            <a:ext cx="8595360" cy="658368"/>
-          </a:xfrm>
-          <a:prstGeom prst="rect">
-            <a:avLst/>
-          </a:prstGeom>
-          <a:solidFill>
-            <a:srgbClr val="ECF0F1"/>
-          </a:solidFill>
-          <a:ln>
-            <a:noFill/>
-          </a:ln>
-        </p:spPr>
-        <p:style>
-          <a:lnRef idx="1">
-            <a:schemeClr val="accent1"/>
-          </a:lnRef>
-          <a:fillRef idx="3">
-            <a:schemeClr val="accent1"/>
-          </a:fillRef>
-          <a:effectRef idx="2">
-            <a:schemeClr val="accent1"/>
-          </a:effectRef>
-          <a:fontRef idx="minor">
-            <a:schemeClr val="lt1"/>
-          </a:fontRef>
-        </p:style>
-        <p:txBody>
-          <a:bodyPr rtlCol="0" anchor="ctr"/>
-          <a:lstStyle/>
-          <a:p>
-            <a:pPr algn="ctr"/>
-          </a:p>
-        </p:txBody>
-      </p:sp>
-      <p:sp>
-        <p:nvSpPr>
-          <p:cNvPr id="26" name="TextBox 25"/>
-          <p:cNvSpPr txBox="1"/>
-          <p:nvPr/>
-        </p:nvSpPr>
-        <p:spPr>
-          <a:xfrm>
-            <a:off x="347472" y="3995927"/>
-            <a:ext cx="2788920" cy="603503"/>
-          </a:xfrm>
-          <a:prstGeom prst="rect">
-            <a:avLst/>
-          </a:prstGeom>
-          <a:noFill/>
-        </p:spPr>
-        <p:txBody>
-          <a:bodyPr wrap="square">
-            <a:spAutoFit/>
-          </a:bodyPr>
-          <a:lstStyle/>
-          <a:p>
-            <a:pPr algn="l"/>
-            <a:r>
-              <a:rPr sz="900" b="1">
-                <a:solidFill>
-                  <a:srgbClr val="2C3E50"/>
-                </a:solidFill>
-              </a:rPr>
-              <a:t>Stage-Konsistenzprüfung</a:t>
-            </a:r>
-          </a:p>
-        </p:txBody>
-      </p:sp>
-      <p:sp>
-        <p:nvSpPr>
-          <p:cNvPr id="27" name="TextBox 26"/>
-          <p:cNvSpPr txBox="1"/>
-          <p:nvPr/>
-        </p:nvSpPr>
-        <p:spPr>
-          <a:xfrm>
-            <a:off x="3364992" y="3995927"/>
-            <a:ext cx="8412480" cy="603503"/>
-          </a:xfrm>
-          <a:prstGeom prst="rect">
-            <a:avLst/>
-          </a:prstGeom>
-          <a:noFill/>
-        </p:spPr>
-        <p:txBody>
-          <a:bodyPr wrap="square">
-            <a:spAutoFit/>
-          </a:bodyPr>
-          <a:lstStyle/>
-          <a:p>
-            <a:pPr algn="l"/>
-            <a:r>
-              <a:rPr sz="900" b="0">
-                <a:solidFill>
-                  <a:srgbClr val="2C3E50"/>
-                </a:solidFill>
-              </a:rPr>
-              <a:t>Warnung wenn IssueTimes und CFD unterschiedliche Stages haben</a:t>
-            </a:r>
-          </a:p>
-        </p:txBody>
-      </p:sp>
-      <p:sp>
-        <p:nvSpPr>
-          <p:cNvPr id="28" name="Rectangle 27"/>
-          <p:cNvSpPr/>
-          <p:nvPr/>
-        </p:nvSpPr>
-        <p:spPr>
-          <a:xfrm>
-            <a:off x="274320" y="4617719"/>
-            <a:ext cx="2926080" cy="658368"/>
-          </a:xfrm>
-          <a:prstGeom prst="rect">
-            <a:avLst/>
-          </a:prstGeom>
-          <a:solidFill>
-            <a:srgbClr val="FFFFFF"/>
-          </a:solidFill>
-          <a:ln>
-            <a:noFill/>
-          </a:ln>
-        </p:spPr>
-        <p:style>
-          <a:lnRef idx="1">
-            <a:schemeClr val="accent1"/>
-          </a:lnRef>
-          <a:fillRef idx="3">
-            <a:schemeClr val="accent1"/>
-          </a:fillRef>
-          <a:effectRef idx="2">
-            <a:schemeClr val="accent1"/>
-          </a:effectRef>
-          <a:fontRef idx="minor">
-            <a:schemeClr val="lt1"/>
-          </a:fontRef>
-        </p:style>
-        <p:txBody>
-          <a:bodyPr rtlCol="0" anchor="ctr"/>
-          <a:lstStyle/>
-          <a:p>
-            <a:pPr algn="ctr"/>
-          </a:p>
-        </p:txBody>
-      </p:sp>
-      <p:sp>
-        <p:nvSpPr>
-          <p:cNvPr id="29" name="Rectangle 28"/>
-          <p:cNvSpPr/>
-          <p:nvPr/>
-        </p:nvSpPr>
-        <p:spPr>
-          <a:xfrm>
-            <a:off x="3291840" y="4617719"/>
-            <a:ext cx="8595360" cy="658368"/>
-          </a:xfrm>
-          <a:prstGeom prst="rect">
-            <a:avLst/>
-          </a:prstGeom>
-          <a:solidFill>
-            <a:srgbClr val="FFFFFF"/>
-          </a:solidFill>
-          <a:ln>
-            <a:noFill/>
-          </a:ln>
-        </p:spPr>
-        <p:style>
-          <a:lnRef idx="1">
-            <a:schemeClr val="accent1"/>
-          </a:lnRef>
-          <a:fillRef idx="3">
-            <a:schemeClr val="accent1"/>
-          </a:fillRef>
-          <a:effectRef idx="2">
-            <a:schemeClr val="accent1"/>
-          </a:effectRef>
-          <a:fontRef idx="minor">
-            <a:schemeClr val="lt1"/>
-          </a:fontRef>
-        </p:style>
-        <p:txBody>
-          <a:bodyPr rtlCol="0" anchor="ctr"/>
-          <a:lstStyle/>
-          <a:p>
-            <a:pPr algn="ctr"/>
-          </a:p>
-        </p:txBody>
-      </p:sp>
-      <p:sp>
-        <p:nvSpPr>
-          <p:cNvPr id="30" name="TextBox 29"/>
-          <p:cNvSpPr txBox="1"/>
-          <p:nvPr/>
-        </p:nvSpPr>
-        <p:spPr>
-          <a:xfrm>
-            <a:off x="347472" y="4654295"/>
-            <a:ext cx="2788920" cy="603503"/>
-          </a:xfrm>
-          <a:prstGeom prst="rect">
-            <a:avLst/>
-          </a:prstGeom>
-          <a:noFill/>
-        </p:spPr>
-        <p:txBody>
-          <a:bodyPr wrap="square">
-            <a:spAutoFit/>
-          </a:bodyPr>
-          <a:lstStyle/>
-          <a:p>
-            <a:pPr algn="l"/>
-            <a:r>
-              <a:rPr sz="900" b="1">
-                <a:solidFill>
-                  <a:srgbClr val="2C3E50"/>
-                </a:solidFill>
-              </a:rPr>
-              <a:t>Kollisionsfreie Annotations</a:t>
-            </a:r>
-          </a:p>
-        </p:txBody>
-      </p:sp>
-      <p:sp>
-        <p:nvSpPr>
-          <p:cNvPr id="31" name="TextBox 30"/>
-          <p:cNvSpPr txBox="1"/>
-          <p:nvPr/>
-        </p:nvSpPr>
-        <p:spPr>
-          <a:xfrm>
-            <a:off x="3364992" y="4654295"/>
-            <a:ext cx="8412480" cy="603503"/>
-          </a:xfrm>
-          <a:prstGeom prst="rect">
-            <a:avLst/>
-          </a:prstGeom>
-          <a:noFill/>
-        </p:spPr>
-        <p:txBody>
-          <a:bodyPr wrap="square">
-            <a:spAutoFit/>
-          </a:bodyPr>
-          <a:lstStyle/>
-          <a:p>
-            <a:pPr algn="l"/>
-            <a:r>
-              <a:rPr sz="900" b="0">
-                <a:solidFill>
-                  <a:srgbClr val="2C3E50"/>
-                </a:solidFill>
-              </a:rPr>
-              <a:t>Referenzlinien-Labels weichen automatisch aus wenn sie sich überlappen</a:t>
-            </a:r>
-          </a:p>
-        </p:txBody>
-      </p:sp>
-      <p:sp>
-        <p:nvSpPr>
-          <p:cNvPr id="32" name="Rectangle 31"/>
-          <p:cNvSpPr/>
-          <p:nvPr/>
-        </p:nvSpPr>
-        <p:spPr>
-          <a:xfrm>
-            <a:off x="274320" y="5276087"/>
-            <a:ext cx="2926080" cy="658368"/>
-          </a:xfrm>
-          <a:prstGeom prst="rect">
-            <a:avLst/>
-          </a:prstGeom>
-          <a:solidFill>
-            <a:srgbClr val="ECF0F1"/>
-          </a:solidFill>
-          <a:ln>
-            <a:noFill/>
-          </a:ln>
-        </p:spPr>
-        <p:style>
-          <a:lnRef idx="1">
-            <a:schemeClr val="accent1"/>
-          </a:lnRef>
-          <a:fillRef idx="3">
-            <a:schemeClr val="accent1"/>
-          </a:fillRef>
-          <a:effectRef idx="2">
-            <a:schemeClr val="accent1"/>
-          </a:effectRef>
-          <a:fontRef idx="minor">
-            <a:schemeClr val="lt1"/>
-          </a:fontRef>
-        </p:style>
-        <p:txBody>
-          <a:bodyPr rtlCol="0" anchor="ctr"/>
-          <a:lstStyle/>
-          <a:p>
-            <a:pPr algn="ctr"/>
-          </a:p>
-        </p:txBody>
-      </p:sp>
-      <p:sp>
-        <p:nvSpPr>
-          <p:cNvPr id="33" name="Rectangle 32"/>
-          <p:cNvSpPr/>
-          <p:nvPr/>
-        </p:nvSpPr>
-        <p:spPr>
-          <a:xfrm>
-            <a:off x="3291840" y="5276087"/>
-            <a:ext cx="8595360" cy="658368"/>
-          </a:xfrm>
-          <a:prstGeom prst="rect">
-            <a:avLst/>
-          </a:prstGeom>
-          <a:solidFill>
-            <a:srgbClr val="ECF0F1"/>
-          </a:solidFill>
-          <a:ln>
-            <a:noFill/>
-          </a:ln>
-        </p:spPr>
-        <p:style>
-          <a:lnRef idx="1">
-            <a:schemeClr val="accent1"/>
-          </a:lnRef>
-          <a:fillRef idx="3">
-            <a:schemeClr val="accent1"/>
-          </a:fillRef>
-          <a:effectRef idx="2">
-            <a:schemeClr val="accent1"/>
-          </a:effectRef>
-          <a:fontRef idx="minor">
-            <a:schemeClr val="lt1"/>
-          </a:fontRef>
-        </p:style>
-        <p:txBody>
-          <a:bodyPr rtlCol="0" anchor="ctr"/>
-          <a:lstStyle/>
-          <a:p>
-            <a:pPr algn="ctr"/>
-          </a:p>
-        </p:txBody>
-      </p:sp>
-      <p:sp>
-        <p:nvSpPr>
-          <p:cNvPr id="34" name="TextBox 33"/>
-          <p:cNvSpPr txBox="1"/>
-          <p:nvPr/>
-        </p:nvSpPr>
-        <p:spPr>
-          <a:xfrm>
-            <a:off x="347472" y="5312663"/>
-            <a:ext cx="2788920" cy="603503"/>
-          </a:xfrm>
-          <a:prstGeom prst="rect">
-            <a:avLst/>
-          </a:prstGeom>
-          <a:noFill/>
-        </p:spPr>
-        <p:txBody>
-          <a:bodyPr wrap="square">
-            <a:spAutoFit/>
-          </a:bodyPr>
-          <a:lstStyle/>
-          <a:p>
-            <a:pPr algn="l"/>
-            <a:r>
-              <a:rPr sz="900" b="1">
-                <a:solidFill>
-                  <a:srgbClr val="2C3E50"/>
-                </a:solidFill>
-              </a:rPr>
-              <a:t>Doppelklick-Starter</a:t>
-            </a:r>
-          </a:p>
-        </p:txBody>
-      </p:sp>
-      <p:sp>
-        <p:nvSpPr>
-          <p:cNvPr id="35" name="TextBox 34"/>
-          <p:cNvSpPr txBox="1"/>
-          <p:nvPr/>
-        </p:nvSpPr>
-        <p:spPr>
-          <a:xfrm>
-            <a:off x="3364992" y="5312663"/>
-            <a:ext cx="8412480" cy="603503"/>
-          </a:xfrm>
-          <a:prstGeom prst="rect">
-            <a:avLst/>
-          </a:prstGeom>
-          <a:noFill/>
-        </p:spPr>
-        <p:txBody>
-          <a:bodyPr wrap="square">
-            <a:spAutoFit/>
-          </a:bodyPr>
-          <a:lstStyle/>
-          <a:p>
-            <a:pPr algn="l"/>
-            <a:r>
-              <a:rPr sz="900" b="0">
-                <a:solidFill>
-                  <a:srgbClr val="2C3E50"/>
-                </a:solidFill>
-              </a:rPr>
-              <a:t>build_reports_gui.pyw startet die GUI ohne Konsolenfenster</a:t>
-            </a:r>
-          </a:p>
-        </p:txBody>
-      </p:sp>
-      <p:sp>
-        <p:nvSpPr>
-          <p:cNvPr id="36" name="Rectangle 35"/>
           <p:cNvSpPr/>
           <p:nvPr/>
         </p:nvSpPr>
@@ -9452,7 +9299,7 @@
                   <a:srgbClr val="FFFFFF"/>
                 </a:solidFill>
               </a:rPr>
-              <a:t>Infrastruktur &amp; Dokumentation</a:t>
+              <a:t>build_reports — GUI &amp; UX</a:t>
             </a:r>
           </a:p>
         </p:txBody>
@@ -9726,7 +9573,7 @@
                   <a:srgbClr val="2C3E50"/>
                 </a:solidFill>
               </a:rPr>
-              <a:t>Versionierung</a:t>
+              <a:t>Terminologie</a:t>
             </a:r>
           </a:p>
         </p:txBody>
@@ -9760,7 +9607,7 @@
                   <a:srgbClr val="2C3E50"/>
                 </a:solidFill>
               </a:rPr>
-              <a:t>SemVer ab v0.2.0; zentrale version.py wird von beiden GUIs und den Manuals gelesen</a:t>
+              <a:t>Umschaltung SAFe ↔ Global (Flow Time ↔ Cycle Time etc.)</a:t>
             </a:r>
           </a:p>
         </p:txBody>
@@ -9880,7 +9727,7 @@
                   <a:srgbClr val="2C3E50"/>
                 </a:solidFill>
               </a:rPr>
-              <a:t>Sprachauswahl</a:t>
+              <a:t>Templates</a:t>
             </a:r>
           </a:p>
         </p:txBody>
@@ -9914,7 +9761,7 @@
                   <a:srgbClr val="2C3E50"/>
                 </a:solidFill>
               </a:rPr>
-              <a:t>DE/EN in beiden GUIs; Flagge 🇩🇪/🇬🇧 ganz rechts im Menüband; letzte Wahl wird in ~/.situation_report/prefs.json gespeichert</a:t>
+              <a:t>Alle Einstellungen als JSON speichern/laden; Ausschlüsse als dauerhafter Standard speicherbar; Menü-Dialog zuverlässig auf allen Windows-Displays dank parent=self und Hover-Scroll-Binding</a:t>
             </a:r>
           </a:p>
         </p:txBody>
@@ -10034,7 +9881,7 @@
                   <a:srgbClr val="2C3E50"/>
                 </a:solidFill>
               </a:rPr>
-              <a:t>PDF-Manuals</a:t>
+              <a:t>Tooltips</a:t>
             </a:r>
           </a:p>
         </p:txBody>
@@ -10068,7 +9915,7 @@
                   <a:srgbClr val="2C3E50"/>
                 </a:solidFill>
               </a:rPr>
-              <a:t>Benutzerhandbuch (DE) + User Manual (EN) für build_reports und transform_data; generiert mit ReportLab inkl. echter Beispieldiagramme</a:t>
+              <a:t>Hover-Tooltips auf allen GUI-Elementen</a:t>
             </a:r>
           </a:p>
         </p:txBody>
@@ -10188,7 +10035,7 @@
                   <a:srgbClr val="2C3E50"/>
                 </a:solidFill>
               </a:rPr>
-              <a:t>Manual-Link in GUI</a:t>
+              <a:t>Ladebalken</a:t>
             </a:r>
           </a:p>
         </p:txBody>
@@ -10222,7 +10069,7 @@
                   <a:srgbClr val="2C3E50"/>
                 </a:solidFill>
               </a:rPr>
-              <a:t>Hilfe-Menü öffnet das sprachpassende PDF direkt auf GitHub Pages</a:t>
+              <a:t>Erscheint nach 3 Sekunden bei laufenden Berechnungen</a:t>
             </a:r>
           </a:p>
         </p:txBody>
@@ -10342,7 +10189,7 @@
                   <a:srgbClr val="2C3E50"/>
                 </a:solidFill>
               </a:rPr>
-              <a:t>GitHub Pages Doku</a:t>
+              <a:t>Stage-Konsistenzprüfung</a:t>
             </a:r>
           </a:p>
         </p:txBody>
@@ -10376,7 +10223,7 @@
                   <a:srgbClr val="2C3E50"/>
                 </a:solidFill>
               </a:rPr>
-              <a:t>MkDocs-Site mit DE/EN-Doku für alle Module; Architektur nach C4-Modell</a:t>
+              <a:t>Warnung wenn IssueTimes und CFD unterschiedliche Stages haben</a:t>
             </a:r>
           </a:p>
         </p:txBody>
@@ -10496,7 +10343,7 @@
                   <a:srgbClr val="2C3E50"/>
                 </a:solidFill>
               </a:rPr>
-              <a:t>CI/CD</a:t>
+              <a:t>Kollisionsfreie Annotations</a:t>
             </a:r>
           </a:p>
         </p:txBody>
@@ -10530,7 +10377,7 @@
                   <a:srgbClr val="2C3E50"/>
                 </a:solidFill>
               </a:rPr>
-              <a:t>GitHub Actions für automatisches Docs-Deployment</a:t>
+              <a:t>Referenzlinien-Labels weichen automatisch aus wenn sie sich überlappen</a:t>
             </a:r>
           </a:p>
         </p:txBody>
@@ -10650,7 +10497,7 @@
                   <a:srgbClr val="2C3E50"/>
                 </a:solidFill>
               </a:rPr>
-              <a:t>Tests</a:t>
+              <a:t>Doppelklick-Starter</a:t>
             </a:r>
           </a:p>
         </p:txBody>
@@ -10684,7 +10531,1531 @@
                   <a:srgbClr val="2C3E50"/>
                 </a:solidFill>
               </a:rPr>
-              <a:t>Unit- und Acceptance-Tests für beide Module; aktuell 448 Tests</a:t>
+              <a:t>build_reports_gui.pyw startet die GUI ohne Konsolenfenster</a:t>
+            </a:r>
+          </a:p>
+        </p:txBody>
+      </p:sp>
+      <p:sp>
+        <p:nvSpPr>
+          <p:cNvPr id="36" name="Rectangle 35"/>
+          <p:cNvSpPr/>
+          <p:nvPr/>
+        </p:nvSpPr>
+        <p:spPr>
+          <a:xfrm>
+            <a:off x="274320" y="5934455"/>
+            <a:ext cx="2926080" cy="658368"/>
+          </a:xfrm>
+          <a:prstGeom prst="rect">
+            <a:avLst/>
+          </a:prstGeom>
+          <a:solidFill>
+            <a:srgbClr val="FFFFFF"/>
+          </a:solidFill>
+          <a:ln>
+            <a:noFill/>
+          </a:ln>
+        </p:spPr>
+        <p:style>
+          <a:lnRef idx="1">
+            <a:schemeClr val="accent1"/>
+          </a:lnRef>
+          <a:fillRef idx="3">
+            <a:schemeClr val="accent1"/>
+          </a:fillRef>
+          <a:effectRef idx="2">
+            <a:schemeClr val="accent1"/>
+          </a:effectRef>
+          <a:fontRef idx="minor">
+            <a:schemeClr val="lt1"/>
+          </a:fontRef>
+        </p:style>
+        <p:txBody>
+          <a:bodyPr rtlCol="0" anchor="ctr"/>
+          <a:lstStyle/>
+          <a:p>
+            <a:pPr algn="ctr"/>
+          </a:p>
+        </p:txBody>
+      </p:sp>
+      <p:sp>
+        <p:nvSpPr>
+          <p:cNvPr id="37" name="Rectangle 36"/>
+          <p:cNvSpPr/>
+          <p:nvPr/>
+        </p:nvSpPr>
+        <p:spPr>
+          <a:xfrm>
+            <a:off x="3291840" y="5934455"/>
+            <a:ext cx="8595360" cy="658368"/>
+          </a:xfrm>
+          <a:prstGeom prst="rect">
+            <a:avLst/>
+          </a:prstGeom>
+          <a:solidFill>
+            <a:srgbClr val="FFFFFF"/>
+          </a:solidFill>
+          <a:ln>
+            <a:noFill/>
+          </a:ln>
+        </p:spPr>
+        <p:style>
+          <a:lnRef idx="1">
+            <a:schemeClr val="accent1"/>
+          </a:lnRef>
+          <a:fillRef idx="3">
+            <a:schemeClr val="accent1"/>
+          </a:fillRef>
+          <a:effectRef idx="2">
+            <a:schemeClr val="accent1"/>
+          </a:effectRef>
+          <a:fontRef idx="minor">
+            <a:schemeClr val="lt1"/>
+          </a:fontRef>
+        </p:style>
+        <p:txBody>
+          <a:bodyPr rtlCol="0" anchor="ctr"/>
+          <a:lstStyle/>
+          <a:p>
+            <a:pPr algn="ctr"/>
+          </a:p>
+        </p:txBody>
+      </p:sp>
+      <p:sp>
+        <p:nvSpPr>
+          <p:cNvPr id="38" name="TextBox 37"/>
+          <p:cNvSpPr txBox="1"/>
+          <p:nvPr/>
+        </p:nvSpPr>
+        <p:spPr>
+          <a:xfrm>
+            <a:off x="347472" y="5971031"/>
+            <a:ext cx="2788920" cy="603503"/>
+          </a:xfrm>
+          <a:prstGeom prst="rect">
+            <a:avLst/>
+          </a:prstGeom>
+          <a:noFill/>
+        </p:spPr>
+        <p:txBody>
+          <a:bodyPr wrap="square">
+            <a:spAutoFit/>
+          </a:bodyPr>
+          <a:lstStyle/>
+          <a:p>
+            <a:pPr algn="l"/>
+            <a:r>
+              <a:rPr sz="900" b="1">
+                <a:solidFill>
+                  <a:srgbClr val="2C3E50"/>
+                </a:solidFill>
+              </a:rPr>
+              <a:t>Scrollbare Form</a:t>
+            </a:r>
+          </a:p>
+        </p:txBody>
+      </p:sp>
+      <p:sp>
+        <p:nvSpPr>
+          <p:cNvPr id="39" name="TextBox 38"/>
+          <p:cNvSpPr txBox="1"/>
+          <p:nvPr/>
+        </p:nvSpPr>
+        <p:spPr>
+          <a:xfrm>
+            <a:off x="3364992" y="5971031"/>
+            <a:ext cx="8412480" cy="603503"/>
+          </a:xfrm>
+          <a:prstGeom prst="rect">
+            <a:avLst/>
+          </a:prstGeom>
+          <a:noFill/>
+        </p:spPr>
+        <p:txBody>
+          <a:bodyPr wrap="square">
+            <a:spAutoFit/>
+          </a:bodyPr>
+          <a:lstStyle/>
+          <a:p>
+            <a:pPr algn="l"/>
+            <a:r>
+              <a:rPr sz="900" b="0">
+                <a:solidFill>
+                  <a:srgbClr val="2C3E50"/>
+                </a:solidFill>
+              </a:rPr>
+              <a:t>Formbereich in Canvas gewrappt — vollständig scrollbar auf FullHD-Displays (1080p); Log-Bereich fest am unteren Rand</a:t>
+            </a:r>
+          </a:p>
+        </p:txBody>
+      </p:sp>
+      <p:sp>
+        <p:nvSpPr>
+          <p:cNvPr id="40" name="Rectangle 39"/>
+          <p:cNvSpPr/>
+          <p:nvPr/>
+        </p:nvSpPr>
+        <p:spPr>
+          <a:xfrm>
+            <a:off x="0" y="6720840"/>
+            <a:ext cx="12188952" cy="137160"/>
+          </a:xfrm>
+          <a:prstGeom prst="rect">
+            <a:avLst/>
+          </a:prstGeom>
+          <a:solidFill>
+            <a:srgbClr val="2980B9"/>
+          </a:solidFill>
+          <a:ln>
+            <a:noFill/>
+          </a:ln>
+        </p:spPr>
+        <p:style>
+          <a:lnRef idx="1">
+            <a:schemeClr val="accent1"/>
+          </a:lnRef>
+          <a:fillRef idx="3">
+            <a:schemeClr val="accent1"/>
+          </a:fillRef>
+          <a:effectRef idx="2">
+            <a:schemeClr val="accent1"/>
+          </a:effectRef>
+          <a:fontRef idx="minor">
+            <a:schemeClr val="lt1"/>
+          </a:fontRef>
+        </p:style>
+        <p:txBody>
+          <a:bodyPr rtlCol="0" anchor="ctr"/>
+          <a:lstStyle/>
+          <a:p>
+            <a:pPr algn="ctr"/>
+          </a:p>
+        </p:txBody>
+      </p:sp>
+    </p:spTree>
+  </p:cSld>
+  <p:clrMapOvr>
+    <a:masterClrMapping/>
+  </p:clrMapOvr>
+</p:sld>
+</file>
+
+<file path=ppt/slides/slide8.xml><?xml version="1.0" encoding="utf-8"?>
+<p:sld xmlns:a="http://schemas.openxmlformats.org/drawingml/2006/main" xmlns:p="http://schemas.openxmlformats.org/presentationml/2006/main" xmlns:r="http://schemas.openxmlformats.org/officeDocument/2006/relationships">
+  <p:cSld>
+    <p:spTree>
+      <p:nvGrpSpPr>
+        <p:cNvPr id="1" name=""/>
+        <p:cNvGrpSpPr/>
+        <p:nvPr/>
+      </p:nvGrpSpPr>
+      <p:grpSpPr/>
+      <p:sp>
+        <p:nvSpPr>
+          <p:cNvPr id="2" name="Rectangle 1"/>
+          <p:cNvSpPr/>
+          <p:nvPr/>
+        </p:nvSpPr>
+        <p:spPr>
+          <a:xfrm>
+            <a:off x="0" y="0"/>
+            <a:ext cx="12188952" cy="822960"/>
+          </a:xfrm>
+          <a:prstGeom prst="rect">
+            <a:avLst/>
+          </a:prstGeom>
+          <a:solidFill>
+            <a:srgbClr val="2C3E50"/>
+          </a:solidFill>
+          <a:ln>
+            <a:noFill/>
+          </a:ln>
+        </p:spPr>
+        <p:style>
+          <a:lnRef idx="1">
+            <a:schemeClr val="accent1"/>
+          </a:lnRef>
+          <a:fillRef idx="3">
+            <a:schemeClr val="accent1"/>
+          </a:fillRef>
+          <a:effectRef idx="2">
+            <a:schemeClr val="accent1"/>
+          </a:effectRef>
+          <a:fontRef idx="minor">
+            <a:schemeClr val="lt1"/>
+          </a:fontRef>
+        </p:style>
+        <p:txBody>
+          <a:bodyPr rtlCol="0" anchor="ctr"/>
+          <a:lstStyle/>
+          <a:p>
+            <a:pPr algn="ctr"/>
+          </a:p>
+        </p:txBody>
+      </p:sp>
+      <p:sp>
+        <p:nvSpPr>
+          <p:cNvPr id="3" name="TextBox 2"/>
+          <p:cNvSpPr txBox="1"/>
+          <p:nvPr/>
+        </p:nvSpPr>
+        <p:spPr>
+          <a:xfrm>
+            <a:off x="274320" y="91440"/>
+            <a:ext cx="11612880" cy="640080"/>
+          </a:xfrm>
+          <a:prstGeom prst="rect">
+            <a:avLst/>
+          </a:prstGeom>
+          <a:noFill/>
+        </p:spPr>
+        <p:txBody>
+          <a:bodyPr wrap="square">
+            <a:spAutoFit/>
+          </a:bodyPr>
+          <a:lstStyle/>
+          <a:p>
+            <a:pPr algn="l"/>
+            <a:r>
+              <a:rPr sz="2200" b="1">
+                <a:solidFill>
+                  <a:srgbClr val="FFFFFF"/>
+                </a:solidFill>
+              </a:rPr>
+              <a:t>Infrastruktur &amp; Dokumentation</a:t>
+            </a:r>
+          </a:p>
+        </p:txBody>
+      </p:sp>
+      <p:sp>
+        <p:nvSpPr>
+          <p:cNvPr id="4" name="Rectangle 3"/>
+          <p:cNvSpPr/>
+          <p:nvPr/>
+        </p:nvSpPr>
+        <p:spPr>
+          <a:xfrm>
+            <a:off x="274320" y="914400"/>
+            <a:ext cx="2926080" cy="320040"/>
+          </a:xfrm>
+          <a:prstGeom prst="rect">
+            <a:avLst/>
+          </a:prstGeom>
+          <a:solidFill>
+            <a:srgbClr val="2980B9"/>
+          </a:solidFill>
+          <a:ln>
+            <a:noFill/>
+          </a:ln>
+        </p:spPr>
+        <p:style>
+          <a:lnRef idx="1">
+            <a:schemeClr val="accent1"/>
+          </a:lnRef>
+          <a:fillRef idx="3">
+            <a:schemeClr val="accent1"/>
+          </a:fillRef>
+          <a:effectRef idx="2">
+            <a:schemeClr val="accent1"/>
+          </a:effectRef>
+          <a:fontRef idx="minor">
+            <a:schemeClr val="lt1"/>
+          </a:fontRef>
+        </p:style>
+        <p:txBody>
+          <a:bodyPr rtlCol="0" anchor="ctr"/>
+          <a:lstStyle/>
+          <a:p>
+            <a:pPr algn="ctr"/>
+          </a:p>
+        </p:txBody>
+      </p:sp>
+      <p:sp>
+        <p:nvSpPr>
+          <p:cNvPr id="5" name="Rectangle 4"/>
+          <p:cNvSpPr/>
+          <p:nvPr/>
+        </p:nvSpPr>
+        <p:spPr>
+          <a:xfrm>
+            <a:off x="3291840" y="914400"/>
+            <a:ext cx="8595360" cy="320040"/>
+          </a:xfrm>
+          <a:prstGeom prst="rect">
+            <a:avLst/>
+          </a:prstGeom>
+          <a:solidFill>
+            <a:srgbClr val="2980B9"/>
+          </a:solidFill>
+          <a:ln>
+            <a:noFill/>
+          </a:ln>
+        </p:spPr>
+        <p:style>
+          <a:lnRef idx="1">
+            <a:schemeClr val="accent1"/>
+          </a:lnRef>
+          <a:fillRef idx="3">
+            <a:schemeClr val="accent1"/>
+          </a:fillRef>
+          <a:effectRef idx="2">
+            <a:schemeClr val="accent1"/>
+          </a:effectRef>
+          <a:fontRef idx="minor">
+            <a:schemeClr val="lt1"/>
+          </a:fontRef>
+        </p:style>
+        <p:txBody>
+          <a:bodyPr rtlCol="0" anchor="ctr"/>
+          <a:lstStyle/>
+          <a:p>
+            <a:pPr algn="ctr"/>
+          </a:p>
+        </p:txBody>
+      </p:sp>
+      <p:sp>
+        <p:nvSpPr>
+          <p:cNvPr id="6" name="TextBox 5"/>
+          <p:cNvSpPr txBox="1"/>
+          <p:nvPr/>
+        </p:nvSpPr>
+        <p:spPr>
+          <a:xfrm>
+            <a:off x="320040" y="932688"/>
+            <a:ext cx="2834640" cy="274320"/>
+          </a:xfrm>
+          <a:prstGeom prst="rect">
+            <a:avLst/>
+          </a:prstGeom>
+          <a:noFill/>
+        </p:spPr>
+        <p:txBody>
+          <a:bodyPr wrap="square">
+            <a:spAutoFit/>
+          </a:bodyPr>
+          <a:lstStyle/>
+          <a:p>
+            <a:pPr algn="l"/>
+            <a:r>
+              <a:rPr sz="900" b="1">
+                <a:solidFill>
+                  <a:srgbClr val="FFFFFF"/>
+                </a:solidFill>
+              </a:rPr>
+              <a:t>Feature</a:t>
+            </a:r>
+          </a:p>
+        </p:txBody>
+      </p:sp>
+      <p:sp>
+        <p:nvSpPr>
+          <p:cNvPr id="7" name="TextBox 6"/>
+          <p:cNvSpPr txBox="1"/>
+          <p:nvPr/>
+        </p:nvSpPr>
+        <p:spPr>
+          <a:xfrm>
+            <a:off x="3337560" y="932688"/>
+            <a:ext cx="8503920" cy="274320"/>
+          </a:xfrm>
+          <a:prstGeom prst="rect">
+            <a:avLst/>
+          </a:prstGeom>
+          <a:noFill/>
+        </p:spPr>
+        <p:txBody>
+          <a:bodyPr wrap="square">
+            <a:spAutoFit/>
+          </a:bodyPr>
+          <a:lstStyle/>
+          <a:p>
+            <a:pPr algn="l"/>
+            <a:r>
+              <a:rPr sz="900" b="1">
+                <a:solidFill>
+                  <a:srgbClr val="FFFFFF"/>
+                </a:solidFill>
+              </a:rPr>
+              <a:t>Beschreibung</a:t>
+            </a:r>
+          </a:p>
+        </p:txBody>
+      </p:sp>
+      <p:sp>
+        <p:nvSpPr>
+          <p:cNvPr id="8" name="Rectangle 7"/>
+          <p:cNvSpPr/>
+          <p:nvPr/>
+        </p:nvSpPr>
+        <p:spPr>
+          <a:xfrm>
+            <a:off x="274320" y="1325880"/>
+            <a:ext cx="2926080" cy="658368"/>
+          </a:xfrm>
+          <a:prstGeom prst="rect">
+            <a:avLst/>
+          </a:prstGeom>
+          <a:solidFill>
+            <a:srgbClr val="ECF0F1"/>
+          </a:solidFill>
+          <a:ln>
+            <a:noFill/>
+          </a:ln>
+        </p:spPr>
+        <p:style>
+          <a:lnRef idx="1">
+            <a:schemeClr val="accent1"/>
+          </a:lnRef>
+          <a:fillRef idx="3">
+            <a:schemeClr val="accent1"/>
+          </a:fillRef>
+          <a:effectRef idx="2">
+            <a:schemeClr val="accent1"/>
+          </a:effectRef>
+          <a:fontRef idx="minor">
+            <a:schemeClr val="lt1"/>
+          </a:fontRef>
+        </p:style>
+        <p:txBody>
+          <a:bodyPr rtlCol="0" anchor="ctr"/>
+          <a:lstStyle/>
+          <a:p>
+            <a:pPr algn="ctr"/>
+          </a:p>
+        </p:txBody>
+      </p:sp>
+      <p:sp>
+        <p:nvSpPr>
+          <p:cNvPr id="9" name="Rectangle 8"/>
+          <p:cNvSpPr/>
+          <p:nvPr/>
+        </p:nvSpPr>
+        <p:spPr>
+          <a:xfrm>
+            <a:off x="3291840" y="1325880"/>
+            <a:ext cx="8595360" cy="658368"/>
+          </a:xfrm>
+          <a:prstGeom prst="rect">
+            <a:avLst/>
+          </a:prstGeom>
+          <a:solidFill>
+            <a:srgbClr val="ECF0F1"/>
+          </a:solidFill>
+          <a:ln>
+            <a:noFill/>
+          </a:ln>
+        </p:spPr>
+        <p:style>
+          <a:lnRef idx="1">
+            <a:schemeClr val="accent1"/>
+          </a:lnRef>
+          <a:fillRef idx="3">
+            <a:schemeClr val="accent1"/>
+          </a:fillRef>
+          <a:effectRef idx="2">
+            <a:schemeClr val="accent1"/>
+          </a:effectRef>
+          <a:fontRef idx="minor">
+            <a:schemeClr val="lt1"/>
+          </a:fontRef>
+        </p:style>
+        <p:txBody>
+          <a:bodyPr rtlCol="0" anchor="ctr"/>
+          <a:lstStyle/>
+          <a:p>
+            <a:pPr algn="ctr"/>
+          </a:p>
+        </p:txBody>
+      </p:sp>
+      <p:sp>
+        <p:nvSpPr>
+          <p:cNvPr id="10" name="TextBox 9"/>
+          <p:cNvSpPr txBox="1"/>
+          <p:nvPr/>
+        </p:nvSpPr>
+        <p:spPr>
+          <a:xfrm>
+            <a:off x="347472" y="1362456"/>
+            <a:ext cx="2788920" cy="603503"/>
+          </a:xfrm>
+          <a:prstGeom prst="rect">
+            <a:avLst/>
+          </a:prstGeom>
+          <a:noFill/>
+        </p:spPr>
+        <p:txBody>
+          <a:bodyPr wrap="square">
+            <a:spAutoFit/>
+          </a:bodyPr>
+          <a:lstStyle/>
+          <a:p>
+            <a:pPr algn="l"/>
+            <a:r>
+              <a:rPr sz="900" b="1">
+                <a:solidFill>
+                  <a:srgbClr val="2C3E50"/>
+                </a:solidFill>
+              </a:rPr>
+              <a:t>Versionierung</a:t>
+            </a:r>
+          </a:p>
+        </p:txBody>
+      </p:sp>
+      <p:sp>
+        <p:nvSpPr>
+          <p:cNvPr id="11" name="TextBox 10"/>
+          <p:cNvSpPr txBox="1"/>
+          <p:nvPr/>
+        </p:nvSpPr>
+        <p:spPr>
+          <a:xfrm>
+            <a:off x="3364992" y="1362456"/>
+            <a:ext cx="8412480" cy="603503"/>
+          </a:xfrm>
+          <a:prstGeom prst="rect">
+            <a:avLst/>
+          </a:prstGeom>
+          <a:noFill/>
+        </p:spPr>
+        <p:txBody>
+          <a:bodyPr wrap="square">
+            <a:spAutoFit/>
+          </a:bodyPr>
+          <a:lstStyle/>
+          <a:p>
+            <a:pPr algn="l"/>
+            <a:r>
+              <a:rPr sz="900" b="0">
+                <a:solidFill>
+                  <a:srgbClr val="2C3E50"/>
+                </a:solidFill>
+              </a:rPr>
+              <a:t>SemVer ab v0.2.0; zentrale version.py wird von allen GUIs und den Manuals gelesen; aktuell v0.8.4</a:t>
+            </a:r>
+          </a:p>
+        </p:txBody>
+      </p:sp>
+      <p:sp>
+        <p:nvSpPr>
+          <p:cNvPr id="12" name="Rectangle 11"/>
+          <p:cNvSpPr/>
+          <p:nvPr/>
+        </p:nvSpPr>
+        <p:spPr>
+          <a:xfrm>
+            <a:off x="274320" y="1984248"/>
+            <a:ext cx="2926080" cy="658368"/>
+          </a:xfrm>
+          <a:prstGeom prst="rect">
+            <a:avLst/>
+          </a:prstGeom>
+          <a:solidFill>
+            <a:srgbClr val="FFFFFF"/>
+          </a:solidFill>
+          <a:ln>
+            <a:noFill/>
+          </a:ln>
+        </p:spPr>
+        <p:style>
+          <a:lnRef idx="1">
+            <a:schemeClr val="accent1"/>
+          </a:lnRef>
+          <a:fillRef idx="3">
+            <a:schemeClr val="accent1"/>
+          </a:fillRef>
+          <a:effectRef idx="2">
+            <a:schemeClr val="accent1"/>
+          </a:effectRef>
+          <a:fontRef idx="minor">
+            <a:schemeClr val="lt1"/>
+          </a:fontRef>
+        </p:style>
+        <p:txBody>
+          <a:bodyPr rtlCol="0" anchor="ctr"/>
+          <a:lstStyle/>
+          <a:p>
+            <a:pPr algn="ctr"/>
+          </a:p>
+        </p:txBody>
+      </p:sp>
+      <p:sp>
+        <p:nvSpPr>
+          <p:cNvPr id="13" name="Rectangle 12"/>
+          <p:cNvSpPr/>
+          <p:nvPr/>
+        </p:nvSpPr>
+        <p:spPr>
+          <a:xfrm>
+            <a:off x="3291840" y="1984248"/>
+            <a:ext cx="8595360" cy="658368"/>
+          </a:xfrm>
+          <a:prstGeom prst="rect">
+            <a:avLst/>
+          </a:prstGeom>
+          <a:solidFill>
+            <a:srgbClr val="FFFFFF"/>
+          </a:solidFill>
+          <a:ln>
+            <a:noFill/>
+          </a:ln>
+        </p:spPr>
+        <p:style>
+          <a:lnRef idx="1">
+            <a:schemeClr val="accent1"/>
+          </a:lnRef>
+          <a:fillRef idx="3">
+            <a:schemeClr val="accent1"/>
+          </a:fillRef>
+          <a:effectRef idx="2">
+            <a:schemeClr val="accent1"/>
+          </a:effectRef>
+          <a:fontRef idx="minor">
+            <a:schemeClr val="lt1"/>
+          </a:fontRef>
+        </p:style>
+        <p:txBody>
+          <a:bodyPr rtlCol="0" anchor="ctr"/>
+          <a:lstStyle/>
+          <a:p>
+            <a:pPr algn="ctr"/>
+          </a:p>
+        </p:txBody>
+      </p:sp>
+      <p:sp>
+        <p:nvSpPr>
+          <p:cNvPr id="14" name="TextBox 13"/>
+          <p:cNvSpPr txBox="1"/>
+          <p:nvPr/>
+        </p:nvSpPr>
+        <p:spPr>
+          <a:xfrm>
+            <a:off x="347472" y="2020824"/>
+            <a:ext cx="2788920" cy="603503"/>
+          </a:xfrm>
+          <a:prstGeom prst="rect">
+            <a:avLst/>
+          </a:prstGeom>
+          <a:noFill/>
+        </p:spPr>
+        <p:txBody>
+          <a:bodyPr wrap="square">
+            <a:spAutoFit/>
+          </a:bodyPr>
+          <a:lstStyle/>
+          <a:p>
+            <a:pPr algn="l"/>
+            <a:r>
+              <a:rPr sz="900" b="1">
+                <a:solidFill>
+                  <a:srgbClr val="2C3E50"/>
+                </a:solidFill>
+              </a:rPr>
+              <a:t>Sprachauswahl</a:t>
+            </a:r>
+          </a:p>
+        </p:txBody>
+      </p:sp>
+      <p:sp>
+        <p:nvSpPr>
+          <p:cNvPr id="15" name="TextBox 14"/>
+          <p:cNvSpPr txBox="1"/>
+          <p:nvPr/>
+        </p:nvSpPr>
+        <p:spPr>
+          <a:xfrm>
+            <a:off x="3364992" y="2020824"/>
+            <a:ext cx="8412480" cy="603503"/>
+          </a:xfrm>
+          <a:prstGeom prst="rect">
+            <a:avLst/>
+          </a:prstGeom>
+          <a:noFill/>
+        </p:spPr>
+        <p:txBody>
+          <a:bodyPr wrap="square">
+            <a:spAutoFit/>
+          </a:bodyPr>
+          <a:lstStyle/>
+          <a:p>
+            <a:pPr algn="l"/>
+            <a:r>
+              <a:rPr sz="900" b="0">
+                <a:solidFill>
+                  <a:srgbClr val="2C3E50"/>
+                </a:solidFill>
+              </a:rPr>
+              <a:t>Launcher: DE/EN/RO/PT/FR (5 Sprachen); build_reports und transform_data: DE/EN; letzte Wahl persistent in ~/.situation_report/prefs.json</a:t>
+            </a:r>
+          </a:p>
+        </p:txBody>
+      </p:sp>
+      <p:sp>
+        <p:nvSpPr>
+          <p:cNvPr id="16" name="Rectangle 15"/>
+          <p:cNvSpPr/>
+          <p:nvPr/>
+        </p:nvSpPr>
+        <p:spPr>
+          <a:xfrm>
+            <a:off x="274320" y="2642615"/>
+            <a:ext cx="2926080" cy="658368"/>
+          </a:xfrm>
+          <a:prstGeom prst="rect">
+            <a:avLst/>
+          </a:prstGeom>
+          <a:solidFill>
+            <a:srgbClr val="ECF0F1"/>
+          </a:solidFill>
+          <a:ln>
+            <a:noFill/>
+          </a:ln>
+        </p:spPr>
+        <p:style>
+          <a:lnRef idx="1">
+            <a:schemeClr val="accent1"/>
+          </a:lnRef>
+          <a:fillRef idx="3">
+            <a:schemeClr val="accent1"/>
+          </a:fillRef>
+          <a:effectRef idx="2">
+            <a:schemeClr val="accent1"/>
+          </a:effectRef>
+          <a:fontRef idx="minor">
+            <a:schemeClr val="lt1"/>
+          </a:fontRef>
+        </p:style>
+        <p:txBody>
+          <a:bodyPr rtlCol="0" anchor="ctr"/>
+          <a:lstStyle/>
+          <a:p>
+            <a:pPr algn="ctr"/>
+          </a:p>
+        </p:txBody>
+      </p:sp>
+      <p:sp>
+        <p:nvSpPr>
+          <p:cNvPr id="17" name="Rectangle 16"/>
+          <p:cNvSpPr/>
+          <p:nvPr/>
+        </p:nvSpPr>
+        <p:spPr>
+          <a:xfrm>
+            <a:off x="3291840" y="2642615"/>
+            <a:ext cx="8595360" cy="658368"/>
+          </a:xfrm>
+          <a:prstGeom prst="rect">
+            <a:avLst/>
+          </a:prstGeom>
+          <a:solidFill>
+            <a:srgbClr val="ECF0F1"/>
+          </a:solidFill>
+          <a:ln>
+            <a:noFill/>
+          </a:ln>
+        </p:spPr>
+        <p:style>
+          <a:lnRef idx="1">
+            <a:schemeClr val="accent1"/>
+          </a:lnRef>
+          <a:fillRef idx="3">
+            <a:schemeClr val="accent1"/>
+          </a:fillRef>
+          <a:effectRef idx="2">
+            <a:schemeClr val="accent1"/>
+          </a:effectRef>
+          <a:fontRef idx="minor">
+            <a:schemeClr val="lt1"/>
+          </a:fontRef>
+        </p:style>
+        <p:txBody>
+          <a:bodyPr rtlCol="0" anchor="ctr"/>
+          <a:lstStyle/>
+          <a:p>
+            <a:pPr algn="ctr"/>
+          </a:p>
+        </p:txBody>
+      </p:sp>
+      <p:sp>
+        <p:nvSpPr>
+          <p:cNvPr id="18" name="TextBox 17"/>
+          <p:cNvSpPr txBox="1"/>
+          <p:nvPr/>
+        </p:nvSpPr>
+        <p:spPr>
+          <a:xfrm>
+            <a:off x="347472" y="2679191"/>
+            <a:ext cx="2788920" cy="603503"/>
+          </a:xfrm>
+          <a:prstGeom prst="rect">
+            <a:avLst/>
+          </a:prstGeom>
+          <a:noFill/>
+        </p:spPr>
+        <p:txBody>
+          <a:bodyPr wrap="square">
+            <a:spAutoFit/>
+          </a:bodyPr>
+          <a:lstStyle/>
+          <a:p>
+            <a:pPr algn="l"/>
+            <a:r>
+              <a:rPr sz="900" b="1">
+                <a:solidFill>
+                  <a:srgbClr val="2C3E50"/>
+                </a:solidFill>
+              </a:rPr>
+              <a:t>PDF-Manuals</a:t>
+            </a:r>
+          </a:p>
+        </p:txBody>
+      </p:sp>
+      <p:sp>
+        <p:nvSpPr>
+          <p:cNvPr id="19" name="TextBox 18"/>
+          <p:cNvSpPr txBox="1"/>
+          <p:nvPr/>
+        </p:nvSpPr>
+        <p:spPr>
+          <a:xfrm>
+            <a:off x="3364992" y="2679191"/>
+            <a:ext cx="8412480" cy="603503"/>
+          </a:xfrm>
+          <a:prstGeom prst="rect">
+            <a:avLst/>
+          </a:prstGeom>
+          <a:noFill/>
+        </p:spPr>
+        <p:txBody>
+          <a:bodyPr wrap="square">
+            <a:spAutoFit/>
+          </a:bodyPr>
+          <a:lstStyle/>
+          <a:p>
+            <a:pPr algn="l"/>
+            <a:r>
+              <a:rPr sz="900" b="0">
+                <a:solidFill>
+                  <a:srgbClr val="2C3E50"/>
+                </a:solidFill>
+              </a:rPr>
+              <a:t>Launcher-Handbuch in 5 Sprachen (DE, EN, RO, PT, FR); build_reports und transform_data je DE + EN; generiert mit ReportLab</a:t>
+            </a:r>
+          </a:p>
+        </p:txBody>
+      </p:sp>
+      <p:sp>
+        <p:nvSpPr>
+          <p:cNvPr id="20" name="Rectangle 19"/>
+          <p:cNvSpPr/>
+          <p:nvPr/>
+        </p:nvSpPr>
+        <p:spPr>
+          <a:xfrm>
+            <a:off x="274320" y="3300983"/>
+            <a:ext cx="2926080" cy="658368"/>
+          </a:xfrm>
+          <a:prstGeom prst="rect">
+            <a:avLst/>
+          </a:prstGeom>
+          <a:solidFill>
+            <a:srgbClr val="FFFFFF"/>
+          </a:solidFill>
+          <a:ln>
+            <a:noFill/>
+          </a:ln>
+        </p:spPr>
+        <p:style>
+          <a:lnRef idx="1">
+            <a:schemeClr val="accent1"/>
+          </a:lnRef>
+          <a:fillRef idx="3">
+            <a:schemeClr val="accent1"/>
+          </a:fillRef>
+          <a:effectRef idx="2">
+            <a:schemeClr val="accent1"/>
+          </a:effectRef>
+          <a:fontRef idx="minor">
+            <a:schemeClr val="lt1"/>
+          </a:fontRef>
+        </p:style>
+        <p:txBody>
+          <a:bodyPr rtlCol="0" anchor="ctr"/>
+          <a:lstStyle/>
+          <a:p>
+            <a:pPr algn="ctr"/>
+          </a:p>
+        </p:txBody>
+      </p:sp>
+      <p:sp>
+        <p:nvSpPr>
+          <p:cNvPr id="21" name="Rectangle 20"/>
+          <p:cNvSpPr/>
+          <p:nvPr/>
+        </p:nvSpPr>
+        <p:spPr>
+          <a:xfrm>
+            <a:off x="3291840" y="3300983"/>
+            <a:ext cx="8595360" cy="658368"/>
+          </a:xfrm>
+          <a:prstGeom prst="rect">
+            <a:avLst/>
+          </a:prstGeom>
+          <a:solidFill>
+            <a:srgbClr val="FFFFFF"/>
+          </a:solidFill>
+          <a:ln>
+            <a:noFill/>
+          </a:ln>
+        </p:spPr>
+        <p:style>
+          <a:lnRef idx="1">
+            <a:schemeClr val="accent1"/>
+          </a:lnRef>
+          <a:fillRef idx="3">
+            <a:schemeClr val="accent1"/>
+          </a:fillRef>
+          <a:effectRef idx="2">
+            <a:schemeClr val="accent1"/>
+          </a:effectRef>
+          <a:fontRef idx="minor">
+            <a:schemeClr val="lt1"/>
+          </a:fontRef>
+        </p:style>
+        <p:txBody>
+          <a:bodyPr rtlCol="0" anchor="ctr"/>
+          <a:lstStyle/>
+          <a:p>
+            <a:pPr algn="ctr"/>
+          </a:p>
+        </p:txBody>
+      </p:sp>
+      <p:sp>
+        <p:nvSpPr>
+          <p:cNvPr id="22" name="TextBox 21"/>
+          <p:cNvSpPr txBox="1"/>
+          <p:nvPr/>
+        </p:nvSpPr>
+        <p:spPr>
+          <a:xfrm>
+            <a:off x="347472" y="3337559"/>
+            <a:ext cx="2788920" cy="603503"/>
+          </a:xfrm>
+          <a:prstGeom prst="rect">
+            <a:avLst/>
+          </a:prstGeom>
+          <a:noFill/>
+        </p:spPr>
+        <p:txBody>
+          <a:bodyPr wrap="square">
+            <a:spAutoFit/>
+          </a:bodyPr>
+          <a:lstStyle/>
+          <a:p>
+            <a:pPr algn="l"/>
+            <a:r>
+              <a:rPr sz="900" b="1">
+                <a:solidFill>
+                  <a:srgbClr val="2C3E50"/>
+                </a:solidFill>
+              </a:rPr>
+              <a:t>Manual-Link in GUI</a:t>
+            </a:r>
+          </a:p>
+        </p:txBody>
+      </p:sp>
+      <p:sp>
+        <p:nvSpPr>
+          <p:cNvPr id="23" name="TextBox 22"/>
+          <p:cNvSpPr txBox="1"/>
+          <p:nvPr/>
+        </p:nvSpPr>
+        <p:spPr>
+          <a:xfrm>
+            <a:off x="3364992" y="3337559"/>
+            <a:ext cx="8412480" cy="603503"/>
+          </a:xfrm>
+          <a:prstGeom prst="rect">
+            <a:avLst/>
+          </a:prstGeom>
+          <a:noFill/>
+        </p:spPr>
+        <p:txBody>
+          <a:bodyPr wrap="square">
+            <a:spAutoFit/>
+          </a:bodyPr>
+          <a:lstStyle/>
+          <a:p>
+            <a:pPr algn="l"/>
+            <a:r>
+              <a:rPr sz="900" b="0">
+                <a:solidFill>
+                  <a:srgbClr val="2C3E50"/>
+                </a:solidFill>
+              </a:rPr>
+              <a:t>Hilfe-Menü / (?)-Button öffnet das sprachpassende PDF direkt auf GitHub Pages</a:t>
+            </a:r>
+          </a:p>
+        </p:txBody>
+      </p:sp>
+      <p:sp>
+        <p:nvSpPr>
+          <p:cNvPr id="24" name="Rectangle 23"/>
+          <p:cNvSpPr/>
+          <p:nvPr/>
+        </p:nvSpPr>
+        <p:spPr>
+          <a:xfrm>
+            <a:off x="274320" y="3959351"/>
+            <a:ext cx="2926080" cy="658368"/>
+          </a:xfrm>
+          <a:prstGeom prst="rect">
+            <a:avLst/>
+          </a:prstGeom>
+          <a:solidFill>
+            <a:srgbClr val="ECF0F1"/>
+          </a:solidFill>
+          <a:ln>
+            <a:noFill/>
+          </a:ln>
+        </p:spPr>
+        <p:style>
+          <a:lnRef idx="1">
+            <a:schemeClr val="accent1"/>
+          </a:lnRef>
+          <a:fillRef idx="3">
+            <a:schemeClr val="accent1"/>
+          </a:fillRef>
+          <a:effectRef idx="2">
+            <a:schemeClr val="accent1"/>
+          </a:effectRef>
+          <a:fontRef idx="minor">
+            <a:schemeClr val="lt1"/>
+          </a:fontRef>
+        </p:style>
+        <p:txBody>
+          <a:bodyPr rtlCol="0" anchor="ctr"/>
+          <a:lstStyle/>
+          <a:p>
+            <a:pPr algn="ctr"/>
+          </a:p>
+        </p:txBody>
+      </p:sp>
+      <p:sp>
+        <p:nvSpPr>
+          <p:cNvPr id="25" name="Rectangle 24"/>
+          <p:cNvSpPr/>
+          <p:nvPr/>
+        </p:nvSpPr>
+        <p:spPr>
+          <a:xfrm>
+            <a:off x="3291840" y="3959351"/>
+            <a:ext cx="8595360" cy="658368"/>
+          </a:xfrm>
+          <a:prstGeom prst="rect">
+            <a:avLst/>
+          </a:prstGeom>
+          <a:solidFill>
+            <a:srgbClr val="ECF0F1"/>
+          </a:solidFill>
+          <a:ln>
+            <a:noFill/>
+          </a:ln>
+        </p:spPr>
+        <p:style>
+          <a:lnRef idx="1">
+            <a:schemeClr val="accent1"/>
+          </a:lnRef>
+          <a:fillRef idx="3">
+            <a:schemeClr val="accent1"/>
+          </a:fillRef>
+          <a:effectRef idx="2">
+            <a:schemeClr val="accent1"/>
+          </a:effectRef>
+          <a:fontRef idx="minor">
+            <a:schemeClr val="lt1"/>
+          </a:fontRef>
+        </p:style>
+        <p:txBody>
+          <a:bodyPr rtlCol="0" anchor="ctr"/>
+          <a:lstStyle/>
+          <a:p>
+            <a:pPr algn="ctr"/>
+          </a:p>
+        </p:txBody>
+      </p:sp>
+      <p:sp>
+        <p:nvSpPr>
+          <p:cNvPr id="26" name="TextBox 25"/>
+          <p:cNvSpPr txBox="1"/>
+          <p:nvPr/>
+        </p:nvSpPr>
+        <p:spPr>
+          <a:xfrm>
+            <a:off x="347472" y="3995927"/>
+            <a:ext cx="2788920" cy="603503"/>
+          </a:xfrm>
+          <a:prstGeom prst="rect">
+            <a:avLst/>
+          </a:prstGeom>
+          <a:noFill/>
+        </p:spPr>
+        <p:txBody>
+          <a:bodyPr wrap="square">
+            <a:spAutoFit/>
+          </a:bodyPr>
+          <a:lstStyle/>
+          <a:p>
+            <a:pPr algn="l"/>
+            <a:r>
+              <a:rPr sz="900" b="1">
+                <a:solidFill>
+                  <a:srgbClr val="2C3E50"/>
+                </a:solidFill>
+              </a:rPr>
+              <a:t>GitHub Pages Doku</a:t>
+            </a:r>
+          </a:p>
+        </p:txBody>
+      </p:sp>
+      <p:sp>
+        <p:nvSpPr>
+          <p:cNvPr id="27" name="TextBox 26"/>
+          <p:cNvSpPr txBox="1"/>
+          <p:nvPr/>
+        </p:nvSpPr>
+        <p:spPr>
+          <a:xfrm>
+            <a:off x="3364992" y="3995927"/>
+            <a:ext cx="8412480" cy="603503"/>
+          </a:xfrm>
+          <a:prstGeom prst="rect">
+            <a:avLst/>
+          </a:prstGeom>
+          <a:noFill/>
+        </p:spPr>
+        <p:txBody>
+          <a:bodyPr wrap="square">
+            <a:spAutoFit/>
+          </a:bodyPr>
+          <a:lstStyle/>
+          <a:p>
+            <a:pPr algn="l"/>
+            <a:r>
+              <a:rPr sz="900" b="0">
+                <a:solidFill>
+                  <a:srgbClr val="2C3E50"/>
+                </a:solidFill>
+              </a:rPr>
+              <a:t>MkDocs-Site mit DE/EN-Doku für alle Module; Architektur nach C4-Modell</a:t>
+            </a:r>
+          </a:p>
+        </p:txBody>
+      </p:sp>
+      <p:sp>
+        <p:nvSpPr>
+          <p:cNvPr id="28" name="Rectangle 27"/>
+          <p:cNvSpPr/>
+          <p:nvPr/>
+        </p:nvSpPr>
+        <p:spPr>
+          <a:xfrm>
+            <a:off x="274320" y="4617719"/>
+            <a:ext cx="2926080" cy="658368"/>
+          </a:xfrm>
+          <a:prstGeom prst="rect">
+            <a:avLst/>
+          </a:prstGeom>
+          <a:solidFill>
+            <a:srgbClr val="FFFFFF"/>
+          </a:solidFill>
+          <a:ln>
+            <a:noFill/>
+          </a:ln>
+        </p:spPr>
+        <p:style>
+          <a:lnRef idx="1">
+            <a:schemeClr val="accent1"/>
+          </a:lnRef>
+          <a:fillRef idx="3">
+            <a:schemeClr val="accent1"/>
+          </a:fillRef>
+          <a:effectRef idx="2">
+            <a:schemeClr val="accent1"/>
+          </a:effectRef>
+          <a:fontRef idx="minor">
+            <a:schemeClr val="lt1"/>
+          </a:fontRef>
+        </p:style>
+        <p:txBody>
+          <a:bodyPr rtlCol="0" anchor="ctr"/>
+          <a:lstStyle/>
+          <a:p>
+            <a:pPr algn="ctr"/>
+          </a:p>
+        </p:txBody>
+      </p:sp>
+      <p:sp>
+        <p:nvSpPr>
+          <p:cNvPr id="29" name="Rectangle 28"/>
+          <p:cNvSpPr/>
+          <p:nvPr/>
+        </p:nvSpPr>
+        <p:spPr>
+          <a:xfrm>
+            <a:off x="3291840" y="4617719"/>
+            <a:ext cx="8595360" cy="658368"/>
+          </a:xfrm>
+          <a:prstGeom prst="rect">
+            <a:avLst/>
+          </a:prstGeom>
+          <a:solidFill>
+            <a:srgbClr val="FFFFFF"/>
+          </a:solidFill>
+          <a:ln>
+            <a:noFill/>
+          </a:ln>
+        </p:spPr>
+        <p:style>
+          <a:lnRef idx="1">
+            <a:schemeClr val="accent1"/>
+          </a:lnRef>
+          <a:fillRef idx="3">
+            <a:schemeClr val="accent1"/>
+          </a:fillRef>
+          <a:effectRef idx="2">
+            <a:schemeClr val="accent1"/>
+          </a:effectRef>
+          <a:fontRef idx="minor">
+            <a:schemeClr val="lt1"/>
+          </a:fontRef>
+        </p:style>
+        <p:txBody>
+          <a:bodyPr rtlCol="0" anchor="ctr"/>
+          <a:lstStyle/>
+          <a:p>
+            <a:pPr algn="ctr"/>
+          </a:p>
+        </p:txBody>
+      </p:sp>
+      <p:sp>
+        <p:nvSpPr>
+          <p:cNvPr id="30" name="TextBox 29"/>
+          <p:cNvSpPr txBox="1"/>
+          <p:nvPr/>
+        </p:nvSpPr>
+        <p:spPr>
+          <a:xfrm>
+            <a:off x="347472" y="4654295"/>
+            <a:ext cx="2788920" cy="603503"/>
+          </a:xfrm>
+          <a:prstGeom prst="rect">
+            <a:avLst/>
+          </a:prstGeom>
+          <a:noFill/>
+        </p:spPr>
+        <p:txBody>
+          <a:bodyPr wrap="square">
+            <a:spAutoFit/>
+          </a:bodyPr>
+          <a:lstStyle/>
+          <a:p>
+            <a:pPr algn="l"/>
+            <a:r>
+              <a:rPr sz="900" b="1">
+                <a:solidFill>
+                  <a:srgbClr val="2C3E50"/>
+                </a:solidFill>
+              </a:rPr>
+              <a:t>CI/CD</a:t>
+            </a:r>
+          </a:p>
+        </p:txBody>
+      </p:sp>
+      <p:sp>
+        <p:nvSpPr>
+          <p:cNvPr id="31" name="TextBox 30"/>
+          <p:cNvSpPr txBox="1"/>
+          <p:nvPr/>
+        </p:nvSpPr>
+        <p:spPr>
+          <a:xfrm>
+            <a:off x="3364992" y="4654295"/>
+            <a:ext cx="8412480" cy="603503"/>
+          </a:xfrm>
+          <a:prstGeom prst="rect">
+            <a:avLst/>
+          </a:prstGeom>
+          <a:noFill/>
+        </p:spPr>
+        <p:txBody>
+          <a:bodyPr wrap="square">
+            <a:spAutoFit/>
+          </a:bodyPr>
+          <a:lstStyle/>
+          <a:p>
+            <a:pPr algn="l"/>
+            <a:r>
+              <a:rPr sz="900" b="0">
+                <a:solidFill>
+                  <a:srgbClr val="2C3E50"/>
+                </a:solidFill>
+              </a:rPr>
+              <a:t>GitHub Actions für automatisches Docs-Deployment und Release-Erstellung bei v*-Tags</a:t>
+            </a:r>
+          </a:p>
+        </p:txBody>
+      </p:sp>
+      <p:sp>
+        <p:nvSpPr>
+          <p:cNvPr id="32" name="Rectangle 31"/>
+          <p:cNvSpPr/>
+          <p:nvPr/>
+        </p:nvSpPr>
+        <p:spPr>
+          <a:xfrm>
+            <a:off x="274320" y="5276087"/>
+            <a:ext cx="2926080" cy="658368"/>
+          </a:xfrm>
+          <a:prstGeom prst="rect">
+            <a:avLst/>
+          </a:prstGeom>
+          <a:solidFill>
+            <a:srgbClr val="ECF0F1"/>
+          </a:solidFill>
+          <a:ln>
+            <a:noFill/>
+          </a:ln>
+        </p:spPr>
+        <p:style>
+          <a:lnRef idx="1">
+            <a:schemeClr val="accent1"/>
+          </a:lnRef>
+          <a:fillRef idx="3">
+            <a:schemeClr val="accent1"/>
+          </a:fillRef>
+          <a:effectRef idx="2">
+            <a:schemeClr val="accent1"/>
+          </a:effectRef>
+          <a:fontRef idx="minor">
+            <a:schemeClr val="lt1"/>
+          </a:fontRef>
+        </p:style>
+        <p:txBody>
+          <a:bodyPr rtlCol="0" anchor="ctr"/>
+          <a:lstStyle/>
+          <a:p>
+            <a:pPr algn="ctr"/>
+          </a:p>
+        </p:txBody>
+      </p:sp>
+      <p:sp>
+        <p:nvSpPr>
+          <p:cNvPr id="33" name="Rectangle 32"/>
+          <p:cNvSpPr/>
+          <p:nvPr/>
+        </p:nvSpPr>
+        <p:spPr>
+          <a:xfrm>
+            <a:off x="3291840" y="5276087"/>
+            <a:ext cx="8595360" cy="658368"/>
+          </a:xfrm>
+          <a:prstGeom prst="rect">
+            <a:avLst/>
+          </a:prstGeom>
+          <a:solidFill>
+            <a:srgbClr val="ECF0F1"/>
+          </a:solidFill>
+          <a:ln>
+            <a:noFill/>
+          </a:ln>
+        </p:spPr>
+        <p:style>
+          <a:lnRef idx="1">
+            <a:schemeClr val="accent1"/>
+          </a:lnRef>
+          <a:fillRef idx="3">
+            <a:schemeClr val="accent1"/>
+          </a:fillRef>
+          <a:effectRef idx="2">
+            <a:schemeClr val="accent1"/>
+          </a:effectRef>
+          <a:fontRef idx="minor">
+            <a:schemeClr val="lt1"/>
+          </a:fontRef>
+        </p:style>
+        <p:txBody>
+          <a:bodyPr rtlCol="0" anchor="ctr"/>
+          <a:lstStyle/>
+          <a:p>
+            <a:pPr algn="ctr"/>
+          </a:p>
+        </p:txBody>
+      </p:sp>
+      <p:sp>
+        <p:nvSpPr>
+          <p:cNvPr id="34" name="TextBox 33"/>
+          <p:cNvSpPr txBox="1"/>
+          <p:nvPr/>
+        </p:nvSpPr>
+        <p:spPr>
+          <a:xfrm>
+            <a:off x="347472" y="5312663"/>
+            <a:ext cx="2788920" cy="603503"/>
+          </a:xfrm>
+          <a:prstGeom prst="rect">
+            <a:avLst/>
+          </a:prstGeom>
+          <a:noFill/>
+        </p:spPr>
+        <p:txBody>
+          <a:bodyPr wrap="square">
+            <a:spAutoFit/>
+          </a:bodyPr>
+          <a:lstStyle/>
+          <a:p>
+            <a:pPr algn="l"/>
+            <a:r>
+              <a:rPr sz="900" b="1">
+                <a:solidFill>
+                  <a:srgbClr val="2C3E50"/>
+                </a:solidFill>
+              </a:rPr>
+              <a:t>Tests</a:t>
+            </a:r>
+          </a:p>
+        </p:txBody>
+      </p:sp>
+      <p:sp>
+        <p:nvSpPr>
+          <p:cNvPr id="35" name="TextBox 34"/>
+          <p:cNvSpPr txBox="1"/>
+          <p:nvPr/>
+        </p:nvSpPr>
+        <p:spPr>
+          <a:xfrm>
+            <a:off x="3364992" y="5312663"/>
+            <a:ext cx="8412480" cy="603503"/>
+          </a:xfrm>
+          <a:prstGeom prst="rect">
+            <a:avLst/>
+          </a:prstGeom>
+          <a:noFill/>
+        </p:spPr>
+        <p:txBody>
+          <a:bodyPr wrap="square">
+            <a:spAutoFit/>
+          </a:bodyPr>
+          <a:lstStyle/>
+          <a:p>
+            <a:pPr algn="l"/>
+            <a:r>
+              <a:rPr sz="900" b="0">
+                <a:solidFill>
+                  <a:srgbClr val="2C3E50"/>
+                </a:solidFill>
+              </a:rPr>
+              <a:t>Unit- und Acceptance-Tests für alle Module; aktuell 542 Tests</a:t>
             </a:r>
           </a:p>
         </p:txBody>

</xml_diff>

<commit_message>
chore(docs): PPTX auf v0.8.4 aktualisiert (#58)
* docs: add AI-driven development disclaimer to README

Co-Authored-By: Claude Sonnet 4.6 <noreply@anthropic.com>

* docs: rebuild manuals with version 0.7.0

Co-Authored-By: Claude Sonnet 4.6 <noreply@anthropic.com>

* feat: add double-click launcher scripts to project root

SituationReport.bat/.sh/.command start the launcher GUI directly
from the source directory, using .venv if present.

Co-Authored-By: Claude Sonnet 4.6 <noreply@anthropic.com>

* chore(docs): update feature and process PPTX to v0.8.4

- features: add Launcher slide, scrollable form entry, 5-language support,
  v0.8.4 in title, 542 tests, updated manuals section
- prozess: 5-language label in step 5, updated manual description

Co-Authored-By: Claude Sonnet 4.6 <noreply@anthropic.com>

---------

Co-authored-by: Claude Sonnet 4.6 <noreply@anthropic.com>
</commit_message>
<xml_diff>
--- a/docs/situation_report_features.pptx
+++ b/docs/situation_report_features.pptx
@@ -12,6 +12,7 @@
     <p:sldId id="260" r:id="rId11"/>
     <p:sldId id="261" r:id="rId12"/>
     <p:sldId id="262" r:id="rId13"/>
+    <p:sldId id="263" r:id="rId14"/>
   </p:sldIdLst>
   <p:sldSz cx="12188952" cy="6858000" type="screen4x3"/>
   <p:notesSz cx="6858000" cy="9144000"/>
@@ -3243,7 +3244,7 @@
                   <a:srgbClr val="ECF0F1"/>
                 </a:solidFill>
               </a:rPr>
-              <a:t>Feature-Übersicht — Stand April 2026</a:t>
+              <a:t>Feature-Übersicht — v0.8.4 | Stand April 2026</a:t>
             </a:r>
           </a:p>
         </p:txBody>
@@ -3372,7 +3373,7 @@
                   <a:srgbClr val="FFFFFF"/>
                 </a:solidFill>
               </a:rPr>
-              <a:t>transform_data</a:t>
+              <a:t>launcher — Zentraler Einstiegspunkt</a:t>
             </a:r>
           </a:p>
         </p:txBody>
@@ -3646,7 +3647,7 @@
                   <a:srgbClr val="2C3E50"/>
                 </a:solidFill>
               </a:rPr>
-              <a:t>Kern-Transformation</a:t>
+              <a:t>Modul-Grid</a:t>
             </a:r>
           </a:p>
         </p:txBody>
@@ -3680,7 +3681,7 @@
                   <a:srgbClr val="2C3E50"/>
                 </a:solidFill>
               </a:rPr>
-              <a:t>Liest Jira-JSON-Export, berechnet Verweildauer je Workflow-Stage, schreibt IssueTimes.xlsx und CFD.xlsx</a:t>
+              <a:t>Alle verfügbaren und geplanten Module als Kacheln; verfügbare Module per Klick direkt starten — öffnen sich als eigenständiger Prozess in eigenem Fenster, Launcher bleibt geöffnet</a:t>
             </a:r>
           </a:p>
         </p:txBody>
@@ -3800,7 +3801,7 @@
                   <a:srgbClr val="2C3E50"/>
                 </a:solidFill>
               </a:rPr>
-              <a:t>Workflow-Datei</a:t>
+              <a:t>5 Sprachen</a:t>
             </a:r>
           </a:p>
         </p:txBody>
@@ -3834,7 +3835,7 @@
                   <a:srgbClr val="2C3E50"/>
                 </a:solidFill>
               </a:rPr>
-              <a:t>Textdatei mit &lt;First&gt;- und &lt;Closed&gt;-Markern definiert Eintritts- und Abschluss-Stage</a:t>
+              <a:t>Vollständig lokalisiert in DE, EN, RO, PT, FR — Umschaltung per Flag-Button oben rechts; Einstellung wird persistent gespeichert und gilt für alle Module gemeinsam</a:t>
             </a:r>
           </a:p>
         </p:txBody>
@@ -3954,7 +3955,7 @@
                   <a:srgbClr val="2C3E50"/>
                 </a:solidFill>
               </a:rPr>
-              <a:t>Datumsregeln</a:t>
+              <a:t>Update-Check</a:t>
             </a:r>
           </a:p>
         </p:txBody>
@@ -3988,7 +3989,7 @@
                   <a:srgbClr val="2C3E50"/>
                 </a:solidFill>
               </a:rPr>
-              <a:t>First Date / Closed Date aus Stage-Übergängen; Fallback bei übersprungenen Stages; Closed Date wird gelöscht wenn Issue wiedereröffnet wurde</a:t>
+              <a:t>Beim Start automatische Prüfung auf neue GitHub-Releases im Hintergrund; gelbes Banner mit Download-Link erscheint bei neuerer Version — kein Fehler bei fehlendem Internet</a:t>
             </a:r>
           </a:p>
         </p:txBody>
@@ -4108,7 +4109,7 @@
                   <a:srgbClr val="2C3E50"/>
                 </a:solidFill>
               </a:rPr>
-              <a:t>Carry-Forward</a:t>
+              <a:t>Handbuch-Button</a:t>
             </a:r>
           </a:p>
         </p:txBody>
@@ -4142,7 +4143,7 @@
                   <a:srgbClr val="2C3E50"/>
                 </a:solidFill>
               </a:rPr>
-              <a:t>Verweildauer wird auf letzte bekannte Stage weitergezählt wenn eine Stage übersprungen wurde</a:t>
+              <a:t>(?)-Button öffnet sprachspezifisches PDF-Handbuch direkt auf GitHub Pages — in allen 5 Sprachen verfügbar</a:t>
             </a:r>
           </a:p>
         </p:txBody>
@@ -4262,7 +4263,7 @@
                   <a:srgbClr val="2C3E50"/>
                 </a:solidFill>
               </a:rPr>
-              <a:t>Validierung &amp; Warnungen</a:t>
+              <a:t>ALPHA-Badge</a:t>
             </a:r>
           </a:p>
         </p:txBody>
@@ -4296,7 +4297,7 @@
                   <a:srgbClr val="2C3E50"/>
                 </a:solidFill>
               </a:rPr>
-              <a:t>Warnt bei fehlenden Workflow-Markern, unmapped Statuses und Stage-Inkonsistenzen</a:t>
+              <a:t>Rotes ALPHA-Badge in der Titelleiste signalisiert Alpha-Status des Projekts</a:t>
             </a:r>
           </a:p>
         </p:txBody>
@@ -4416,7 +4417,7 @@
                   <a:srgbClr val="2C3E50"/>
                 </a:solidFill>
               </a:rPr>
-              <a:t>GUI</a:t>
+              <a:t>Portable Start</a:t>
             </a:r>
           </a:p>
         </p:txBody>
@@ -4450,7 +4451,7 @@
                   <a:srgbClr val="2C3E50"/>
                 </a:solidFill>
               </a:rPr>
-              <a:t>tkinter-Oberfläche mit Dateidialogen für JSON, Workflow-Datei und Ausgabeordner; Präfix automatisch aus Dateiname vorbelegt</a:t>
+              <a:t>SituationReport.bat (Windows) / .command (macOS) / .sh (Linux) — kein Python oder Terminal erforderlich</a:t>
             </a:r>
           </a:p>
         </p:txBody>
@@ -4458,314 +4459,6 @@
       <p:sp>
         <p:nvSpPr>
           <p:cNvPr id="32" name="Rectangle 31"/>
-          <p:cNvSpPr/>
-          <p:nvPr/>
-        </p:nvSpPr>
-        <p:spPr>
-          <a:xfrm>
-            <a:off x="274320" y="5276087"/>
-            <a:ext cx="2926080" cy="658368"/>
-          </a:xfrm>
-          <a:prstGeom prst="rect">
-            <a:avLst/>
-          </a:prstGeom>
-          <a:solidFill>
-            <a:srgbClr val="ECF0F1"/>
-          </a:solidFill>
-          <a:ln>
-            <a:noFill/>
-          </a:ln>
-        </p:spPr>
-        <p:style>
-          <a:lnRef idx="1">
-            <a:schemeClr val="accent1"/>
-          </a:lnRef>
-          <a:fillRef idx="3">
-            <a:schemeClr val="accent1"/>
-          </a:fillRef>
-          <a:effectRef idx="2">
-            <a:schemeClr val="accent1"/>
-          </a:effectRef>
-          <a:fontRef idx="minor">
-            <a:schemeClr val="lt1"/>
-          </a:fontRef>
-        </p:style>
-        <p:txBody>
-          <a:bodyPr rtlCol="0" anchor="ctr"/>
-          <a:lstStyle/>
-          <a:p>
-            <a:pPr algn="ctr"/>
-          </a:p>
-        </p:txBody>
-      </p:sp>
-      <p:sp>
-        <p:nvSpPr>
-          <p:cNvPr id="33" name="Rectangle 32"/>
-          <p:cNvSpPr/>
-          <p:nvPr/>
-        </p:nvSpPr>
-        <p:spPr>
-          <a:xfrm>
-            <a:off x="3291840" y="5276087"/>
-            <a:ext cx="8595360" cy="658368"/>
-          </a:xfrm>
-          <a:prstGeom prst="rect">
-            <a:avLst/>
-          </a:prstGeom>
-          <a:solidFill>
-            <a:srgbClr val="ECF0F1"/>
-          </a:solidFill>
-          <a:ln>
-            <a:noFill/>
-          </a:ln>
-        </p:spPr>
-        <p:style>
-          <a:lnRef idx="1">
-            <a:schemeClr val="accent1"/>
-          </a:lnRef>
-          <a:fillRef idx="3">
-            <a:schemeClr val="accent1"/>
-          </a:fillRef>
-          <a:effectRef idx="2">
-            <a:schemeClr val="accent1"/>
-          </a:effectRef>
-          <a:fontRef idx="minor">
-            <a:schemeClr val="lt1"/>
-          </a:fontRef>
-        </p:style>
-        <p:txBody>
-          <a:bodyPr rtlCol="0" anchor="ctr"/>
-          <a:lstStyle/>
-          <a:p>
-            <a:pPr algn="ctr"/>
-          </a:p>
-        </p:txBody>
-      </p:sp>
-      <p:sp>
-        <p:nvSpPr>
-          <p:cNvPr id="34" name="TextBox 33"/>
-          <p:cNvSpPr txBox="1"/>
-          <p:nvPr/>
-        </p:nvSpPr>
-        <p:spPr>
-          <a:xfrm>
-            <a:off x="347472" y="5312663"/>
-            <a:ext cx="2788920" cy="603503"/>
-          </a:xfrm>
-          <a:prstGeom prst="rect">
-            <a:avLst/>
-          </a:prstGeom>
-          <a:noFill/>
-        </p:spPr>
-        <p:txBody>
-          <a:bodyPr wrap="square">
-            <a:spAutoFit/>
-          </a:bodyPr>
-          <a:lstStyle/>
-          <a:p>
-            <a:pPr algn="l"/>
-            <a:r>
-              <a:rPr sz="900" b="1">
-                <a:solidFill>
-                  <a:srgbClr val="2C3E50"/>
-                </a:solidFill>
-              </a:rPr>
-              <a:t>Ladebalken</a:t>
-            </a:r>
-          </a:p>
-        </p:txBody>
-      </p:sp>
-      <p:sp>
-        <p:nvSpPr>
-          <p:cNvPr id="35" name="TextBox 34"/>
-          <p:cNvSpPr txBox="1"/>
-          <p:nvPr/>
-        </p:nvSpPr>
-        <p:spPr>
-          <a:xfrm>
-            <a:off x="3364992" y="5312663"/>
-            <a:ext cx="8412480" cy="603503"/>
-          </a:xfrm>
-          <a:prstGeom prst="rect">
-            <a:avLst/>
-          </a:prstGeom>
-          <a:noFill/>
-        </p:spPr>
-        <p:txBody>
-          <a:bodyPr wrap="square">
-            <a:spAutoFit/>
-          </a:bodyPr>
-          <a:lstStyle/>
-          <a:p>
-            <a:pPr algn="l"/>
-            <a:r>
-              <a:rPr sz="900" b="0">
-                <a:solidFill>
-                  <a:srgbClr val="2C3E50"/>
-                </a:solidFill>
-              </a:rPr>
-              <a:t>Erscheint nach 3 Sekunden wenn die Transformation noch läuft</a:t>
-            </a:r>
-          </a:p>
-        </p:txBody>
-      </p:sp>
-      <p:sp>
-        <p:nvSpPr>
-          <p:cNvPr id="36" name="Rectangle 35"/>
-          <p:cNvSpPr/>
-          <p:nvPr/>
-        </p:nvSpPr>
-        <p:spPr>
-          <a:xfrm>
-            <a:off x="274320" y="5934455"/>
-            <a:ext cx="2926080" cy="658368"/>
-          </a:xfrm>
-          <a:prstGeom prst="rect">
-            <a:avLst/>
-          </a:prstGeom>
-          <a:solidFill>
-            <a:srgbClr val="FFFFFF"/>
-          </a:solidFill>
-          <a:ln>
-            <a:noFill/>
-          </a:ln>
-        </p:spPr>
-        <p:style>
-          <a:lnRef idx="1">
-            <a:schemeClr val="accent1"/>
-          </a:lnRef>
-          <a:fillRef idx="3">
-            <a:schemeClr val="accent1"/>
-          </a:fillRef>
-          <a:effectRef idx="2">
-            <a:schemeClr val="accent1"/>
-          </a:effectRef>
-          <a:fontRef idx="minor">
-            <a:schemeClr val="lt1"/>
-          </a:fontRef>
-        </p:style>
-        <p:txBody>
-          <a:bodyPr rtlCol="0" anchor="ctr"/>
-          <a:lstStyle/>
-          <a:p>
-            <a:pPr algn="ctr"/>
-          </a:p>
-        </p:txBody>
-      </p:sp>
-      <p:sp>
-        <p:nvSpPr>
-          <p:cNvPr id="37" name="Rectangle 36"/>
-          <p:cNvSpPr/>
-          <p:nvPr/>
-        </p:nvSpPr>
-        <p:spPr>
-          <a:xfrm>
-            <a:off x="3291840" y="5934455"/>
-            <a:ext cx="8595360" cy="658368"/>
-          </a:xfrm>
-          <a:prstGeom prst="rect">
-            <a:avLst/>
-          </a:prstGeom>
-          <a:solidFill>
-            <a:srgbClr val="FFFFFF"/>
-          </a:solidFill>
-          <a:ln>
-            <a:noFill/>
-          </a:ln>
-        </p:spPr>
-        <p:style>
-          <a:lnRef idx="1">
-            <a:schemeClr val="accent1"/>
-          </a:lnRef>
-          <a:fillRef idx="3">
-            <a:schemeClr val="accent1"/>
-          </a:fillRef>
-          <a:effectRef idx="2">
-            <a:schemeClr val="accent1"/>
-          </a:effectRef>
-          <a:fontRef idx="minor">
-            <a:schemeClr val="lt1"/>
-          </a:fontRef>
-        </p:style>
-        <p:txBody>
-          <a:bodyPr rtlCol="0" anchor="ctr"/>
-          <a:lstStyle/>
-          <a:p>
-            <a:pPr algn="ctr"/>
-          </a:p>
-        </p:txBody>
-      </p:sp>
-      <p:sp>
-        <p:nvSpPr>
-          <p:cNvPr id="38" name="TextBox 37"/>
-          <p:cNvSpPr txBox="1"/>
-          <p:nvPr/>
-        </p:nvSpPr>
-        <p:spPr>
-          <a:xfrm>
-            <a:off x="347472" y="5971031"/>
-            <a:ext cx="2788920" cy="603503"/>
-          </a:xfrm>
-          <a:prstGeom prst="rect">
-            <a:avLst/>
-          </a:prstGeom>
-          <a:noFill/>
-        </p:spPr>
-        <p:txBody>
-          <a:bodyPr wrap="square">
-            <a:spAutoFit/>
-          </a:bodyPr>
-          <a:lstStyle/>
-          <a:p>
-            <a:pPr algn="l"/>
-            <a:r>
-              <a:rPr sz="900" b="1">
-                <a:solidFill>
-                  <a:srgbClr val="2C3E50"/>
-                </a:solidFill>
-              </a:rPr>
-              <a:t>Doppelklick-Starter</a:t>
-            </a:r>
-          </a:p>
-        </p:txBody>
-      </p:sp>
-      <p:sp>
-        <p:nvSpPr>
-          <p:cNvPr id="39" name="TextBox 38"/>
-          <p:cNvSpPr txBox="1"/>
-          <p:nvPr/>
-        </p:nvSpPr>
-        <p:spPr>
-          <a:xfrm>
-            <a:off x="3364992" y="5971031"/>
-            <a:ext cx="8412480" cy="603503"/>
-          </a:xfrm>
-          <a:prstGeom prst="rect">
-            <a:avLst/>
-          </a:prstGeom>
-          <a:noFill/>
-        </p:spPr>
-        <p:txBody>
-          <a:bodyPr wrap="square">
-            <a:spAutoFit/>
-          </a:bodyPr>
-          <a:lstStyle/>
-          <a:p>
-            <a:pPr algn="l"/>
-            <a:r>
-              <a:rPr sz="900" b="0">
-                <a:solidFill>
-                  <a:srgbClr val="2C3E50"/>
-                </a:solidFill>
-              </a:rPr>
-              <a:t>transform_data_gui.pyw startet die GUI ohne Konsolenfenster</a:t>
-            </a:r>
-          </a:p>
-        </p:txBody>
-      </p:sp>
-      <p:sp>
-        <p:nvSpPr>
-          <p:cNvPr id="40" name="Rectangle 39"/>
           <p:cNvSpPr/>
           <p:nvPr/>
         </p:nvSpPr>
@@ -4896,7 +4589,7 @@
                   <a:srgbClr val="FFFFFF"/>
                 </a:solidFill>
               </a:rPr>
-              <a:t>build_reports — Metriken</a:t>
+              <a:t>transform_data</a:t>
             </a:r>
           </a:p>
         </p:txBody>
@@ -5170,7 +4863,7 @@
                   <a:srgbClr val="2C3E50"/>
                 </a:solidFill>
               </a:rPr>
-              <a:t>Flow Time / Cycle Time</a:t>
+              <a:t>Kern-Transformation</a:t>
             </a:r>
           </a:p>
         </p:txBody>
@@ -5204,7 +4897,7 @@
                   <a:srgbClr val="2C3E50"/>
                 </a:solidFill>
               </a:rPr>
-              <a:t>Boxplot + Scatterplot; Methode A &amp; B; LOESS-Trendlinie; Perzentil-Referenzlinien; farbige Punkte; rote Ausreißer; Issue-Key als Hover-Tooltip</a:t>
+              <a:t>Liest Jira-JSON-Export, berechnet Verweildauer je Workflow-Stage, schreibt IssueTimes.xlsx und CFD.xlsx</a:t>
             </a:r>
           </a:p>
         </p:txBody>
@@ -5324,7 +5017,7 @@
                   <a:srgbClr val="2C3E50"/>
                 </a:solidFill>
               </a:rPr>
-              <a:t>Flow Velocity / Throughput</a:t>
+              <a:t>Workflow-Datei</a:t>
             </a:r>
           </a:p>
         </p:txBody>
@@ -5358,7 +5051,7 @@
                   <a:srgbClr val="2C3E50"/>
                 </a:solidFill>
               </a:rPr>
-              <a:t>Tagesfrequenz-Histogramm + Wochenverlauf-Linienchart + PI-Balkendiagramm; konfigurierbares Target CT</a:t>
+              <a:t>Textdatei mit &lt;First&gt;- und &lt;Closed&gt;-Markern definiert Eintritts- und Abschluss-Stage</a:t>
             </a:r>
           </a:p>
         </p:txBody>
@@ -5478,7 +5171,7 @@
                   <a:srgbClr val="2C3E50"/>
                 </a:solidFill>
               </a:rPr>
-              <a:t>Flow Load / WIP</a:t>
+              <a:t>Datumsregeln</a:t>
             </a:r>
           </a:p>
         </p:txBody>
@@ -5512,7 +5205,7 @@
                   <a:srgbClr val="2C3E50"/>
                 </a:solidFill>
               </a:rPr>
-              <a:t>Aging-WIP-Boxplot pro Stage; Issue-Anzahl je Stage als Annotation; Referenzlinien (Median, P85, Target CT); Legende</a:t>
+              <a:t>First Date / Closed Date aus Stage-Übergängen; Fallback bei übersprungenen Stages; Closed Date wird gelöscht wenn Issue wiedereröffnet wurde</a:t>
             </a:r>
           </a:p>
         </p:txBody>
@@ -5632,7 +5325,7 @@
                   <a:srgbClr val="2C3E50"/>
                 </a:solidFill>
               </a:rPr>
-              <a:t>CFD</a:t>
+              <a:t>Carry-Forward</a:t>
             </a:r>
           </a:p>
         </p:txBody>
@@ -5666,7 +5359,7 @@
                   <a:srgbClr val="2C3E50"/>
                 </a:solidFill>
               </a:rPr>
-              <a:t>Gestapeltes Flächendiagramm; Trendlinien an visuellen Oberkanten der &lt;First&gt;- und &lt;Closed&gt;-Stages; Monats-/KW-Achse ohne Überlappung; In/Out-Ratio im Titel</a:t>
+              <a:t>Verweildauer wird auf letzte bekannte Stage weitergezählt wenn eine Stage übersprungen wurde</a:t>
             </a:r>
           </a:p>
         </p:txBody>
@@ -5786,7 +5479,7 @@
                   <a:srgbClr val="2C3E50"/>
                 </a:solidFill>
               </a:rPr>
-              <a:t>Flow Distribution</a:t>
+              <a:t>Validierung &amp; Warnungen</a:t>
             </a:r>
           </a:p>
         </p:txBody>
@@ -5820,7 +5513,7 @@
                   <a:srgbClr val="2C3E50"/>
                 </a:solidFill>
               </a:rPr>
-              <a:t>Drei Teildiagramme: Issue-Typ-Donut, Stage-Prominence-Donut, Ø Cycle Time je Typ als Balken</a:t>
+              <a:t>Warnt bei fehlenden Workflow-Markern, unmapped Statuses und Stage-Inkonsistenzen</a:t>
             </a:r>
           </a:p>
         </p:txBody>
@@ -5828,6 +5521,468 @@
       <p:sp>
         <p:nvSpPr>
           <p:cNvPr id="28" name="Rectangle 27"/>
+          <p:cNvSpPr/>
+          <p:nvPr/>
+        </p:nvSpPr>
+        <p:spPr>
+          <a:xfrm>
+            <a:off x="274320" y="4617719"/>
+            <a:ext cx="2926080" cy="658368"/>
+          </a:xfrm>
+          <a:prstGeom prst="rect">
+            <a:avLst/>
+          </a:prstGeom>
+          <a:solidFill>
+            <a:srgbClr val="FFFFFF"/>
+          </a:solidFill>
+          <a:ln>
+            <a:noFill/>
+          </a:ln>
+        </p:spPr>
+        <p:style>
+          <a:lnRef idx="1">
+            <a:schemeClr val="accent1"/>
+          </a:lnRef>
+          <a:fillRef idx="3">
+            <a:schemeClr val="accent1"/>
+          </a:fillRef>
+          <a:effectRef idx="2">
+            <a:schemeClr val="accent1"/>
+          </a:effectRef>
+          <a:fontRef idx="minor">
+            <a:schemeClr val="lt1"/>
+          </a:fontRef>
+        </p:style>
+        <p:txBody>
+          <a:bodyPr rtlCol="0" anchor="ctr"/>
+          <a:lstStyle/>
+          <a:p>
+            <a:pPr algn="ctr"/>
+          </a:p>
+        </p:txBody>
+      </p:sp>
+      <p:sp>
+        <p:nvSpPr>
+          <p:cNvPr id="29" name="Rectangle 28"/>
+          <p:cNvSpPr/>
+          <p:nvPr/>
+        </p:nvSpPr>
+        <p:spPr>
+          <a:xfrm>
+            <a:off x="3291840" y="4617719"/>
+            <a:ext cx="8595360" cy="658368"/>
+          </a:xfrm>
+          <a:prstGeom prst="rect">
+            <a:avLst/>
+          </a:prstGeom>
+          <a:solidFill>
+            <a:srgbClr val="FFFFFF"/>
+          </a:solidFill>
+          <a:ln>
+            <a:noFill/>
+          </a:ln>
+        </p:spPr>
+        <p:style>
+          <a:lnRef idx="1">
+            <a:schemeClr val="accent1"/>
+          </a:lnRef>
+          <a:fillRef idx="3">
+            <a:schemeClr val="accent1"/>
+          </a:fillRef>
+          <a:effectRef idx="2">
+            <a:schemeClr val="accent1"/>
+          </a:effectRef>
+          <a:fontRef idx="minor">
+            <a:schemeClr val="lt1"/>
+          </a:fontRef>
+        </p:style>
+        <p:txBody>
+          <a:bodyPr rtlCol="0" anchor="ctr"/>
+          <a:lstStyle/>
+          <a:p>
+            <a:pPr algn="ctr"/>
+          </a:p>
+        </p:txBody>
+      </p:sp>
+      <p:sp>
+        <p:nvSpPr>
+          <p:cNvPr id="30" name="TextBox 29"/>
+          <p:cNvSpPr txBox="1"/>
+          <p:nvPr/>
+        </p:nvSpPr>
+        <p:spPr>
+          <a:xfrm>
+            <a:off x="347472" y="4654295"/>
+            <a:ext cx="2788920" cy="603503"/>
+          </a:xfrm>
+          <a:prstGeom prst="rect">
+            <a:avLst/>
+          </a:prstGeom>
+          <a:noFill/>
+        </p:spPr>
+        <p:txBody>
+          <a:bodyPr wrap="square">
+            <a:spAutoFit/>
+          </a:bodyPr>
+          <a:lstStyle/>
+          <a:p>
+            <a:pPr algn="l"/>
+            <a:r>
+              <a:rPr sz="900" b="1">
+                <a:solidFill>
+                  <a:srgbClr val="2C3E50"/>
+                </a:solidFill>
+              </a:rPr>
+              <a:t>GUI</a:t>
+            </a:r>
+          </a:p>
+        </p:txBody>
+      </p:sp>
+      <p:sp>
+        <p:nvSpPr>
+          <p:cNvPr id="31" name="TextBox 30"/>
+          <p:cNvSpPr txBox="1"/>
+          <p:nvPr/>
+        </p:nvSpPr>
+        <p:spPr>
+          <a:xfrm>
+            <a:off x="3364992" y="4654295"/>
+            <a:ext cx="8412480" cy="603503"/>
+          </a:xfrm>
+          <a:prstGeom prst="rect">
+            <a:avLst/>
+          </a:prstGeom>
+          <a:noFill/>
+        </p:spPr>
+        <p:txBody>
+          <a:bodyPr wrap="square">
+            <a:spAutoFit/>
+          </a:bodyPr>
+          <a:lstStyle/>
+          <a:p>
+            <a:pPr algn="l"/>
+            <a:r>
+              <a:rPr sz="900" b="0">
+                <a:solidFill>
+                  <a:srgbClr val="2C3E50"/>
+                </a:solidFill>
+              </a:rPr>
+              <a:t>tkinter-Oberfläche mit Dateidialogen für JSON, Workflow-Datei und Ausgabeordner; Präfix automatisch aus Dateiname vorbelegt</a:t>
+            </a:r>
+          </a:p>
+        </p:txBody>
+      </p:sp>
+      <p:sp>
+        <p:nvSpPr>
+          <p:cNvPr id="32" name="Rectangle 31"/>
+          <p:cNvSpPr/>
+          <p:nvPr/>
+        </p:nvSpPr>
+        <p:spPr>
+          <a:xfrm>
+            <a:off x="274320" y="5276087"/>
+            <a:ext cx="2926080" cy="658368"/>
+          </a:xfrm>
+          <a:prstGeom prst="rect">
+            <a:avLst/>
+          </a:prstGeom>
+          <a:solidFill>
+            <a:srgbClr val="ECF0F1"/>
+          </a:solidFill>
+          <a:ln>
+            <a:noFill/>
+          </a:ln>
+        </p:spPr>
+        <p:style>
+          <a:lnRef idx="1">
+            <a:schemeClr val="accent1"/>
+          </a:lnRef>
+          <a:fillRef idx="3">
+            <a:schemeClr val="accent1"/>
+          </a:fillRef>
+          <a:effectRef idx="2">
+            <a:schemeClr val="accent1"/>
+          </a:effectRef>
+          <a:fontRef idx="minor">
+            <a:schemeClr val="lt1"/>
+          </a:fontRef>
+        </p:style>
+        <p:txBody>
+          <a:bodyPr rtlCol="0" anchor="ctr"/>
+          <a:lstStyle/>
+          <a:p>
+            <a:pPr algn="ctr"/>
+          </a:p>
+        </p:txBody>
+      </p:sp>
+      <p:sp>
+        <p:nvSpPr>
+          <p:cNvPr id="33" name="Rectangle 32"/>
+          <p:cNvSpPr/>
+          <p:nvPr/>
+        </p:nvSpPr>
+        <p:spPr>
+          <a:xfrm>
+            <a:off x="3291840" y="5276087"/>
+            <a:ext cx="8595360" cy="658368"/>
+          </a:xfrm>
+          <a:prstGeom prst="rect">
+            <a:avLst/>
+          </a:prstGeom>
+          <a:solidFill>
+            <a:srgbClr val="ECF0F1"/>
+          </a:solidFill>
+          <a:ln>
+            <a:noFill/>
+          </a:ln>
+        </p:spPr>
+        <p:style>
+          <a:lnRef idx="1">
+            <a:schemeClr val="accent1"/>
+          </a:lnRef>
+          <a:fillRef idx="3">
+            <a:schemeClr val="accent1"/>
+          </a:fillRef>
+          <a:effectRef idx="2">
+            <a:schemeClr val="accent1"/>
+          </a:effectRef>
+          <a:fontRef idx="minor">
+            <a:schemeClr val="lt1"/>
+          </a:fontRef>
+        </p:style>
+        <p:txBody>
+          <a:bodyPr rtlCol="0" anchor="ctr"/>
+          <a:lstStyle/>
+          <a:p>
+            <a:pPr algn="ctr"/>
+          </a:p>
+        </p:txBody>
+      </p:sp>
+      <p:sp>
+        <p:nvSpPr>
+          <p:cNvPr id="34" name="TextBox 33"/>
+          <p:cNvSpPr txBox="1"/>
+          <p:nvPr/>
+        </p:nvSpPr>
+        <p:spPr>
+          <a:xfrm>
+            <a:off x="347472" y="5312663"/>
+            <a:ext cx="2788920" cy="603503"/>
+          </a:xfrm>
+          <a:prstGeom prst="rect">
+            <a:avLst/>
+          </a:prstGeom>
+          <a:noFill/>
+        </p:spPr>
+        <p:txBody>
+          <a:bodyPr wrap="square">
+            <a:spAutoFit/>
+          </a:bodyPr>
+          <a:lstStyle/>
+          <a:p>
+            <a:pPr algn="l"/>
+            <a:r>
+              <a:rPr sz="900" b="1">
+                <a:solidFill>
+                  <a:srgbClr val="2C3E50"/>
+                </a:solidFill>
+              </a:rPr>
+              <a:t>Ladebalken</a:t>
+            </a:r>
+          </a:p>
+        </p:txBody>
+      </p:sp>
+      <p:sp>
+        <p:nvSpPr>
+          <p:cNvPr id="35" name="TextBox 34"/>
+          <p:cNvSpPr txBox="1"/>
+          <p:nvPr/>
+        </p:nvSpPr>
+        <p:spPr>
+          <a:xfrm>
+            <a:off x="3364992" y="5312663"/>
+            <a:ext cx="8412480" cy="603503"/>
+          </a:xfrm>
+          <a:prstGeom prst="rect">
+            <a:avLst/>
+          </a:prstGeom>
+          <a:noFill/>
+        </p:spPr>
+        <p:txBody>
+          <a:bodyPr wrap="square">
+            <a:spAutoFit/>
+          </a:bodyPr>
+          <a:lstStyle/>
+          <a:p>
+            <a:pPr algn="l"/>
+            <a:r>
+              <a:rPr sz="900" b="0">
+                <a:solidFill>
+                  <a:srgbClr val="2C3E50"/>
+                </a:solidFill>
+              </a:rPr>
+              <a:t>Erscheint nach 3 Sekunden wenn die Transformation noch läuft</a:t>
+            </a:r>
+          </a:p>
+        </p:txBody>
+      </p:sp>
+      <p:sp>
+        <p:nvSpPr>
+          <p:cNvPr id="36" name="Rectangle 35"/>
+          <p:cNvSpPr/>
+          <p:nvPr/>
+        </p:nvSpPr>
+        <p:spPr>
+          <a:xfrm>
+            <a:off x="274320" y="5934455"/>
+            <a:ext cx="2926080" cy="658368"/>
+          </a:xfrm>
+          <a:prstGeom prst="rect">
+            <a:avLst/>
+          </a:prstGeom>
+          <a:solidFill>
+            <a:srgbClr val="FFFFFF"/>
+          </a:solidFill>
+          <a:ln>
+            <a:noFill/>
+          </a:ln>
+        </p:spPr>
+        <p:style>
+          <a:lnRef idx="1">
+            <a:schemeClr val="accent1"/>
+          </a:lnRef>
+          <a:fillRef idx="3">
+            <a:schemeClr val="accent1"/>
+          </a:fillRef>
+          <a:effectRef idx="2">
+            <a:schemeClr val="accent1"/>
+          </a:effectRef>
+          <a:fontRef idx="minor">
+            <a:schemeClr val="lt1"/>
+          </a:fontRef>
+        </p:style>
+        <p:txBody>
+          <a:bodyPr rtlCol="0" anchor="ctr"/>
+          <a:lstStyle/>
+          <a:p>
+            <a:pPr algn="ctr"/>
+          </a:p>
+        </p:txBody>
+      </p:sp>
+      <p:sp>
+        <p:nvSpPr>
+          <p:cNvPr id="37" name="Rectangle 36"/>
+          <p:cNvSpPr/>
+          <p:nvPr/>
+        </p:nvSpPr>
+        <p:spPr>
+          <a:xfrm>
+            <a:off x="3291840" y="5934455"/>
+            <a:ext cx="8595360" cy="658368"/>
+          </a:xfrm>
+          <a:prstGeom prst="rect">
+            <a:avLst/>
+          </a:prstGeom>
+          <a:solidFill>
+            <a:srgbClr val="FFFFFF"/>
+          </a:solidFill>
+          <a:ln>
+            <a:noFill/>
+          </a:ln>
+        </p:spPr>
+        <p:style>
+          <a:lnRef idx="1">
+            <a:schemeClr val="accent1"/>
+          </a:lnRef>
+          <a:fillRef idx="3">
+            <a:schemeClr val="accent1"/>
+          </a:fillRef>
+          <a:effectRef idx="2">
+            <a:schemeClr val="accent1"/>
+          </a:effectRef>
+          <a:fontRef idx="minor">
+            <a:schemeClr val="lt1"/>
+          </a:fontRef>
+        </p:style>
+        <p:txBody>
+          <a:bodyPr rtlCol="0" anchor="ctr"/>
+          <a:lstStyle/>
+          <a:p>
+            <a:pPr algn="ctr"/>
+          </a:p>
+        </p:txBody>
+      </p:sp>
+      <p:sp>
+        <p:nvSpPr>
+          <p:cNvPr id="38" name="TextBox 37"/>
+          <p:cNvSpPr txBox="1"/>
+          <p:nvPr/>
+        </p:nvSpPr>
+        <p:spPr>
+          <a:xfrm>
+            <a:off x="347472" y="5971031"/>
+            <a:ext cx="2788920" cy="603503"/>
+          </a:xfrm>
+          <a:prstGeom prst="rect">
+            <a:avLst/>
+          </a:prstGeom>
+          <a:noFill/>
+        </p:spPr>
+        <p:txBody>
+          <a:bodyPr wrap="square">
+            <a:spAutoFit/>
+          </a:bodyPr>
+          <a:lstStyle/>
+          <a:p>
+            <a:pPr algn="l"/>
+            <a:r>
+              <a:rPr sz="900" b="1">
+                <a:solidFill>
+                  <a:srgbClr val="2C3E50"/>
+                </a:solidFill>
+              </a:rPr>
+              <a:t>Doppelklick-Starter</a:t>
+            </a:r>
+          </a:p>
+        </p:txBody>
+      </p:sp>
+      <p:sp>
+        <p:nvSpPr>
+          <p:cNvPr id="39" name="TextBox 38"/>
+          <p:cNvSpPr txBox="1"/>
+          <p:nvPr/>
+        </p:nvSpPr>
+        <p:spPr>
+          <a:xfrm>
+            <a:off x="3364992" y="5971031"/>
+            <a:ext cx="8412480" cy="603503"/>
+          </a:xfrm>
+          <a:prstGeom prst="rect">
+            <a:avLst/>
+          </a:prstGeom>
+          <a:noFill/>
+        </p:spPr>
+        <p:txBody>
+          <a:bodyPr wrap="square">
+            <a:spAutoFit/>
+          </a:bodyPr>
+          <a:lstStyle/>
+          <a:p>
+            <a:pPr algn="l"/>
+            <a:r>
+              <a:rPr sz="900" b="0">
+                <a:solidFill>
+                  <a:srgbClr val="2C3E50"/>
+                </a:solidFill>
+              </a:rPr>
+              <a:t>transform_data_gui.pyw startet die GUI ohne Konsolenfenster</a:t>
+            </a:r>
+          </a:p>
+        </p:txBody>
+      </p:sp>
+      <p:sp>
+        <p:nvSpPr>
+          <p:cNvPr id="40" name="Rectangle 39"/>
           <p:cNvSpPr/>
           <p:nvPr/>
         </p:nvSpPr>
@@ -5958,7 +6113,7 @@
                   <a:srgbClr val="FFFFFF"/>
                 </a:solidFill>
               </a:rPr>
-              <a:t>build_reports — Filter &amp; Ausschlüsse</a:t>
+              <a:t>build_reports — Metriken</a:t>
             </a:r>
           </a:p>
         </p:txBody>
@@ -6232,7 +6387,7 @@
                   <a:srgbClr val="2C3E50"/>
                 </a:solidFill>
               </a:rPr>
-              <a:t>Datumsfilter</a:t>
+              <a:t>Flow Time / Cycle Time</a:t>
             </a:r>
           </a:p>
         </p:txBody>
@@ -6266,7 +6421,7 @@
                   <a:srgbClr val="2C3E50"/>
                 </a:solidFill>
               </a:rPr>
-              <a:t>Von/Bis mit Kalender-Picker; "Letzte 365 Tage"-Button</a:t>
+              <a:t>Boxplot + Scatterplot; Methode A &amp; B; LOESS-Trendlinie; Perzentil-Referenzlinien; farbige Punkte; rote Ausreißer; Issue-Key als Hover-Tooltip</a:t>
             </a:r>
           </a:p>
         </p:txBody>
@@ -6386,7 +6541,7 @@
                   <a:srgbClr val="2C3E50"/>
                 </a:solidFill>
               </a:rPr>
-              <a:t>Projektfilter</a:t>
+              <a:t>Flow Velocity / Throughput</a:t>
             </a:r>
           </a:p>
         </p:txBody>
@@ -6420,7 +6575,7 @@
                   <a:srgbClr val="2C3E50"/>
                 </a:solidFill>
               </a:rPr>
-              <a:t>Auswahl aus allen in IssueTimes vorhandenen Projekten</a:t>
+              <a:t>Tagesfrequenz-Histogramm + Wochenverlauf-Linienchart + PI-Balkendiagramm; konfigurierbares Target CT</a:t>
             </a:r>
           </a:p>
         </p:txBody>
@@ -6540,7 +6695,7 @@
                   <a:srgbClr val="2C3E50"/>
                 </a:solidFill>
               </a:rPr>
-              <a:t>Issuetype-Filter</a:t>
+              <a:t>Flow Load / WIP</a:t>
             </a:r>
           </a:p>
         </p:txBody>
@@ -6574,7 +6729,7 @@
                   <a:srgbClr val="2C3E50"/>
                 </a:solidFill>
               </a:rPr>
-              <a:t>Auswahl aus allen vorhandenen Issue-Typen</a:t>
+              <a:t>Aging-WIP-Boxplot pro Stage; Issue-Anzahl je Stage als Annotation; Referenzlinien (Median, P85, Target CT); Legende</a:t>
             </a:r>
           </a:p>
         </p:txBody>
@@ -6694,7 +6849,7 @@
                   <a:srgbClr val="2C3E50"/>
                 </a:solidFill>
               </a:rPr>
-              <a:t>Ausschluss Status / Resolution</a:t>
+              <a:t>CFD</a:t>
             </a:r>
           </a:p>
         </p:txBody>
@@ -6728,7 +6883,7 @@
                   <a:srgbClr val="2C3E50"/>
                 </a:solidFill>
               </a:rPr>
-              <a:t>Issues komplett aus allen Metriken entfernen</a:t>
+              <a:t>Gestapeltes Flächendiagramm; Trendlinien an visuellen Oberkanten der &lt;First&gt;- und &lt;Closed&gt;-Stages; Monats-/KW-Achse ohne Überlappung; In/Out-Ratio im Titel</a:t>
             </a:r>
           </a:p>
         </p:txBody>
@@ -6848,7 +7003,7 @@
                   <a:srgbClr val="2C3E50"/>
                 </a:solidFill>
               </a:rPr>
-              <a:t>Zero-Day-Filter</a:t>
+              <a:t>Flow Distribution</a:t>
             </a:r>
           </a:p>
         </p:txBody>
@@ -6882,7 +7037,7 @@
                   <a:srgbClr val="2C3E50"/>
                 </a:solidFill>
               </a:rPr>
-              <a:t>Konfigurierbarer Schwellwert (Standard 5 min); ausgeschlossene Issues in separater Excel dokumentiert</a:t>
+              <a:t>Drei Teildiagramme: Issue-Typ-Donut, Stage-Prominence-Donut, Ø Cycle Time je Typ als Balken</a:t>
             </a:r>
           </a:p>
         </p:txBody>
@@ -6890,160 +7045,6 @@
       <p:sp>
         <p:nvSpPr>
           <p:cNvPr id="28" name="Rectangle 27"/>
-          <p:cNvSpPr/>
-          <p:nvPr/>
-        </p:nvSpPr>
-        <p:spPr>
-          <a:xfrm>
-            <a:off x="274320" y="4617719"/>
-            <a:ext cx="2926080" cy="658368"/>
-          </a:xfrm>
-          <a:prstGeom prst="rect">
-            <a:avLst/>
-          </a:prstGeom>
-          <a:solidFill>
-            <a:srgbClr val="FFFFFF"/>
-          </a:solidFill>
-          <a:ln>
-            <a:noFill/>
-          </a:ln>
-        </p:spPr>
-        <p:style>
-          <a:lnRef idx="1">
-            <a:schemeClr val="accent1"/>
-          </a:lnRef>
-          <a:fillRef idx="3">
-            <a:schemeClr val="accent1"/>
-          </a:fillRef>
-          <a:effectRef idx="2">
-            <a:schemeClr val="accent1"/>
-          </a:effectRef>
-          <a:fontRef idx="minor">
-            <a:schemeClr val="lt1"/>
-          </a:fontRef>
-        </p:style>
-        <p:txBody>
-          <a:bodyPr rtlCol="0" anchor="ctr"/>
-          <a:lstStyle/>
-          <a:p>
-            <a:pPr algn="ctr"/>
-          </a:p>
-        </p:txBody>
-      </p:sp>
-      <p:sp>
-        <p:nvSpPr>
-          <p:cNvPr id="29" name="Rectangle 28"/>
-          <p:cNvSpPr/>
-          <p:nvPr/>
-        </p:nvSpPr>
-        <p:spPr>
-          <a:xfrm>
-            <a:off x="3291840" y="4617719"/>
-            <a:ext cx="8595360" cy="658368"/>
-          </a:xfrm>
-          <a:prstGeom prst="rect">
-            <a:avLst/>
-          </a:prstGeom>
-          <a:solidFill>
-            <a:srgbClr val="FFFFFF"/>
-          </a:solidFill>
-          <a:ln>
-            <a:noFill/>
-          </a:ln>
-        </p:spPr>
-        <p:style>
-          <a:lnRef idx="1">
-            <a:schemeClr val="accent1"/>
-          </a:lnRef>
-          <a:fillRef idx="3">
-            <a:schemeClr val="accent1"/>
-          </a:fillRef>
-          <a:effectRef idx="2">
-            <a:schemeClr val="accent1"/>
-          </a:effectRef>
-          <a:fontRef idx="minor">
-            <a:schemeClr val="lt1"/>
-          </a:fontRef>
-        </p:style>
-        <p:txBody>
-          <a:bodyPr rtlCol="0" anchor="ctr"/>
-          <a:lstStyle/>
-          <a:p>
-            <a:pPr algn="ctr"/>
-          </a:p>
-        </p:txBody>
-      </p:sp>
-      <p:sp>
-        <p:nvSpPr>
-          <p:cNvPr id="30" name="TextBox 29"/>
-          <p:cNvSpPr txBox="1"/>
-          <p:nvPr/>
-        </p:nvSpPr>
-        <p:spPr>
-          <a:xfrm>
-            <a:off x="347472" y="4654295"/>
-            <a:ext cx="2788920" cy="603503"/>
-          </a:xfrm>
-          <a:prstGeom prst="rect">
-            <a:avLst/>
-          </a:prstGeom>
-          <a:noFill/>
-        </p:spPr>
-        <p:txBody>
-          <a:bodyPr wrap="square">
-            <a:spAutoFit/>
-          </a:bodyPr>
-          <a:lstStyle/>
-          <a:p>
-            <a:pPr algn="l"/>
-            <a:r>
-              <a:rPr sz="900" b="1">
-                <a:solidFill>
-                  <a:srgbClr val="2C3E50"/>
-                </a:solidFill>
-              </a:rPr>
-              <a:t>Datumsfilter-Bugfix</a:t>
-            </a:r>
-          </a:p>
-        </p:txBody>
-      </p:sp>
-      <p:sp>
-        <p:nvSpPr>
-          <p:cNvPr id="31" name="TextBox 30"/>
-          <p:cNvSpPr txBox="1"/>
-          <p:nvPr/>
-        </p:nvSpPr>
-        <p:spPr>
-          <a:xfrm>
-            <a:off x="3364992" y="4654295"/>
-            <a:ext cx="8412480" cy="603503"/>
-          </a:xfrm>
-          <a:prstGeom prst="rect">
-            <a:avLst/>
-          </a:prstGeom>
-          <a:noFill/>
-        </p:spPr>
-        <p:txBody>
-          <a:bodyPr wrap="square">
-            <a:spAutoFit/>
-          </a:bodyPr>
-          <a:lstStyle/>
-          <a:p>
-            <a:pPr algn="l"/>
-            <a:r>
-              <a:rPr sz="900" b="0">
-                <a:solidFill>
-                  <a:srgbClr val="2C3E50"/>
-                </a:solidFill>
-              </a:rPr>
-              <a:t>Offene Issues (kein Closed Date) wurden fälschlich vom Datumsfilter ausgeschlossen — behoben</a:t>
-            </a:r>
-          </a:p>
-        </p:txBody>
-      </p:sp>
-      <p:sp>
-        <p:nvSpPr>
-          <p:cNvPr id="32" name="Rectangle 31"/>
           <p:cNvSpPr/>
           <p:nvPr/>
         </p:nvSpPr>
@@ -7174,7 +7175,7 @@
                   <a:srgbClr val="FFFFFF"/>
                 </a:solidFill>
               </a:rPr>
-              <a:t>build_reports — Export &amp; Reporting</a:t>
+              <a:t>build_reports — Filter &amp; Ausschlüsse</a:t>
             </a:r>
           </a:p>
         </p:txBody>
@@ -7448,7 +7449,7 @@
                   <a:srgbClr val="2C3E50"/>
                 </a:solidFill>
               </a:rPr>
-              <a:t>Browser-Anzeige</a:t>
+              <a:t>Datumsfilter</a:t>
             </a:r>
           </a:p>
         </p:txBody>
@@ -7482,7 +7483,7 @@
                   <a:srgbClr val="2C3E50"/>
                 </a:solidFill>
               </a:rPr>
-              <a:t>Vollständig interaktive Plotly-Diagramme im Browser</a:t>
+              <a:t>Von/Bis mit Kalender-Picker; "Letzte 365 Tage"-Button</a:t>
             </a:r>
           </a:p>
         </p:txBody>
@@ -7602,7 +7603,7 @@
                   <a:srgbClr val="2C3E50"/>
                 </a:solidFill>
               </a:rPr>
-              <a:t>PDF-Export</a:t>
+              <a:t>Projektfilter</a:t>
             </a:r>
           </a:p>
         </p:txBody>
@@ -7636,7 +7637,7 @@
                   <a:srgbClr val="2C3E50"/>
                 </a:solidFill>
               </a:rPr>
-              <a:t>Mehrseitige PDF mit allen gewählten Metriken</a:t>
+              <a:t>Auswahl aus allen in IssueTimes vorhandenen Projekten</a:t>
             </a:r>
           </a:p>
         </p:txBody>
@@ -7756,7 +7757,7 @@
                   <a:srgbClr val="2C3E50"/>
                 </a:solidFill>
               </a:rPr>
-              <a:t>Report-Excel</a:t>
+              <a:t>Issuetype-Filter</a:t>
             </a:r>
           </a:p>
         </p:txBody>
@@ -7790,7 +7791,7 @@
                   <a:srgbClr val="2C3E50"/>
                 </a:solidFill>
               </a:rPr>
-              <a:t>Wird automatisch beim PDF-Export erzeugt; enthält gefilterte Issues mit Status Group, CT Methode A und B</a:t>
+              <a:t>Auswahl aus allen vorhandenen Issue-Typen</a:t>
             </a:r>
           </a:p>
         </p:txBody>
@@ -7910,7 +7911,7 @@
                   <a:srgbClr val="2C3E50"/>
                 </a:solidFill>
               </a:rPr>
-              <a:t>PI-Konfiguration</a:t>
+              <a:t>Ausschluss Status / Resolution</a:t>
             </a:r>
           </a:p>
         </p:txBody>
@@ -7944,7 +7945,7 @@
                   <a:srgbClr val="2C3E50"/>
                 </a:solidFill>
               </a:rPr>
-              <a:t>Eigene PI-Intervalle per JSON-Datei; ohne Datei werden Kalenderquartale verwendet</a:t>
+              <a:t>Issues komplett aus allen Metriken entfernen</a:t>
             </a:r>
           </a:p>
         </p:txBody>
@@ -7952,6 +7953,314 @@
       <p:sp>
         <p:nvSpPr>
           <p:cNvPr id="24" name="Rectangle 23"/>
+          <p:cNvSpPr/>
+          <p:nvPr/>
+        </p:nvSpPr>
+        <p:spPr>
+          <a:xfrm>
+            <a:off x="274320" y="3959351"/>
+            <a:ext cx="2926080" cy="658368"/>
+          </a:xfrm>
+          <a:prstGeom prst="rect">
+            <a:avLst/>
+          </a:prstGeom>
+          <a:solidFill>
+            <a:srgbClr val="ECF0F1"/>
+          </a:solidFill>
+          <a:ln>
+            <a:noFill/>
+          </a:ln>
+        </p:spPr>
+        <p:style>
+          <a:lnRef idx="1">
+            <a:schemeClr val="accent1"/>
+          </a:lnRef>
+          <a:fillRef idx="3">
+            <a:schemeClr val="accent1"/>
+          </a:fillRef>
+          <a:effectRef idx="2">
+            <a:schemeClr val="accent1"/>
+          </a:effectRef>
+          <a:fontRef idx="minor">
+            <a:schemeClr val="lt1"/>
+          </a:fontRef>
+        </p:style>
+        <p:txBody>
+          <a:bodyPr rtlCol="0" anchor="ctr"/>
+          <a:lstStyle/>
+          <a:p>
+            <a:pPr algn="ctr"/>
+          </a:p>
+        </p:txBody>
+      </p:sp>
+      <p:sp>
+        <p:nvSpPr>
+          <p:cNvPr id="25" name="Rectangle 24"/>
+          <p:cNvSpPr/>
+          <p:nvPr/>
+        </p:nvSpPr>
+        <p:spPr>
+          <a:xfrm>
+            <a:off x="3291840" y="3959351"/>
+            <a:ext cx="8595360" cy="658368"/>
+          </a:xfrm>
+          <a:prstGeom prst="rect">
+            <a:avLst/>
+          </a:prstGeom>
+          <a:solidFill>
+            <a:srgbClr val="ECF0F1"/>
+          </a:solidFill>
+          <a:ln>
+            <a:noFill/>
+          </a:ln>
+        </p:spPr>
+        <p:style>
+          <a:lnRef idx="1">
+            <a:schemeClr val="accent1"/>
+          </a:lnRef>
+          <a:fillRef idx="3">
+            <a:schemeClr val="accent1"/>
+          </a:fillRef>
+          <a:effectRef idx="2">
+            <a:schemeClr val="accent1"/>
+          </a:effectRef>
+          <a:fontRef idx="minor">
+            <a:schemeClr val="lt1"/>
+          </a:fontRef>
+        </p:style>
+        <p:txBody>
+          <a:bodyPr rtlCol="0" anchor="ctr"/>
+          <a:lstStyle/>
+          <a:p>
+            <a:pPr algn="ctr"/>
+          </a:p>
+        </p:txBody>
+      </p:sp>
+      <p:sp>
+        <p:nvSpPr>
+          <p:cNvPr id="26" name="TextBox 25"/>
+          <p:cNvSpPr txBox="1"/>
+          <p:nvPr/>
+        </p:nvSpPr>
+        <p:spPr>
+          <a:xfrm>
+            <a:off x="347472" y="3995927"/>
+            <a:ext cx="2788920" cy="603503"/>
+          </a:xfrm>
+          <a:prstGeom prst="rect">
+            <a:avLst/>
+          </a:prstGeom>
+          <a:noFill/>
+        </p:spPr>
+        <p:txBody>
+          <a:bodyPr wrap="square">
+            <a:spAutoFit/>
+          </a:bodyPr>
+          <a:lstStyle/>
+          <a:p>
+            <a:pPr algn="l"/>
+            <a:r>
+              <a:rPr sz="900" b="1">
+                <a:solidFill>
+                  <a:srgbClr val="2C3E50"/>
+                </a:solidFill>
+              </a:rPr>
+              <a:t>Zero-Day-Filter</a:t>
+            </a:r>
+          </a:p>
+        </p:txBody>
+      </p:sp>
+      <p:sp>
+        <p:nvSpPr>
+          <p:cNvPr id="27" name="TextBox 26"/>
+          <p:cNvSpPr txBox="1"/>
+          <p:nvPr/>
+        </p:nvSpPr>
+        <p:spPr>
+          <a:xfrm>
+            <a:off x="3364992" y="3995927"/>
+            <a:ext cx="8412480" cy="603503"/>
+          </a:xfrm>
+          <a:prstGeom prst="rect">
+            <a:avLst/>
+          </a:prstGeom>
+          <a:noFill/>
+        </p:spPr>
+        <p:txBody>
+          <a:bodyPr wrap="square">
+            <a:spAutoFit/>
+          </a:bodyPr>
+          <a:lstStyle/>
+          <a:p>
+            <a:pPr algn="l"/>
+            <a:r>
+              <a:rPr sz="900" b="0">
+                <a:solidFill>
+                  <a:srgbClr val="2C3E50"/>
+                </a:solidFill>
+              </a:rPr>
+              <a:t>Konfigurierbarer Schwellwert (Standard 5 min); ausgeschlossene Issues in separater Excel dokumentiert</a:t>
+            </a:r>
+          </a:p>
+        </p:txBody>
+      </p:sp>
+      <p:sp>
+        <p:nvSpPr>
+          <p:cNvPr id="28" name="Rectangle 27"/>
+          <p:cNvSpPr/>
+          <p:nvPr/>
+        </p:nvSpPr>
+        <p:spPr>
+          <a:xfrm>
+            <a:off x="274320" y="4617719"/>
+            <a:ext cx="2926080" cy="658368"/>
+          </a:xfrm>
+          <a:prstGeom prst="rect">
+            <a:avLst/>
+          </a:prstGeom>
+          <a:solidFill>
+            <a:srgbClr val="FFFFFF"/>
+          </a:solidFill>
+          <a:ln>
+            <a:noFill/>
+          </a:ln>
+        </p:spPr>
+        <p:style>
+          <a:lnRef idx="1">
+            <a:schemeClr val="accent1"/>
+          </a:lnRef>
+          <a:fillRef idx="3">
+            <a:schemeClr val="accent1"/>
+          </a:fillRef>
+          <a:effectRef idx="2">
+            <a:schemeClr val="accent1"/>
+          </a:effectRef>
+          <a:fontRef idx="minor">
+            <a:schemeClr val="lt1"/>
+          </a:fontRef>
+        </p:style>
+        <p:txBody>
+          <a:bodyPr rtlCol="0" anchor="ctr"/>
+          <a:lstStyle/>
+          <a:p>
+            <a:pPr algn="ctr"/>
+          </a:p>
+        </p:txBody>
+      </p:sp>
+      <p:sp>
+        <p:nvSpPr>
+          <p:cNvPr id="29" name="Rectangle 28"/>
+          <p:cNvSpPr/>
+          <p:nvPr/>
+        </p:nvSpPr>
+        <p:spPr>
+          <a:xfrm>
+            <a:off x="3291840" y="4617719"/>
+            <a:ext cx="8595360" cy="658368"/>
+          </a:xfrm>
+          <a:prstGeom prst="rect">
+            <a:avLst/>
+          </a:prstGeom>
+          <a:solidFill>
+            <a:srgbClr val="FFFFFF"/>
+          </a:solidFill>
+          <a:ln>
+            <a:noFill/>
+          </a:ln>
+        </p:spPr>
+        <p:style>
+          <a:lnRef idx="1">
+            <a:schemeClr val="accent1"/>
+          </a:lnRef>
+          <a:fillRef idx="3">
+            <a:schemeClr val="accent1"/>
+          </a:fillRef>
+          <a:effectRef idx="2">
+            <a:schemeClr val="accent1"/>
+          </a:effectRef>
+          <a:fontRef idx="minor">
+            <a:schemeClr val="lt1"/>
+          </a:fontRef>
+        </p:style>
+        <p:txBody>
+          <a:bodyPr rtlCol="0" anchor="ctr"/>
+          <a:lstStyle/>
+          <a:p>
+            <a:pPr algn="ctr"/>
+          </a:p>
+        </p:txBody>
+      </p:sp>
+      <p:sp>
+        <p:nvSpPr>
+          <p:cNvPr id="30" name="TextBox 29"/>
+          <p:cNvSpPr txBox="1"/>
+          <p:nvPr/>
+        </p:nvSpPr>
+        <p:spPr>
+          <a:xfrm>
+            <a:off x="347472" y="4654295"/>
+            <a:ext cx="2788920" cy="603503"/>
+          </a:xfrm>
+          <a:prstGeom prst="rect">
+            <a:avLst/>
+          </a:prstGeom>
+          <a:noFill/>
+        </p:spPr>
+        <p:txBody>
+          <a:bodyPr wrap="square">
+            <a:spAutoFit/>
+          </a:bodyPr>
+          <a:lstStyle/>
+          <a:p>
+            <a:pPr algn="l"/>
+            <a:r>
+              <a:rPr sz="900" b="1">
+                <a:solidFill>
+                  <a:srgbClr val="2C3E50"/>
+                </a:solidFill>
+              </a:rPr>
+              <a:t>Datumsfilter-Bugfix</a:t>
+            </a:r>
+          </a:p>
+        </p:txBody>
+      </p:sp>
+      <p:sp>
+        <p:nvSpPr>
+          <p:cNvPr id="31" name="TextBox 30"/>
+          <p:cNvSpPr txBox="1"/>
+          <p:nvPr/>
+        </p:nvSpPr>
+        <p:spPr>
+          <a:xfrm>
+            <a:off x="3364992" y="4654295"/>
+            <a:ext cx="8412480" cy="603503"/>
+          </a:xfrm>
+          <a:prstGeom prst="rect">
+            <a:avLst/>
+          </a:prstGeom>
+          <a:noFill/>
+        </p:spPr>
+        <p:txBody>
+          <a:bodyPr wrap="square">
+            <a:spAutoFit/>
+          </a:bodyPr>
+          <a:lstStyle/>
+          <a:p>
+            <a:pPr algn="l"/>
+            <a:r>
+              <a:rPr sz="900" b="0">
+                <a:solidFill>
+                  <a:srgbClr val="2C3E50"/>
+                </a:solidFill>
+              </a:rPr>
+              <a:t>Offene Issues (kein Closed Date) wurden fälschlich vom Datumsfilter ausgeschlossen — behoben</a:t>
+            </a:r>
+          </a:p>
+        </p:txBody>
+      </p:sp>
+      <p:sp>
+        <p:nvSpPr>
+          <p:cNvPr id="32" name="Rectangle 31"/>
           <p:cNvSpPr/>
           <p:nvPr/>
         </p:nvSpPr>
@@ -8082,7 +8391,7 @@
                   <a:srgbClr val="FFFFFF"/>
                 </a:solidFill>
               </a:rPr>
-              <a:t>build_reports — GUI &amp; UX</a:t>
+              <a:t>build_reports — Export &amp; Reporting</a:t>
             </a:r>
           </a:p>
         </p:txBody>
@@ -8356,7 +8665,7 @@
                   <a:srgbClr val="2C3E50"/>
                 </a:solidFill>
               </a:rPr>
-              <a:t>Terminologie</a:t>
+              <a:t>Browser-Anzeige</a:t>
             </a:r>
           </a:p>
         </p:txBody>
@@ -8390,7 +8699,7 @@
                   <a:srgbClr val="2C3E50"/>
                 </a:solidFill>
               </a:rPr>
-              <a:t>Umschaltung SAFe ↔ Global (Flow Time ↔ Cycle Time etc.)</a:t>
+              <a:t>Vollständig interaktive Plotly-Diagramme im Browser</a:t>
             </a:r>
           </a:p>
         </p:txBody>
@@ -8510,7 +8819,7 @@
                   <a:srgbClr val="2C3E50"/>
                 </a:solidFill>
               </a:rPr>
-              <a:t>Templates</a:t>
+              <a:t>PDF-Export</a:t>
             </a:r>
           </a:p>
         </p:txBody>
@@ -8544,7 +8853,7 @@
                   <a:srgbClr val="2C3E50"/>
                 </a:solidFill>
               </a:rPr>
-              <a:t>Alle Einstellungen als JSON speichern/laden; Ausschlüsse als dauerhafter Standard speicherbar</a:t>
+              <a:t>Mehrseitige PDF mit allen gewählten Metriken</a:t>
             </a:r>
           </a:p>
         </p:txBody>
@@ -8664,7 +8973,7 @@
                   <a:srgbClr val="2C3E50"/>
                 </a:solidFill>
               </a:rPr>
-              <a:t>Tooltips</a:t>
+              <a:t>Report-Excel</a:t>
             </a:r>
           </a:p>
         </p:txBody>
@@ -8698,7 +9007,7 @@
                   <a:srgbClr val="2C3E50"/>
                 </a:solidFill>
               </a:rPr>
-              <a:t>Hover-Tooltips auf allen GUI-Elementen</a:t>
+              <a:t>Wird automatisch beim PDF-Export erzeugt; enthält gefilterte Issues mit Status Group, CT Methode A und B</a:t>
             </a:r>
           </a:p>
         </p:txBody>
@@ -8818,7 +9127,7 @@
                   <a:srgbClr val="2C3E50"/>
                 </a:solidFill>
               </a:rPr>
-              <a:t>Ladebalken</a:t>
+              <a:t>PI-Konfiguration</a:t>
             </a:r>
           </a:p>
         </p:txBody>
@@ -8852,7 +9161,7 @@
                   <a:srgbClr val="2C3E50"/>
                 </a:solidFill>
               </a:rPr>
-              <a:t>Erscheint nach 3 Sekunden bei laufenden Berechnungen</a:t>
+              <a:t>Eigene PI-Intervalle per JSON-Datei; ohne Datei werden Kalenderquartale verwendet</a:t>
             </a:r>
           </a:p>
         </p:txBody>
@@ -8860,468 +9169,6 @@
       <p:sp>
         <p:nvSpPr>
           <p:cNvPr id="24" name="Rectangle 23"/>
-          <p:cNvSpPr/>
-          <p:nvPr/>
-        </p:nvSpPr>
-        <p:spPr>
-          <a:xfrm>
-            <a:off x="274320" y="3959351"/>
-            <a:ext cx="2926080" cy="658368"/>
-          </a:xfrm>
-          <a:prstGeom prst="rect">
-            <a:avLst/>
-          </a:prstGeom>
-          <a:solidFill>
-            <a:srgbClr val="ECF0F1"/>
-          </a:solidFill>
-          <a:ln>
-            <a:noFill/>
-          </a:ln>
-        </p:spPr>
-        <p:style>
-          <a:lnRef idx="1">
-            <a:schemeClr val="accent1"/>
-          </a:lnRef>
-          <a:fillRef idx="3">
-            <a:schemeClr val="accent1"/>
-          </a:fillRef>
-          <a:effectRef idx="2">
-            <a:schemeClr val="accent1"/>
-          </a:effectRef>
-          <a:fontRef idx="minor">
-            <a:schemeClr val="lt1"/>
-          </a:fontRef>
-        </p:style>
-        <p:txBody>
-          <a:bodyPr rtlCol="0" anchor="ctr"/>
-          <a:lstStyle/>
-          <a:p>
-            <a:pPr algn="ctr"/>
-          </a:p>
-        </p:txBody>
-      </p:sp>
-      <p:sp>
-        <p:nvSpPr>
-          <p:cNvPr id="25" name="Rectangle 24"/>
-          <p:cNvSpPr/>
-          <p:nvPr/>
-        </p:nvSpPr>
-        <p:spPr>
-          <a:xfrm>
-            <a:off x="3291840" y="3959351"/>
-            <a:ext cx="8595360" cy="658368"/>
-          </a:xfrm>
-          <a:prstGeom prst="rect">
-            <a:avLst/>
-          </a:prstGeom>
-          <a:solidFill>
-            <a:srgbClr val="ECF0F1"/>
-          </a:solidFill>
-          <a:ln>
-            <a:noFill/>
-          </a:ln>
-        </p:spPr>
-        <p:style>
-          <a:lnRef idx="1">
-            <a:schemeClr val="accent1"/>
-          </a:lnRef>
-          <a:fillRef idx="3">
-            <a:schemeClr val="accent1"/>
-          </a:fillRef>
-          <a:effectRef idx="2">
-            <a:schemeClr val="accent1"/>
-          </a:effectRef>
-          <a:fontRef idx="minor">
-            <a:schemeClr val="lt1"/>
-          </a:fontRef>
-        </p:style>
-        <p:txBody>
-          <a:bodyPr rtlCol="0" anchor="ctr"/>
-          <a:lstStyle/>
-          <a:p>
-            <a:pPr algn="ctr"/>
-          </a:p>
-        </p:txBody>
-      </p:sp>
-      <p:sp>
-        <p:nvSpPr>
-          <p:cNvPr id="26" name="TextBox 25"/>
-          <p:cNvSpPr txBox="1"/>
-          <p:nvPr/>
-        </p:nvSpPr>
-        <p:spPr>
-          <a:xfrm>
-            <a:off x="347472" y="3995927"/>
-            <a:ext cx="2788920" cy="603503"/>
-          </a:xfrm>
-          <a:prstGeom prst="rect">
-            <a:avLst/>
-          </a:prstGeom>
-          <a:noFill/>
-        </p:spPr>
-        <p:txBody>
-          <a:bodyPr wrap="square">
-            <a:spAutoFit/>
-          </a:bodyPr>
-          <a:lstStyle/>
-          <a:p>
-            <a:pPr algn="l"/>
-            <a:r>
-              <a:rPr sz="900" b="1">
-                <a:solidFill>
-                  <a:srgbClr val="2C3E50"/>
-                </a:solidFill>
-              </a:rPr>
-              <a:t>Stage-Konsistenzprüfung</a:t>
-            </a:r>
-          </a:p>
-        </p:txBody>
-      </p:sp>
-      <p:sp>
-        <p:nvSpPr>
-          <p:cNvPr id="27" name="TextBox 26"/>
-          <p:cNvSpPr txBox="1"/>
-          <p:nvPr/>
-        </p:nvSpPr>
-        <p:spPr>
-          <a:xfrm>
-            <a:off x="3364992" y="3995927"/>
-            <a:ext cx="8412480" cy="603503"/>
-          </a:xfrm>
-          <a:prstGeom prst="rect">
-            <a:avLst/>
-          </a:prstGeom>
-          <a:noFill/>
-        </p:spPr>
-        <p:txBody>
-          <a:bodyPr wrap="square">
-            <a:spAutoFit/>
-          </a:bodyPr>
-          <a:lstStyle/>
-          <a:p>
-            <a:pPr algn="l"/>
-            <a:r>
-              <a:rPr sz="900" b="0">
-                <a:solidFill>
-                  <a:srgbClr val="2C3E50"/>
-                </a:solidFill>
-              </a:rPr>
-              <a:t>Warnung wenn IssueTimes und CFD unterschiedliche Stages haben</a:t>
-            </a:r>
-          </a:p>
-        </p:txBody>
-      </p:sp>
-      <p:sp>
-        <p:nvSpPr>
-          <p:cNvPr id="28" name="Rectangle 27"/>
-          <p:cNvSpPr/>
-          <p:nvPr/>
-        </p:nvSpPr>
-        <p:spPr>
-          <a:xfrm>
-            <a:off x="274320" y="4617719"/>
-            <a:ext cx="2926080" cy="658368"/>
-          </a:xfrm>
-          <a:prstGeom prst="rect">
-            <a:avLst/>
-          </a:prstGeom>
-          <a:solidFill>
-            <a:srgbClr val="FFFFFF"/>
-          </a:solidFill>
-          <a:ln>
-            <a:noFill/>
-          </a:ln>
-        </p:spPr>
-        <p:style>
-          <a:lnRef idx="1">
-            <a:schemeClr val="accent1"/>
-          </a:lnRef>
-          <a:fillRef idx="3">
-            <a:schemeClr val="accent1"/>
-          </a:fillRef>
-          <a:effectRef idx="2">
-            <a:schemeClr val="accent1"/>
-          </a:effectRef>
-          <a:fontRef idx="minor">
-            <a:schemeClr val="lt1"/>
-          </a:fontRef>
-        </p:style>
-        <p:txBody>
-          <a:bodyPr rtlCol="0" anchor="ctr"/>
-          <a:lstStyle/>
-          <a:p>
-            <a:pPr algn="ctr"/>
-          </a:p>
-        </p:txBody>
-      </p:sp>
-      <p:sp>
-        <p:nvSpPr>
-          <p:cNvPr id="29" name="Rectangle 28"/>
-          <p:cNvSpPr/>
-          <p:nvPr/>
-        </p:nvSpPr>
-        <p:spPr>
-          <a:xfrm>
-            <a:off x="3291840" y="4617719"/>
-            <a:ext cx="8595360" cy="658368"/>
-          </a:xfrm>
-          <a:prstGeom prst="rect">
-            <a:avLst/>
-          </a:prstGeom>
-          <a:solidFill>
-            <a:srgbClr val="FFFFFF"/>
-          </a:solidFill>
-          <a:ln>
-            <a:noFill/>
-          </a:ln>
-        </p:spPr>
-        <p:style>
-          <a:lnRef idx="1">
-            <a:schemeClr val="accent1"/>
-          </a:lnRef>
-          <a:fillRef idx="3">
-            <a:schemeClr val="accent1"/>
-          </a:fillRef>
-          <a:effectRef idx="2">
-            <a:schemeClr val="accent1"/>
-          </a:effectRef>
-          <a:fontRef idx="minor">
-            <a:schemeClr val="lt1"/>
-          </a:fontRef>
-        </p:style>
-        <p:txBody>
-          <a:bodyPr rtlCol="0" anchor="ctr"/>
-          <a:lstStyle/>
-          <a:p>
-            <a:pPr algn="ctr"/>
-          </a:p>
-        </p:txBody>
-      </p:sp>
-      <p:sp>
-        <p:nvSpPr>
-          <p:cNvPr id="30" name="TextBox 29"/>
-          <p:cNvSpPr txBox="1"/>
-          <p:nvPr/>
-        </p:nvSpPr>
-        <p:spPr>
-          <a:xfrm>
-            <a:off x="347472" y="4654295"/>
-            <a:ext cx="2788920" cy="603503"/>
-          </a:xfrm>
-          <a:prstGeom prst="rect">
-            <a:avLst/>
-          </a:prstGeom>
-          <a:noFill/>
-        </p:spPr>
-        <p:txBody>
-          <a:bodyPr wrap="square">
-            <a:spAutoFit/>
-          </a:bodyPr>
-          <a:lstStyle/>
-          <a:p>
-            <a:pPr algn="l"/>
-            <a:r>
-              <a:rPr sz="900" b="1">
-                <a:solidFill>
-                  <a:srgbClr val="2C3E50"/>
-                </a:solidFill>
-              </a:rPr>
-              <a:t>Kollisionsfreie Annotations</a:t>
-            </a:r>
-          </a:p>
-        </p:txBody>
-      </p:sp>
-      <p:sp>
-        <p:nvSpPr>
-          <p:cNvPr id="31" name="TextBox 30"/>
-          <p:cNvSpPr txBox="1"/>
-          <p:nvPr/>
-        </p:nvSpPr>
-        <p:spPr>
-          <a:xfrm>
-            <a:off x="3364992" y="4654295"/>
-            <a:ext cx="8412480" cy="603503"/>
-          </a:xfrm>
-          <a:prstGeom prst="rect">
-            <a:avLst/>
-          </a:prstGeom>
-          <a:noFill/>
-        </p:spPr>
-        <p:txBody>
-          <a:bodyPr wrap="square">
-            <a:spAutoFit/>
-          </a:bodyPr>
-          <a:lstStyle/>
-          <a:p>
-            <a:pPr algn="l"/>
-            <a:r>
-              <a:rPr sz="900" b="0">
-                <a:solidFill>
-                  <a:srgbClr val="2C3E50"/>
-                </a:solidFill>
-              </a:rPr>
-              <a:t>Referenzlinien-Labels weichen automatisch aus wenn sie sich überlappen</a:t>
-            </a:r>
-          </a:p>
-        </p:txBody>
-      </p:sp>
-      <p:sp>
-        <p:nvSpPr>
-          <p:cNvPr id="32" name="Rectangle 31"/>
-          <p:cNvSpPr/>
-          <p:nvPr/>
-        </p:nvSpPr>
-        <p:spPr>
-          <a:xfrm>
-            <a:off x="274320" y="5276087"/>
-            <a:ext cx="2926080" cy="658368"/>
-          </a:xfrm>
-          <a:prstGeom prst="rect">
-            <a:avLst/>
-          </a:prstGeom>
-          <a:solidFill>
-            <a:srgbClr val="ECF0F1"/>
-          </a:solidFill>
-          <a:ln>
-            <a:noFill/>
-          </a:ln>
-        </p:spPr>
-        <p:style>
-          <a:lnRef idx="1">
-            <a:schemeClr val="accent1"/>
-          </a:lnRef>
-          <a:fillRef idx="3">
-            <a:schemeClr val="accent1"/>
-          </a:fillRef>
-          <a:effectRef idx="2">
-            <a:schemeClr val="accent1"/>
-          </a:effectRef>
-          <a:fontRef idx="minor">
-            <a:schemeClr val="lt1"/>
-          </a:fontRef>
-        </p:style>
-        <p:txBody>
-          <a:bodyPr rtlCol="0" anchor="ctr"/>
-          <a:lstStyle/>
-          <a:p>
-            <a:pPr algn="ctr"/>
-          </a:p>
-        </p:txBody>
-      </p:sp>
-      <p:sp>
-        <p:nvSpPr>
-          <p:cNvPr id="33" name="Rectangle 32"/>
-          <p:cNvSpPr/>
-          <p:nvPr/>
-        </p:nvSpPr>
-        <p:spPr>
-          <a:xfrm>
-            <a:off x="3291840" y="5276087"/>
-            <a:ext cx="8595360" cy="658368"/>
-          </a:xfrm>
-          <a:prstGeom prst="rect">
-            <a:avLst/>
-          </a:prstGeom>
-          <a:solidFill>
-            <a:srgbClr val="ECF0F1"/>
-          </a:solidFill>
-          <a:ln>
-            <a:noFill/>
-          </a:ln>
-        </p:spPr>
-        <p:style>
-          <a:lnRef idx="1">
-            <a:schemeClr val="accent1"/>
-          </a:lnRef>
-          <a:fillRef idx="3">
-            <a:schemeClr val="accent1"/>
-          </a:fillRef>
-          <a:effectRef idx="2">
-            <a:schemeClr val="accent1"/>
-          </a:effectRef>
-          <a:fontRef idx="minor">
-            <a:schemeClr val="lt1"/>
-          </a:fontRef>
-        </p:style>
-        <p:txBody>
-          <a:bodyPr rtlCol="0" anchor="ctr"/>
-          <a:lstStyle/>
-          <a:p>
-            <a:pPr algn="ctr"/>
-          </a:p>
-        </p:txBody>
-      </p:sp>
-      <p:sp>
-        <p:nvSpPr>
-          <p:cNvPr id="34" name="TextBox 33"/>
-          <p:cNvSpPr txBox="1"/>
-          <p:nvPr/>
-        </p:nvSpPr>
-        <p:spPr>
-          <a:xfrm>
-            <a:off x="347472" y="5312663"/>
-            <a:ext cx="2788920" cy="603503"/>
-          </a:xfrm>
-          <a:prstGeom prst="rect">
-            <a:avLst/>
-          </a:prstGeom>
-          <a:noFill/>
-        </p:spPr>
-        <p:txBody>
-          <a:bodyPr wrap="square">
-            <a:spAutoFit/>
-          </a:bodyPr>
-          <a:lstStyle/>
-          <a:p>
-            <a:pPr algn="l"/>
-            <a:r>
-              <a:rPr sz="900" b="1">
-                <a:solidFill>
-                  <a:srgbClr val="2C3E50"/>
-                </a:solidFill>
-              </a:rPr>
-              <a:t>Doppelklick-Starter</a:t>
-            </a:r>
-          </a:p>
-        </p:txBody>
-      </p:sp>
-      <p:sp>
-        <p:nvSpPr>
-          <p:cNvPr id="35" name="TextBox 34"/>
-          <p:cNvSpPr txBox="1"/>
-          <p:nvPr/>
-        </p:nvSpPr>
-        <p:spPr>
-          <a:xfrm>
-            <a:off x="3364992" y="5312663"/>
-            <a:ext cx="8412480" cy="603503"/>
-          </a:xfrm>
-          <a:prstGeom prst="rect">
-            <a:avLst/>
-          </a:prstGeom>
-          <a:noFill/>
-        </p:spPr>
-        <p:txBody>
-          <a:bodyPr wrap="square">
-            <a:spAutoFit/>
-          </a:bodyPr>
-          <a:lstStyle/>
-          <a:p>
-            <a:pPr algn="l"/>
-            <a:r>
-              <a:rPr sz="900" b="0">
-                <a:solidFill>
-                  <a:srgbClr val="2C3E50"/>
-                </a:solidFill>
-              </a:rPr>
-              <a:t>build_reports_gui.pyw startet die GUI ohne Konsolenfenster</a:t>
-            </a:r>
-          </a:p>
-        </p:txBody>
-      </p:sp>
-      <p:sp>
-        <p:nvSpPr>
-          <p:cNvPr id="36" name="Rectangle 35"/>
           <p:cNvSpPr/>
           <p:nvPr/>
         </p:nvSpPr>
@@ -9452,7 +9299,7 @@
                   <a:srgbClr val="FFFFFF"/>
                 </a:solidFill>
               </a:rPr>
-              <a:t>Infrastruktur &amp; Dokumentation</a:t>
+              <a:t>build_reports — GUI &amp; UX</a:t>
             </a:r>
           </a:p>
         </p:txBody>
@@ -9726,7 +9573,7 @@
                   <a:srgbClr val="2C3E50"/>
                 </a:solidFill>
               </a:rPr>
-              <a:t>Versionierung</a:t>
+              <a:t>Terminologie</a:t>
             </a:r>
           </a:p>
         </p:txBody>
@@ -9760,7 +9607,7 @@
                   <a:srgbClr val="2C3E50"/>
                 </a:solidFill>
               </a:rPr>
-              <a:t>SemVer ab v0.2.0; zentrale version.py wird von beiden GUIs und den Manuals gelesen</a:t>
+              <a:t>Umschaltung SAFe ↔ Global (Flow Time ↔ Cycle Time etc.)</a:t>
             </a:r>
           </a:p>
         </p:txBody>
@@ -9880,7 +9727,7 @@
                   <a:srgbClr val="2C3E50"/>
                 </a:solidFill>
               </a:rPr>
-              <a:t>Sprachauswahl</a:t>
+              <a:t>Templates</a:t>
             </a:r>
           </a:p>
         </p:txBody>
@@ -9914,7 +9761,7 @@
                   <a:srgbClr val="2C3E50"/>
                 </a:solidFill>
               </a:rPr>
-              <a:t>DE/EN in beiden GUIs; Flagge 🇩🇪/🇬🇧 ganz rechts im Menüband; letzte Wahl wird in ~/.situation_report/prefs.json gespeichert</a:t>
+              <a:t>Alle Einstellungen als JSON speichern/laden; Ausschlüsse als dauerhafter Standard speicherbar; Menü-Dialog zuverlässig auf allen Windows-Displays dank parent=self und Hover-Scroll-Binding</a:t>
             </a:r>
           </a:p>
         </p:txBody>
@@ -10034,7 +9881,7 @@
                   <a:srgbClr val="2C3E50"/>
                 </a:solidFill>
               </a:rPr>
-              <a:t>PDF-Manuals</a:t>
+              <a:t>Tooltips</a:t>
             </a:r>
           </a:p>
         </p:txBody>
@@ -10068,7 +9915,7 @@
                   <a:srgbClr val="2C3E50"/>
                 </a:solidFill>
               </a:rPr>
-              <a:t>Benutzerhandbuch (DE) + User Manual (EN) für build_reports und transform_data; generiert mit ReportLab inkl. echter Beispieldiagramme</a:t>
+              <a:t>Hover-Tooltips auf allen GUI-Elementen</a:t>
             </a:r>
           </a:p>
         </p:txBody>
@@ -10188,7 +10035,7 @@
                   <a:srgbClr val="2C3E50"/>
                 </a:solidFill>
               </a:rPr>
-              <a:t>Manual-Link in GUI</a:t>
+              <a:t>Ladebalken</a:t>
             </a:r>
           </a:p>
         </p:txBody>
@@ -10222,7 +10069,7 @@
                   <a:srgbClr val="2C3E50"/>
                 </a:solidFill>
               </a:rPr>
-              <a:t>Hilfe-Menü öffnet das sprachpassende PDF direkt auf GitHub Pages</a:t>
+              <a:t>Erscheint nach 3 Sekunden bei laufenden Berechnungen</a:t>
             </a:r>
           </a:p>
         </p:txBody>
@@ -10342,7 +10189,7 @@
                   <a:srgbClr val="2C3E50"/>
                 </a:solidFill>
               </a:rPr>
-              <a:t>GitHub Pages Doku</a:t>
+              <a:t>Stage-Konsistenzprüfung</a:t>
             </a:r>
           </a:p>
         </p:txBody>
@@ -10376,7 +10223,7 @@
                   <a:srgbClr val="2C3E50"/>
                 </a:solidFill>
               </a:rPr>
-              <a:t>MkDocs-Site mit DE/EN-Doku für alle Module; Architektur nach C4-Modell</a:t>
+              <a:t>Warnung wenn IssueTimes und CFD unterschiedliche Stages haben</a:t>
             </a:r>
           </a:p>
         </p:txBody>
@@ -10496,7 +10343,7 @@
                   <a:srgbClr val="2C3E50"/>
                 </a:solidFill>
               </a:rPr>
-              <a:t>CI/CD</a:t>
+              <a:t>Kollisionsfreie Annotations</a:t>
             </a:r>
           </a:p>
         </p:txBody>
@@ -10530,7 +10377,7 @@
                   <a:srgbClr val="2C3E50"/>
                 </a:solidFill>
               </a:rPr>
-              <a:t>GitHub Actions für automatisches Docs-Deployment</a:t>
+              <a:t>Referenzlinien-Labels weichen automatisch aus wenn sie sich überlappen</a:t>
             </a:r>
           </a:p>
         </p:txBody>
@@ -10650,7 +10497,7 @@
                   <a:srgbClr val="2C3E50"/>
                 </a:solidFill>
               </a:rPr>
-              <a:t>Tests</a:t>
+              <a:t>Doppelklick-Starter</a:t>
             </a:r>
           </a:p>
         </p:txBody>
@@ -10684,7 +10531,1531 @@
                   <a:srgbClr val="2C3E50"/>
                 </a:solidFill>
               </a:rPr>
-              <a:t>Unit- und Acceptance-Tests für beide Module; aktuell 448 Tests</a:t>
+              <a:t>build_reports_gui.pyw startet die GUI ohne Konsolenfenster</a:t>
+            </a:r>
+          </a:p>
+        </p:txBody>
+      </p:sp>
+      <p:sp>
+        <p:nvSpPr>
+          <p:cNvPr id="36" name="Rectangle 35"/>
+          <p:cNvSpPr/>
+          <p:nvPr/>
+        </p:nvSpPr>
+        <p:spPr>
+          <a:xfrm>
+            <a:off x="274320" y="5934455"/>
+            <a:ext cx="2926080" cy="658368"/>
+          </a:xfrm>
+          <a:prstGeom prst="rect">
+            <a:avLst/>
+          </a:prstGeom>
+          <a:solidFill>
+            <a:srgbClr val="FFFFFF"/>
+          </a:solidFill>
+          <a:ln>
+            <a:noFill/>
+          </a:ln>
+        </p:spPr>
+        <p:style>
+          <a:lnRef idx="1">
+            <a:schemeClr val="accent1"/>
+          </a:lnRef>
+          <a:fillRef idx="3">
+            <a:schemeClr val="accent1"/>
+          </a:fillRef>
+          <a:effectRef idx="2">
+            <a:schemeClr val="accent1"/>
+          </a:effectRef>
+          <a:fontRef idx="minor">
+            <a:schemeClr val="lt1"/>
+          </a:fontRef>
+        </p:style>
+        <p:txBody>
+          <a:bodyPr rtlCol="0" anchor="ctr"/>
+          <a:lstStyle/>
+          <a:p>
+            <a:pPr algn="ctr"/>
+          </a:p>
+        </p:txBody>
+      </p:sp>
+      <p:sp>
+        <p:nvSpPr>
+          <p:cNvPr id="37" name="Rectangle 36"/>
+          <p:cNvSpPr/>
+          <p:nvPr/>
+        </p:nvSpPr>
+        <p:spPr>
+          <a:xfrm>
+            <a:off x="3291840" y="5934455"/>
+            <a:ext cx="8595360" cy="658368"/>
+          </a:xfrm>
+          <a:prstGeom prst="rect">
+            <a:avLst/>
+          </a:prstGeom>
+          <a:solidFill>
+            <a:srgbClr val="FFFFFF"/>
+          </a:solidFill>
+          <a:ln>
+            <a:noFill/>
+          </a:ln>
+        </p:spPr>
+        <p:style>
+          <a:lnRef idx="1">
+            <a:schemeClr val="accent1"/>
+          </a:lnRef>
+          <a:fillRef idx="3">
+            <a:schemeClr val="accent1"/>
+          </a:fillRef>
+          <a:effectRef idx="2">
+            <a:schemeClr val="accent1"/>
+          </a:effectRef>
+          <a:fontRef idx="minor">
+            <a:schemeClr val="lt1"/>
+          </a:fontRef>
+        </p:style>
+        <p:txBody>
+          <a:bodyPr rtlCol="0" anchor="ctr"/>
+          <a:lstStyle/>
+          <a:p>
+            <a:pPr algn="ctr"/>
+          </a:p>
+        </p:txBody>
+      </p:sp>
+      <p:sp>
+        <p:nvSpPr>
+          <p:cNvPr id="38" name="TextBox 37"/>
+          <p:cNvSpPr txBox="1"/>
+          <p:nvPr/>
+        </p:nvSpPr>
+        <p:spPr>
+          <a:xfrm>
+            <a:off x="347472" y="5971031"/>
+            <a:ext cx="2788920" cy="603503"/>
+          </a:xfrm>
+          <a:prstGeom prst="rect">
+            <a:avLst/>
+          </a:prstGeom>
+          <a:noFill/>
+        </p:spPr>
+        <p:txBody>
+          <a:bodyPr wrap="square">
+            <a:spAutoFit/>
+          </a:bodyPr>
+          <a:lstStyle/>
+          <a:p>
+            <a:pPr algn="l"/>
+            <a:r>
+              <a:rPr sz="900" b="1">
+                <a:solidFill>
+                  <a:srgbClr val="2C3E50"/>
+                </a:solidFill>
+              </a:rPr>
+              <a:t>Scrollbare Form</a:t>
+            </a:r>
+          </a:p>
+        </p:txBody>
+      </p:sp>
+      <p:sp>
+        <p:nvSpPr>
+          <p:cNvPr id="39" name="TextBox 38"/>
+          <p:cNvSpPr txBox="1"/>
+          <p:nvPr/>
+        </p:nvSpPr>
+        <p:spPr>
+          <a:xfrm>
+            <a:off x="3364992" y="5971031"/>
+            <a:ext cx="8412480" cy="603503"/>
+          </a:xfrm>
+          <a:prstGeom prst="rect">
+            <a:avLst/>
+          </a:prstGeom>
+          <a:noFill/>
+        </p:spPr>
+        <p:txBody>
+          <a:bodyPr wrap="square">
+            <a:spAutoFit/>
+          </a:bodyPr>
+          <a:lstStyle/>
+          <a:p>
+            <a:pPr algn="l"/>
+            <a:r>
+              <a:rPr sz="900" b="0">
+                <a:solidFill>
+                  <a:srgbClr val="2C3E50"/>
+                </a:solidFill>
+              </a:rPr>
+              <a:t>Formbereich in Canvas gewrappt — vollständig scrollbar auf FullHD-Displays (1080p); Log-Bereich fest am unteren Rand</a:t>
+            </a:r>
+          </a:p>
+        </p:txBody>
+      </p:sp>
+      <p:sp>
+        <p:nvSpPr>
+          <p:cNvPr id="40" name="Rectangle 39"/>
+          <p:cNvSpPr/>
+          <p:nvPr/>
+        </p:nvSpPr>
+        <p:spPr>
+          <a:xfrm>
+            <a:off x="0" y="6720840"/>
+            <a:ext cx="12188952" cy="137160"/>
+          </a:xfrm>
+          <a:prstGeom prst="rect">
+            <a:avLst/>
+          </a:prstGeom>
+          <a:solidFill>
+            <a:srgbClr val="2980B9"/>
+          </a:solidFill>
+          <a:ln>
+            <a:noFill/>
+          </a:ln>
+        </p:spPr>
+        <p:style>
+          <a:lnRef idx="1">
+            <a:schemeClr val="accent1"/>
+          </a:lnRef>
+          <a:fillRef idx="3">
+            <a:schemeClr val="accent1"/>
+          </a:fillRef>
+          <a:effectRef idx="2">
+            <a:schemeClr val="accent1"/>
+          </a:effectRef>
+          <a:fontRef idx="minor">
+            <a:schemeClr val="lt1"/>
+          </a:fontRef>
+        </p:style>
+        <p:txBody>
+          <a:bodyPr rtlCol="0" anchor="ctr"/>
+          <a:lstStyle/>
+          <a:p>
+            <a:pPr algn="ctr"/>
+          </a:p>
+        </p:txBody>
+      </p:sp>
+    </p:spTree>
+  </p:cSld>
+  <p:clrMapOvr>
+    <a:masterClrMapping/>
+  </p:clrMapOvr>
+</p:sld>
+</file>
+
+<file path=ppt/slides/slide8.xml><?xml version="1.0" encoding="utf-8"?>
+<p:sld xmlns:a="http://schemas.openxmlformats.org/drawingml/2006/main" xmlns:p="http://schemas.openxmlformats.org/presentationml/2006/main" xmlns:r="http://schemas.openxmlformats.org/officeDocument/2006/relationships">
+  <p:cSld>
+    <p:spTree>
+      <p:nvGrpSpPr>
+        <p:cNvPr id="1" name=""/>
+        <p:cNvGrpSpPr/>
+        <p:nvPr/>
+      </p:nvGrpSpPr>
+      <p:grpSpPr/>
+      <p:sp>
+        <p:nvSpPr>
+          <p:cNvPr id="2" name="Rectangle 1"/>
+          <p:cNvSpPr/>
+          <p:nvPr/>
+        </p:nvSpPr>
+        <p:spPr>
+          <a:xfrm>
+            <a:off x="0" y="0"/>
+            <a:ext cx="12188952" cy="822960"/>
+          </a:xfrm>
+          <a:prstGeom prst="rect">
+            <a:avLst/>
+          </a:prstGeom>
+          <a:solidFill>
+            <a:srgbClr val="2C3E50"/>
+          </a:solidFill>
+          <a:ln>
+            <a:noFill/>
+          </a:ln>
+        </p:spPr>
+        <p:style>
+          <a:lnRef idx="1">
+            <a:schemeClr val="accent1"/>
+          </a:lnRef>
+          <a:fillRef idx="3">
+            <a:schemeClr val="accent1"/>
+          </a:fillRef>
+          <a:effectRef idx="2">
+            <a:schemeClr val="accent1"/>
+          </a:effectRef>
+          <a:fontRef idx="minor">
+            <a:schemeClr val="lt1"/>
+          </a:fontRef>
+        </p:style>
+        <p:txBody>
+          <a:bodyPr rtlCol="0" anchor="ctr"/>
+          <a:lstStyle/>
+          <a:p>
+            <a:pPr algn="ctr"/>
+          </a:p>
+        </p:txBody>
+      </p:sp>
+      <p:sp>
+        <p:nvSpPr>
+          <p:cNvPr id="3" name="TextBox 2"/>
+          <p:cNvSpPr txBox="1"/>
+          <p:nvPr/>
+        </p:nvSpPr>
+        <p:spPr>
+          <a:xfrm>
+            <a:off x="274320" y="91440"/>
+            <a:ext cx="11612880" cy="640080"/>
+          </a:xfrm>
+          <a:prstGeom prst="rect">
+            <a:avLst/>
+          </a:prstGeom>
+          <a:noFill/>
+        </p:spPr>
+        <p:txBody>
+          <a:bodyPr wrap="square">
+            <a:spAutoFit/>
+          </a:bodyPr>
+          <a:lstStyle/>
+          <a:p>
+            <a:pPr algn="l"/>
+            <a:r>
+              <a:rPr sz="2200" b="1">
+                <a:solidFill>
+                  <a:srgbClr val="FFFFFF"/>
+                </a:solidFill>
+              </a:rPr>
+              <a:t>Infrastruktur &amp; Dokumentation</a:t>
+            </a:r>
+          </a:p>
+        </p:txBody>
+      </p:sp>
+      <p:sp>
+        <p:nvSpPr>
+          <p:cNvPr id="4" name="Rectangle 3"/>
+          <p:cNvSpPr/>
+          <p:nvPr/>
+        </p:nvSpPr>
+        <p:spPr>
+          <a:xfrm>
+            <a:off x="274320" y="914400"/>
+            <a:ext cx="2926080" cy="320040"/>
+          </a:xfrm>
+          <a:prstGeom prst="rect">
+            <a:avLst/>
+          </a:prstGeom>
+          <a:solidFill>
+            <a:srgbClr val="2980B9"/>
+          </a:solidFill>
+          <a:ln>
+            <a:noFill/>
+          </a:ln>
+        </p:spPr>
+        <p:style>
+          <a:lnRef idx="1">
+            <a:schemeClr val="accent1"/>
+          </a:lnRef>
+          <a:fillRef idx="3">
+            <a:schemeClr val="accent1"/>
+          </a:fillRef>
+          <a:effectRef idx="2">
+            <a:schemeClr val="accent1"/>
+          </a:effectRef>
+          <a:fontRef idx="minor">
+            <a:schemeClr val="lt1"/>
+          </a:fontRef>
+        </p:style>
+        <p:txBody>
+          <a:bodyPr rtlCol="0" anchor="ctr"/>
+          <a:lstStyle/>
+          <a:p>
+            <a:pPr algn="ctr"/>
+          </a:p>
+        </p:txBody>
+      </p:sp>
+      <p:sp>
+        <p:nvSpPr>
+          <p:cNvPr id="5" name="Rectangle 4"/>
+          <p:cNvSpPr/>
+          <p:nvPr/>
+        </p:nvSpPr>
+        <p:spPr>
+          <a:xfrm>
+            <a:off x="3291840" y="914400"/>
+            <a:ext cx="8595360" cy="320040"/>
+          </a:xfrm>
+          <a:prstGeom prst="rect">
+            <a:avLst/>
+          </a:prstGeom>
+          <a:solidFill>
+            <a:srgbClr val="2980B9"/>
+          </a:solidFill>
+          <a:ln>
+            <a:noFill/>
+          </a:ln>
+        </p:spPr>
+        <p:style>
+          <a:lnRef idx="1">
+            <a:schemeClr val="accent1"/>
+          </a:lnRef>
+          <a:fillRef idx="3">
+            <a:schemeClr val="accent1"/>
+          </a:fillRef>
+          <a:effectRef idx="2">
+            <a:schemeClr val="accent1"/>
+          </a:effectRef>
+          <a:fontRef idx="minor">
+            <a:schemeClr val="lt1"/>
+          </a:fontRef>
+        </p:style>
+        <p:txBody>
+          <a:bodyPr rtlCol="0" anchor="ctr"/>
+          <a:lstStyle/>
+          <a:p>
+            <a:pPr algn="ctr"/>
+          </a:p>
+        </p:txBody>
+      </p:sp>
+      <p:sp>
+        <p:nvSpPr>
+          <p:cNvPr id="6" name="TextBox 5"/>
+          <p:cNvSpPr txBox="1"/>
+          <p:nvPr/>
+        </p:nvSpPr>
+        <p:spPr>
+          <a:xfrm>
+            <a:off x="320040" y="932688"/>
+            <a:ext cx="2834640" cy="274320"/>
+          </a:xfrm>
+          <a:prstGeom prst="rect">
+            <a:avLst/>
+          </a:prstGeom>
+          <a:noFill/>
+        </p:spPr>
+        <p:txBody>
+          <a:bodyPr wrap="square">
+            <a:spAutoFit/>
+          </a:bodyPr>
+          <a:lstStyle/>
+          <a:p>
+            <a:pPr algn="l"/>
+            <a:r>
+              <a:rPr sz="900" b="1">
+                <a:solidFill>
+                  <a:srgbClr val="FFFFFF"/>
+                </a:solidFill>
+              </a:rPr>
+              <a:t>Feature</a:t>
+            </a:r>
+          </a:p>
+        </p:txBody>
+      </p:sp>
+      <p:sp>
+        <p:nvSpPr>
+          <p:cNvPr id="7" name="TextBox 6"/>
+          <p:cNvSpPr txBox="1"/>
+          <p:nvPr/>
+        </p:nvSpPr>
+        <p:spPr>
+          <a:xfrm>
+            <a:off x="3337560" y="932688"/>
+            <a:ext cx="8503920" cy="274320"/>
+          </a:xfrm>
+          <a:prstGeom prst="rect">
+            <a:avLst/>
+          </a:prstGeom>
+          <a:noFill/>
+        </p:spPr>
+        <p:txBody>
+          <a:bodyPr wrap="square">
+            <a:spAutoFit/>
+          </a:bodyPr>
+          <a:lstStyle/>
+          <a:p>
+            <a:pPr algn="l"/>
+            <a:r>
+              <a:rPr sz="900" b="1">
+                <a:solidFill>
+                  <a:srgbClr val="FFFFFF"/>
+                </a:solidFill>
+              </a:rPr>
+              <a:t>Beschreibung</a:t>
+            </a:r>
+          </a:p>
+        </p:txBody>
+      </p:sp>
+      <p:sp>
+        <p:nvSpPr>
+          <p:cNvPr id="8" name="Rectangle 7"/>
+          <p:cNvSpPr/>
+          <p:nvPr/>
+        </p:nvSpPr>
+        <p:spPr>
+          <a:xfrm>
+            <a:off x="274320" y="1325880"/>
+            <a:ext cx="2926080" cy="658368"/>
+          </a:xfrm>
+          <a:prstGeom prst="rect">
+            <a:avLst/>
+          </a:prstGeom>
+          <a:solidFill>
+            <a:srgbClr val="ECF0F1"/>
+          </a:solidFill>
+          <a:ln>
+            <a:noFill/>
+          </a:ln>
+        </p:spPr>
+        <p:style>
+          <a:lnRef idx="1">
+            <a:schemeClr val="accent1"/>
+          </a:lnRef>
+          <a:fillRef idx="3">
+            <a:schemeClr val="accent1"/>
+          </a:fillRef>
+          <a:effectRef idx="2">
+            <a:schemeClr val="accent1"/>
+          </a:effectRef>
+          <a:fontRef idx="minor">
+            <a:schemeClr val="lt1"/>
+          </a:fontRef>
+        </p:style>
+        <p:txBody>
+          <a:bodyPr rtlCol="0" anchor="ctr"/>
+          <a:lstStyle/>
+          <a:p>
+            <a:pPr algn="ctr"/>
+          </a:p>
+        </p:txBody>
+      </p:sp>
+      <p:sp>
+        <p:nvSpPr>
+          <p:cNvPr id="9" name="Rectangle 8"/>
+          <p:cNvSpPr/>
+          <p:nvPr/>
+        </p:nvSpPr>
+        <p:spPr>
+          <a:xfrm>
+            <a:off x="3291840" y="1325880"/>
+            <a:ext cx="8595360" cy="658368"/>
+          </a:xfrm>
+          <a:prstGeom prst="rect">
+            <a:avLst/>
+          </a:prstGeom>
+          <a:solidFill>
+            <a:srgbClr val="ECF0F1"/>
+          </a:solidFill>
+          <a:ln>
+            <a:noFill/>
+          </a:ln>
+        </p:spPr>
+        <p:style>
+          <a:lnRef idx="1">
+            <a:schemeClr val="accent1"/>
+          </a:lnRef>
+          <a:fillRef idx="3">
+            <a:schemeClr val="accent1"/>
+          </a:fillRef>
+          <a:effectRef idx="2">
+            <a:schemeClr val="accent1"/>
+          </a:effectRef>
+          <a:fontRef idx="minor">
+            <a:schemeClr val="lt1"/>
+          </a:fontRef>
+        </p:style>
+        <p:txBody>
+          <a:bodyPr rtlCol="0" anchor="ctr"/>
+          <a:lstStyle/>
+          <a:p>
+            <a:pPr algn="ctr"/>
+          </a:p>
+        </p:txBody>
+      </p:sp>
+      <p:sp>
+        <p:nvSpPr>
+          <p:cNvPr id="10" name="TextBox 9"/>
+          <p:cNvSpPr txBox="1"/>
+          <p:nvPr/>
+        </p:nvSpPr>
+        <p:spPr>
+          <a:xfrm>
+            <a:off x="347472" y="1362456"/>
+            <a:ext cx="2788920" cy="603503"/>
+          </a:xfrm>
+          <a:prstGeom prst="rect">
+            <a:avLst/>
+          </a:prstGeom>
+          <a:noFill/>
+        </p:spPr>
+        <p:txBody>
+          <a:bodyPr wrap="square">
+            <a:spAutoFit/>
+          </a:bodyPr>
+          <a:lstStyle/>
+          <a:p>
+            <a:pPr algn="l"/>
+            <a:r>
+              <a:rPr sz="900" b="1">
+                <a:solidFill>
+                  <a:srgbClr val="2C3E50"/>
+                </a:solidFill>
+              </a:rPr>
+              <a:t>Versionierung</a:t>
+            </a:r>
+          </a:p>
+        </p:txBody>
+      </p:sp>
+      <p:sp>
+        <p:nvSpPr>
+          <p:cNvPr id="11" name="TextBox 10"/>
+          <p:cNvSpPr txBox="1"/>
+          <p:nvPr/>
+        </p:nvSpPr>
+        <p:spPr>
+          <a:xfrm>
+            <a:off x="3364992" y="1362456"/>
+            <a:ext cx="8412480" cy="603503"/>
+          </a:xfrm>
+          <a:prstGeom prst="rect">
+            <a:avLst/>
+          </a:prstGeom>
+          <a:noFill/>
+        </p:spPr>
+        <p:txBody>
+          <a:bodyPr wrap="square">
+            <a:spAutoFit/>
+          </a:bodyPr>
+          <a:lstStyle/>
+          <a:p>
+            <a:pPr algn="l"/>
+            <a:r>
+              <a:rPr sz="900" b="0">
+                <a:solidFill>
+                  <a:srgbClr val="2C3E50"/>
+                </a:solidFill>
+              </a:rPr>
+              <a:t>SemVer ab v0.2.0; zentrale version.py wird von allen GUIs und den Manuals gelesen; aktuell v0.8.4</a:t>
+            </a:r>
+          </a:p>
+        </p:txBody>
+      </p:sp>
+      <p:sp>
+        <p:nvSpPr>
+          <p:cNvPr id="12" name="Rectangle 11"/>
+          <p:cNvSpPr/>
+          <p:nvPr/>
+        </p:nvSpPr>
+        <p:spPr>
+          <a:xfrm>
+            <a:off x="274320" y="1984248"/>
+            <a:ext cx="2926080" cy="658368"/>
+          </a:xfrm>
+          <a:prstGeom prst="rect">
+            <a:avLst/>
+          </a:prstGeom>
+          <a:solidFill>
+            <a:srgbClr val="FFFFFF"/>
+          </a:solidFill>
+          <a:ln>
+            <a:noFill/>
+          </a:ln>
+        </p:spPr>
+        <p:style>
+          <a:lnRef idx="1">
+            <a:schemeClr val="accent1"/>
+          </a:lnRef>
+          <a:fillRef idx="3">
+            <a:schemeClr val="accent1"/>
+          </a:fillRef>
+          <a:effectRef idx="2">
+            <a:schemeClr val="accent1"/>
+          </a:effectRef>
+          <a:fontRef idx="minor">
+            <a:schemeClr val="lt1"/>
+          </a:fontRef>
+        </p:style>
+        <p:txBody>
+          <a:bodyPr rtlCol="0" anchor="ctr"/>
+          <a:lstStyle/>
+          <a:p>
+            <a:pPr algn="ctr"/>
+          </a:p>
+        </p:txBody>
+      </p:sp>
+      <p:sp>
+        <p:nvSpPr>
+          <p:cNvPr id="13" name="Rectangle 12"/>
+          <p:cNvSpPr/>
+          <p:nvPr/>
+        </p:nvSpPr>
+        <p:spPr>
+          <a:xfrm>
+            <a:off x="3291840" y="1984248"/>
+            <a:ext cx="8595360" cy="658368"/>
+          </a:xfrm>
+          <a:prstGeom prst="rect">
+            <a:avLst/>
+          </a:prstGeom>
+          <a:solidFill>
+            <a:srgbClr val="FFFFFF"/>
+          </a:solidFill>
+          <a:ln>
+            <a:noFill/>
+          </a:ln>
+        </p:spPr>
+        <p:style>
+          <a:lnRef idx="1">
+            <a:schemeClr val="accent1"/>
+          </a:lnRef>
+          <a:fillRef idx="3">
+            <a:schemeClr val="accent1"/>
+          </a:fillRef>
+          <a:effectRef idx="2">
+            <a:schemeClr val="accent1"/>
+          </a:effectRef>
+          <a:fontRef idx="minor">
+            <a:schemeClr val="lt1"/>
+          </a:fontRef>
+        </p:style>
+        <p:txBody>
+          <a:bodyPr rtlCol="0" anchor="ctr"/>
+          <a:lstStyle/>
+          <a:p>
+            <a:pPr algn="ctr"/>
+          </a:p>
+        </p:txBody>
+      </p:sp>
+      <p:sp>
+        <p:nvSpPr>
+          <p:cNvPr id="14" name="TextBox 13"/>
+          <p:cNvSpPr txBox="1"/>
+          <p:nvPr/>
+        </p:nvSpPr>
+        <p:spPr>
+          <a:xfrm>
+            <a:off x="347472" y="2020824"/>
+            <a:ext cx="2788920" cy="603503"/>
+          </a:xfrm>
+          <a:prstGeom prst="rect">
+            <a:avLst/>
+          </a:prstGeom>
+          <a:noFill/>
+        </p:spPr>
+        <p:txBody>
+          <a:bodyPr wrap="square">
+            <a:spAutoFit/>
+          </a:bodyPr>
+          <a:lstStyle/>
+          <a:p>
+            <a:pPr algn="l"/>
+            <a:r>
+              <a:rPr sz="900" b="1">
+                <a:solidFill>
+                  <a:srgbClr val="2C3E50"/>
+                </a:solidFill>
+              </a:rPr>
+              <a:t>Sprachauswahl</a:t>
+            </a:r>
+          </a:p>
+        </p:txBody>
+      </p:sp>
+      <p:sp>
+        <p:nvSpPr>
+          <p:cNvPr id="15" name="TextBox 14"/>
+          <p:cNvSpPr txBox="1"/>
+          <p:nvPr/>
+        </p:nvSpPr>
+        <p:spPr>
+          <a:xfrm>
+            <a:off x="3364992" y="2020824"/>
+            <a:ext cx="8412480" cy="603503"/>
+          </a:xfrm>
+          <a:prstGeom prst="rect">
+            <a:avLst/>
+          </a:prstGeom>
+          <a:noFill/>
+        </p:spPr>
+        <p:txBody>
+          <a:bodyPr wrap="square">
+            <a:spAutoFit/>
+          </a:bodyPr>
+          <a:lstStyle/>
+          <a:p>
+            <a:pPr algn="l"/>
+            <a:r>
+              <a:rPr sz="900" b="0">
+                <a:solidFill>
+                  <a:srgbClr val="2C3E50"/>
+                </a:solidFill>
+              </a:rPr>
+              <a:t>Launcher: DE/EN/RO/PT/FR (5 Sprachen); build_reports und transform_data: DE/EN; letzte Wahl persistent in ~/.situation_report/prefs.json</a:t>
+            </a:r>
+          </a:p>
+        </p:txBody>
+      </p:sp>
+      <p:sp>
+        <p:nvSpPr>
+          <p:cNvPr id="16" name="Rectangle 15"/>
+          <p:cNvSpPr/>
+          <p:nvPr/>
+        </p:nvSpPr>
+        <p:spPr>
+          <a:xfrm>
+            <a:off x="274320" y="2642615"/>
+            <a:ext cx="2926080" cy="658368"/>
+          </a:xfrm>
+          <a:prstGeom prst="rect">
+            <a:avLst/>
+          </a:prstGeom>
+          <a:solidFill>
+            <a:srgbClr val="ECF0F1"/>
+          </a:solidFill>
+          <a:ln>
+            <a:noFill/>
+          </a:ln>
+        </p:spPr>
+        <p:style>
+          <a:lnRef idx="1">
+            <a:schemeClr val="accent1"/>
+          </a:lnRef>
+          <a:fillRef idx="3">
+            <a:schemeClr val="accent1"/>
+          </a:fillRef>
+          <a:effectRef idx="2">
+            <a:schemeClr val="accent1"/>
+          </a:effectRef>
+          <a:fontRef idx="minor">
+            <a:schemeClr val="lt1"/>
+          </a:fontRef>
+        </p:style>
+        <p:txBody>
+          <a:bodyPr rtlCol="0" anchor="ctr"/>
+          <a:lstStyle/>
+          <a:p>
+            <a:pPr algn="ctr"/>
+          </a:p>
+        </p:txBody>
+      </p:sp>
+      <p:sp>
+        <p:nvSpPr>
+          <p:cNvPr id="17" name="Rectangle 16"/>
+          <p:cNvSpPr/>
+          <p:nvPr/>
+        </p:nvSpPr>
+        <p:spPr>
+          <a:xfrm>
+            <a:off x="3291840" y="2642615"/>
+            <a:ext cx="8595360" cy="658368"/>
+          </a:xfrm>
+          <a:prstGeom prst="rect">
+            <a:avLst/>
+          </a:prstGeom>
+          <a:solidFill>
+            <a:srgbClr val="ECF0F1"/>
+          </a:solidFill>
+          <a:ln>
+            <a:noFill/>
+          </a:ln>
+        </p:spPr>
+        <p:style>
+          <a:lnRef idx="1">
+            <a:schemeClr val="accent1"/>
+          </a:lnRef>
+          <a:fillRef idx="3">
+            <a:schemeClr val="accent1"/>
+          </a:fillRef>
+          <a:effectRef idx="2">
+            <a:schemeClr val="accent1"/>
+          </a:effectRef>
+          <a:fontRef idx="minor">
+            <a:schemeClr val="lt1"/>
+          </a:fontRef>
+        </p:style>
+        <p:txBody>
+          <a:bodyPr rtlCol="0" anchor="ctr"/>
+          <a:lstStyle/>
+          <a:p>
+            <a:pPr algn="ctr"/>
+          </a:p>
+        </p:txBody>
+      </p:sp>
+      <p:sp>
+        <p:nvSpPr>
+          <p:cNvPr id="18" name="TextBox 17"/>
+          <p:cNvSpPr txBox="1"/>
+          <p:nvPr/>
+        </p:nvSpPr>
+        <p:spPr>
+          <a:xfrm>
+            <a:off x="347472" y="2679191"/>
+            <a:ext cx="2788920" cy="603503"/>
+          </a:xfrm>
+          <a:prstGeom prst="rect">
+            <a:avLst/>
+          </a:prstGeom>
+          <a:noFill/>
+        </p:spPr>
+        <p:txBody>
+          <a:bodyPr wrap="square">
+            <a:spAutoFit/>
+          </a:bodyPr>
+          <a:lstStyle/>
+          <a:p>
+            <a:pPr algn="l"/>
+            <a:r>
+              <a:rPr sz="900" b="1">
+                <a:solidFill>
+                  <a:srgbClr val="2C3E50"/>
+                </a:solidFill>
+              </a:rPr>
+              <a:t>PDF-Manuals</a:t>
+            </a:r>
+          </a:p>
+        </p:txBody>
+      </p:sp>
+      <p:sp>
+        <p:nvSpPr>
+          <p:cNvPr id="19" name="TextBox 18"/>
+          <p:cNvSpPr txBox="1"/>
+          <p:nvPr/>
+        </p:nvSpPr>
+        <p:spPr>
+          <a:xfrm>
+            <a:off x="3364992" y="2679191"/>
+            <a:ext cx="8412480" cy="603503"/>
+          </a:xfrm>
+          <a:prstGeom prst="rect">
+            <a:avLst/>
+          </a:prstGeom>
+          <a:noFill/>
+        </p:spPr>
+        <p:txBody>
+          <a:bodyPr wrap="square">
+            <a:spAutoFit/>
+          </a:bodyPr>
+          <a:lstStyle/>
+          <a:p>
+            <a:pPr algn="l"/>
+            <a:r>
+              <a:rPr sz="900" b="0">
+                <a:solidFill>
+                  <a:srgbClr val="2C3E50"/>
+                </a:solidFill>
+              </a:rPr>
+              <a:t>Launcher-Handbuch in 5 Sprachen (DE, EN, RO, PT, FR); build_reports und transform_data je DE + EN; generiert mit ReportLab</a:t>
+            </a:r>
+          </a:p>
+        </p:txBody>
+      </p:sp>
+      <p:sp>
+        <p:nvSpPr>
+          <p:cNvPr id="20" name="Rectangle 19"/>
+          <p:cNvSpPr/>
+          <p:nvPr/>
+        </p:nvSpPr>
+        <p:spPr>
+          <a:xfrm>
+            <a:off x="274320" y="3300983"/>
+            <a:ext cx="2926080" cy="658368"/>
+          </a:xfrm>
+          <a:prstGeom prst="rect">
+            <a:avLst/>
+          </a:prstGeom>
+          <a:solidFill>
+            <a:srgbClr val="FFFFFF"/>
+          </a:solidFill>
+          <a:ln>
+            <a:noFill/>
+          </a:ln>
+        </p:spPr>
+        <p:style>
+          <a:lnRef idx="1">
+            <a:schemeClr val="accent1"/>
+          </a:lnRef>
+          <a:fillRef idx="3">
+            <a:schemeClr val="accent1"/>
+          </a:fillRef>
+          <a:effectRef idx="2">
+            <a:schemeClr val="accent1"/>
+          </a:effectRef>
+          <a:fontRef idx="minor">
+            <a:schemeClr val="lt1"/>
+          </a:fontRef>
+        </p:style>
+        <p:txBody>
+          <a:bodyPr rtlCol="0" anchor="ctr"/>
+          <a:lstStyle/>
+          <a:p>
+            <a:pPr algn="ctr"/>
+          </a:p>
+        </p:txBody>
+      </p:sp>
+      <p:sp>
+        <p:nvSpPr>
+          <p:cNvPr id="21" name="Rectangle 20"/>
+          <p:cNvSpPr/>
+          <p:nvPr/>
+        </p:nvSpPr>
+        <p:spPr>
+          <a:xfrm>
+            <a:off x="3291840" y="3300983"/>
+            <a:ext cx="8595360" cy="658368"/>
+          </a:xfrm>
+          <a:prstGeom prst="rect">
+            <a:avLst/>
+          </a:prstGeom>
+          <a:solidFill>
+            <a:srgbClr val="FFFFFF"/>
+          </a:solidFill>
+          <a:ln>
+            <a:noFill/>
+          </a:ln>
+        </p:spPr>
+        <p:style>
+          <a:lnRef idx="1">
+            <a:schemeClr val="accent1"/>
+          </a:lnRef>
+          <a:fillRef idx="3">
+            <a:schemeClr val="accent1"/>
+          </a:fillRef>
+          <a:effectRef idx="2">
+            <a:schemeClr val="accent1"/>
+          </a:effectRef>
+          <a:fontRef idx="minor">
+            <a:schemeClr val="lt1"/>
+          </a:fontRef>
+        </p:style>
+        <p:txBody>
+          <a:bodyPr rtlCol="0" anchor="ctr"/>
+          <a:lstStyle/>
+          <a:p>
+            <a:pPr algn="ctr"/>
+          </a:p>
+        </p:txBody>
+      </p:sp>
+      <p:sp>
+        <p:nvSpPr>
+          <p:cNvPr id="22" name="TextBox 21"/>
+          <p:cNvSpPr txBox="1"/>
+          <p:nvPr/>
+        </p:nvSpPr>
+        <p:spPr>
+          <a:xfrm>
+            <a:off x="347472" y="3337559"/>
+            <a:ext cx="2788920" cy="603503"/>
+          </a:xfrm>
+          <a:prstGeom prst="rect">
+            <a:avLst/>
+          </a:prstGeom>
+          <a:noFill/>
+        </p:spPr>
+        <p:txBody>
+          <a:bodyPr wrap="square">
+            <a:spAutoFit/>
+          </a:bodyPr>
+          <a:lstStyle/>
+          <a:p>
+            <a:pPr algn="l"/>
+            <a:r>
+              <a:rPr sz="900" b="1">
+                <a:solidFill>
+                  <a:srgbClr val="2C3E50"/>
+                </a:solidFill>
+              </a:rPr>
+              <a:t>Manual-Link in GUI</a:t>
+            </a:r>
+          </a:p>
+        </p:txBody>
+      </p:sp>
+      <p:sp>
+        <p:nvSpPr>
+          <p:cNvPr id="23" name="TextBox 22"/>
+          <p:cNvSpPr txBox="1"/>
+          <p:nvPr/>
+        </p:nvSpPr>
+        <p:spPr>
+          <a:xfrm>
+            <a:off x="3364992" y="3337559"/>
+            <a:ext cx="8412480" cy="603503"/>
+          </a:xfrm>
+          <a:prstGeom prst="rect">
+            <a:avLst/>
+          </a:prstGeom>
+          <a:noFill/>
+        </p:spPr>
+        <p:txBody>
+          <a:bodyPr wrap="square">
+            <a:spAutoFit/>
+          </a:bodyPr>
+          <a:lstStyle/>
+          <a:p>
+            <a:pPr algn="l"/>
+            <a:r>
+              <a:rPr sz="900" b="0">
+                <a:solidFill>
+                  <a:srgbClr val="2C3E50"/>
+                </a:solidFill>
+              </a:rPr>
+              <a:t>Hilfe-Menü / (?)-Button öffnet das sprachpassende PDF direkt auf GitHub Pages</a:t>
+            </a:r>
+          </a:p>
+        </p:txBody>
+      </p:sp>
+      <p:sp>
+        <p:nvSpPr>
+          <p:cNvPr id="24" name="Rectangle 23"/>
+          <p:cNvSpPr/>
+          <p:nvPr/>
+        </p:nvSpPr>
+        <p:spPr>
+          <a:xfrm>
+            <a:off x="274320" y="3959351"/>
+            <a:ext cx="2926080" cy="658368"/>
+          </a:xfrm>
+          <a:prstGeom prst="rect">
+            <a:avLst/>
+          </a:prstGeom>
+          <a:solidFill>
+            <a:srgbClr val="ECF0F1"/>
+          </a:solidFill>
+          <a:ln>
+            <a:noFill/>
+          </a:ln>
+        </p:spPr>
+        <p:style>
+          <a:lnRef idx="1">
+            <a:schemeClr val="accent1"/>
+          </a:lnRef>
+          <a:fillRef idx="3">
+            <a:schemeClr val="accent1"/>
+          </a:fillRef>
+          <a:effectRef idx="2">
+            <a:schemeClr val="accent1"/>
+          </a:effectRef>
+          <a:fontRef idx="minor">
+            <a:schemeClr val="lt1"/>
+          </a:fontRef>
+        </p:style>
+        <p:txBody>
+          <a:bodyPr rtlCol="0" anchor="ctr"/>
+          <a:lstStyle/>
+          <a:p>
+            <a:pPr algn="ctr"/>
+          </a:p>
+        </p:txBody>
+      </p:sp>
+      <p:sp>
+        <p:nvSpPr>
+          <p:cNvPr id="25" name="Rectangle 24"/>
+          <p:cNvSpPr/>
+          <p:nvPr/>
+        </p:nvSpPr>
+        <p:spPr>
+          <a:xfrm>
+            <a:off x="3291840" y="3959351"/>
+            <a:ext cx="8595360" cy="658368"/>
+          </a:xfrm>
+          <a:prstGeom prst="rect">
+            <a:avLst/>
+          </a:prstGeom>
+          <a:solidFill>
+            <a:srgbClr val="ECF0F1"/>
+          </a:solidFill>
+          <a:ln>
+            <a:noFill/>
+          </a:ln>
+        </p:spPr>
+        <p:style>
+          <a:lnRef idx="1">
+            <a:schemeClr val="accent1"/>
+          </a:lnRef>
+          <a:fillRef idx="3">
+            <a:schemeClr val="accent1"/>
+          </a:fillRef>
+          <a:effectRef idx="2">
+            <a:schemeClr val="accent1"/>
+          </a:effectRef>
+          <a:fontRef idx="minor">
+            <a:schemeClr val="lt1"/>
+          </a:fontRef>
+        </p:style>
+        <p:txBody>
+          <a:bodyPr rtlCol="0" anchor="ctr"/>
+          <a:lstStyle/>
+          <a:p>
+            <a:pPr algn="ctr"/>
+          </a:p>
+        </p:txBody>
+      </p:sp>
+      <p:sp>
+        <p:nvSpPr>
+          <p:cNvPr id="26" name="TextBox 25"/>
+          <p:cNvSpPr txBox="1"/>
+          <p:nvPr/>
+        </p:nvSpPr>
+        <p:spPr>
+          <a:xfrm>
+            <a:off x="347472" y="3995927"/>
+            <a:ext cx="2788920" cy="603503"/>
+          </a:xfrm>
+          <a:prstGeom prst="rect">
+            <a:avLst/>
+          </a:prstGeom>
+          <a:noFill/>
+        </p:spPr>
+        <p:txBody>
+          <a:bodyPr wrap="square">
+            <a:spAutoFit/>
+          </a:bodyPr>
+          <a:lstStyle/>
+          <a:p>
+            <a:pPr algn="l"/>
+            <a:r>
+              <a:rPr sz="900" b="1">
+                <a:solidFill>
+                  <a:srgbClr val="2C3E50"/>
+                </a:solidFill>
+              </a:rPr>
+              <a:t>GitHub Pages Doku</a:t>
+            </a:r>
+          </a:p>
+        </p:txBody>
+      </p:sp>
+      <p:sp>
+        <p:nvSpPr>
+          <p:cNvPr id="27" name="TextBox 26"/>
+          <p:cNvSpPr txBox="1"/>
+          <p:nvPr/>
+        </p:nvSpPr>
+        <p:spPr>
+          <a:xfrm>
+            <a:off x="3364992" y="3995927"/>
+            <a:ext cx="8412480" cy="603503"/>
+          </a:xfrm>
+          <a:prstGeom prst="rect">
+            <a:avLst/>
+          </a:prstGeom>
+          <a:noFill/>
+        </p:spPr>
+        <p:txBody>
+          <a:bodyPr wrap="square">
+            <a:spAutoFit/>
+          </a:bodyPr>
+          <a:lstStyle/>
+          <a:p>
+            <a:pPr algn="l"/>
+            <a:r>
+              <a:rPr sz="900" b="0">
+                <a:solidFill>
+                  <a:srgbClr val="2C3E50"/>
+                </a:solidFill>
+              </a:rPr>
+              <a:t>MkDocs-Site mit DE/EN-Doku für alle Module; Architektur nach C4-Modell</a:t>
+            </a:r>
+          </a:p>
+        </p:txBody>
+      </p:sp>
+      <p:sp>
+        <p:nvSpPr>
+          <p:cNvPr id="28" name="Rectangle 27"/>
+          <p:cNvSpPr/>
+          <p:nvPr/>
+        </p:nvSpPr>
+        <p:spPr>
+          <a:xfrm>
+            <a:off x="274320" y="4617719"/>
+            <a:ext cx="2926080" cy="658368"/>
+          </a:xfrm>
+          <a:prstGeom prst="rect">
+            <a:avLst/>
+          </a:prstGeom>
+          <a:solidFill>
+            <a:srgbClr val="FFFFFF"/>
+          </a:solidFill>
+          <a:ln>
+            <a:noFill/>
+          </a:ln>
+        </p:spPr>
+        <p:style>
+          <a:lnRef idx="1">
+            <a:schemeClr val="accent1"/>
+          </a:lnRef>
+          <a:fillRef idx="3">
+            <a:schemeClr val="accent1"/>
+          </a:fillRef>
+          <a:effectRef idx="2">
+            <a:schemeClr val="accent1"/>
+          </a:effectRef>
+          <a:fontRef idx="minor">
+            <a:schemeClr val="lt1"/>
+          </a:fontRef>
+        </p:style>
+        <p:txBody>
+          <a:bodyPr rtlCol="0" anchor="ctr"/>
+          <a:lstStyle/>
+          <a:p>
+            <a:pPr algn="ctr"/>
+          </a:p>
+        </p:txBody>
+      </p:sp>
+      <p:sp>
+        <p:nvSpPr>
+          <p:cNvPr id="29" name="Rectangle 28"/>
+          <p:cNvSpPr/>
+          <p:nvPr/>
+        </p:nvSpPr>
+        <p:spPr>
+          <a:xfrm>
+            <a:off x="3291840" y="4617719"/>
+            <a:ext cx="8595360" cy="658368"/>
+          </a:xfrm>
+          <a:prstGeom prst="rect">
+            <a:avLst/>
+          </a:prstGeom>
+          <a:solidFill>
+            <a:srgbClr val="FFFFFF"/>
+          </a:solidFill>
+          <a:ln>
+            <a:noFill/>
+          </a:ln>
+        </p:spPr>
+        <p:style>
+          <a:lnRef idx="1">
+            <a:schemeClr val="accent1"/>
+          </a:lnRef>
+          <a:fillRef idx="3">
+            <a:schemeClr val="accent1"/>
+          </a:fillRef>
+          <a:effectRef idx="2">
+            <a:schemeClr val="accent1"/>
+          </a:effectRef>
+          <a:fontRef idx="minor">
+            <a:schemeClr val="lt1"/>
+          </a:fontRef>
+        </p:style>
+        <p:txBody>
+          <a:bodyPr rtlCol="0" anchor="ctr"/>
+          <a:lstStyle/>
+          <a:p>
+            <a:pPr algn="ctr"/>
+          </a:p>
+        </p:txBody>
+      </p:sp>
+      <p:sp>
+        <p:nvSpPr>
+          <p:cNvPr id="30" name="TextBox 29"/>
+          <p:cNvSpPr txBox="1"/>
+          <p:nvPr/>
+        </p:nvSpPr>
+        <p:spPr>
+          <a:xfrm>
+            <a:off x="347472" y="4654295"/>
+            <a:ext cx="2788920" cy="603503"/>
+          </a:xfrm>
+          <a:prstGeom prst="rect">
+            <a:avLst/>
+          </a:prstGeom>
+          <a:noFill/>
+        </p:spPr>
+        <p:txBody>
+          <a:bodyPr wrap="square">
+            <a:spAutoFit/>
+          </a:bodyPr>
+          <a:lstStyle/>
+          <a:p>
+            <a:pPr algn="l"/>
+            <a:r>
+              <a:rPr sz="900" b="1">
+                <a:solidFill>
+                  <a:srgbClr val="2C3E50"/>
+                </a:solidFill>
+              </a:rPr>
+              <a:t>CI/CD</a:t>
+            </a:r>
+          </a:p>
+        </p:txBody>
+      </p:sp>
+      <p:sp>
+        <p:nvSpPr>
+          <p:cNvPr id="31" name="TextBox 30"/>
+          <p:cNvSpPr txBox="1"/>
+          <p:nvPr/>
+        </p:nvSpPr>
+        <p:spPr>
+          <a:xfrm>
+            <a:off x="3364992" y="4654295"/>
+            <a:ext cx="8412480" cy="603503"/>
+          </a:xfrm>
+          <a:prstGeom prst="rect">
+            <a:avLst/>
+          </a:prstGeom>
+          <a:noFill/>
+        </p:spPr>
+        <p:txBody>
+          <a:bodyPr wrap="square">
+            <a:spAutoFit/>
+          </a:bodyPr>
+          <a:lstStyle/>
+          <a:p>
+            <a:pPr algn="l"/>
+            <a:r>
+              <a:rPr sz="900" b="0">
+                <a:solidFill>
+                  <a:srgbClr val="2C3E50"/>
+                </a:solidFill>
+              </a:rPr>
+              <a:t>GitHub Actions für automatisches Docs-Deployment und Release-Erstellung bei v*-Tags</a:t>
+            </a:r>
+          </a:p>
+        </p:txBody>
+      </p:sp>
+      <p:sp>
+        <p:nvSpPr>
+          <p:cNvPr id="32" name="Rectangle 31"/>
+          <p:cNvSpPr/>
+          <p:nvPr/>
+        </p:nvSpPr>
+        <p:spPr>
+          <a:xfrm>
+            <a:off x="274320" y="5276087"/>
+            <a:ext cx="2926080" cy="658368"/>
+          </a:xfrm>
+          <a:prstGeom prst="rect">
+            <a:avLst/>
+          </a:prstGeom>
+          <a:solidFill>
+            <a:srgbClr val="ECF0F1"/>
+          </a:solidFill>
+          <a:ln>
+            <a:noFill/>
+          </a:ln>
+        </p:spPr>
+        <p:style>
+          <a:lnRef idx="1">
+            <a:schemeClr val="accent1"/>
+          </a:lnRef>
+          <a:fillRef idx="3">
+            <a:schemeClr val="accent1"/>
+          </a:fillRef>
+          <a:effectRef idx="2">
+            <a:schemeClr val="accent1"/>
+          </a:effectRef>
+          <a:fontRef idx="minor">
+            <a:schemeClr val="lt1"/>
+          </a:fontRef>
+        </p:style>
+        <p:txBody>
+          <a:bodyPr rtlCol="0" anchor="ctr"/>
+          <a:lstStyle/>
+          <a:p>
+            <a:pPr algn="ctr"/>
+          </a:p>
+        </p:txBody>
+      </p:sp>
+      <p:sp>
+        <p:nvSpPr>
+          <p:cNvPr id="33" name="Rectangle 32"/>
+          <p:cNvSpPr/>
+          <p:nvPr/>
+        </p:nvSpPr>
+        <p:spPr>
+          <a:xfrm>
+            <a:off x="3291840" y="5276087"/>
+            <a:ext cx="8595360" cy="658368"/>
+          </a:xfrm>
+          <a:prstGeom prst="rect">
+            <a:avLst/>
+          </a:prstGeom>
+          <a:solidFill>
+            <a:srgbClr val="ECF0F1"/>
+          </a:solidFill>
+          <a:ln>
+            <a:noFill/>
+          </a:ln>
+        </p:spPr>
+        <p:style>
+          <a:lnRef idx="1">
+            <a:schemeClr val="accent1"/>
+          </a:lnRef>
+          <a:fillRef idx="3">
+            <a:schemeClr val="accent1"/>
+          </a:fillRef>
+          <a:effectRef idx="2">
+            <a:schemeClr val="accent1"/>
+          </a:effectRef>
+          <a:fontRef idx="minor">
+            <a:schemeClr val="lt1"/>
+          </a:fontRef>
+        </p:style>
+        <p:txBody>
+          <a:bodyPr rtlCol="0" anchor="ctr"/>
+          <a:lstStyle/>
+          <a:p>
+            <a:pPr algn="ctr"/>
+          </a:p>
+        </p:txBody>
+      </p:sp>
+      <p:sp>
+        <p:nvSpPr>
+          <p:cNvPr id="34" name="TextBox 33"/>
+          <p:cNvSpPr txBox="1"/>
+          <p:nvPr/>
+        </p:nvSpPr>
+        <p:spPr>
+          <a:xfrm>
+            <a:off x="347472" y="5312663"/>
+            <a:ext cx="2788920" cy="603503"/>
+          </a:xfrm>
+          <a:prstGeom prst="rect">
+            <a:avLst/>
+          </a:prstGeom>
+          <a:noFill/>
+        </p:spPr>
+        <p:txBody>
+          <a:bodyPr wrap="square">
+            <a:spAutoFit/>
+          </a:bodyPr>
+          <a:lstStyle/>
+          <a:p>
+            <a:pPr algn="l"/>
+            <a:r>
+              <a:rPr sz="900" b="1">
+                <a:solidFill>
+                  <a:srgbClr val="2C3E50"/>
+                </a:solidFill>
+              </a:rPr>
+              <a:t>Tests</a:t>
+            </a:r>
+          </a:p>
+        </p:txBody>
+      </p:sp>
+      <p:sp>
+        <p:nvSpPr>
+          <p:cNvPr id="35" name="TextBox 34"/>
+          <p:cNvSpPr txBox="1"/>
+          <p:nvPr/>
+        </p:nvSpPr>
+        <p:spPr>
+          <a:xfrm>
+            <a:off x="3364992" y="5312663"/>
+            <a:ext cx="8412480" cy="603503"/>
+          </a:xfrm>
+          <a:prstGeom prst="rect">
+            <a:avLst/>
+          </a:prstGeom>
+          <a:noFill/>
+        </p:spPr>
+        <p:txBody>
+          <a:bodyPr wrap="square">
+            <a:spAutoFit/>
+          </a:bodyPr>
+          <a:lstStyle/>
+          <a:p>
+            <a:pPr algn="l"/>
+            <a:r>
+              <a:rPr sz="900" b="0">
+                <a:solidFill>
+                  <a:srgbClr val="2C3E50"/>
+                </a:solidFill>
+              </a:rPr>
+              <a:t>Unit- und Acceptance-Tests für alle Module; aktuell 542 Tests</a:t>
             </a:r>
           </a:p>
         </p:txBody>

</xml_diff>

<commit_message>
chore(release): v0.9.0 – helper stabil, Doku + PPTX aktualisiert
- version.py auf 0.9.0 gesetzt
- helper/gui.py: fehlende _browse_output-Methode ergänzt (AttributeError-Fix)
- CHANGELOG.md: [Unreleased] → [0.9.0] mit helper-Added + Bugfix-Eintrag
- README.md: testdata_generator + helper als available gelistet
- modules/launcher.*: helper in Modul-Grid und Tabelle ergänzt
- modules/helper.*: Versionsnummer v0.9.0
- modules/index.*: helper im Verzeichnisbaum + Datenflusspfade aktualisiert
- PPTX: v0.9.0, Stand Mai 2026, neue Folien testdata_generator + helper

Co-Authored-By: Claude Sonnet 4.6 <noreply@anthropic.com>
</commit_message>
<xml_diff>
--- a/docs/situation_report_features.pptx
+++ b/docs/situation_report_features.pptx
@@ -13,6 +13,8 @@
     <p:sldId id="261" r:id="rId12"/>
     <p:sldId id="262" r:id="rId13"/>
     <p:sldId id="263" r:id="rId14"/>
+    <p:sldId id="264" r:id="rId15"/>
+    <p:sldId id="265" r:id="rId16"/>
   </p:sldIdLst>
   <p:sldSz cx="12188952" cy="6858000" type="screen4x3"/>
   <p:notesSz cx="6858000" cy="9144000"/>
@@ -3244,7 +3246,7 @@
                   <a:srgbClr val="ECF0F1"/>
                 </a:solidFill>
               </a:rPr>
-              <a:t>Feature-Übersicht — v0.8.4 | Stand April 2026</a:t>
+              <a:t>Feature-Übersicht — v0.9.0 | Stand Mai 2026</a:t>
             </a:r>
           </a:p>
         </p:txBody>
@@ -3280,6 +3282,1530 @@
               </a:rPr>
               <a:t>github.com/Jaegerfeld/situation-report</a:t>
             </a:r>
+          </a:p>
+        </p:txBody>
+      </p:sp>
+    </p:spTree>
+  </p:cSld>
+  <p:clrMapOvr>
+    <a:masterClrMapping/>
+  </p:clrMapOvr>
+</p:sld>
+</file>
+
+<file path=ppt/slides/slide10.xml><?xml version="1.0" encoding="utf-8"?>
+<p:sld xmlns:a="http://schemas.openxmlformats.org/drawingml/2006/main" xmlns:p="http://schemas.openxmlformats.org/presentationml/2006/main" xmlns:r="http://schemas.openxmlformats.org/officeDocument/2006/relationships">
+  <p:cSld>
+    <p:spTree>
+      <p:nvGrpSpPr>
+        <p:cNvPr id="1" name=""/>
+        <p:cNvGrpSpPr/>
+        <p:nvPr/>
+      </p:nvGrpSpPr>
+      <p:grpSpPr/>
+      <p:sp>
+        <p:nvSpPr>
+          <p:cNvPr id="2" name="Rectangle 1"/>
+          <p:cNvSpPr/>
+          <p:nvPr/>
+        </p:nvSpPr>
+        <p:spPr>
+          <a:xfrm>
+            <a:off x="0" y="0"/>
+            <a:ext cx="12188952" cy="822960"/>
+          </a:xfrm>
+          <a:prstGeom prst="rect">
+            <a:avLst/>
+          </a:prstGeom>
+          <a:solidFill>
+            <a:srgbClr val="2C3E50"/>
+          </a:solidFill>
+          <a:ln>
+            <a:noFill/>
+          </a:ln>
+        </p:spPr>
+        <p:style>
+          <a:lnRef idx="1">
+            <a:schemeClr val="accent1"/>
+          </a:lnRef>
+          <a:fillRef idx="3">
+            <a:schemeClr val="accent1"/>
+          </a:fillRef>
+          <a:effectRef idx="2">
+            <a:schemeClr val="accent1"/>
+          </a:effectRef>
+          <a:fontRef idx="minor">
+            <a:schemeClr val="lt1"/>
+          </a:fontRef>
+        </p:style>
+        <p:txBody>
+          <a:bodyPr rtlCol="0" anchor="ctr"/>
+          <a:lstStyle/>
+          <a:p>
+            <a:pPr algn="ctr"/>
+          </a:p>
+        </p:txBody>
+      </p:sp>
+      <p:sp>
+        <p:nvSpPr>
+          <p:cNvPr id="3" name="TextBox 2"/>
+          <p:cNvSpPr txBox="1"/>
+          <p:nvPr/>
+        </p:nvSpPr>
+        <p:spPr>
+          <a:xfrm>
+            <a:off x="274320" y="91440"/>
+            <a:ext cx="11612880" cy="640080"/>
+          </a:xfrm>
+          <a:prstGeom prst="rect">
+            <a:avLst/>
+          </a:prstGeom>
+          <a:noFill/>
+        </p:spPr>
+        <p:txBody>
+          <a:bodyPr wrap="square">
+            <a:spAutoFit/>
+          </a:bodyPr>
+          <a:lstStyle/>
+          <a:p>
+            <a:pPr algn="l"/>
+            <a:r>
+              <a:rPr sz="2200" b="1">
+                <a:solidFill>
+                  <a:srgbClr val="FFFFFF"/>
+                </a:solidFill>
+              </a:rPr>
+              <a:t>helper — JSON Merger</a:t>
+            </a:r>
+          </a:p>
+        </p:txBody>
+      </p:sp>
+      <p:sp>
+        <p:nvSpPr>
+          <p:cNvPr id="4" name="Rectangle 3"/>
+          <p:cNvSpPr/>
+          <p:nvPr/>
+        </p:nvSpPr>
+        <p:spPr>
+          <a:xfrm>
+            <a:off x="274320" y="914400"/>
+            <a:ext cx="2926080" cy="320040"/>
+          </a:xfrm>
+          <a:prstGeom prst="rect">
+            <a:avLst/>
+          </a:prstGeom>
+          <a:solidFill>
+            <a:srgbClr val="2980B9"/>
+          </a:solidFill>
+          <a:ln>
+            <a:noFill/>
+          </a:ln>
+        </p:spPr>
+        <p:style>
+          <a:lnRef idx="1">
+            <a:schemeClr val="accent1"/>
+          </a:lnRef>
+          <a:fillRef idx="3">
+            <a:schemeClr val="accent1"/>
+          </a:fillRef>
+          <a:effectRef idx="2">
+            <a:schemeClr val="accent1"/>
+          </a:effectRef>
+          <a:fontRef idx="minor">
+            <a:schemeClr val="lt1"/>
+          </a:fontRef>
+        </p:style>
+        <p:txBody>
+          <a:bodyPr rtlCol="0" anchor="ctr"/>
+          <a:lstStyle/>
+          <a:p>
+            <a:pPr algn="ctr"/>
+          </a:p>
+        </p:txBody>
+      </p:sp>
+      <p:sp>
+        <p:nvSpPr>
+          <p:cNvPr id="5" name="Rectangle 4"/>
+          <p:cNvSpPr/>
+          <p:nvPr/>
+        </p:nvSpPr>
+        <p:spPr>
+          <a:xfrm>
+            <a:off x="3291840" y="914400"/>
+            <a:ext cx="8595360" cy="320040"/>
+          </a:xfrm>
+          <a:prstGeom prst="rect">
+            <a:avLst/>
+          </a:prstGeom>
+          <a:solidFill>
+            <a:srgbClr val="2980B9"/>
+          </a:solidFill>
+          <a:ln>
+            <a:noFill/>
+          </a:ln>
+        </p:spPr>
+        <p:style>
+          <a:lnRef idx="1">
+            <a:schemeClr val="accent1"/>
+          </a:lnRef>
+          <a:fillRef idx="3">
+            <a:schemeClr val="accent1"/>
+          </a:fillRef>
+          <a:effectRef idx="2">
+            <a:schemeClr val="accent1"/>
+          </a:effectRef>
+          <a:fontRef idx="minor">
+            <a:schemeClr val="lt1"/>
+          </a:fontRef>
+        </p:style>
+        <p:txBody>
+          <a:bodyPr rtlCol="0" anchor="ctr"/>
+          <a:lstStyle/>
+          <a:p>
+            <a:pPr algn="ctr"/>
+          </a:p>
+        </p:txBody>
+      </p:sp>
+      <p:sp>
+        <p:nvSpPr>
+          <p:cNvPr id="6" name="TextBox 5"/>
+          <p:cNvSpPr txBox="1"/>
+          <p:nvPr/>
+        </p:nvSpPr>
+        <p:spPr>
+          <a:xfrm>
+            <a:off x="320040" y="932688"/>
+            <a:ext cx="2834640" cy="274320"/>
+          </a:xfrm>
+          <a:prstGeom prst="rect">
+            <a:avLst/>
+          </a:prstGeom>
+          <a:noFill/>
+        </p:spPr>
+        <p:txBody>
+          <a:bodyPr wrap="square">
+            <a:spAutoFit/>
+          </a:bodyPr>
+          <a:lstStyle/>
+          <a:p>
+            <a:pPr algn="l"/>
+            <a:r>
+              <a:rPr sz="900" b="1">
+                <a:solidFill>
+                  <a:srgbClr val="FFFFFF"/>
+                </a:solidFill>
+              </a:rPr>
+              <a:t>Feature</a:t>
+            </a:r>
+          </a:p>
+        </p:txBody>
+      </p:sp>
+      <p:sp>
+        <p:nvSpPr>
+          <p:cNvPr id="7" name="TextBox 6"/>
+          <p:cNvSpPr txBox="1"/>
+          <p:nvPr/>
+        </p:nvSpPr>
+        <p:spPr>
+          <a:xfrm>
+            <a:off x="3337560" y="932688"/>
+            <a:ext cx="8503920" cy="274320"/>
+          </a:xfrm>
+          <a:prstGeom prst="rect">
+            <a:avLst/>
+          </a:prstGeom>
+          <a:noFill/>
+        </p:spPr>
+        <p:txBody>
+          <a:bodyPr wrap="square">
+            <a:spAutoFit/>
+          </a:bodyPr>
+          <a:lstStyle/>
+          <a:p>
+            <a:pPr algn="l"/>
+            <a:r>
+              <a:rPr sz="900" b="1">
+                <a:solidFill>
+                  <a:srgbClr val="FFFFFF"/>
+                </a:solidFill>
+              </a:rPr>
+              <a:t>Beschreibung</a:t>
+            </a:r>
+          </a:p>
+        </p:txBody>
+      </p:sp>
+      <p:sp>
+        <p:nvSpPr>
+          <p:cNvPr id="8" name="Rectangle 7"/>
+          <p:cNvSpPr/>
+          <p:nvPr/>
+        </p:nvSpPr>
+        <p:spPr>
+          <a:xfrm>
+            <a:off x="274320" y="1325880"/>
+            <a:ext cx="2926080" cy="658368"/>
+          </a:xfrm>
+          <a:prstGeom prst="rect">
+            <a:avLst/>
+          </a:prstGeom>
+          <a:solidFill>
+            <a:srgbClr val="ECF0F1"/>
+          </a:solidFill>
+          <a:ln>
+            <a:noFill/>
+          </a:ln>
+        </p:spPr>
+        <p:style>
+          <a:lnRef idx="1">
+            <a:schemeClr val="accent1"/>
+          </a:lnRef>
+          <a:fillRef idx="3">
+            <a:schemeClr val="accent1"/>
+          </a:fillRef>
+          <a:effectRef idx="2">
+            <a:schemeClr val="accent1"/>
+          </a:effectRef>
+          <a:fontRef idx="minor">
+            <a:schemeClr val="lt1"/>
+          </a:fontRef>
+        </p:style>
+        <p:txBody>
+          <a:bodyPr rtlCol="0" anchor="ctr"/>
+          <a:lstStyle/>
+          <a:p>
+            <a:pPr algn="ctr"/>
+          </a:p>
+        </p:txBody>
+      </p:sp>
+      <p:sp>
+        <p:nvSpPr>
+          <p:cNvPr id="9" name="Rectangle 8"/>
+          <p:cNvSpPr/>
+          <p:nvPr/>
+        </p:nvSpPr>
+        <p:spPr>
+          <a:xfrm>
+            <a:off x="3291840" y="1325880"/>
+            <a:ext cx="8595360" cy="658368"/>
+          </a:xfrm>
+          <a:prstGeom prst="rect">
+            <a:avLst/>
+          </a:prstGeom>
+          <a:solidFill>
+            <a:srgbClr val="ECF0F1"/>
+          </a:solidFill>
+          <a:ln>
+            <a:noFill/>
+          </a:ln>
+        </p:spPr>
+        <p:style>
+          <a:lnRef idx="1">
+            <a:schemeClr val="accent1"/>
+          </a:lnRef>
+          <a:fillRef idx="3">
+            <a:schemeClr val="accent1"/>
+          </a:fillRef>
+          <a:effectRef idx="2">
+            <a:schemeClr val="accent1"/>
+          </a:effectRef>
+          <a:fontRef idx="minor">
+            <a:schemeClr val="lt1"/>
+          </a:fontRef>
+        </p:style>
+        <p:txBody>
+          <a:bodyPr rtlCol="0" anchor="ctr"/>
+          <a:lstStyle/>
+          <a:p>
+            <a:pPr algn="ctr"/>
+          </a:p>
+        </p:txBody>
+      </p:sp>
+      <p:sp>
+        <p:nvSpPr>
+          <p:cNvPr id="10" name="TextBox 9"/>
+          <p:cNvSpPr txBox="1"/>
+          <p:nvPr/>
+        </p:nvSpPr>
+        <p:spPr>
+          <a:xfrm>
+            <a:off x="347472" y="1362456"/>
+            <a:ext cx="2788920" cy="603503"/>
+          </a:xfrm>
+          <a:prstGeom prst="rect">
+            <a:avLst/>
+          </a:prstGeom>
+          <a:noFill/>
+        </p:spPr>
+        <p:txBody>
+          <a:bodyPr wrap="square">
+            <a:spAutoFit/>
+          </a:bodyPr>
+          <a:lstStyle/>
+          <a:p>
+            <a:pPr algn="l"/>
+            <a:r>
+              <a:rPr sz="900" b="1">
+                <a:solidFill>
+                  <a:srgbClr val="2C3E50"/>
+                </a:solidFill>
+              </a:rPr>
+              <a:t>Problem: Paginierung</a:t>
+            </a:r>
+          </a:p>
+        </p:txBody>
+      </p:sp>
+      <p:sp>
+        <p:nvSpPr>
+          <p:cNvPr id="11" name="TextBox 10"/>
+          <p:cNvSpPr txBox="1"/>
+          <p:nvPr/>
+        </p:nvSpPr>
+        <p:spPr>
+          <a:xfrm>
+            <a:off x="3364992" y="1362456"/>
+            <a:ext cx="8412480" cy="603503"/>
+          </a:xfrm>
+          <a:prstGeom prst="rect">
+            <a:avLst/>
+          </a:prstGeom>
+          <a:noFill/>
+        </p:spPr>
+        <p:txBody>
+          <a:bodyPr wrap="square">
+            <a:spAutoFit/>
+          </a:bodyPr>
+          <a:lstStyle/>
+          <a:p>
+            <a:pPr algn="l"/>
+            <a:r>
+              <a:rPr sz="900" b="0">
+                <a:solidFill>
+                  <a:srgbClr val="2C3E50"/>
+                </a:solidFill>
+              </a:rPr>
+              <a:t>Jira REST API liefert max. 1000 Issues pro Abfrage — bei größeren Projekten entstehen mehrere JSON-Dateien</a:t>
+            </a:r>
+          </a:p>
+        </p:txBody>
+      </p:sp>
+      <p:sp>
+        <p:nvSpPr>
+          <p:cNvPr id="12" name="Rectangle 11"/>
+          <p:cNvSpPr/>
+          <p:nvPr/>
+        </p:nvSpPr>
+        <p:spPr>
+          <a:xfrm>
+            <a:off x="274320" y="1984248"/>
+            <a:ext cx="2926080" cy="658368"/>
+          </a:xfrm>
+          <a:prstGeom prst="rect">
+            <a:avLst/>
+          </a:prstGeom>
+          <a:solidFill>
+            <a:srgbClr val="FFFFFF"/>
+          </a:solidFill>
+          <a:ln>
+            <a:noFill/>
+          </a:ln>
+        </p:spPr>
+        <p:style>
+          <a:lnRef idx="1">
+            <a:schemeClr val="accent1"/>
+          </a:lnRef>
+          <a:fillRef idx="3">
+            <a:schemeClr val="accent1"/>
+          </a:fillRef>
+          <a:effectRef idx="2">
+            <a:schemeClr val="accent1"/>
+          </a:effectRef>
+          <a:fontRef idx="minor">
+            <a:schemeClr val="lt1"/>
+          </a:fontRef>
+        </p:style>
+        <p:txBody>
+          <a:bodyPr rtlCol="0" anchor="ctr"/>
+          <a:lstStyle/>
+          <a:p>
+            <a:pPr algn="ctr"/>
+          </a:p>
+        </p:txBody>
+      </p:sp>
+      <p:sp>
+        <p:nvSpPr>
+          <p:cNvPr id="13" name="Rectangle 12"/>
+          <p:cNvSpPr/>
+          <p:nvPr/>
+        </p:nvSpPr>
+        <p:spPr>
+          <a:xfrm>
+            <a:off x="3291840" y="1984248"/>
+            <a:ext cx="8595360" cy="658368"/>
+          </a:xfrm>
+          <a:prstGeom prst="rect">
+            <a:avLst/>
+          </a:prstGeom>
+          <a:solidFill>
+            <a:srgbClr val="FFFFFF"/>
+          </a:solidFill>
+          <a:ln>
+            <a:noFill/>
+          </a:ln>
+        </p:spPr>
+        <p:style>
+          <a:lnRef idx="1">
+            <a:schemeClr val="accent1"/>
+          </a:lnRef>
+          <a:fillRef idx="3">
+            <a:schemeClr val="accent1"/>
+          </a:fillRef>
+          <a:effectRef idx="2">
+            <a:schemeClr val="accent1"/>
+          </a:effectRef>
+          <a:fontRef idx="minor">
+            <a:schemeClr val="lt1"/>
+          </a:fontRef>
+        </p:style>
+        <p:txBody>
+          <a:bodyPr rtlCol="0" anchor="ctr"/>
+          <a:lstStyle/>
+          <a:p>
+            <a:pPr algn="ctr"/>
+          </a:p>
+        </p:txBody>
+      </p:sp>
+      <p:sp>
+        <p:nvSpPr>
+          <p:cNvPr id="14" name="TextBox 13"/>
+          <p:cNvSpPr txBox="1"/>
+          <p:nvPr/>
+        </p:nvSpPr>
+        <p:spPr>
+          <a:xfrm>
+            <a:off x="347472" y="2020824"/>
+            <a:ext cx="2788920" cy="603503"/>
+          </a:xfrm>
+          <a:prstGeom prst="rect">
+            <a:avLst/>
+          </a:prstGeom>
+          <a:noFill/>
+        </p:spPr>
+        <p:txBody>
+          <a:bodyPr wrap="square">
+            <a:spAutoFit/>
+          </a:bodyPr>
+          <a:lstStyle/>
+          <a:p>
+            <a:pPr algn="l"/>
+            <a:r>
+              <a:rPr sz="900" b="1">
+                <a:solidFill>
+                  <a:srgbClr val="2C3E50"/>
+                </a:solidFill>
+              </a:rPr>
+              <a:t>JSON Merger</a:t>
+            </a:r>
+          </a:p>
+        </p:txBody>
+      </p:sp>
+      <p:sp>
+        <p:nvSpPr>
+          <p:cNvPr id="15" name="TextBox 14"/>
+          <p:cNvSpPr txBox="1"/>
+          <p:nvPr/>
+        </p:nvSpPr>
+        <p:spPr>
+          <a:xfrm>
+            <a:off x="3364992" y="2020824"/>
+            <a:ext cx="8412480" cy="603503"/>
+          </a:xfrm>
+          <a:prstGeom prst="rect">
+            <a:avLst/>
+          </a:prstGeom>
+          <a:noFill/>
+        </p:spPr>
+        <p:txBody>
+          <a:bodyPr wrap="square">
+            <a:spAutoFit/>
+          </a:bodyPr>
+          <a:lstStyle/>
+          <a:p>
+            <a:pPr algn="l"/>
+            <a:r>
+              <a:rPr sz="900" b="0">
+                <a:solidFill>
+                  <a:srgbClr val="2C3E50"/>
+                </a:solidFill>
+              </a:rPr>
+              <a:t>Fügt alle Teilexporte zu einem einzigen Jira-kompatiblen JSON zusammen — direkt mit transform_data verarbeitbar</a:t>
+            </a:r>
+          </a:p>
+        </p:txBody>
+      </p:sp>
+      <p:sp>
+        <p:nvSpPr>
+          <p:cNvPr id="16" name="Rectangle 15"/>
+          <p:cNvSpPr/>
+          <p:nvPr/>
+        </p:nvSpPr>
+        <p:spPr>
+          <a:xfrm>
+            <a:off x="274320" y="2642615"/>
+            <a:ext cx="2926080" cy="658368"/>
+          </a:xfrm>
+          <a:prstGeom prst="rect">
+            <a:avLst/>
+          </a:prstGeom>
+          <a:solidFill>
+            <a:srgbClr val="ECF0F1"/>
+          </a:solidFill>
+          <a:ln>
+            <a:noFill/>
+          </a:ln>
+        </p:spPr>
+        <p:style>
+          <a:lnRef idx="1">
+            <a:schemeClr val="accent1"/>
+          </a:lnRef>
+          <a:fillRef idx="3">
+            <a:schemeClr val="accent1"/>
+          </a:fillRef>
+          <a:effectRef idx="2">
+            <a:schemeClr val="accent1"/>
+          </a:effectRef>
+          <a:fontRef idx="minor">
+            <a:schemeClr val="lt1"/>
+          </a:fontRef>
+        </p:style>
+        <p:txBody>
+          <a:bodyPr rtlCol="0" anchor="ctr"/>
+          <a:lstStyle/>
+          <a:p>
+            <a:pPr algn="ctr"/>
+          </a:p>
+        </p:txBody>
+      </p:sp>
+      <p:sp>
+        <p:nvSpPr>
+          <p:cNvPr id="17" name="Rectangle 16"/>
+          <p:cNvSpPr/>
+          <p:nvPr/>
+        </p:nvSpPr>
+        <p:spPr>
+          <a:xfrm>
+            <a:off x="3291840" y="2642615"/>
+            <a:ext cx="8595360" cy="658368"/>
+          </a:xfrm>
+          <a:prstGeom prst="rect">
+            <a:avLst/>
+          </a:prstGeom>
+          <a:solidFill>
+            <a:srgbClr val="ECF0F1"/>
+          </a:solidFill>
+          <a:ln>
+            <a:noFill/>
+          </a:ln>
+        </p:spPr>
+        <p:style>
+          <a:lnRef idx="1">
+            <a:schemeClr val="accent1"/>
+          </a:lnRef>
+          <a:fillRef idx="3">
+            <a:schemeClr val="accent1"/>
+          </a:fillRef>
+          <a:effectRef idx="2">
+            <a:schemeClr val="accent1"/>
+          </a:effectRef>
+          <a:fontRef idx="minor">
+            <a:schemeClr val="lt1"/>
+          </a:fontRef>
+        </p:style>
+        <p:txBody>
+          <a:bodyPr rtlCol="0" anchor="ctr"/>
+          <a:lstStyle/>
+          <a:p>
+            <a:pPr algn="ctr"/>
+          </a:p>
+        </p:txBody>
+      </p:sp>
+      <p:sp>
+        <p:nvSpPr>
+          <p:cNvPr id="18" name="TextBox 17"/>
+          <p:cNvSpPr txBox="1"/>
+          <p:nvPr/>
+        </p:nvSpPr>
+        <p:spPr>
+          <a:xfrm>
+            <a:off x="347472" y="2679191"/>
+            <a:ext cx="2788920" cy="603503"/>
+          </a:xfrm>
+          <a:prstGeom prst="rect">
+            <a:avLst/>
+          </a:prstGeom>
+          <a:noFill/>
+        </p:spPr>
+        <p:txBody>
+          <a:bodyPr wrap="square">
+            <a:spAutoFit/>
+          </a:bodyPr>
+          <a:lstStyle/>
+          <a:p>
+            <a:pPr algn="l"/>
+            <a:r>
+              <a:rPr sz="900" b="1">
+                <a:solidFill>
+                  <a:srgbClr val="2C3E50"/>
+                </a:solidFill>
+              </a:rPr>
+              <a:t>Deduplizierung</a:t>
+            </a:r>
+          </a:p>
+        </p:txBody>
+      </p:sp>
+      <p:sp>
+        <p:nvSpPr>
+          <p:cNvPr id="19" name="TextBox 18"/>
+          <p:cNvSpPr txBox="1"/>
+          <p:nvPr/>
+        </p:nvSpPr>
+        <p:spPr>
+          <a:xfrm>
+            <a:off x="3364992" y="2679191"/>
+            <a:ext cx="8412480" cy="603503"/>
+          </a:xfrm>
+          <a:prstGeom prst="rect">
+            <a:avLst/>
+          </a:prstGeom>
+          <a:noFill/>
+        </p:spPr>
+        <p:txBody>
+          <a:bodyPr wrap="square">
+            <a:spAutoFit/>
+          </a:bodyPr>
+          <a:lstStyle/>
+          <a:p>
+            <a:pPr algn="l"/>
+            <a:r>
+              <a:rPr sz="900" b="0">
+                <a:solidFill>
+                  <a:srgbClr val="2C3E50"/>
+                </a:solidFill>
+              </a:rPr>
+              <a:t>Issues mit identischer id werden standardmäßig nur einmal übernommen; Warnung je Duplikat im Log</a:t>
+            </a:r>
+          </a:p>
+        </p:txBody>
+      </p:sp>
+      <p:sp>
+        <p:nvSpPr>
+          <p:cNvPr id="20" name="Rectangle 19"/>
+          <p:cNvSpPr/>
+          <p:nvPr/>
+        </p:nvSpPr>
+        <p:spPr>
+          <a:xfrm>
+            <a:off x="274320" y="3300983"/>
+            <a:ext cx="2926080" cy="658368"/>
+          </a:xfrm>
+          <a:prstGeom prst="rect">
+            <a:avLst/>
+          </a:prstGeom>
+          <a:solidFill>
+            <a:srgbClr val="FFFFFF"/>
+          </a:solidFill>
+          <a:ln>
+            <a:noFill/>
+          </a:ln>
+        </p:spPr>
+        <p:style>
+          <a:lnRef idx="1">
+            <a:schemeClr val="accent1"/>
+          </a:lnRef>
+          <a:fillRef idx="3">
+            <a:schemeClr val="accent1"/>
+          </a:fillRef>
+          <a:effectRef idx="2">
+            <a:schemeClr val="accent1"/>
+          </a:effectRef>
+          <a:fontRef idx="minor">
+            <a:schemeClr val="lt1"/>
+          </a:fontRef>
+        </p:style>
+        <p:txBody>
+          <a:bodyPr rtlCol="0" anchor="ctr"/>
+          <a:lstStyle/>
+          <a:p>
+            <a:pPr algn="ctr"/>
+          </a:p>
+        </p:txBody>
+      </p:sp>
+      <p:sp>
+        <p:nvSpPr>
+          <p:cNvPr id="21" name="Rectangle 20"/>
+          <p:cNvSpPr/>
+          <p:nvPr/>
+        </p:nvSpPr>
+        <p:spPr>
+          <a:xfrm>
+            <a:off x="3291840" y="3300983"/>
+            <a:ext cx="8595360" cy="658368"/>
+          </a:xfrm>
+          <a:prstGeom prst="rect">
+            <a:avLst/>
+          </a:prstGeom>
+          <a:solidFill>
+            <a:srgbClr val="FFFFFF"/>
+          </a:solidFill>
+          <a:ln>
+            <a:noFill/>
+          </a:ln>
+        </p:spPr>
+        <p:style>
+          <a:lnRef idx="1">
+            <a:schemeClr val="accent1"/>
+          </a:lnRef>
+          <a:fillRef idx="3">
+            <a:schemeClr val="accent1"/>
+          </a:fillRef>
+          <a:effectRef idx="2">
+            <a:schemeClr val="accent1"/>
+          </a:effectRef>
+          <a:fontRef idx="minor">
+            <a:schemeClr val="lt1"/>
+          </a:fontRef>
+        </p:style>
+        <p:txBody>
+          <a:bodyPr rtlCol="0" anchor="ctr"/>
+          <a:lstStyle/>
+          <a:p>
+            <a:pPr algn="ctr"/>
+          </a:p>
+        </p:txBody>
+      </p:sp>
+      <p:sp>
+        <p:nvSpPr>
+          <p:cNvPr id="22" name="TextBox 21"/>
+          <p:cNvSpPr txBox="1"/>
+          <p:nvPr/>
+        </p:nvSpPr>
+        <p:spPr>
+          <a:xfrm>
+            <a:off x="347472" y="3337559"/>
+            <a:ext cx="2788920" cy="603503"/>
+          </a:xfrm>
+          <a:prstGeom prst="rect">
+            <a:avLst/>
+          </a:prstGeom>
+          <a:noFill/>
+        </p:spPr>
+        <p:txBody>
+          <a:bodyPr wrap="square">
+            <a:spAutoFit/>
+          </a:bodyPr>
+          <a:lstStyle/>
+          <a:p>
+            <a:pPr algn="l"/>
+            <a:r>
+              <a:rPr sz="900" b="1">
+                <a:solidFill>
+                  <a:srgbClr val="2C3E50"/>
+                </a:solidFill>
+              </a:rPr>
+              <a:t>Dedup-Kontrolle</a:t>
+            </a:r>
+          </a:p>
+        </p:txBody>
+      </p:sp>
+      <p:sp>
+        <p:nvSpPr>
+          <p:cNvPr id="23" name="TextBox 22"/>
+          <p:cNvSpPr txBox="1"/>
+          <p:nvPr/>
+        </p:nvSpPr>
+        <p:spPr>
+          <a:xfrm>
+            <a:off x="3364992" y="3337559"/>
+            <a:ext cx="8412480" cy="603503"/>
+          </a:xfrm>
+          <a:prstGeom prst="rect">
+            <a:avLst/>
+          </a:prstGeom>
+          <a:noFill/>
+        </p:spPr>
+        <p:txBody>
+          <a:bodyPr wrap="square">
+            <a:spAutoFit/>
+          </a:bodyPr>
+          <a:lstStyle/>
+          <a:p>
+            <a:pPr algn="l"/>
+            <a:r>
+              <a:rPr sz="900" b="0">
+                <a:solidFill>
+                  <a:srgbClr val="2C3E50"/>
+                </a:solidFill>
+              </a:rPr>
+              <a:t>--no-dedup behält alle Issues — nützlich wenn sich Zeitfenster der Abfragen überschneiden</a:t>
+            </a:r>
+          </a:p>
+        </p:txBody>
+      </p:sp>
+      <p:sp>
+        <p:nvSpPr>
+          <p:cNvPr id="24" name="Rectangle 23"/>
+          <p:cNvSpPr/>
+          <p:nvPr/>
+        </p:nvSpPr>
+        <p:spPr>
+          <a:xfrm>
+            <a:off x="274320" y="3959351"/>
+            <a:ext cx="2926080" cy="658368"/>
+          </a:xfrm>
+          <a:prstGeom prst="rect">
+            <a:avLst/>
+          </a:prstGeom>
+          <a:solidFill>
+            <a:srgbClr val="ECF0F1"/>
+          </a:solidFill>
+          <a:ln>
+            <a:noFill/>
+          </a:ln>
+        </p:spPr>
+        <p:style>
+          <a:lnRef idx="1">
+            <a:schemeClr val="accent1"/>
+          </a:lnRef>
+          <a:fillRef idx="3">
+            <a:schemeClr val="accent1"/>
+          </a:fillRef>
+          <a:effectRef idx="2">
+            <a:schemeClr val="accent1"/>
+          </a:effectRef>
+          <a:fontRef idx="minor">
+            <a:schemeClr val="lt1"/>
+          </a:fontRef>
+        </p:style>
+        <p:txBody>
+          <a:bodyPr rtlCol="0" anchor="ctr"/>
+          <a:lstStyle/>
+          <a:p>
+            <a:pPr algn="ctr"/>
+          </a:p>
+        </p:txBody>
+      </p:sp>
+      <p:sp>
+        <p:nvSpPr>
+          <p:cNvPr id="25" name="Rectangle 24"/>
+          <p:cNvSpPr/>
+          <p:nvPr/>
+        </p:nvSpPr>
+        <p:spPr>
+          <a:xfrm>
+            <a:off x="3291840" y="3959351"/>
+            <a:ext cx="8595360" cy="658368"/>
+          </a:xfrm>
+          <a:prstGeom prst="rect">
+            <a:avLst/>
+          </a:prstGeom>
+          <a:solidFill>
+            <a:srgbClr val="ECF0F1"/>
+          </a:solidFill>
+          <a:ln>
+            <a:noFill/>
+          </a:ln>
+        </p:spPr>
+        <p:style>
+          <a:lnRef idx="1">
+            <a:schemeClr val="accent1"/>
+          </a:lnRef>
+          <a:fillRef idx="3">
+            <a:schemeClr val="accent1"/>
+          </a:fillRef>
+          <a:effectRef idx="2">
+            <a:schemeClr val="accent1"/>
+          </a:effectRef>
+          <a:fontRef idx="minor">
+            <a:schemeClr val="lt1"/>
+          </a:fontRef>
+        </p:style>
+        <p:txBody>
+          <a:bodyPr rtlCol="0" anchor="ctr"/>
+          <a:lstStyle/>
+          <a:p>
+            <a:pPr algn="ctr"/>
+          </a:p>
+        </p:txBody>
+      </p:sp>
+      <p:sp>
+        <p:nvSpPr>
+          <p:cNvPr id="26" name="TextBox 25"/>
+          <p:cNvSpPr txBox="1"/>
+          <p:nvPr/>
+        </p:nvSpPr>
+        <p:spPr>
+          <a:xfrm>
+            <a:off x="347472" y="3995927"/>
+            <a:ext cx="2788920" cy="603503"/>
+          </a:xfrm>
+          <a:prstGeom prst="rect">
+            <a:avLst/>
+          </a:prstGeom>
+          <a:noFill/>
+        </p:spPr>
+        <p:txBody>
+          <a:bodyPr wrap="square">
+            <a:spAutoFit/>
+          </a:bodyPr>
+          <a:lstStyle/>
+          <a:p>
+            <a:pPr algn="l"/>
+            <a:r>
+              <a:rPr sz="900" b="1">
+                <a:solidFill>
+                  <a:srgbClr val="2C3E50"/>
+                </a:solidFill>
+              </a:rPr>
+              <a:t>GUI</a:t>
+            </a:r>
+          </a:p>
+        </p:txBody>
+      </p:sp>
+      <p:sp>
+        <p:nvSpPr>
+          <p:cNvPr id="27" name="TextBox 26"/>
+          <p:cNvSpPr txBox="1"/>
+          <p:nvPr/>
+        </p:nvSpPr>
+        <p:spPr>
+          <a:xfrm>
+            <a:off x="3364992" y="3995927"/>
+            <a:ext cx="8412480" cy="603503"/>
+          </a:xfrm>
+          <a:prstGeom prst="rect">
+            <a:avLst/>
+          </a:prstGeom>
+          <a:noFill/>
+        </p:spPr>
+        <p:txBody>
+          <a:bodyPr wrap="square">
+            <a:spAutoFit/>
+          </a:bodyPr>
+          <a:lstStyle/>
+          <a:p>
+            <a:pPr algn="l"/>
+            <a:r>
+              <a:rPr sz="900" b="0">
+                <a:solidFill>
+                  <a:srgbClr val="2C3E50"/>
+                </a:solidFill>
+              </a:rPr>
+              <a:t>Multi-File-Listbox + Ausgabepfad-Dialog + Dedup-Checkbox; Ladebalken nach 3 Sekunden</a:t>
+            </a:r>
+          </a:p>
+        </p:txBody>
+      </p:sp>
+      <p:sp>
+        <p:nvSpPr>
+          <p:cNvPr id="28" name="Rectangle 27"/>
+          <p:cNvSpPr/>
+          <p:nvPr/>
+        </p:nvSpPr>
+        <p:spPr>
+          <a:xfrm>
+            <a:off x="274320" y="4617719"/>
+            <a:ext cx="2926080" cy="658368"/>
+          </a:xfrm>
+          <a:prstGeom prst="rect">
+            <a:avLst/>
+          </a:prstGeom>
+          <a:solidFill>
+            <a:srgbClr val="FFFFFF"/>
+          </a:solidFill>
+          <a:ln>
+            <a:noFill/>
+          </a:ln>
+        </p:spPr>
+        <p:style>
+          <a:lnRef idx="1">
+            <a:schemeClr val="accent1"/>
+          </a:lnRef>
+          <a:fillRef idx="3">
+            <a:schemeClr val="accent1"/>
+          </a:fillRef>
+          <a:effectRef idx="2">
+            <a:schemeClr val="accent1"/>
+          </a:effectRef>
+          <a:fontRef idx="minor">
+            <a:schemeClr val="lt1"/>
+          </a:fontRef>
+        </p:style>
+        <p:txBody>
+          <a:bodyPr rtlCol="0" anchor="ctr"/>
+          <a:lstStyle/>
+          <a:p>
+            <a:pPr algn="ctr"/>
+          </a:p>
+        </p:txBody>
+      </p:sp>
+      <p:sp>
+        <p:nvSpPr>
+          <p:cNvPr id="29" name="Rectangle 28"/>
+          <p:cNvSpPr/>
+          <p:nvPr/>
+        </p:nvSpPr>
+        <p:spPr>
+          <a:xfrm>
+            <a:off x="3291840" y="4617719"/>
+            <a:ext cx="8595360" cy="658368"/>
+          </a:xfrm>
+          <a:prstGeom prst="rect">
+            <a:avLst/>
+          </a:prstGeom>
+          <a:solidFill>
+            <a:srgbClr val="FFFFFF"/>
+          </a:solidFill>
+          <a:ln>
+            <a:noFill/>
+          </a:ln>
+        </p:spPr>
+        <p:style>
+          <a:lnRef idx="1">
+            <a:schemeClr val="accent1"/>
+          </a:lnRef>
+          <a:fillRef idx="3">
+            <a:schemeClr val="accent1"/>
+          </a:fillRef>
+          <a:effectRef idx="2">
+            <a:schemeClr val="accent1"/>
+          </a:effectRef>
+          <a:fontRef idx="minor">
+            <a:schemeClr val="lt1"/>
+          </a:fontRef>
+        </p:style>
+        <p:txBody>
+          <a:bodyPr rtlCol="0" anchor="ctr"/>
+          <a:lstStyle/>
+          <a:p>
+            <a:pPr algn="ctr"/>
+          </a:p>
+        </p:txBody>
+      </p:sp>
+      <p:sp>
+        <p:nvSpPr>
+          <p:cNvPr id="30" name="TextBox 29"/>
+          <p:cNvSpPr txBox="1"/>
+          <p:nvPr/>
+        </p:nvSpPr>
+        <p:spPr>
+          <a:xfrm>
+            <a:off x="347472" y="4654295"/>
+            <a:ext cx="2788920" cy="603503"/>
+          </a:xfrm>
+          <a:prstGeom prst="rect">
+            <a:avLst/>
+          </a:prstGeom>
+          <a:noFill/>
+        </p:spPr>
+        <p:txBody>
+          <a:bodyPr wrap="square">
+            <a:spAutoFit/>
+          </a:bodyPr>
+          <a:lstStyle/>
+          <a:p>
+            <a:pPr algn="l"/>
+            <a:r>
+              <a:rPr sz="900" b="1">
+                <a:solidFill>
+                  <a:srgbClr val="2C3E50"/>
+                </a:solidFill>
+              </a:rPr>
+              <a:t>CLI</a:t>
+            </a:r>
+          </a:p>
+        </p:txBody>
+      </p:sp>
+      <p:sp>
+        <p:nvSpPr>
+          <p:cNvPr id="31" name="TextBox 30"/>
+          <p:cNvSpPr txBox="1"/>
+          <p:nvPr/>
+        </p:nvSpPr>
+        <p:spPr>
+          <a:xfrm>
+            <a:off x="3364992" y="4654295"/>
+            <a:ext cx="8412480" cy="603503"/>
+          </a:xfrm>
+          <a:prstGeom prst="rect">
+            <a:avLst/>
+          </a:prstGeom>
+          <a:noFill/>
+        </p:spPr>
+        <p:txBody>
+          <a:bodyPr wrap="square">
+            <a:spAutoFit/>
+          </a:bodyPr>
+          <a:lstStyle/>
+          <a:p>
+            <a:pPr algn="l"/>
+            <a:r>
+              <a:rPr sz="900" b="0">
+                <a:solidFill>
+                  <a:srgbClr val="2C3E50"/>
+                </a:solidFill>
+              </a:rPr>
+              <a:t>python -m helper file1.json file2.json --output merged.json [--no-dedup]</a:t>
+            </a:r>
+          </a:p>
+        </p:txBody>
+      </p:sp>
+      <p:sp>
+        <p:nvSpPr>
+          <p:cNvPr id="32" name="Rectangle 31"/>
+          <p:cNvSpPr/>
+          <p:nvPr/>
+        </p:nvSpPr>
+        <p:spPr>
+          <a:xfrm>
+            <a:off x="274320" y="5276087"/>
+            <a:ext cx="2926080" cy="658368"/>
+          </a:xfrm>
+          <a:prstGeom prst="rect">
+            <a:avLst/>
+          </a:prstGeom>
+          <a:solidFill>
+            <a:srgbClr val="ECF0F1"/>
+          </a:solidFill>
+          <a:ln>
+            <a:noFill/>
+          </a:ln>
+        </p:spPr>
+        <p:style>
+          <a:lnRef idx="1">
+            <a:schemeClr val="accent1"/>
+          </a:lnRef>
+          <a:fillRef idx="3">
+            <a:schemeClr val="accent1"/>
+          </a:fillRef>
+          <a:effectRef idx="2">
+            <a:schemeClr val="accent1"/>
+          </a:effectRef>
+          <a:fontRef idx="minor">
+            <a:schemeClr val="lt1"/>
+          </a:fontRef>
+        </p:style>
+        <p:txBody>
+          <a:bodyPr rtlCol="0" anchor="ctr"/>
+          <a:lstStyle/>
+          <a:p>
+            <a:pPr algn="ctr"/>
+          </a:p>
+        </p:txBody>
+      </p:sp>
+      <p:sp>
+        <p:nvSpPr>
+          <p:cNvPr id="33" name="Rectangle 32"/>
+          <p:cNvSpPr/>
+          <p:nvPr/>
+        </p:nvSpPr>
+        <p:spPr>
+          <a:xfrm>
+            <a:off x="3291840" y="5276087"/>
+            <a:ext cx="8595360" cy="658368"/>
+          </a:xfrm>
+          <a:prstGeom prst="rect">
+            <a:avLst/>
+          </a:prstGeom>
+          <a:solidFill>
+            <a:srgbClr val="ECF0F1"/>
+          </a:solidFill>
+          <a:ln>
+            <a:noFill/>
+          </a:ln>
+        </p:spPr>
+        <p:style>
+          <a:lnRef idx="1">
+            <a:schemeClr val="accent1"/>
+          </a:lnRef>
+          <a:fillRef idx="3">
+            <a:schemeClr val="accent1"/>
+          </a:fillRef>
+          <a:effectRef idx="2">
+            <a:schemeClr val="accent1"/>
+          </a:effectRef>
+          <a:fontRef idx="minor">
+            <a:schemeClr val="lt1"/>
+          </a:fontRef>
+        </p:style>
+        <p:txBody>
+          <a:bodyPr rtlCol="0" anchor="ctr"/>
+          <a:lstStyle/>
+          <a:p>
+            <a:pPr algn="ctr"/>
+          </a:p>
+        </p:txBody>
+      </p:sp>
+      <p:sp>
+        <p:nvSpPr>
+          <p:cNvPr id="34" name="TextBox 33"/>
+          <p:cNvSpPr txBox="1"/>
+          <p:nvPr/>
+        </p:nvSpPr>
+        <p:spPr>
+          <a:xfrm>
+            <a:off x="347472" y="5312663"/>
+            <a:ext cx="2788920" cy="603503"/>
+          </a:xfrm>
+          <a:prstGeom prst="rect">
+            <a:avLst/>
+          </a:prstGeom>
+          <a:noFill/>
+        </p:spPr>
+        <p:txBody>
+          <a:bodyPr wrap="square">
+            <a:spAutoFit/>
+          </a:bodyPr>
+          <a:lstStyle/>
+          <a:p>
+            <a:pPr algn="l"/>
+            <a:r>
+              <a:rPr sz="900" b="1">
+                <a:solidFill>
+                  <a:srgbClr val="2C3E50"/>
+                </a:solidFill>
+              </a:rPr>
+              <a:t>Ausgabeformat</a:t>
+            </a:r>
+          </a:p>
+        </p:txBody>
+      </p:sp>
+      <p:sp>
+        <p:nvSpPr>
+          <p:cNvPr id="35" name="TextBox 34"/>
+          <p:cNvSpPr txBox="1"/>
+          <p:nvPr/>
+        </p:nvSpPr>
+        <p:spPr>
+          <a:xfrm>
+            <a:off x="3364992" y="5312663"/>
+            <a:ext cx="8412480" cy="603503"/>
+          </a:xfrm>
+          <a:prstGeom prst="rect">
+            <a:avLst/>
+          </a:prstGeom>
+          <a:noFill/>
+        </p:spPr>
+        <p:txBody>
+          <a:bodyPr wrap="square">
+            <a:spAutoFit/>
+          </a:bodyPr>
+          <a:lstStyle/>
+          <a:p>
+            <a:pPr algn="l"/>
+            <a:r>
+              <a:rPr sz="900" b="0">
+                <a:solidFill>
+                  <a:srgbClr val="2C3E50"/>
+                </a:solidFill>
+              </a:rPr>
+              <a:t>Gültiger Jira REST API Envelope (startAt, maxResults, total, issues) — direkt mit transform_data verarbeitbar</a:t>
+            </a:r>
+          </a:p>
+        </p:txBody>
+      </p:sp>
+      <p:sp>
+        <p:nvSpPr>
+          <p:cNvPr id="36" name="Rectangle 35"/>
+          <p:cNvSpPr/>
+          <p:nvPr/>
+        </p:nvSpPr>
+        <p:spPr>
+          <a:xfrm>
+            <a:off x="274320" y="5934455"/>
+            <a:ext cx="2926080" cy="658368"/>
+          </a:xfrm>
+          <a:prstGeom prst="rect">
+            <a:avLst/>
+          </a:prstGeom>
+          <a:solidFill>
+            <a:srgbClr val="FFFFFF"/>
+          </a:solidFill>
+          <a:ln>
+            <a:noFill/>
+          </a:ln>
+        </p:spPr>
+        <p:style>
+          <a:lnRef idx="1">
+            <a:schemeClr val="accent1"/>
+          </a:lnRef>
+          <a:fillRef idx="3">
+            <a:schemeClr val="accent1"/>
+          </a:fillRef>
+          <a:effectRef idx="2">
+            <a:schemeClr val="accent1"/>
+          </a:effectRef>
+          <a:fontRef idx="minor">
+            <a:schemeClr val="lt1"/>
+          </a:fontRef>
+        </p:style>
+        <p:txBody>
+          <a:bodyPr rtlCol="0" anchor="ctr"/>
+          <a:lstStyle/>
+          <a:p>
+            <a:pPr algn="ctr"/>
+          </a:p>
+        </p:txBody>
+      </p:sp>
+      <p:sp>
+        <p:nvSpPr>
+          <p:cNvPr id="37" name="Rectangle 36"/>
+          <p:cNvSpPr/>
+          <p:nvPr/>
+        </p:nvSpPr>
+        <p:spPr>
+          <a:xfrm>
+            <a:off x="3291840" y="5934455"/>
+            <a:ext cx="8595360" cy="658368"/>
+          </a:xfrm>
+          <a:prstGeom prst="rect">
+            <a:avLst/>
+          </a:prstGeom>
+          <a:solidFill>
+            <a:srgbClr val="FFFFFF"/>
+          </a:solidFill>
+          <a:ln>
+            <a:noFill/>
+          </a:ln>
+        </p:spPr>
+        <p:style>
+          <a:lnRef idx="1">
+            <a:schemeClr val="accent1"/>
+          </a:lnRef>
+          <a:fillRef idx="3">
+            <a:schemeClr val="accent1"/>
+          </a:fillRef>
+          <a:effectRef idx="2">
+            <a:schemeClr val="accent1"/>
+          </a:effectRef>
+          <a:fontRef idx="minor">
+            <a:schemeClr val="lt1"/>
+          </a:fontRef>
+        </p:style>
+        <p:txBody>
+          <a:bodyPr rtlCol="0" anchor="ctr"/>
+          <a:lstStyle/>
+          <a:p>
+            <a:pPr algn="ctr"/>
+          </a:p>
+        </p:txBody>
+      </p:sp>
+      <p:sp>
+        <p:nvSpPr>
+          <p:cNvPr id="38" name="TextBox 37"/>
+          <p:cNvSpPr txBox="1"/>
+          <p:nvPr/>
+        </p:nvSpPr>
+        <p:spPr>
+          <a:xfrm>
+            <a:off x="347472" y="5971031"/>
+            <a:ext cx="2788920" cy="603503"/>
+          </a:xfrm>
+          <a:prstGeom prst="rect">
+            <a:avLst/>
+          </a:prstGeom>
+          <a:noFill/>
+        </p:spPr>
+        <p:txBody>
+          <a:bodyPr wrap="square">
+            <a:spAutoFit/>
+          </a:bodyPr>
+          <a:lstStyle/>
+          <a:p>
+            <a:pPr algn="l"/>
+            <a:r>
+              <a:rPr sz="900" b="1">
+                <a:solidFill>
+                  <a:srgbClr val="2C3E50"/>
+                </a:solidFill>
+              </a:rPr>
+              <a:t>Doppelklick-Starter</a:t>
+            </a:r>
+          </a:p>
+        </p:txBody>
+      </p:sp>
+      <p:sp>
+        <p:nvSpPr>
+          <p:cNvPr id="39" name="TextBox 38"/>
+          <p:cNvSpPr txBox="1"/>
+          <p:nvPr/>
+        </p:nvSpPr>
+        <p:spPr>
+          <a:xfrm>
+            <a:off x="3364992" y="5971031"/>
+            <a:ext cx="8412480" cy="603503"/>
+          </a:xfrm>
+          <a:prstGeom prst="rect">
+            <a:avLst/>
+          </a:prstGeom>
+          <a:noFill/>
+        </p:spPr>
+        <p:txBody>
+          <a:bodyPr wrap="square">
+            <a:spAutoFit/>
+          </a:bodyPr>
+          <a:lstStyle/>
+          <a:p>
+            <a:pPr algn="l"/>
+            <a:r>
+              <a:rPr sz="900" b="0">
+                <a:solidFill>
+                  <a:srgbClr val="2C3E50"/>
+                </a:solidFill>
+              </a:rPr>
+              <a:t>helper_gui.pyw startet die GUI ohne Konsolenfenster</a:t>
+            </a:r>
+          </a:p>
+        </p:txBody>
+      </p:sp>
+      <p:sp>
+        <p:nvSpPr>
+          <p:cNvPr id="40" name="Rectangle 39"/>
+          <p:cNvSpPr/>
+          <p:nvPr/>
+        </p:nvSpPr>
+        <p:spPr>
+          <a:xfrm>
+            <a:off x="0" y="6720840"/>
+            <a:ext cx="12188952" cy="137160"/>
+          </a:xfrm>
+          <a:prstGeom prst="rect">
+            <a:avLst/>
+          </a:prstGeom>
+          <a:solidFill>
+            <a:srgbClr val="2980B9"/>
+          </a:solidFill>
+          <a:ln>
+            <a:noFill/>
+          </a:ln>
+        </p:spPr>
+        <p:style>
+          <a:lnRef idx="1">
+            <a:schemeClr val="accent1"/>
+          </a:lnRef>
+          <a:fillRef idx="3">
+            <a:schemeClr val="accent1"/>
+          </a:fillRef>
+          <a:effectRef idx="2">
+            <a:schemeClr val="accent1"/>
+          </a:effectRef>
+          <a:fontRef idx="minor">
+            <a:schemeClr val="lt1"/>
+          </a:fontRef>
+        </p:style>
+        <p:txBody>
+          <a:bodyPr rtlCol="0" anchor="ctr"/>
+          <a:lstStyle/>
+          <a:p>
+            <a:pPr algn="ctr"/>
           </a:p>
         </p:txBody>
       </p:sp>
@@ -4263,7 +5789,7 @@
                   <a:srgbClr val="2C3E50"/>
                 </a:solidFill>
               </a:rPr>
-              <a:t>ALPHA-Badge</a:t>
+              <a:t>BETA / ALPHA-Badges</a:t>
             </a:r>
           </a:p>
         </p:txBody>
@@ -4297,7 +5823,7 @@
                   <a:srgbClr val="2C3E50"/>
                 </a:solidFill>
               </a:rPr>
-              <a:t>Rotes ALPHA-Badge in der Titelleiste signalisiert Alpha-Status des Projekts</a:t>
+              <a:t>Orangefarbenes BETA-Badge im Titel zeigt den Gesamtreifegrad; jede Modul-Karte trägt ein eigenes ALPHA- oder BETA-Badge neben dem Namen</a:t>
             </a:r>
           </a:p>
         </p:txBody>
@@ -11131,7 +12657,7 @@
                   <a:srgbClr val="2C3E50"/>
                 </a:solidFill>
               </a:rPr>
-              <a:t>SemVer ab v0.2.0; zentrale version.py wird von allen GUIs und den Manuals gelesen; aktuell v0.8.4</a:t>
+              <a:t>SemVer ab v0.2.0; zentrale version.py wird von allen GUIs und den Manuals gelesen; aktuell v0.9.0</a:t>
             </a:r>
           </a:p>
         </p:txBody>
@@ -12055,7 +13581,7 @@
                   <a:srgbClr val="2C3E50"/>
                 </a:solidFill>
               </a:rPr>
-              <a:t>Unit- und Acceptance-Tests für alle Module; aktuell 542 Tests</a:t>
+              <a:t>Unit- und Acceptance-Tests für alle Module; aktuell 628 Tests</a:t>
             </a:r>
           </a:p>
         </p:txBody>
@@ -12076,6 +13602,1530 @@
           </a:prstGeom>
           <a:solidFill>
             <a:srgbClr val="27AE60"/>
+          </a:solidFill>
+          <a:ln>
+            <a:noFill/>
+          </a:ln>
+        </p:spPr>
+        <p:style>
+          <a:lnRef idx="1">
+            <a:schemeClr val="accent1"/>
+          </a:lnRef>
+          <a:fillRef idx="3">
+            <a:schemeClr val="accent1"/>
+          </a:fillRef>
+          <a:effectRef idx="2">
+            <a:schemeClr val="accent1"/>
+          </a:effectRef>
+          <a:fontRef idx="minor">
+            <a:schemeClr val="lt1"/>
+          </a:fontRef>
+        </p:style>
+        <p:txBody>
+          <a:bodyPr rtlCol="0" anchor="ctr"/>
+          <a:lstStyle/>
+          <a:p>
+            <a:pPr algn="ctr"/>
+          </a:p>
+        </p:txBody>
+      </p:sp>
+    </p:spTree>
+  </p:cSld>
+  <p:clrMapOvr>
+    <a:masterClrMapping/>
+  </p:clrMapOvr>
+</p:sld>
+</file>
+
+<file path=ppt/slides/slide9.xml><?xml version="1.0" encoding="utf-8"?>
+<p:sld xmlns:a="http://schemas.openxmlformats.org/drawingml/2006/main" xmlns:p="http://schemas.openxmlformats.org/presentationml/2006/main" xmlns:r="http://schemas.openxmlformats.org/officeDocument/2006/relationships">
+  <p:cSld>
+    <p:spTree>
+      <p:nvGrpSpPr>
+        <p:cNvPr id="1" name=""/>
+        <p:cNvGrpSpPr/>
+        <p:nvPr/>
+      </p:nvGrpSpPr>
+      <p:grpSpPr/>
+      <p:sp>
+        <p:nvSpPr>
+          <p:cNvPr id="2" name="Rectangle 1"/>
+          <p:cNvSpPr/>
+          <p:nvPr/>
+        </p:nvSpPr>
+        <p:spPr>
+          <a:xfrm>
+            <a:off x="0" y="0"/>
+            <a:ext cx="12188952" cy="822960"/>
+          </a:xfrm>
+          <a:prstGeom prst="rect">
+            <a:avLst/>
+          </a:prstGeom>
+          <a:solidFill>
+            <a:srgbClr val="2C3E50"/>
+          </a:solidFill>
+          <a:ln>
+            <a:noFill/>
+          </a:ln>
+        </p:spPr>
+        <p:style>
+          <a:lnRef idx="1">
+            <a:schemeClr val="accent1"/>
+          </a:lnRef>
+          <a:fillRef idx="3">
+            <a:schemeClr val="accent1"/>
+          </a:fillRef>
+          <a:effectRef idx="2">
+            <a:schemeClr val="accent1"/>
+          </a:effectRef>
+          <a:fontRef idx="minor">
+            <a:schemeClr val="lt1"/>
+          </a:fontRef>
+        </p:style>
+        <p:txBody>
+          <a:bodyPr rtlCol="0" anchor="ctr"/>
+          <a:lstStyle/>
+          <a:p>
+            <a:pPr algn="ctr"/>
+          </a:p>
+        </p:txBody>
+      </p:sp>
+      <p:sp>
+        <p:nvSpPr>
+          <p:cNvPr id="3" name="TextBox 2"/>
+          <p:cNvSpPr txBox="1"/>
+          <p:nvPr/>
+        </p:nvSpPr>
+        <p:spPr>
+          <a:xfrm>
+            <a:off x="274320" y="91440"/>
+            <a:ext cx="11612880" cy="640080"/>
+          </a:xfrm>
+          <a:prstGeom prst="rect">
+            <a:avLst/>
+          </a:prstGeom>
+          <a:noFill/>
+        </p:spPr>
+        <p:txBody>
+          <a:bodyPr wrap="square">
+            <a:spAutoFit/>
+          </a:bodyPr>
+          <a:lstStyle/>
+          <a:p>
+            <a:pPr algn="l"/>
+            <a:r>
+              <a:rPr sz="2200" b="1">
+                <a:solidFill>
+                  <a:srgbClr val="FFFFFF"/>
+                </a:solidFill>
+              </a:rPr>
+              <a:t>testdata_generator</a:t>
+            </a:r>
+          </a:p>
+        </p:txBody>
+      </p:sp>
+      <p:sp>
+        <p:nvSpPr>
+          <p:cNvPr id="4" name="Rectangle 3"/>
+          <p:cNvSpPr/>
+          <p:nvPr/>
+        </p:nvSpPr>
+        <p:spPr>
+          <a:xfrm>
+            <a:off x="274320" y="914400"/>
+            <a:ext cx="2926080" cy="320040"/>
+          </a:xfrm>
+          <a:prstGeom prst="rect">
+            <a:avLst/>
+          </a:prstGeom>
+          <a:solidFill>
+            <a:srgbClr val="2980B9"/>
+          </a:solidFill>
+          <a:ln>
+            <a:noFill/>
+          </a:ln>
+        </p:spPr>
+        <p:style>
+          <a:lnRef idx="1">
+            <a:schemeClr val="accent1"/>
+          </a:lnRef>
+          <a:fillRef idx="3">
+            <a:schemeClr val="accent1"/>
+          </a:fillRef>
+          <a:effectRef idx="2">
+            <a:schemeClr val="accent1"/>
+          </a:effectRef>
+          <a:fontRef idx="minor">
+            <a:schemeClr val="lt1"/>
+          </a:fontRef>
+        </p:style>
+        <p:txBody>
+          <a:bodyPr rtlCol="0" anchor="ctr"/>
+          <a:lstStyle/>
+          <a:p>
+            <a:pPr algn="ctr"/>
+          </a:p>
+        </p:txBody>
+      </p:sp>
+      <p:sp>
+        <p:nvSpPr>
+          <p:cNvPr id="5" name="Rectangle 4"/>
+          <p:cNvSpPr/>
+          <p:nvPr/>
+        </p:nvSpPr>
+        <p:spPr>
+          <a:xfrm>
+            <a:off x="3291840" y="914400"/>
+            <a:ext cx="8595360" cy="320040"/>
+          </a:xfrm>
+          <a:prstGeom prst="rect">
+            <a:avLst/>
+          </a:prstGeom>
+          <a:solidFill>
+            <a:srgbClr val="2980B9"/>
+          </a:solidFill>
+          <a:ln>
+            <a:noFill/>
+          </a:ln>
+        </p:spPr>
+        <p:style>
+          <a:lnRef idx="1">
+            <a:schemeClr val="accent1"/>
+          </a:lnRef>
+          <a:fillRef idx="3">
+            <a:schemeClr val="accent1"/>
+          </a:fillRef>
+          <a:effectRef idx="2">
+            <a:schemeClr val="accent1"/>
+          </a:effectRef>
+          <a:fontRef idx="minor">
+            <a:schemeClr val="lt1"/>
+          </a:fontRef>
+        </p:style>
+        <p:txBody>
+          <a:bodyPr rtlCol="0" anchor="ctr"/>
+          <a:lstStyle/>
+          <a:p>
+            <a:pPr algn="ctr"/>
+          </a:p>
+        </p:txBody>
+      </p:sp>
+      <p:sp>
+        <p:nvSpPr>
+          <p:cNvPr id="6" name="TextBox 5"/>
+          <p:cNvSpPr txBox="1"/>
+          <p:nvPr/>
+        </p:nvSpPr>
+        <p:spPr>
+          <a:xfrm>
+            <a:off x="320040" y="932688"/>
+            <a:ext cx="2834640" cy="274320"/>
+          </a:xfrm>
+          <a:prstGeom prst="rect">
+            <a:avLst/>
+          </a:prstGeom>
+          <a:noFill/>
+        </p:spPr>
+        <p:txBody>
+          <a:bodyPr wrap="square">
+            <a:spAutoFit/>
+          </a:bodyPr>
+          <a:lstStyle/>
+          <a:p>
+            <a:pPr algn="l"/>
+            <a:r>
+              <a:rPr sz="900" b="1">
+                <a:solidFill>
+                  <a:srgbClr val="FFFFFF"/>
+                </a:solidFill>
+              </a:rPr>
+              <a:t>Feature</a:t>
+            </a:r>
+          </a:p>
+        </p:txBody>
+      </p:sp>
+      <p:sp>
+        <p:nvSpPr>
+          <p:cNvPr id="7" name="TextBox 6"/>
+          <p:cNvSpPr txBox="1"/>
+          <p:nvPr/>
+        </p:nvSpPr>
+        <p:spPr>
+          <a:xfrm>
+            <a:off x="3337560" y="932688"/>
+            <a:ext cx="8503920" cy="274320"/>
+          </a:xfrm>
+          <a:prstGeom prst="rect">
+            <a:avLst/>
+          </a:prstGeom>
+          <a:noFill/>
+        </p:spPr>
+        <p:txBody>
+          <a:bodyPr wrap="square">
+            <a:spAutoFit/>
+          </a:bodyPr>
+          <a:lstStyle/>
+          <a:p>
+            <a:pPr algn="l"/>
+            <a:r>
+              <a:rPr sz="900" b="1">
+                <a:solidFill>
+                  <a:srgbClr val="FFFFFF"/>
+                </a:solidFill>
+              </a:rPr>
+              <a:t>Beschreibung</a:t>
+            </a:r>
+          </a:p>
+        </p:txBody>
+      </p:sp>
+      <p:sp>
+        <p:nvSpPr>
+          <p:cNvPr id="8" name="Rectangle 7"/>
+          <p:cNvSpPr/>
+          <p:nvPr/>
+        </p:nvSpPr>
+        <p:spPr>
+          <a:xfrm>
+            <a:off x="274320" y="1325880"/>
+            <a:ext cx="2926080" cy="658368"/>
+          </a:xfrm>
+          <a:prstGeom prst="rect">
+            <a:avLst/>
+          </a:prstGeom>
+          <a:solidFill>
+            <a:srgbClr val="ECF0F1"/>
+          </a:solidFill>
+          <a:ln>
+            <a:noFill/>
+          </a:ln>
+        </p:spPr>
+        <p:style>
+          <a:lnRef idx="1">
+            <a:schemeClr val="accent1"/>
+          </a:lnRef>
+          <a:fillRef idx="3">
+            <a:schemeClr val="accent1"/>
+          </a:fillRef>
+          <a:effectRef idx="2">
+            <a:schemeClr val="accent1"/>
+          </a:effectRef>
+          <a:fontRef idx="minor">
+            <a:schemeClr val="lt1"/>
+          </a:fontRef>
+        </p:style>
+        <p:txBody>
+          <a:bodyPr rtlCol="0" anchor="ctr"/>
+          <a:lstStyle/>
+          <a:p>
+            <a:pPr algn="ctr"/>
+          </a:p>
+        </p:txBody>
+      </p:sp>
+      <p:sp>
+        <p:nvSpPr>
+          <p:cNvPr id="9" name="Rectangle 8"/>
+          <p:cNvSpPr/>
+          <p:nvPr/>
+        </p:nvSpPr>
+        <p:spPr>
+          <a:xfrm>
+            <a:off x="3291840" y="1325880"/>
+            <a:ext cx="8595360" cy="658368"/>
+          </a:xfrm>
+          <a:prstGeom prst="rect">
+            <a:avLst/>
+          </a:prstGeom>
+          <a:solidFill>
+            <a:srgbClr val="ECF0F1"/>
+          </a:solidFill>
+          <a:ln>
+            <a:noFill/>
+          </a:ln>
+        </p:spPr>
+        <p:style>
+          <a:lnRef idx="1">
+            <a:schemeClr val="accent1"/>
+          </a:lnRef>
+          <a:fillRef idx="3">
+            <a:schemeClr val="accent1"/>
+          </a:fillRef>
+          <a:effectRef idx="2">
+            <a:schemeClr val="accent1"/>
+          </a:effectRef>
+          <a:fontRef idx="minor">
+            <a:schemeClr val="lt1"/>
+          </a:fontRef>
+        </p:style>
+        <p:txBody>
+          <a:bodyPr rtlCol="0" anchor="ctr"/>
+          <a:lstStyle/>
+          <a:p>
+            <a:pPr algn="ctr"/>
+          </a:p>
+        </p:txBody>
+      </p:sp>
+      <p:sp>
+        <p:nvSpPr>
+          <p:cNvPr id="10" name="TextBox 9"/>
+          <p:cNvSpPr txBox="1"/>
+          <p:nvPr/>
+        </p:nvSpPr>
+        <p:spPr>
+          <a:xfrm>
+            <a:off x="347472" y="1362456"/>
+            <a:ext cx="2788920" cy="603503"/>
+          </a:xfrm>
+          <a:prstGeom prst="rect">
+            <a:avLst/>
+          </a:prstGeom>
+          <a:noFill/>
+        </p:spPr>
+        <p:txBody>
+          <a:bodyPr wrap="square">
+            <a:spAutoFit/>
+          </a:bodyPr>
+          <a:lstStyle/>
+          <a:p>
+            <a:pPr algn="l"/>
+            <a:r>
+              <a:rPr sz="900" b="1">
+                <a:solidFill>
+                  <a:srgbClr val="2C3E50"/>
+                </a:solidFill>
+              </a:rPr>
+              <a:t>Synthetische Testdaten</a:t>
+            </a:r>
+          </a:p>
+        </p:txBody>
+      </p:sp>
+      <p:sp>
+        <p:nvSpPr>
+          <p:cNvPr id="11" name="TextBox 10"/>
+          <p:cNvSpPr txBox="1"/>
+          <p:nvPr/>
+        </p:nvSpPr>
+        <p:spPr>
+          <a:xfrm>
+            <a:off x="3364992" y="1362456"/>
+            <a:ext cx="8412480" cy="603503"/>
+          </a:xfrm>
+          <a:prstGeom prst="rect">
+            <a:avLst/>
+          </a:prstGeom>
+          <a:noFill/>
+        </p:spPr>
+        <p:txBody>
+          <a:bodyPr wrap="square">
+            <a:spAutoFit/>
+          </a:bodyPr>
+          <a:lstStyle/>
+          <a:p>
+            <a:pPr algn="l"/>
+            <a:r>
+              <a:rPr sz="900" b="0">
+                <a:solidFill>
+                  <a:srgbClr val="2C3E50"/>
+                </a:solidFill>
+              </a:rPr>
+              <a:t>Erzeugt Jira-JSON-Exporte mit realistischem Workflow-Verlauf — direkt mit transform_data verarbeitbar</a:t>
+            </a:r>
+          </a:p>
+        </p:txBody>
+      </p:sp>
+      <p:sp>
+        <p:nvSpPr>
+          <p:cNvPr id="12" name="Rectangle 11"/>
+          <p:cNvSpPr/>
+          <p:nvPr/>
+        </p:nvSpPr>
+        <p:spPr>
+          <a:xfrm>
+            <a:off x="274320" y="1984248"/>
+            <a:ext cx="2926080" cy="658368"/>
+          </a:xfrm>
+          <a:prstGeom prst="rect">
+            <a:avLst/>
+          </a:prstGeom>
+          <a:solidFill>
+            <a:srgbClr val="FFFFFF"/>
+          </a:solidFill>
+          <a:ln>
+            <a:noFill/>
+          </a:ln>
+        </p:spPr>
+        <p:style>
+          <a:lnRef idx="1">
+            <a:schemeClr val="accent1"/>
+          </a:lnRef>
+          <a:fillRef idx="3">
+            <a:schemeClr val="accent1"/>
+          </a:fillRef>
+          <a:effectRef idx="2">
+            <a:schemeClr val="accent1"/>
+          </a:effectRef>
+          <a:fontRef idx="minor">
+            <a:schemeClr val="lt1"/>
+          </a:fontRef>
+        </p:style>
+        <p:txBody>
+          <a:bodyPr rtlCol="0" anchor="ctr"/>
+          <a:lstStyle/>
+          <a:p>
+            <a:pPr algn="ctr"/>
+          </a:p>
+        </p:txBody>
+      </p:sp>
+      <p:sp>
+        <p:nvSpPr>
+          <p:cNvPr id="13" name="Rectangle 12"/>
+          <p:cNvSpPr/>
+          <p:nvPr/>
+        </p:nvSpPr>
+        <p:spPr>
+          <a:xfrm>
+            <a:off x="3291840" y="1984248"/>
+            <a:ext cx="8595360" cy="658368"/>
+          </a:xfrm>
+          <a:prstGeom prst="rect">
+            <a:avLst/>
+          </a:prstGeom>
+          <a:solidFill>
+            <a:srgbClr val="FFFFFF"/>
+          </a:solidFill>
+          <a:ln>
+            <a:noFill/>
+          </a:ln>
+        </p:spPr>
+        <p:style>
+          <a:lnRef idx="1">
+            <a:schemeClr val="accent1"/>
+          </a:lnRef>
+          <a:fillRef idx="3">
+            <a:schemeClr val="accent1"/>
+          </a:fillRef>
+          <a:effectRef idx="2">
+            <a:schemeClr val="accent1"/>
+          </a:effectRef>
+          <a:fontRef idx="minor">
+            <a:schemeClr val="lt1"/>
+          </a:fontRef>
+        </p:style>
+        <p:txBody>
+          <a:bodyPr rtlCol="0" anchor="ctr"/>
+          <a:lstStyle/>
+          <a:p>
+            <a:pPr algn="ctr"/>
+          </a:p>
+        </p:txBody>
+      </p:sp>
+      <p:sp>
+        <p:nvSpPr>
+          <p:cNvPr id="14" name="TextBox 13"/>
+          <p:cNvSpPr txBox="1"/>
+          <p:nvPr/>
+        </p:nvSpPr>
+        <p:spPr>
+          <a:xfrm>
+            <a:off x="347472" y="2020824"/>
+            <a:ext cx="2788920" cy="603503"/>
+          </a:xfrm>
+          <a:prstGeom prst="rect">
+            <a:avLst/>
+          </a:prstGeom>
+          <a:noFill/>
+        </p:spPr>
+        <p:txBody>
+          <a:bodyPr wrap="square">
+            <a:spAutoFit/>
+          </a:bodyPr>
+          <a:lstStyle/>
+          <a:p>
+            <a:pPr algn="l"/>
+            <a:r>
+              <a:rPr sz="900" b="1">
+                <a:solidFill>
+                  <a:srgbClr val="2C3E50"/>
+                </a:solidFill>
+              </a:rPr>
+              <a:t>Konfigurierbar</a:t>
+            </a:r>
+          </a:p>
+        </p:txBody>
+      </p:sp>
+      <p:sp>
+        <p:nvSpPr>
+          <p:cNvPr id="15" name="TextBox 14"/>
+          <p:cNvSpPr txBox="1"/>
+          <p:nvPr/>
+        </p:nvSpPr>
+        <p:spPr>
+          <a:xfrm>
+            <a:off x="3364992" y="2020824"/>
+            <a:ext cx="8412480" cy="603503"/>
+          </a:xfrm>
+          <a:prstGeom prst="rect">
+            <a:avLst/>
+          </a:prstGeom>
+          <a:noFill/>
+        </p:spPr>
+        <p:txBody>
+          <a:bodyPr wrap="square">
+            <a:spAutoFit/>
+          </a:bodyPr>
+          <a:lstStyle/>
+          <a:p>
+            <a:pPr algn="l"/>
+            <a:r>
+              <a:rPr sz="900" b="0">
+                <a:solidFill>
+                  <a:srgbClr val="2C3E50"/>
+                </a:solidFill>
+              </a:rPr>
+              <a:t>Projekt-Key, Issue-Anzahl, Zeitraum, Completion-Rate, Backflow-Wahrscheinlichkeit und Seed — via GUI oder CLI</a:t>
+            </a:r>
+          </a:p>
+        </p:txBody>
+      </p:sp>
+      <p:sp>
+        <p:nvSpPr>
+          <p:cNvPr id="16" name="Rectangle 15"/>
+          <p:cNvSpPr/>
+          <p:nvPr/>
+        </p:nvSpPr>
+        <p:spPr>
+          <a:xfrm>
+            <a:off x="274320" y="2642615"/>
+            <a:ext cx="2926080" cy="658368"/>
+          </a:xfrm>
+          <a:prstGeom prst="rect">
+            <a:avLst/>
+          </a:prstGeom>
+          <a:solidFill>
+            <a:srgbClr val="ECF0F1"/>
+          </a:solidFill>
+          <a:ln>
+            <a:noFill/>
+          </a:ln>
+        </p:spPr>
+        <p:style>
+          <a:lnRef idx="1">
+            <a:schemeClr val="accent1"/>
+          </a:lnRef>
+          <a:fillRef idx="3">
+            <a:schemeClr val="accent1"/>
+          </a:fillRef>
+          <a:effectRef idx="2">
+            <a:schemeClr val="accent1"/>
+          </a:effectRef>
+          <a:fontRef idx="minor">
+            <a:schemeClr val="lt1"/>
+          </a:fontRef>
+        </p:style>
+        <p:txBody>
+          <a:bodyPr rtlCol="0" anchor="ctr"/>
+          <a:lstStyle/>
+          <a:p>
+            <a:pPr algn="ctr"/>
+          </a:p>
+        </p:txBody>
+      </p:sp>
+      <p:sp>
+        <p:nvSpPr>
+          <p:cNvPr id="17" name="Rectangle 16"/>
+          <p:cNvSpPr/>
+          <p:nvPr/>
+        </p:nvSpPr>
+        <p:spPr>
+          <a:xfrm>
+            <a:off x="3291840" y="2642615"/>
+            <a:ext cx="8595360" cy="658368"/>
+          </a:xfrm>
+          <a:prstGeom prst="rect">
+            <a:avLst/>
+          </a:prstGeom>
+          <a:solidFill>
+            <a:srgbClr val="ECF0F1"/>
+          </a:solidFill>
+          <a:ln>
+            <a:noFill/>
+          </a:ln>
+        </p:spPr>
+        <p:style>
+          <a:lnRef idx="1">
+            <a:schemeClr val="accent1"/>
+          </a:lnRef>
+          <a:fillRef idx="3">
+            <a:schemeClr val="accent1"/>
+          </a:fillRef>
+          <a:effectRef idx="2">
+            <a:schemeClr val="accent1"/>
+          </a:effectRef>
+          <a:fontRef idx="minor">
+            <a:schemeClr val="lt1"/>
+          </a:fontRef>
+        </p:style>
+        <p:txBody>
+          <a:bodyPr rtlCol="0" anchor="ctr"/>
+          <a:lstStyle/>
+          <a:p>
+            <a:pPr algn="ctr"/>
+          </a:p>
+        </p:txBody>
+      </p:sp>
+      <p:sp>
+        <p:nvSpPr>
+          <p:cNvPr id="18" name="TextBox 17"/>
+          <p:cNvSpPr txBox="1"/>
+          <p:nvPr/>
+        </p:nvSpPr>
+        <p:spPr>
+          <a:xfrm>
+            <a:off x="347472" y="2679191"/>
+            <a:ext cx="2788920" cy="603503"/>
+          </a:xfrm>
+          <a:prstGeom prst="rect">
+            <a:avLst/>
+          </a:prstGeom>
+          <a:noFill/>
+        </p:spPr>
+        <p:txBody>
+          <a:bodyPr wrap="square">
+            <a:spAutoFit/>
+          </a:bodyPr>
+          <a:lstStyle/>
+          <a:p>
+            <a:pPr algn="l"/>
+            <a:r>
+              <a:rPr sz="900" b="1">
+                <a:solidFill>
+                  <a:srgbClr val="2C3E50"/>
+                </a:solidFill>
+              </a:rPr>
+              <a:t>Workflow-Datei</a:t>
+            </a:r>
+          </a:p>
+        </p:txBody>
+      </p:sp>
+      <p:sp>
+        <p:nvSpPr>
+          <p:cNvPr id="19" name="TextBox 18"/>
+          <p:cNvSpPr txBox="1"/>
+          <p:nvPr/>
+        </p:nvSpPr>
+        <p:spPr>
+          <a:xfrm>
+            <a:off x="3364992" y="2679191"/>
+            <a:ext cx="8412480" cy="603503"/>
+          </a:xfrm>
+          <a:prstGeom prst="rect">
+            <a:avLst/>
+          </a:prstGeom>
+          <a:noFill/>
+        </p:spPr>
+        <p:txBody>
+          <a:bodyPr wrap="square">
+            <a:spAutoFit/>
+          </a:bodyPr>
+          <a:lstStyle/>
+          <a:p>
+            <a:pPr algn="l"/>
+            <a:r>
+              <a:rPr sz="900" b="0">
+                <a:solidFill>
+                  <a:srgbClr val="2C3E50"/>
+                </a:solidFill>
+              </a:rPr>
+              <a:t>Stages und Übergänge aus bestehender workflow.txt — kompatibel mit transform_data-Format</a:t>
+            </a:r>
+          </a:p>
+        </p:txBody>
+      </p:sp>
+      <p:sp>
+        <p:nvSpPr>
+          <p:cNvPr id="20" name="Rectangle 19"/>
+          <p:cNvSpPr/>
+          <p:nvPr/>
+        </p:nvSpPr>
+        <p:spPr>
+          <a:xfrm>
+            <a:off x="274320" y="3300983"/>
+            <a:ext cx="2926080" cy="658368"/>
+          </a:xfrm>
+          <a:prstGeom prst="rect">
+            <a:avLst/>
+          </a:prstGeom>
+          <a:solidFill>
+            <a:srgbClr val="FFFFFF"/>
+          </a:solidFill>
+          <a:ln>
+            <a:noFill/>
+          </a:ln>
+        </p:spPr>
+        <p:style>
+          <a:lnRef idx="1">
+            <a:schemeClr val="accent1"/>
+          </a:lnRef>
+          <a:fillRef idx="3">
+            <a:schemeClr val="accent1"/>
+          </a:fillRef>
+          <a:effectRef idx="2">
+            <a:schemeClr val="accent1"/>
+          </a:effectRef>
+          <a:fontRef idx="minor">
+            <a:schemeClr val="lt1"/>
+          </a:fontRef>
+        </p:style>
+        <p:txBody>
+          <a:bodyPr rtlCol="0" anchor="ctr"/>
+          <a:lstStyle/>
+          <a:p>
+            <a:pPr algn="ctr"/>
+          </a:p>
+        </p:txBody>
+      </p:sp>
+      <p:sp>
+        <p:nvSpPr>
+          <p:cNvPr id="21" name="Rectangle 20"/>
+          <p:cNvSpPr/>
+          <p:nvPr/>
+        </p:nvSpPr>
+        <p:spPr>
+          <a:xfrm>
+            <a:off x="3291840" y="3300983"/>
+            <a:ext cx="8595360" cy="658368"/>
+          </a:xfrm>
+          <a:prstGeom prst="rect">
+            <a:avLst/>
+          </a:prstGeom>
+          <a:solidFill>
+            <a:srgbClr val="FFFFFF"/>
+          </a:solidFill>
+          <a:ln>
+            <a:noFill/>
+          </a:ln>
+        </p:spPr>
+        <p:style>
+          <a:lnRef idx="1">
+            <a:schemeClr val="accent1"/>
+          </a:lnRef>
+          <a:fillRef idx="3">
+            <a:schemeClr val="accent1"/>
+          </a:fillRef>
+          <a:effectRef idx="2">
+            <a:schemeClr val="accent1"/>
+          </a:effectRef>
+          <a:fontRef idx="minor">
+            <a:schemeClr val="lt1"/>
+          </a:fontRef>
+        </p:style>
+        <p:txBody>
+          <a:bodyPr rtlCol="0" anchor="ctr"/>
+          <a:lstStyle/>
+          <a:p>
+            <a:pPr algn="ctr"/>
+          </a:p>
+        </p:txBody>
+      </p:sp>
+      <p:sp>
+        <p:nvSpPr>
+          <p:cNvPr id="22" name="TextBox 21"/>
+          <p:cNvSpPr txBox="1"/>
+          <p:nvPr/>
+        </p:nvSpPr>
+        <p:spPr>
+          <a:xfrm>
+            <a:off x="347472" y="3337559"/>
+            <a:ext cx="2788920" cy="603503"/>
+          </a:xfrm>
+          <a:prstGeom prst="rect">
+            <a:avLst/>
+          </a:prstGeom>
+          <a:noFill/>
+        </p:spPr>
+        <p:txBody>
+          <a:bodyPr wrap="square">
+            <a:spAutoFit/>
+          </a:bodyPr>
+          <a:lstStyle/>
+          <a:p>
+            <a:pPr algn="l"/>
+            <a:r>
+              <a:rPr sz="900" b="1">
+                <a:solidFill>
+                  <a:srgbClr val="2C3E50"/>
+                </a:solidFill>
+              </a:rPr>
+              <a:t>Reproduzierbar</a:t>
+            </a:r>
+          </a:p>
+        </p:txBody>
+      </p:sp>
+      <p:sp>
+        <p:nvSpPr>
+          <p:cNvPr id="23" name="TextBox 22"/>
+          <p:cNvSpPr txBox="1"/>
+          <p:nvPr/>
+        </p:nvSpPr>
+        <p:spPr>
+          <a:xfrm>
+            <a:off x="3364992" y="3337559"/>
+            <a:ext cx="8412480" cy="603503"/>
+          </a:xfrm>
+          <a:prstGeom prst="rect">
+            <a:avLst/>
+          </a:prstGeom>
+          <a:noFill/>
+        </p:spPr>
+        <p:txBody>
+          <a:bodyPr wrap="square">
+            <a:spAutoFit/>
+          </a:bodyPr>
+          <a:lstStyle/>
+          <a:p>
+            <a:pPr algn="l"/>
+            <a:r>
+              <a:rPr sz="900" b="0">
+                <a:solidFill>
+                  <a:srgbClr val="2C3E50"/>
+                </a:solidFill>
+              </a:rPr>
+              <a:t>Seed-Parameter garantiert identische Ausgabe — stabile, reproduzierbare Tests</a:t>
+            </a:r>
+          </a:p>
+        </p:txBody>
+      </p:sp>
+      <p:sp>
+        <p:nvSpPr>
+          <p:cNvPr id="24" name="Rectangle 23"/>
+          <p:cNvSpPr/>
+          <p:nvPr/>
+        </p:nvSpPr>
+        <p:spPr>
+          <a:xfrm>
+            <a:off x="274320" y="3959351"/>
+            <a:ext cx="2926080" cy="658368"/>
+          </a:xfrm>
+          <a:prstGeom prst="rect">
+            <a:avLst/>
+          </a:prstGeom>
+          <a:solidFill>
+            <a:srgbClr val="ECF0F1"/>
+          </a:solidFill>
+          <a:ln>
+            <a:noFill/>
+          </a:ln>
+        </p:spPr>
+        <p:style>
+          <a:lnRef idx="1">
+            <a:schemeClr val="accent1"/>
+          </a:lnRef>
+          <a:fillRef idx="3">
+            <a:schemeClr val="accent1"/>
+          </a:fillRef>
+          <a:effectRef idx="2">
+            <a:schemeClr val="accent1"/>
+          </a:effectRef>
+          <a:fontRef idx="minor">
+            <a:schemeClr val="lt1"/>
+          </a:fontRef>
+        </p:style>
+        <p:txBody>
+          <a:bodyPr rtlCol="0" anchor="ctr"/>
+          <a:lstStyle/>
+          <a:p>
+            <a:pPr algn="ctr"/>
+          </a:p>
+        </p:txBody>
+      </p:sp>
+      <p:sp>
+        <p:nvSpPr>
+          <p:cNvPr id="25" name="Rectangle 24"/>
+          <p:cNvSpPr/>
+          <p:nvPr/>
+        </p:nvSpPr>
+        <p:spPr>
+          <a:xfrm>
+            <a:off x="3291840" y="3959351"/>
+            <a:ext cx="8595360" cy="658368"/>
+          </a:xfrm>
+          <a:prstGeom prst="rect">
+            <a:avLst/>
+          </a:prstGeom>
+          <a:solidFill>
+            <a:srgbClr val="ECF0F1"/>
+          </a:solidFill>
+          <a:ln>
+            <a:noFill/>
+          </a:ln>
+        </p:spPr>
+        <p:style>
+          <a:lnRef idx="1">
+            <a:schemeClr val="accent1"/>
+          </a:lnRef>
+          <a:fillRef idx="3">
+            <a:schemeClr val="accent1"/>
+          </a:fillRef>
+          <a:effectRef idx="2">
+            <a:schemeClr val="accent1"/>
+          </a:effectRef>
+          <a:fontRef idx="minor">
+            <a:schemeClr val="lt1"/>
+          </a:fontRef>
+        </p:style>
+        <p:txBody>
+          <a:bodyPr rtlCol="0" anchor="ctr"/>
+          <a:lstStyle/>
+          <a:p>
+            <a:pPr algn="ctr"/>
+          </a:p>
+        </p:txBody>
+      </p:sp>
+      <p:sp>
+        <p:nvSpPr>
+          <p:cNvPr id="26" name="TextBox 25"/>
+          <p:cNvSpPr txBox="1"/>
+          <p:nvPr/>
+        </p:nvSpPr>
+        <p:spPr>
+          <a:xfrm>
+            <a:off x="347472" y="3995927"/>
+            <a:ext cx="2788920" cy="603503"/>
+          </a:xfrm>
+          <a:prstGeom prst="rect">
+            <a:avLst/>
+          </a:prstGeom>
+          <a:noFill/>
+        </p:spPr>
+        <p:txBody>
+          <a:bodyPr wrap="square">
+            <a:spAutoFit/>
+          </a:bodyPr>
+          <a:lstStyle/>
+          <a:p>
+            <a:pPr algn="l"/>
+            <a:r>
+              <a:rPr sz="900" b="1">
+                <a:solidFill>
+                  <a:srgbClr val="2C3E50"/>
+                </a:solidFill>
+              </a:rPr>
+              <a:t>Issue-Typen</a:t>
+            </a:r>
+          </a:p>
+        </p:txBody>
+      </p:sp>
+      <p:sp>
+        <p:nvSpPr>
+          <p:cNvPr id="27" name="TextBox 26"/>
+          <p:cNvSpPr txBox="1"/>
+          <p:nvPr/>
+        </p:nvSpPr>
+        <p:spPr>
+          <a:xfrm>
+            <a:off x="3364992" y="3995927"/>
+            <a:ext cx="8412480" cy="603503"/>
+          </a:xfrm>
+          <a:prstGeom prst="rect">
+            <a:avLst/>
+          </a:prstGeom>
+          <a:noFill/>
+        </p:spPr>
+        <p:txBody>
+          <a:bodyPr wrap="square">
+            <a:spAutoFit/>
+          </a:bodyPr>
+          <a:lstStyle/>
+          <a:p>
+            <a:pPr algn="l"/>
+            <a:r>
+              <a:rPr sz="900" b="0">
+                <a:solidFill>
+                  <a:srgbClr val="2C3E50"/>
+                </a:solidFill>
+              </a:rPr>
+              <a:t>Gewichtete Verteilung konfigurierbar (z. B. 70 % Story, 20 % Bug, 10 % Task)</a:t>
+            </a:r>
+          </a:p>
+        </p:txBody>
+      </p:sp>
+      <p:sp>
+        <p:nvSpPr>
+          <p:cNvPr id="28" name="Rectangle 27"/>
+          <p:cNvSpPr/>
+          <p:nvPr/>
+        </p:nvSpPr>
+        <p:spPr>
+          <a:xfrm>
+            <a:off x="274320" y="4617719"/>
+            <a:ext cx="2926080" cy="658368"/>
+          </a:xfrm>
+          <a:prstGeom prst="rect">
+            <a:avLst/>
+          </a:prstGeom>
+          <a:solidFill>
+            <a:srgbClr val="FFFFFF"/>
+          </a:solidFill>
+          <a:ln>
+            <a:noFill/>
+          </a:ln>
+        </p:spPr>
+        <p:style>
+          <a:lnRef idx="1">
+            <a:schemeClr val="accent1"/>
+          </a:lnRef>
+          <a:fillRef idx="3">
+            <a:schemeClr val="accent1"/>
+          </a:fillRef>
+          <a:effectRef idx="2">
+            <a:schemeClr val="accent1"/>
+          </a:effectRef>
+          <a:fontRef idx="minor">
+            <a:schemeClr val="lt1"/>
+          </a:fontRef>
+        </p:style>
+        <p:txBody>
+          <a:bodyPr rtlCol="0" anchor="ctr"/>
+          <a:lstStyle/>
+          <a:p>
+            <a:pPr algn="ctr"/>
+          </a:p>
+        </p:txBody>
+      </p:sp>
+      <p:sp>
+        <p:nvSpPr>
+          <p:cNvPr id="29" name="Rectangle 28"/>
+          <p:cNvSpPr/>
+          <p:nvPr/>
+        </p:nvSpPr>
+        <p:spPr>
+          <a:xfrm>
+            <a:off x="3291840" y="4617719"/>
+            <a:ext cx="8595360" cy="658368"/>
+          </a:xfrm>
+          <a:prstGeom prst="rect">
+            <a:avLst/>
+          </a:prstGeom>
+          <a:solidFill>
+            <a:srgbClr val="FFFFFF"/>
+          </a:solidFill>
+          <a:ln>
+            <a:noFill/>
+          </a:ln>
+        </p:spPr>
+        <p:style>
+          <a:lnRef idx="1">
+            <a:schemeClr val="accent1"/>
+          </a:lnRef>
+          <a:fillRef idx="3">
+            <a:schemeClr val="accent1"/>
+          </a:fillRef>
+          <a:effectRef idx="2">
+            <a:schemeClr val="accent1"/>
+          </a:effectRef>
+          <a:fontRef idx="minor">
+            <a:schemeClr val="lt1"/>
+          </a:fontRef>
+        </p:style>
+        <p:txBody>
+          <a:bodyPr rtlCol="0" anchor="ctr"/>
+          <a:lstStyle/>
+          <a:p>
+            <a:pPr algn="ctr"/>
+          </a:p>
+        </p:txBody>
+      </p:sp>
+      <p:sp>
+        <p:nvSpPr>
+          <p:cNvPr id="30" name="TextBox 29"/>
+          <p:cNvSpPr txBox="1"/>
+          <p:nvPr/>
+        </p:nvSpPr>
+        <p:spPr>
+          <a:xfrm>
+            <a:off x="347472" y="4654295"/>
+            <a:ext cx="2788920" cy="603503"/>
+          </a:xfrm>
+          <a:prstGeom prst="rect">
+            <a:avLst/>
+          </a:prstGeom>
+          <a:noFill/>
+        </p:spPr>
+        <p:txBody>
+          <a:bodyPr wrap="square">
+            <a:spAutoFit/>
+          </a:bodyPr>
+          <a:lstStyle/>
+          <a:p>
+            <a:pPr algn="l"/>
+            <a:r>
+              <a:rPr sz="900" b="1">
+                <a:solidFill>
+                  <a:srgbClr val="2C3E50"/>
+                </a:solidFill>
+              </a:rPr>
+              <a:t>GUI</a:t>
+            </a:r>
+          </a:p>
+        </p:txBody>
+      </p:sp>
+      <p:sp>
+        <p:nvSpPr>
+          <p:cNvPr id="31" name="TextBox 30"/>
+          <p:cNvSpPr txBox="1"/>
+          <p:nvPr/>
+        </p:nvSpPr>
+        <p:spPr>
+          <a:xfrm>
+            <a:off x="3364992" y="4654295"/>
+            <a:ext cx="8412480" cy="603503"/>
+          </a:xfrm>
+          <a:prstGeom prst="rect">
+            <a:avLst/>
+          </a:prstGeom>
+          <a:noFill/>
+        </p:spPr>
+        <p:txBody>
+          <a:bodyPr wrap="square">
+            <a:spAutoFit/>
+          </a:bodyPr>
+          <a:lstStyle/>
+          <a:p>
+            <a:pPr algn="l"/>
+            <a:r>
+              <a:rPr sz="900" b="0">
+                <a:solidFill>
+                  <a:srgbClr val="2C3E50"/>
+                </a:solidFill>
+              </a:rPr>
+              <a:t>tkinter-Oberfläche mit allen Parametern; Ladebalken nach 3 Sekunden</a:t>
+            </a:r>
+          </a:p>
+        </p:txBody>
+      </p:sp>
+      <p:sp>
+        <p:nvSpPr>
+          <p:cNvPr id="32" name="Rectangle 31"/>
+          <p:cNvSpPr/>
+          <p:nvPr/>
+        </p:nvSpPr>
+        <p:spPr>
+          <a:xfrm>
+            <a:off x="274320" y="5276087"/>
+            <a:ext cx="2926080" cy="658368"/>
+          </a:xfrm>
+          <a:prstGeom prst="rect">
+            <a:avLst/>
+          </a:prstGeom>
+          <a:solidFill>
+            <a:srgbClr val="ECF0F1"/>
+          </a:solidFill>
+          <a:ln>
+            <a:noFill/>
+          </a:ln>
+        </p:spPr>
+        <p:style>
+          <a:lnRef idx="1">
+            <a:schemeClr val="accent1"/>
+          </a:lnRef>
+          <a:fillRef idx="3">
+            <a:schemeClr val="accent1"/>
+          </a:fillRef>
+          <a:effectRef idx="2">
+            <a:schemeClr val="accent1"/>
+          </a:effectRef>
+          <a:fontRef idx="minor">
+            <a:schemeClr val="lt1"/>
+          </a:fontRef>
+        </p:style>
+        <p:txBody>
+          <a:bodyPr rtlCol="0" anchor="ctr"/>
+          <a:lstStyle/>
+          <a:p>
+            <a:pPr algn="ctr"/>
+          </a:p>
+        </p:txBody>
+      </p:sp>
+      <p:sp>
+        <p:nvSpPr>
+          <p:cNvPr id="33" name="Rectangle 32"/>
+          <p:cNvSpPr/>
+          <p:nvPr/>
+        </p:nvSpPr>
+        <p:spPr>
+          <a:xfrm>
+            <a:off x="3291840" y="5276087"/>
+            <a:ext cx="8595360" cy="658368"/>
+          </a:xfrm>
+          <a:prstGeom prst="rect">
+            <a:avLst/>
+          </a:prstGeom>
+          <a:solidFill>
+            <a:srgbClr val="ECF0F1"/>
+          </a:solidFill>
+          <a:ln>
+            <a:noFill/>
+          </a:ln>
+        </p:spPr>
+        <p:style>
+          <a:lnRef idx="1">
+            <a:schemeClr val="accent1"/>
+          </a:lnRef>
+          <a:fillRef idx="3">
+            <a:schemeClr val="accent1"/>
+          </a:fillRef>
+          <a:effectRef idx="2">
+            <a:schemeClr val="accent1"/>
+          </a:effectRef>
+          <a:fontRef idx="minor">
+            <a:schemeClr val="lt1"/>
+          </a:fontRef>
+        </p:style>
+        <p:txBody>
+          <a:bodyPr rtlCol="0" anchor="ctr"/>
+          <a:lstStyle/>
+          <a:p>
+            <a:pPr algn="ctr"/>
+          </a:p>
+        </p:txBody>
+      </p:sp>
+      <p:sp>
+        <p:nvSpPr>
+          <p:cNvPr id="34" name="TextBox 33"/>
+          <p:cNvSpPr txBox="1"/>
+          <p:nvPr/>
+        </p:nvSpPr>
+        <p:spPr>
+          <a:xfrm>
+            <a:off x="347472" y="5312663"/>
+            <a:ext cx="2788920" cy="603503"/>
+          </a:xfrm>
+          <a:prstGeom prst="rect">
+            <a:avLst/>
+          </a:prstGeom>
+          <a:noFill/>
+        </p:spPr>
+        <p:txBody>
+          <a:bodyPr wrap="square">
+            <a:spAutoFit/>
+          </a:bodyPr>
+          <a:lstStyle/>
+          <a:p>
+            <a:pPr algn="l"/>
+            <a:r>
+              <a:rPr sz="900" b="1">
+                <a:solidFill>
+                  <a:srgbClr val="2C3E50"/>
+                </a:solidFill>
+              </a:rPr>
+              <a:t>CLI</a:t>
+            </a:r>
+          </a:p>
+        </p:txBody>
+      </p:sp>
+      <p:sp>
+        <p:nvSpPr>
+          <p:cNvPr id="35" name="TextBox 34"/>
+          <p:cNvSpPr txBox="1"/>
+          <p:nvPr/>
+        </p:nvSpPr>
+        <p:spPr>
+          <a:xfrm>
+            <a:off x="3364992" y="5312663"/>
+            <a:ext cx="8412480" cy="603503"/>
+          </a:xfrm>
+          <a:prstGeom prst="rect">
+            <a:avLst/>
+          </a:prstGeom>
+          <a:noFill/>
+        </p:spPr>
+        <p:txBody>
+          <a:bodyPr wrap="square">
+            <a:spAutoFit/>
+          </a:bodyPr>
+          <a:lstStyle/>
+          <a:p>
+            <a:pPr algn="l"/>
+            <a:r>
+              <a:rPr sz="900" b="0">
+                <a:solidFill>
+                  <a:srgbClr val="2C3E50"/>
+                </a:solidFill>
+              </a:rPr>
+              <a:t>python -m testdata_generator; alle Parameter als Kommandozeilenargumente</a:t>
+            </a:r>
+          </a:p>
+        </p:txBody>
+      </p:sp>
+      <p:sp>
+        <p:nvSpPr>
+          <p:cNvPr id="36" name="Rectangle 35"/>
+          <p:cNvSpPr/>
+          <p:nvPr/>
+        </p:nvSpPr>
+        <p:spPr>
+          <a:xfrm>
+            <a:off x="274320" y="5934455"/>
+            <a:ext cx="2926080" cy="658368"/>
+          </a:xfrm>
+          <a:prstGeom prst="rect">
+            <a:avLst/>
+          </a:prstGeom>
+          <a:solidFill>
+            <a:srgbClr val="FFFFFF"/>
+          </a:solidFill>
+          <a:ln>
+            <a:noFill/>
+          </a:ln>
+        </p:spPr>
+        <p:style>
+          <a:lnRef idx="1">
+            <a:schemeClr val="accent1"/>
+          </a:lnRef>
+          <a:fillRef idx="3">
+            <a:schemeClr val="accent1"/>
+          </a:fillRef>
+          <a:effectRef idx="2">
+            <a:schemeClr val="accent1"/>
+          </a:effectRef>
+          <a:fontRef idx="minor">
+            <a:schemeClr val="lt1"/>
+          </a:fontRef>
+        </p:style>
+        <p:txBody>
+          <a:bodyPr rtlCol="0" anchor="ctr"/>
+          <a:lstStyle/>
+          <a:p>
+            <a:pPr algn="ctr"/>
+          </a:p>
+        </p:txBody>
+      </p:sp>
+      <p:sp>
+        <p:nvSpPr>
+          <p:cNvPr id="37" name="Rectangle 36"/>
+          <p:cNvSpPr/>
+          <p:nvPr/>
+        </p:nvSpPr>
+        <p:spPr>
+          <a:xfrm>
+            <a:off x="3291840" y="5934455"/>
+            <a:ext cx="8595360" cy="658368"/>
+          </a:xfrm>
+          <a:prstGeom prst="rect">
+            <a:avLst/>
+          </a:prstGeom>
+          <a:solidFill>
+            <a:srgbClr val="FFFFFF"/>
+          </a:solidFill>
+          <a:ln>
+            <a:noFill/>
+          </a:ln>
+        </p:spPr>
+        <p:style>
+          <a:lnRef idx="1">
+            <a:schemeClr val="accent1"/>
+          </a:lnRef>
+          <a:fillRef idx="3">
+            <a:schemeClr val="accent1"/>
+          </a:fillRef>
+          <a:effectRef idx="2">
+            <a:schemeClr val="accent1"/>
+          </a:effectRef>
+          <a:fontRef idx="minor">
+            <a:schemeClr val="lt1"/>
+          </a:fontRef>
+        </p:style>
+        <p:txBody>
+          <a:bodyPr rtlCol="0" anchor="ctr"/>
+          <a:lstStyle/>
+          <a:p>
+            <a:pPr algn="ctr"/>
+          </a:p>
+        </p:txBody>
+      </p:sp>
+      <p:sp>
+        <p:nvSpPr>
+          <p:cNvPr id="38" name="TextBox 37"/>
+          <p:cNvSpPr txBox="1"/>
+          <p:nvPr/>
+        </p:nvSpPr>
+        <p:spPr>
+          <a:xfrm>
+            <a:off x="347472" y="5971031"/>
+            <a:ext cx="2788920" cy="603503"/>
+          </a:xfrm>
+          <a:prstGeom prst="rect">
+            <a:avLst/>
+          </a:prstGeom>
+          <a:noFill/>
+        </p:spPr>
+        <p:txBody>
+          <a:bodyPr wrap="square">
+            <a:spAutoFit/>
+          </a:bodyPr>
+          <a:lstStyle/>
+          <a:p>
+            <a:pPr algn="l"/>
+            <a:r>
+              <a:rPr sz="900" b="1">
+                <a:solidFill>
+                  <a:srgbClr val="2C3E50"/>
+                </a:solidFill>
+              </a:rPr>
+              <a:t>Doppelklick-Starter</a:t>
+            </a:r>
+          </a:p>
+        </p:txBody>
+      </p:sp>
+      <p:sp>
+        <p:nvSpPr>
+          <p:cNvPr id="39" name="TextBox 38"/>
+          <p:cNvSpPr txBox="1"/>
+          <p:nvPr/>
+        </p:nvSpPr>
+        <p:spPr>
+          <a:xfrm>
+            <a:off x="3364992" y="5971031"/>
+            <a:ext cx="8412480" cy="603503"/>
+          </a:xfrm>
+          <a:prstGeom prst="rect">
+            <a:avLst/>
+          </a:prstGeom>
+          <a:noFill/>
+        </p:spPr>
+        <p:txBody>
+          <a:bodyPr wrap="square">
+            <a:spAutoFit/>
+          </a:bodyPr>
+          <a:lstStyle/>
+          <a:p>
+            <a:pPr algn="l"/>
+            <a:r>
+              <a:rPr sz="900" b="0">
+                <a:solidFill>
+                  <a:srgbClr val="2C3E50"/>
+                </a:solidFill>
+              </a:rPr>
+              <a:t>testdata_generator_gui.pyw startet die GUI ohne Konsolenfenster</a:t>
+            </a:r>
+          </a:p>
+        </p:txBody>
+      </p:sp>
+      <p:sp>
+        <p:nvSpPr>
+          <p:cNvPr id="40" name="Rectangle 39"/>
+          <p:cNvSpPr/>
+          <p:nvPr/>
+        </p:nvSpPr>
+        <p:spPr>
+          <a:xfrm>
+            <a:off x="0" y="6720840"/>
+            <a:ext cx="12188952" cy="137160"/>
+          </a:xfrm>
+          <a:prstGeom prst="rect">
+            <a:avLst/>
+          </a:prstGeom>
+          <a:solidFill>
+            <a:srgbClr val="2980B9"/>
           </a:solidFill>
           <a:ln>
             <a:noFill/>

</xml_diff>

<commit_message>
chore(release): v0.99 – testdata_generator Flow-Antipattern + ALPHA-Doku
### Neue Features (testdata_generator)
- Vier Flow-Antipattern-Muster: triangle, flat_triangle, cluster, batch
- Lognormale Cycle-Time-Steuerung (--mean-cycle-days, --std-cycle-days)
- PI-Zyklus-Länge konfigurierbar (--pi-duration-weeks)
- GUI: Schieberegler + Radiobuttons für alle neuen Parameter

### Bugfixes
- Completion-Rate im Muster-Modus: doppeltes Würfeln behoben (0 offene Issues)
- OneDrive-Kompatibilität: openpyxl BytesIO-Fix in writers.py + export.py

### Dokumentation
- version.py: 0.9.8 → 0.99
- CHANGELOG, README, alle Modul-Docs und Übersicht auf v0.99 aktualisiert
- Benutzerhandbücher (DE + EN) neu generiert: Kapitel 4b Flow-Muster
- Feature-Übersicht PPTX: testdata_generator-Folie + v0.99
- Prozess-PPTX: Stand Mai 2026 aktualisiert

682 Tests grün.

Co-Authored-By: Claude Sonnet 4.6 <noreply@anthropic.com>
</commit_message>
<xml_diff>
--- a/docs/situation_report_features.pptx
+++ b/docs/situation_report_features.pptx
@@ -14,7 +14,6 @@
     <p:sldId id="262" r:id="rId13"/>
     <p:sldId id="263" r:id="rId14"/>
     <p:sldId id="264" r:id="rId15"/>
-    <p:sldId id="265" r:id="rId16"/>
   </p:sldIdLst>
   <p:sldSz cx="12188952" cy="6858000" type="screen4x3"/>
   <p:notesSz cx="6858000" cy="9144000"/>
@@ -3246,7 +3245,7 @@
                   <a:srgbClr val="ECF0F1"/>
                 </a:solidFill>
               </a:rPr>
-              <a:t>Feature-Übersicht — v0.9.0 | Stand Mai 2026</a:t>
+              <a:t>Feature-Übersicht — v0.99 | Stand Mai 2026</a:t>
             </a:r>
           </a:p>
         </p:txBody>
@@ -3282,1530 +3281,6 @@
               </a:rPr>
               <a:t>github.com/Jaegerfeld/situation-report</a:t>
             </a:r>
-          </a:p>
-        </p:txBody>
-      </p:sp>
-    </p:spTree>
-  </p:cSld>
-  <p:clrMapOvr>
-    <a:masterClrMapping/>
-  </p:clrMapOvr>
-</p:sld>
-</file>
-
-<file path=ppt/slides/slide10.xml><?xml version="1.0" encoding="utf-8"?>
-<p:sld xmlns:a="http://schemas.openxmlformats.org/drawingml/2006/main" xmlns:p="http://schemas.openxmlformats.org/presentationml/2006/main" xmlns:r="http://schemas.openxmlformats.org/officeDocument/2006/relationships">
-  <p:cSld>
-    <p:spTree>
-      <p:nvGrpSpPr>
-        <p:cNvPr id="1" name=""/>
-        <p:cNvGrpSpPr/>
-        <p:nvPr/>
-      </p:nvGrpSpPr>
-      <p:grpSpPr/>
-      <p:sp>
-        <p:nvSpPr>
-          <p:cNvPr id="2" name="Rectangle 1"/>
-          <p:cNvSpPr/>
-          <p:nvPr/>
-        </p:nvSpPr>
-        <p:spPr>
-          <a:xfrm>
-            <a:off x="0" y="0"/>
-            <a:ext cx="12188952" cy="822960"/>
-          </a:xfrm>
-          <a:prstGeom prst="rect">
-            <a:avLst/>
-          </a:prstGeom>
-          <a:solidFill>
-            <a:srgbClr val="2C3E50"/>
-          </a:solidFill>
-          <a:ln>
-            <a:noFill/>
-          </a:ln>
-        </p:spPr>
-        <p:style>
-          <a:lnRef idx="1">
-            <a:schemeClr val="accent1"/>
-          </a:lnRef>
-          <a:fillRef idx="3">
-            <a:schemeClr val="accent1"/>
-          </a:fillRef>
-          <a:effectRef idx="2">
-            <a:schemeClr val="accent1"/>
-          </a:effectRef>
-          <a:fontRef idx="minor">
-            <a:schemeClr val="lt1"/>
-          </a:fontRef>
-        </p:style>
-        <p:txBody>
-          <a:bodyPr rtlCol="0" anchor="ctr"/>
-          <a:lstStyle/>
-          <a:p>
-            <a:pPr algn="ctr"/>
-          </a:p>
-        </p:txBody>
-      </p:sp>
-      <p:sp>
-        <p:nvSpPr>
-          <p:cNvPr id="3" name="TextBox 2"/>
-          <p:cNvSpPr txBox="1"/>
-          <p:nvPr/>
-        </p:nvSpPr>
-        <p:spPr>
-          <a:xfrm>
-            <a:off x="274320" y="91440"/>
-            <a:ext cx="11612880" cy="640080"/>
-          </a:xfrm>
-          <a:prstGeom prst="rect">
-            <a:avLst/>
-          </a:prstGeom>
-          <a:noFill/>
-        </p:spPr>
-        <p:txBody>
-          <a:bodyPr wrap="square">
-            <a:spAutoFit/>
-          </a:bodyPr>
-          <a:lstStyle/>
-          <a:p>
-            <a:pPr algn="l"/>
-            <a:r>
-              <a:rPr sz="2200" b="1">
-                <a:solidFill>
-                  <a:srgbClr val="FFFFFF"/>
-                </a:solidFill>
-              </a:rPr>
-              <a:t>helper — JSON Merger</a:t>
-            </a:r>
-          </a:p>
-        </p:txBody>
-      </p:sp>
-      <p:sp>
-        <p:nvSpPr>
-          <p:cNvPr id="4" name="Rectangle 3"/>
-          <p:cNvSpPr/>
-          <p:nvPr/>
-        </p:nvSpPr>
-        <p:spPr>
-          <a:xfrm>
-            <a:off x="274320" y="914400"/>
-            <a:ext cx="2926080" cy="320040"/>
-          </a:xfrm>
-          <a:prstGeom prst="rect">
-            <a:avLst/>
-          </a:prstGeom>
-          <a:solidFill>
-            <a:srgbClr val="2980B9"/>
-          </a:solidFill>
-          <a:ln>
-            <a:noFill/>
-          </a:ln>
-        </p:spPr>
-        <p:style>
-          <a:lnRef idx="1">
-            <a:schemeClr val="accent1"/>
-          </a:lnRef>
-          <a:fillRef idx="3">
-            <a:schemeClr val="accent1"/>
-          </a:fillRef>
-          <a:effectRef idx="2">
-            <a:schemeClr val="accent1"/>
-          </a:effectRef>
-          <a:fontRef idx="minor">
-            <a:schemeClr val="lt1"/>
-          </a:fontRef>
-        </p:style>
-        <p:txBody>
-          <a:bodyPr rtlCol="0" anchor="ctr"/>
-          <a:lstStyle/>
-          <a:p>
-            <a:pPr algn="ctr"/>
-          </a:p>
-        </p:txBody>
-      </p:sp>
-      <p:sp>
-        <p:nvSpPr>
-          <p:cNvPr id="5" name="Rectangle 4"/>
-          <p:cNvSpPr/>
-          <p:nvPr/>
-        </p:nvSpPr>
-        <p:spPr>
-          <a:xfrm>
-            <a:off x="3291840" y="914400"/>
-            <a:ext cx="8595360" cy="320040"/>
-          </a:xfrm>
-          <a:prstGeom prst="rect">
-            <a:avLst/>
-          </a:prstGeom>
-          <a:solidFill>
-            <a:srgbClr val="2980B9"/>
-          </a:solidFill>
-          <a:ln>
-            <a:noFill/>
-          </a:ln>
-        </p:spPr>
-        <p:style>
-          <a:lnRef idx="1">
-            <a:schemeClr val="accent1"/>
-          </a:lnRef>
-          <a:fillRef idx="3">
-            <a:schemeClr val="accent1"/>
-          </a:fillRef>
-          <a:effectRef idx="2">
-            <a:schemeClr val="accent1"/>
-          </a:effectRef>
-          <a:fontRef idx="minor">
-            <a:schemeClr val="lt1"/>
-          </a:fontRef>
-        </p:style>
-        <p:txBody>
-          <a:bodyPr rtlCol="0" anchor="ctr"/>
-          <a:lstStyle/>
-          <a:p>
-            <a:pPr algn="ctr"/>
-          </a:p>
-        </p:txBody>
-      </p:sp>
-      <p:sp>
-        <p:nvSpPr>
-          <p:cNvPr id="6" name="TextBox 5"/>
-          <p:cNvSpPr txBox="1"/>
-          <p:nvPr/>
-        </p:nvSpPr>
-        <p:spPr>
-          <a:xfrm>
-            <a:off x="320040" y="932688"/>
-            <a:ext cx="2834640" cy="274320"/>
-          </a:xfrm>
-          <a:prstGeom prst="rect">
-            <a:avLst/>
-          </a:prstGeom>
-          <a:noFill/>
-        </p:spPr>
-        <p:txBody>
-          <a:bodyPr wrap="square">
-            <a:spAutoFit/>
-          </a:bodyPr>
-          <a:lstStyle/>
-          <a:p>
-            <a:pPr algn="l"/>
-            <a:r>
-              <a:rPr sz="900" b="1">
-                <a:solidFill>
-                  <a:srgbClr val="FFFFFF"/>
-                </a:solidFill>
-              </a:rPr>
-              <a:t>Feature</a:t>
-            </a:r>
-          </a:p>
-        </p:txBody>
-      </p:sp>
-      <p:sp>
-        <p:nvSpPr>
-          <p:cNvPr id="7" name="TextBox 6"/>
-          <p:cNvSpPr txBox="1"/>
-          <p:nvPr/>
-        </p:nvSpPr>
-        <p:spPr>
-          <a:xfrm>
-            <a:off x="3337560" y="932688"/>
-            <a:ext cx="8503920" cy="274320"/>
-          </a:xfrm>
-          <a:prstGeom prst="rect">
-            <a:avLst/>
-          </a:prstGeom>
-          <a:noFill/>
-        </p:spPr>
-        <p:txBody>
-          <a:bodyPr wrap="square">
-            <a:spAutoFit/>
-          </a:bodyPr>
-          <a:lstStyle/>
-          <a:p>
-            <a:pPr algn="l"/>
-            <a:r>
-              <a:rPr sz="900" b="1">
-                <a:solidFill>
-                  <a:srgbClr val="FFFFFF"/>
-                </a:solidFill>
-              </a:rPr>
-              <a:t>Beschreibung</a:t>
-            </a:r>
-          </a:p>
-        </p:txBody>
-      </p:sp>
-      <p:sp>
-        <p:nvSpPr>
-          <p:cNvPr id="8" name="Rectangle 7"/>
-          <p:cNvSpPr/>
-          <p:nvPr/>
-        </p:nvSpPr>
-        <p:spPr>
-          <a:xfrm>
-            <a:off x="274320" y="1325880"/>
-            <a:ext cx="2926080" cy="658368"/>
-          </a:xfrm>
-          <a:prstGeom prst="rect">
-            <a:avLst/>
-          </a:prstGeom>
-          <a:solidFill>
-            <a:srgbClr val="ECF0F1"/>
-          </a:solidFill>
-          <a:ln>
-            <a:noFill/>
-          </a:ln>
-        </p:spPr>
-        <p:style>
-          <a:lnRef idx="1">
-            <a:schemeClr val="accent1"/>
-          </a:lnRef>
-          <a:fillRef idx="3">
-            <a:schemeClr val="accent1"/>
-          </a:fillRef>
-          <a:effectRef idx="2">
-            <a:schemeClr val="accent1"/>
-          </a:effectRef>
-          <a:fontRef idx="minor">
-            <a:schemeClr val="lt1"/>
-          </a:fontRef>
-        </p:style>
-        <p:txBody>
-          <a:bodyPr rtlCol="0" anchor="ctr"/>
-          <a:lstStyle/>
-          <a:p>
-            <a:pPr algn="ctr"/>
-          </a:p>
-        </p:txBody>
-      </p:sp>
-      <p:sp>
-        <p:nvSpPr>
-          <p:cNvPr id="9" name="Rectangle 8"/>
-          <p:cNvSpPr/>
-          <p:nvPr/>
-        </p:nvSpPr>
-        <p:spPr>
-          <a:xfrm>
-            <a:off x="3291840" y="1325880"/>
-            <a:ext cx="8595360" cy="658368"/>
-          </a:xfrm>
-          <a:prstGeom prst="rect">
-            <a:avLst/>
-          </a:prstGeom>
-          <a:solidFill>
-            <a:srgbClr val="ECF0F1"/>
-          </a:solidFill>
-          <a:ln>
-            <a:noFill/>
-          </a:ln>
-        </p:spPr>
-        <p:style>
-          <a:lnRef idx="1">
-            <a:schemeClr val="accent1"/>
-          </a:lnRef>
-          <a:fillRef idx="3">
-            <a:schemeClr val="accent1"/>
-          </a:fillRef>
-          <a:effectRef idx="2">
-            <a:schemeClr val="accent1"/>
-          </a:effectRef>
-          <a:fontRef idx="minor">
-            <a:schemeClr val="lt1"/>
-          </a:fontRef>
-        </p:style>
-        <p:txBody>
-          <a:bodyPr rtlCol="0" anchor="ctr"/>
-          <a:lstStyle/>
-          <a:p>
-            <a:pPr algn="ctr"/>
-          </a:p>
-        </p:txBody>
-      </p:sp>
-      <p:sp>
-        <p:nvSpPr>
-          <p:cNvPr id="10" name="TextBox 9"/>
-          <p:cNvSpPr txBox="1"/>
-          <p:nvPr/>
-        </p:nvSpPr>
-        <p:spPr>
-          <a:xfrm>
-            <a:off x="347472" y="1362456"/>
-            <a:ext cx="2788920" cy="603503"/>
-          </a:xfrm>
-          <a:prstGeom prst="rect">
-            <a:avLst/>
-          </a:prstGeom>
-          <a:noFill/>
-        </p:spPr>
-        <p:txBody>
-          <a:bodyPr wrap="square">
-            <a:spAutoFit/>
-          </a:bodyPr>
-          <a:lstStyle/>
-          <a:p>
-            <a:pPr algn="l"/>
-            <a:r>
-              <a:rPr sz="900" b="1">
-                <a:solidFill>
-                  <a:srgbClr val="2C3E50"/>
-                </a:solidFill>
-              </a:rPr>
-              <a:t>Problem: Paginierung</a:t>
-            </a:r>
-          </a:p>
-        </p:txBody>
-      </p:sp>
-      <p:sp>
-        <p:nvSpPr>
-          <p:cNvPr id="11" name="TextBox 10"/>
-          <p:cNvSpPr txBox="1"/>
-          <p:nvPr/>
-        </p:nvSpPr>
-        <p:spPr>
-          <a:xfrm>
-            <a:off x="3364992" y="1362456"/>
-            <a:ext cx="8412480" cy="603503"/>
-          </a:xfrm>
-          <a:prstGeom prst="rect">
-            <a:avLst/>
-          </a:prstGeom>
-          <a:noFill/>
-        </p:spPr>
-        <p:txBody>
-          <a:bodyPr wrap="square">
-            <a:spAutoFit/>
-          </a:bodyPr>
-          <a:lstStyle/>
-          <a:p>
-            <a:pPr algn="l"/>
-            <a:r>
-              <a:rPr sz="900" b="0">
-                <a:solidFill>
-                  <a:srgbClr val="2C3E50"/>
-                </a:solidFill>
-              </a:rPr>
-              <a:t>Jira REST API liefert max. 1000 Issues pro Abfrage — bei größeren Projekten entstehen mehrere JSON-Dateien</a:t>
-            </a:r>
-          </a:p>
-        </p:txBody>
-      </p:sp>
-      <p:sp>
-        <p:nvSpPr>
-          <p:cNvPr id="12" name="Rectangle 11"/>
-          <p:cNvSpPr/>
-          <p:nvPr/>
-        </p:nvSpPr>
-        <p:spPr>
-          <a:xfrm>
-            <a:off x="274320" y="1984248"/>
-            <a:ext cx="2926080" cy="658368"/>
-          </a:xfrm>
-          <a:prstGeom prst="rect">
-            <a:avLst/>
-          </a:prstGeom>
-          <a:solidFill>
-            <a:srgbClr val="FFFFFF"/>
-          </a:solidFill>
-          <a:ln>
-            <a:noFill/>
-          </a:ln>
-        </p:spPr>
-        <p:style>
-          <a:lnRef idx="1">
-            <a:schemeClr val="accent1"/>
-          </a:lnRef>
-          <a:fillRef idx="3">
-            <a:schemeClr val="accent1"/>
-          </a:fillRef>
-          <a:effectRef idx="2">
-            <a:schemeClr val="accent1"/>
-          </a:effectRef>
-          <a:fontRef idx="minor">
-            <a:schemeClr val="lt1"/>
-          </a:fontRef>
-        </p:style>
-        <p:txBody>
-          <a:bodyPr rtlCol="0" anchor="ctr"/>
-          <a:lstStyle/>
-          <a:p>
-            <a:pPr algn="ctr"/>
-          </a:p>
-        </p:txBody>
-      </p:sp>
-      <p:sp>
-        <p:nvSpPr>
-          <p:cNvPr id="13" name="Rectangle 12"/>
-          <p:cNvSpPr/>
-          <p:nvPr/>
-        </p:nvSpPr>
-        <p:spPr>
-          <a:xfrm>
-            <a:off x="3291840" y="1984248"/>
-            <a:ext cx="8595360" cy="658368"/>
-          </a:xfrm>
-          <a:prstGeom prst="rect">
-            <a:avLst/>
-          </a:prstGeom>
-          <a:solidFill>
-            <a:srgbClr val="FFFFFF"/>
-          </a:solidFill>
-          <a:ln>
-            <a:noFill/>
-          </a:ln>
-        </p:spPr>
-        <p:style>
-          <a:lnRef idx="1">
-            <a:schemeClr val="accent1"/>
-          </a:lnRef>
-          <a:fillRef idx="3">
-            <a:schemeClr val="accent1"/>
-          </a:fillRef>
-          <a:effectRef idx="2">
-            <a:schemeClr val="accent1"/>
-          </a:effectRef>
-          <a:fontRef idx="minor">
-            <a:schemeClr val="lt1"/>
-          </a:fontRef>
-        </p:style>
-        <p:txBody>
-          <a:bodyPr rtlCol="0" anchor="ctr"/>
-          <a:lstStyle/>
-          <a:p>
-            <a:pPr algn="ctr"/>
-          </a:p>
-        </p:txBody>
-      </p:sp>
-      <p:sp>
-        <p:nvSpPr>
-          <p:cNvPr id="14" name="TextBox 13"/>
-          <p:cNvSpPr txBox="1"/>
-          <p:nvPr/>
-        </p:nvSpPr>
-        <p:spPr>
-          <a:xfrm>
-            <a:off x="347472" y="2020824"/>
-            <a:ext cx="2788920" cy="603503"/>
-          </a:xfrm>
-          <a:prstGeom prst="rect">
-            <a:avLst/>
-          </a:prstGeom>
-          <a:noFill/>
-        </p:spPr>
-        <p:txBody>
-          <a:bodyPr wrap="square">
-            <a:spAutoFit/>
-          </a:bodyPr>
-          <a:lstStyle/>
-          <a:p>
-            <a:pPr algn="l"/>
-            <a:r>
-              <a:rPr sz="900" b="1">
-                <a:solidFill>
-                  <a:srgbClr val="2C3E50"/>
-                </a:solidFill>
-              </a:rPr>
-              <a:t>JSON Merger</a:t>
-            </a:r>
-          </a:p>
-        </p:txBody>
-      </p:sp>
-      <p:sp>
-        <p:nvSpPr>
-          <p:cNvPr id="15" name="TextBox 14"/>
-          <p:cNvSpPr txBox="1"/>
-          <p:nvPr/>
-        </p:nvSpPr>
-        <p:spPr>
-          <a:xfrm>
-            <a:off x="3364992" y="2020824"/>
-            <a:ext cx="8412480" cy="603503"/>
-          </a:xfrm>
-          <a:prstGeom prst="rect">
-            <a:avLst/>
-          </a:prstGeom>
-          <a:noFill/>
-        </p:spPr>
-        <p:txBody>
-          <a:bodyPr wrap="square">
-            <a:spAutoFit/>
-          </a:bodyPr>
-          <a:lstStyle/>
-          <a:p>
-            <a:pPr algn="l"/>
-            <a:r>
-              <a:rPr sz="900" b="0">
-                <a:solidFill>
-                  <a:srgbClr val="2C3E50"/>
-                </a:solidFill>
-              </a:rPr>
-              <a:t>Fügt alle Teilexporte zu einem einzigen Jira-kompatiblen JSON zusammen — direkt mit transform_data verarbeitbar</a:t>
-            </a:r>
-          </a:p>
-        </p:txBody>
-      </p:sp>
-      <p:sp>
-        <p:nvSpPr>
-          <p:cNvPr id="16" name="Rectangle 15"/>
-          <p:cNvSpPr/>
-          <p:nvPr/>
-        </p:nvSpPr>
-        <p:spPr>
-          <a:xfrm>
-            <a:off x="274320" y="2642615"/>
-            <a:ext cx="2926080" cy="658368"/>
-          </a:xfrm>
-          <a:prstGeom prst="rect">
-            <a:avLst/>
-          </a:prstGeom>
-          <a:solidFill>
-            <a:srgbClr val="ECF0F1"/>
-          </a:solidFill>
-          <a:ln>
-            <a:noFill/>
-          </a:ln>
-        </p:spPr>
-        <p:style>
-          <a:lnRef idx="1">
-            <a:schemeClr val="accent1"/>
-          </a:lnRef>
-          <a:fillRef idx="3">
-            <a:schemeClr val="accent1"/>
-          </a:fillRef>
-          <a:effectRef idx="2">
-            <a:schemeClr val="accent1"/>
-          </a:effectRef>
-          <a:fontRef idx="minor">
-            <a:schemeClr val="lt1"/>
-          </a:fontRef>
-        </p:style>
-        <p:txBody>
-          <a:bodyPr rtlCol="0" anchor="ctr"/>
-          <a:lstStyle/>
-          <a:p>
-            <a:pPr algn="ctr"/>
-          </a:p>
-        </p:txBody>
-      </p:sp>
-      <p:sp>
-        <p:nvSpPr>
-          <p:cNvPr id="17" name="Rectangle 16"/>
-          <p:cNvSpPr/>
-          <p:nvPr/>
-        </p:nvSpPr>
-        <p:spPr>
-          <a:xfrm>
-            <a:off x="3291840" y="2642615"/>
-            <a:ext cx="8595360" cy="658368"/>
-          </a:xfrm>
-          <a:prstGeom prst="rect">
-            <a:avLst/>
-          </a:prstGeom>
-          <a:solidFill>
-            <a:srgbClr val="ECF0F1"/>
-          </a:solidFill>
-          <a:ln>
-            <a:noFill/>
-          </a:ln>
-        </p:spPr>
-        <p:style>
-          <a:lnRef idx="1">
-            <a:schemeClr val="accent1"/>
-          </a:lnRef>
-          <a:fillRef idx="3">
-            <a:schemeClr val="accent1"/>
-          </a:fillRef>
-          <a:effectRef idx="2">
-            <a:schemeClr val="accent1"/>
-          </a:effectRef>
-          <a:fontRef idx="minor">
-            <a:schemeClr val="lt1"/>
-          </a:fontRef>
-        </p:style>
-        <p:txBody>
-          <a:bodyPr rtlCol="0" anchor="ctr"/>
-          <a:lstStyle/>
-          <a:p>
-            <a:pPr algn="ctr"/>
-          </a:p>
-        </p:txBody>
-      </p:sp>
-      <p:sp>
-        <p:nvSpPr>
-          <p:cNvPr id="18" name="TextBox 17"/>
-          <p:cNvSpPr txBox="1"/>
-          <p:nvPr/>
-        </p:nvSpPr>
-        <p:spPr>
-          <a:xfrm>
-            <a:off x="347472" y="2679191"/>
-            <a:ext cx="2788920" cy="603503"/>
-          </a:xfrm>
-          <a:prstGeom prst="rect">
-            <a:avLst/>
-          </a:prstGeom>
-          <a:noFill/>
-        </p:spPr>
-        <p:txBody>
-          <a:bodyPr wrap="square">
-            <a:spAutoFit/>
-          </a:bodyPr>
-          <a:lstStyle/>
-          <a:p>
-            <a:pPr algn="l"/>
-            <a:r>
-              <a:rPr sz="900" b="1">
-                <a:solidFill>
-                  <a:srgbClr val="2C3E50"/>
-                </a:solidFill>
-              </a:rPr>
-              <a:t>Deduplizierung</a:t>
-            </a:r>
-          </a:p>
-        </p:txBody>
-      </p:sp>
-      <p:sp>
-        <p:nvSpPr>
-          <p:cNvPr id="19" name="TextBox 18"/>
-          <p:cNvSpPr txBox="1"/>
-          <p:nvPr/>
-        </p:nvSpPr>
-        <p:spPr>
-          <a:xfrm>
-            <a:off x="3364992" y="2679191"/>
-            <a:ext cx="8412480" cy="603503"/>
-          </a:xfrm>
-          <a:prstGeom prst="rect">
-            <a:avLst/>
-          </a:prstGeom>
-          <a:noFill/>
-        </p:spPr>
-        <p:txBody>
-          <a:bodyPr wrap="square">
-            <a:spAutoFit/>
-          </a:bodyPr>
-          <a:lstStyle/>
-          <a:p>
-            <a:pPr algn="l"/>
-            <a:r>
-              <a:rPr sz="900" b="0">
-                <a:solidFill>
-                  <a:srgbClr val="2C3E50"/>
-                </a:solidFill>
-              </a:rPr>
-              <a:t>Issues mit identischer id werden standardmäßig nur einmal übernommen; Warnung je Duplikat im Log</a:t>
-            </a:r>
-          </a:p>
-        </p:txBody>
-      </p:sp>
-      <p:sp>
-        <p:nvSpPr>
-          <p:cNvPr id="20" name="Rectangle 19"/>
-          <p:cNvSpPr/>
-          <p:nvPr/>
-        </p:nvSpPr>
-        <p:spPr>
-          <a:xfrm>
-            <a:off x="274320" y="3300983"/>
-            <a:ext cx="2926080" cy="658368"/>
-          </a:xfrm>
-          <a:prstGeom prst="rect">
-            <a:avLst/>
-          </a:prstGeom>
-          <a:solidFill>
-            <a:srgbClr val="FFFFFF"/>
-          </a:solidFill>
-          <a:ln>
-            <a:noFill/>
-          </a:ln>
-        </p:spPr>
-        <p:style>
-          <a:lnRef idx="1">
-            <a:schemeClr val="accent1"/>
-          </a:lnRef>
-          <a:fillRef idx="3">
-            <a:schemeClr val="accent1"/>
-          </a:fillRef>
-          <a:effectRef idx="2">
-            <a:schemeClr val="accent1"/>
-          </a:effectRef>
-          <a:fontRef idx="minor">
-            <a:schemeClr val="lt1"/>
-          </a:fontRef>
-        </p:style>
-        <p:txBody>
-          <a:bodyPr rtlCol="0" anchor="ctr"/>
-          <a:lstStyle/>
-          <a:p>
-            <a:pPr algn="ctr"/>
-          </a:p>
-        </p:txBody>
-      </p:sp>
-      <p:sp>
-        <p:nvSpPr>
-          <p:cNvPr id="21" name="Rectangle 20"/>
-          <p:cNvSpPr/>
-          <p:nvPr/>
-        </p:nvSpPr>
-        <p:spPr>
-          <a:xfrm>
-            <a:off x="3291840" y="3300983"/>
-            <a:ext cx="8595360" cy="658368"/>
-          </a:xfrm>
-          <a:prstGeom prst="rect">
-            <a:avLst/>
-          </a:prstGeom>
-          <a:solidFill>
-            <a:srgbClr val="FFFFFF"/>
-          </a:solidFill>
-          <a:ln>
-            <a:noFill/>
-          </a:ln>
-        </p:spPr>
-        <p:style>
-          <a:lnRef idx="1">
-            <a:schemeClr val="accent1"/>
-          </a:lnRef>
-          <a:fillRef idx="3">
-            <a:schemeClr val="accent1"/>
-          </a:fillRef>
-          <a:effectRef idx="2">
-            <a:schemeClr val="accent1"/>
-          </a:effectRef>
-          <a:fontRef idx="minor">
-            <a:schemeClr val="lt1"/>
-          </a:fontRef>
-        </p:style>
-        <p:txBody>
-          <a:bodyPr rtlCol="0" anchor="ctr"/>
-          <a:lstStyle/>
-          <a:p>
-            <a:pPr algn="ctr"/>
-          </a:p>
-        </p:txBody>
-      </p:sp>
-      <p:sp>
-        <p:nvSpPr>
-          <p:cNvPr id="22" name="TextBox 21"/>
-          <p:cNvSpPr txBox="1"/>
-          <p:nvPr/>
-        </p:nvSpPr>
-        <p:spPr>
-          <a:xfrm>
-            <a:off x="347472" y="3337559"/>
-            <a:ext cx="2788920" cy="603503"/>
-          </a:xfrm>
-          <a:prstGeom prst="rect">
-            <a:avLst/>
-          </a:prstGeom>
-          <a:noFill/>
-        </p:spPr>
-        <p:txBody>
-          <a:bodyPr wrap="square">
-            <a:spAutoFit/>
-          </a:bodyPr>
-          <a:lstStyle/>
-          <a:p>
-            <a:pPr algn="l"/>
-            <a:r>
-              <a:rPr sz="900" b="1">
-                <a:solidFill>
-                  <a:srgbClr val="2C3E50"/>
-                </a:solidFill>
-              </a:rPr>
-              <a:t>Dedup-Kontrolle</a:t>
-            </a:r>
-          </a:p>
-        </p:txBody>
-      </p:sp>
-      <p:sp>
-        <p:nvSpPr>
-          <p:cNvPr id="23" name="TextBox 22"/>
-          <p:cNvSpPr txBox="1"/>
-          <p:nvPr/>
-        </p:nvSpPr>
-        <p:spPr>
-          <a:xfrm>
-            <a:off x="3364992" y="3337559"/>
-            <a:ext cx="8412480" cy="603503"/>
-          </a:xfrm>
-          <a:prstGeom prst="rect">
-            <a:avLst/>
-          </a:prstGeom>
-          <a:noFill/>
-        </p:spPr>
-        <p:txBody>
-          <a:bodyPr wrap="square">
-            <a:spAutoFit/>
-          </a:bodyPr>
-          <a:lstStyle/>
-          <a:p>
-            <a:pPr algn="l"/>
-            <a:r>
-              <a:rPr sz="900" b="0">
-                <a:solidFill>
-                  <a:srgbClr val="2C3E50"/>
-                </a:solidFill>
-              </a:rPr>
-              <a:t>--no-dedup behält alle Issues — nützlich wenn sich Zeitfenster der Abfragen überschneiden</a:t>
-            </a:r>
-          </a:p>
-        </p:txBody>
-      </p:sp>
-      <p:sp>
-        <p:nvSpPr>
-          <p:cNvPr id="24" name="Rectangle 23"/>
-          <p:cNvSpPr/>
-          <p:nvPr/>
-        </p:nvSpPr>
-        <p:spPr>
-          <a:xfrm>
-            <a:off x="274320" y="3959351"/>
-            <a:ext cx="2926080" cy="658368"/>
-          </a:xfrm>
-          <a:prstGeom prst="rect">
-            <a:avLst/>
-          </a:prstGeom>
-          <a:solidFill>
-            <a:srgbClr val="ECF0F1"/>
-          </a:solidFill>
-          <a:ln>
-            <a:noFill/>
-          </a:ln>
-        </p:spPr>
-        <p:style>
-          <a:lnRef idx="1">
-            <a:schemeClr val="accent1"/>
-          </a:lnRef>
-          <a:fillRef idx="3">
-            <a:schemeClr val="accent1"/>
-          </a:fillRef>
-          <a:effectRef idx="2">
-            <a:schemeClr val="accent1"/>
-          </a:effectRef>
-          <a:fontRef idx="minor">
-            <a:schemeClr val="lt1"/>
-          </a:fontRef>
-        </p:style>
-        <p:txBody>
-          <a:bodyPr rtlCol="0" anchor="ctr"/>
-          <a:lstStyle/>
-          <a:p>
-            <a:pPr algn="ctr"/>
-          </a:p>
-        </p:txBody>
-      </p:sp>
-      <p:sp>
-        <p:nvSpPr>
-          <p:cNvPr id="25" name="Rectangle 24"/>
-          <p:cNvSpPr/>
-          <p:nvPr/>
-        </p:nvSpPr>
-        <p:spPr>
-          <a:xfrm>
-            <a:off x="3291840" y="3959351"/>
-            <a:ext cx="8595360" cy="658368"/>
-          </a:xfrm>
-          <a:prstGeom prst="rect">
-            <a:avLst/>
-          </a:prstGeom>
-          <a:solidFill>
-            <a:srgbClr val="ECF0F1"/>
-          </a:solidFill>
-          <a:ln>
-            <a:noFill/>
-          </a:ln>
-        </p:spPr>
-        <p:style>
-          <a:lnRef idx="1">
-            <a:schemeClr val="accent1"/>
-          </a:lnRef>
-          <a:fillRef idx="3">
-            <a:schemeClr val="accent1"/>
-          </a:fillRef>
-          <a:effectRef idx="2">
-            <a:schemeClr val="accent1"/>
-          </a:effectRef>
-          <a:fontRef idx="minor">
-            <a:schemeClr val="lt1"/>
-          </a:fontRef>
-        </p:style>
-        <p:txBody>
-          <a:bodyPr rtlCol="0" anchor="ctr"/>
-          <a:lstStyle/>
-          <a:p>
-            <a:pPr algn="ctr"/>
-          </a:p>
-        </p:txBody>
-      </p:sp>
-      <p:sp>
-        <p:nvSpPr>
-          <p:cNvPr id="26" name="TextBox 25"/>
-          <p:cNvSpPr txBox="1"/>
-          <p:nvPr/>
-        </p:nvSpPr>
-        <p:spPr>
-          <a:xfrm>
-            <a:off x="347472" y="3995927"/>
-            <a:ext cx="2788920" cy="603503"/>
-          </a:xfrm>
-          <a:prstGeom prst="rect">
-            <a:avLst/>
-          </a:prstGeom>
-          <a:noFill/>
-        </p:spPr>
-        <p:txBody>
-          <a:bodyPr wrap="square">
-            <a:spAutoFit/>
-          </a:bodyPr>
-          <a:lstStyle/>
-          <a:p>
-            <a:pPr algn="l"/>
-            <a:r>
-              <a:rPr sz="900" b="1">
-                <a:solidFill>
-                  <a:srgbClr val="2C3E50"/>
-                </a:solidFill>
-              </a:rPr>
-              <a:t>GUI</a:t>
-            </a:r>
-          </a:p>
-        </p:txBody>
-      </p:sp>
-      <p:sp>
-        <p:nvSpPr>
-          <p:cNvPr id="27" name="TextBox 26"/>
-          <p:cNvSpPr txBox="1"/>
-          <p:nvPr/>
-        </p:nvSpPr>
-        <p:spPr>
-          <a:xfrm>
-            <a:off x="3364992" y="3995927"/>
-            <a:ext cx="8412480" cy="603503"/>
-          </a:xfrm>
-          <a:prstGeom prst="rect">
-            <a:avLst/>
-          </a:prstGeom>
-          <a:noFill/>
-        </p:spPr>
-        <p:txBody>
-          <a:bodyPr wrap="square">
-            <a:spAutoFit/>
-          </a:bodyPr>
-          <a:lstStyle/>
-          <a:p>
-            <a:pPr algn="l"/>
-            <a:r>
-              <a:rPr sz="900" b="0">
-                <a:solidFill>
-                  <a:srgbClr val="2C3E50"/>
-                </a:solidFill>
-              </a:rPr>
-              <a:t>Multi-File-Listbox + Ausgabepfad-Dialog + Dedup-Checkbox; Ladebalken nach 3 Sekunden</a:t>
-            </a:r>
-          </a:p>
-        </p:txBody>
-      </p:sp>
-      <p:sp>
-        <p:nvSpPr>
-          <p:cNvPr id="28" name="Rectangle 27"/>
-          <p:cNvSpPr/>
-          <p:nvPr/>
-        </p:nvSpPr>
-        <p:spPr>
-          <a:xfrm>
-            <a:off x="274320" y="4617719"/>
-            <a:ext cx="2926080" cy="658368"/>
-          </a:xfrm>
-          <a:prstGeom prst="rect">
-            <a:avLst/>
-          </a:prstGeom>
-          <a:solidFill>
-            <a:srgbClr val="FFFFFF"/>
-          </a:solidFill>
-          <a:ln>
-            <a:noFill/>
-          </a:ln>
-        </p:spPr>
-        <p:style>
-          <a:lnRef idx="1">
-            <a:schemeClr val="accent1"/>
-          </a:lnRef>
-          <a:fillRef idx="3">
-            <a:schemeClr val="accent1"/>
-          </a:fillRef>
-          <a:effectRef idx="2">
-            <a:schemeClr val="accent1"/>
-          </a:effectRef>
-          <a:fontRef idx="minor">
-            <a:schemeClr val="lt1"/>
-          </a:fontRef>
-        </p:style>
-        <p:txBody>
-          <a:bodyPr rtlCol="0" anchor="ctr"/>
-          <a:lstStyle/>
-          <a:p>
-            <a:pPr algn="ctr"/>
-          </a:p>
-        </p:txBody>
-      </p:sp>
-      <p:sp>
-        <p:nvSpPr>
-          <p:cNvPr id="29" name="Rectangle 28"/>
-          <p:cNvSpPr/>
-          <p:nvPr/>
-        </p:nvSpPr>
-        <p:spPr>
-          <a:xfrm>
-            <a:off x="3291840" y="4617719"/>
-            <a:ext cx="8595360" cy="658368"/>
-          </a:xfrm>
-          <a:prstGeom prst="rect">
-            <a:avLst/>
-          </a:prstGeom>
-          <a:solidFill>
-            <a:srgbClr val="FFFFFF"/>
-          </a:solidFill>
-          <a:ln>
-            <a:noFill/>
-          </a:ln>
-        </p:spPr>
-        <p:style>
-          <a:lnRef idx="1">
-            <a:schemeClr val="accent1"/>
-          </a:lnRef>
-          <a:fillRef idx="3">
-            <a:schemeClr val="accent1"/>
-          </a:fillRef>
-          <a:effectRef idx="2">
-            <a:schemeClr val="accent1"/>
-          </a:effectRef>
-          <a:fontRef idx="minor">
-            <a:schemeClr val="lt1"/>
-          </a:fontRef>
-        </p:style>
-        <p:txBody>
-          <a:bodyPr rtlCol="0" anchor="ctr"/>
-          <a:lstStyle/>
-          <a:p>
-            <a:pPr algn="ctr"/>
-          </a:p>
-        </p:txBody>
-      </p:sp>
-      <p:sp>
-        <p:nvSpPr>
-          <p:cNvPr id="30" name="TextBox 29"/>
-          <p:cNvSpPr txBox="1"/>
-          <p:nvPr/>
-        </p:nvSpPr>
-        <p:spPr>
-          <a:xfrm>
-            <a:off x="347472" y="4654295"/>
-            <a:ext cx="2788920" cy="603503"/>
-          </a:xfrm>
-          <a:prstGeom prst="rect">
-            <a:avLst/>
-          </a:prstGeom>
-          <a:noFill/>
-        </p:spPr>
-        <p:txBody>
-          <a:bodyPr wrap="square">
-            <a:spAutoFit/>
-          </a:bodyPr>
-          <a:lstStyle/>
-          <a:p>
-            <a:pPr algn="l"/>
-            <a:r>
-              <a:rPr sz="900" b="1">
-                <a:solidFill>
-                  <a:srgbClr val="2C3E50"/>
-                </a:solidFill>
-              </a:rPr>
-              <a:t>CLI</a:t>
-            </a:r>
-          </a:p>
-        </p:txBody>
-      </p:sp>
-      <p:sp>
-        <p:nvSpPr>
-          <p:cNvPr id="31" name="TextBox 30"/>
-          <p:cNvSpPr txBox="1"/>
-          <p:nvPr/>
-        </p:nvSpPr>
-        <p:spPr>
-          <a:xfrm>
-            <a:off x="3364992" y="4654295"/>
-            <a:ext cx="8412480" cy="603503"/>
-          </a:xfrm>
-          <a:prstGeom prst="rect">
-            <a:avLst/>
-          </a:prstGeom>
-          <a:noFill/>
-        </p:spPr>
-        <p:txBody>
-          <a:bodyPr wrap="square">
-            <a:spAutoFit/>
-          </a:bodyPr>
-          <a:lstStyle/>
-          <a:p>
-            <a:pPr algn="l"/>
-            <a:r>
-              <a:rPr sz="900" b="0">
-                <a:solidFill>
-                  <a:srgbClr val="2C3E50"/>
-                </a:solidFill>
-              </a:rPr>
-              <a:t>python -m helper file1.json file2.json --output merged.json [--no-dedup]</a:t>
-            </a:r>
-          </a:p>
-        </p:txBody>
-      </p:sp>
-      <p:sp>
-        <p:nvSpPr>
-          <p:cNvPr id="32" name="Rectangle 31"/>
-          <p:cNvSpPr/>
-          <p:nvPr/>
-        </p:nvSpPr>
-        <p:spPr>
-          <a:xfrm>
-            <a:off x="274320" y="5276087"/>
-            <a:ext cx="2926080" cy="658368"/>
-          </a:xfrm>
-          <a:prstGeom prst="rect">
-            <a:avLst/>
-          </a:prstGeom>
-          <a:solidFill>
-            <a:srgbClr val="ECF0F1"/>
-          </a:solidFill>
-          <a:ln>
-            <a:noFill/>
-          </a:ln>
-        </p:spPr>
-        <p:style>
-          <a:lnRef idx="1">
-            <a:schemeClr val="accent1"/>
-          </a:lnRef>
-          <a:fillRef idx="3">
-            <a:schemeClr val="accent1"/>
-          </a:fillRef>
-          <a:effectRef idx="2">
-            <a:schemeClr val="accent1"/>
-          </a:effectRef>
-          <a:fontRef idx="minor">
-            <a:schemeClr val="lt1"/>
-          </a:fontRef>
-        </p:style>
-        <p:txBody>
-          <a:bodyPr rtlCol="0" anchor="ctr"/>
-          <a:lstStyle/>
-          <a:p>
-            <a:pPr algn="ctr"/>
-          </a:p>
-        </p:txBody>
-      </p:sp>
-      <p:sp>
-        <p:nvSpPr>
-          <p:cNvPr id="33" name="Rectangle 32"/>
-          <p:cNvSpPr/>
-          <p:nvPr/>
-        </p:nvSpPr>
-        <p:spPr>
-          <a:xfrm>
-            <a:off x="3291840" y="5276087"/>
-            <a:ext cx="8595360" cy="658368"/>
-          </a:xfrm>
-          <a:prstGeom prst="rect">
-            <a:avLst/>
-          </a:prstGeom>
-          <a:solidFill>
-            <a:srgbClr val="ECF0F1"/>
-          </a:solidFill>
-          <a:ln>
-            <a:noFill/>
-          </a:ln>
-        </p:spPr>
-        <p:style>
-          <a:lnRef idx="1">
-            <a:schemeClr val="accent1"/>
-          </a:lnRef>
-          <a:fillRef idx="3">
-            <a:schemeClr val="accent1"/>
-          </a:fillRef>
-          <a:effectRef idx="2">
-            <a:schemeClr val="accent1"/>
-          </a:effectRef>
-          <a:fontRef idx="minor">
-            <a:schemeClr val="lt1"/>
-          </a:fontRef>
-        </p:style>
-        <p:txBody>
-          <a:bodyPr rtlCol="0" anchor="ctr"/>
-          <a:lstStyle/>
-          <a:p>
-            <a:pPr algn="ctr"/>
-          </a:p>
-        </p:txBody>
-      </p:sp>
-      <p:sp>
-        <p:nvSpPr>
-          <p:cNvPr id="34" name="TextBox 33"/>
-          <p:cNvSpPr txBox="1"/>
-          <p:nvPr/>
-        </p:nvSpPr>
-        <p:spPr>
-          <a:xfrm>
-            <a:off x="347472" y="5312663"/>
-            <a:ext cx="2788920" cy="603503"/>
-          </a:xfrm>
-          <a:prstGeom prst="rect">
-            <a:avLst/>
-          </a:prstGeom>
-          <a:noFill/>
-        </p:spPr>
-        <p:txBody>
-          <a:bodyPr wrap="square">
-            <a:spAutoFit/>
-          </a:bodyPr>
-          <a:lstStyle/>
-          <a:p>
-            <a:pPr algn="l"/>
-            <a:r>
-              <a:rPr sz="900" b="1">
-                <a:solidFill>
-                  <a:srgbClr val="2C3E50"/>
-                </a:solidFill>
-              </a:rPr>
-              <a:t>Ausgabeformat</a:t>
-            </a:r>
-          </a:p>
-        </p:txBody>
-      </p:sp>
-      <p:sp>
-        <p:nvSpPr>
-          <p:cNvPr id="35" name="TextBox 34"/>
-          <p:cNvSpPr txBox="1"/>
-          <p:nvPr/>
-        </p:nvSpPr>
-        <p:spPr>
-          <a:xfrm>
-            <a:off x="3364992" y="5312663"/>
-            <a:ext cx="8412480" cy="603503"/>
-          </a:xfrm>
-          <a:prstGeom prst="rect">
-            <a:avLst/>
-          </a:prstGeom>
-          <a:noFill/>
-        </p:spPr>
-        <p:txBody>
-          <a:bodyPr wrap="square">
-            <a:spAutoFit/>
-          </a:bodyPr>
-          <a:lstStyle/>
-          <a:p>
-            <a:pPr algn="l"/>
-            <a:r>
-              <a:rPr sz="900" b="0">
-                <a:solidFill>
-                  <a:srgbClr val="2C3E50"/>
-                </a:solidFill>
-              </a:rPr>
-              <a:t>Gültiger Jira REST API Envelope (startAt, maxResults, total, issues) — direkt mit transform_data verarbeitbar</a:t>
-            </a:r>
-          </a:p>
-        </p:txBody>
-      </p:sp>
-      <p:sp>
-        <p:nvSpPr>
-          <p:cNvPr id="36" name="Rectangle 35"/>
-          <p:cNvSpPr/>
-          <p:nvPr/>
-        </p:nvSpPr>
-        <p:spPr>
-          <a:xfrm>
-            <a:off x="274320" y="5934455"/>
-            <a:ext cx="2926080" cy="658368"/>
-          </a:xfrm>
-          <a:prstGeom prst="rect">
-            <a:avLst/>
-          </a:prstGeom>
-          <a:solidFill>
-            <a:srgbClr val="FFFFFF"/>
-          </a:solidFill>
-          <a:ln>
-            <a:noFill/>
-          </a:ln>
-        </p:spPr>
-        <p:style>
-          <a:lnRef idx="1">
-            <a:schemeClr val="accent1"/>
-          </a:lnRef>
-          <a:fillRef idx="3">
-            <a:schemeClr val="accent1"/>
-          </a:fillRef>
-          <a:effectRef idx="2">
-            <a:schemeClr val="accent1"/>
-          </a:effectRef>
-          <a:fontRef idx="minor">
-            <a:schemeClr val="lt1"/>
-          </a:fontRef>
-        </p:style>
-        <p:txBody>
-          <a:bodyPr rtlCol="0" anchor="ctr"/>
-          <a:lstStyle/>
-          <a:p>
-            <a:pPr algn="ctr"/>
-          </a:p>
-        </p:txBody>
-      </p:sp>
-      <p:sp>
-        <p:nvSpPr>
-          <p:cNvPr id="37" name="Rectangle 36"/>
-          <p:cNvSpPr/>
-          <p:nvPr/>
-        </p:nvSpPr>
-        <p:spPr>
-          <a:xfrm>
-            <a:off x="3291840" y="5934455"/>
-            <a:ext cx="8595360" cy="658368"/>
-          </a:xfrm>
-          <a:prstGeom prst="rect">
-            <a:avLst/>
-          </a:prstGeom>
-          <a:solidFill>
-            <a:srgbClr val="FFFFFF"/>
-          </a:solidFill>
-          <a:ln>
-            <a:noFill/>
-          </a:ln>
-        </p:spPr>
-        <p:style>
-          <a:lnRef idx="1">
-            <a:schemeClr val="accent1"/>
-          </a:lnRef>
-          <a:fillRef idx="3">
-            <a:schemeClr val="accent1"/>
-          </a:fillRef>
-          <a:effectRef idx="2">
-            <a:schemeClr val="accent1"/>
-          </a:effectRef>
-          <a:fontRef idx="minor">
-            <a:schemeClr val="lt1"/>
-          </a:fontRef>
-        </p:style>
-        <p:txBody>
-          <a:bodyPr rtlCol="0" anchor="ctr"/>
-          <a:lstStyle/>
-          <a:p>
-            <a:pPr algn="ctr"/>
-          </a:p>
-        </p:txBody>
-      </p:sp>
-      <p:sp>
-        <p:nvSpPr>
-          <p:cNvPr id="38" name="TextBox 37"/>
-          <p:cNvSpPr txBox="1"/>
-          <p:nvPr/>
-        </p:nvSpPr>
-        <p:spPr>
-          <a:xfrm>
-            <a:off x="347472" y="5971031"/>
-            <a:ext cx="2788920" cy="603503"/>
-          </a:xfrm>
-          <a:prstGeom prst="rect">
-            <a:avLst/>
-          </a:prstGeom>
-          <a:noFill/>
-        </p:spPr>
-        <p:txBody>
-          <a:bodyPr wrap="square">
-            <a:spAutoFit/>
-          </a:bodyPr>
-          <a:lstStyle/>
-          <a:p>
-            <a:pPr algn="l"/>
-            <a:r>
-              <a:rPr sz="900" b="1">
-                <a:solidFill>
-                  <a:srgbClr val="2C3E50"/>
-                </a:solidFill>
-              </a:rPr>
-              <a:t>Doppelklick-Starter</a:t>
-            </a:r>
-          </a:p>
-        </p:txBody>
-      </p:sp>
-      <p:sp>
-        <p:nvSpPr>
-          <p:cNvPr id="39" name="TextBox 38"/>
-          <p:cNvSpPr txBox="1"/>
-          <p:nvPr/>
-        </p:nvSpPr>
-        <p:spPr>
-          <a:xfrm>
-            <a:off x="3364992" y="5971031"/>
-            <a:ext cx="8412480" cy="603503"/>
-          </a:xfrm>
-          <a:prstGeom prst="rect">
-            <a:avLst/>
-          </a:prstGeom>
-          <a:noFill/>
-        </p:spPr>
-        <p:txBody>
-          <a:bodyPr wrap="square">
-            <a:spAutoFit/>
-          </a:bodyPr>
-          <a:lstStyle/>
-          <a:p>
-            <a:pPr algn="l"/>
-            <a:r>
-              <a:rPr sz="900" b="0">
-                <a:solidFill>
-                  <a:srgbClr val="2C3E50"/>
-                </a:solidFill>
-              </a:rPr>
-              <a:t>helper_gui.pyw startet die GUI ohne Konsolenfenster</a:t>
-            </a:r>
-          </a:p>
-        </p:txBody>
-      </p:sp>
-      <p:sp>
-        <p:nvSpPr>
-          <p:cNvPr id="40" name="Rectangle 39"/>
-          <p:cNvSpPr/>
-          <p:nvPr/>
-        </p:nvSpPr>
-        <p:spPr>
-          <a:xfrm>
-            <a:off x="0" y="6720840"/>
-            <a:ext cx="12188952" cy="137160"/>
-          </a:xfrm>
-          <a:prstGeom prst="rect">
-            <a:avLst/>
-          </a:prstGeom>
-          <a:solidFill>
-            <a:srgbClr val="2980B9"/>
-          </a:solidFill>
-          <a:ln>
-            <a:noFill/>
-          </a:ln>
-        </p:spPr>
-        <p:style>
-          <a:lnRef idx="1">
-            <a:schemeClr val="accent1"/>
-          </a:lnRef>
-          <a:fillRef idx="3">
-            <a:schemeClr val="accent1"/>
-          </a:fillRef>
-          <a:effectRef idx="2">
-            <a:schemeClr val="accent1"/>
-          </a:effectRef>
-          <a:fontRef idx="minor">
-            <a:schemeClr val="lt1"/>
-          </a:fontRef>
-        </p:style>
-        <p:txBody>
-          <a:bodyPr rtlCol="0" anchor="ctr"/>
-          <a:lstStyle/>
-          <a:p>
-            <a:pPr algn="ctr"/>
           </a:p>
         </p:txBody>
       </p:sp>
@@ -5789,7 +4264,7 @@
                   <a:srgbClr val="2C3E50"/>
                 </a:solidFill>
               </a:rPr>
-              <a:t>BETA / ALPHA-Badges</a:t>
+              <a:t>Reifegrad-Badges</a:t>
             </a:r>
           </a:p>
         </p:txBody>
@@ -5823,7 +4298,7 @@
                   <a:srgbClr val="2C3E50"/>
                 </a:solidFill>
               </a:rPr>
-              <a:t>Orangefarbenes BETA-Badge im Titel zeigt den Gesamtreifegrad; jede Modul-Karte trägt ein eigenes ALPHA- oder BETA-Badge neben dem Namen</a:t>
+              <a:t>App-Badge in der Titelleiste (orange BETA); jede Modulkarte zeigt eigenes Badge: transform_data + build_reports → BETA (orange), testdata_generator → ALPHA (rot), geplante Module → kein Badge</a:t>
             </a:r>
           </a:p>
         </p:txBody>
@@ -12349,7 +10824,7 @@
                   <a:srgbClr val="FFFFFF"/>
                 </a:solidFill>
               </a:rPr>
-              <a:t>Infrastruktur &amp; Dokumentation</a:t>
+              <a:t>testdata_generator  ⚠ ALPHA</a:t>
             </a:r>
           </a:p>
         </p:txBody>
@@ -12623,7 +11098,7 @@
                   <a:srgbClr val="2C3E50"/>
                 </a:solidFill>
               </a:rPr>
-              <a:t>Versionierung</a:t>
+              <a:t>Synthetische Jira-Daten</a:t>
             </a:r>
           </a:p>
         </p:txBody>
@@ -12657,7 +11132,7 @@
                   <a:srgbClr val="2C3E50"/>
                 </a:solidFill>
               </a:rPr>
-              <a:t>SemVer ab v0.2.0; zentrale version.py wird von allen GUIs und den Manuals gelesen; aktuell v0.9.0</a:t>
+              <a:t>Erzeugt Jira-Issues im REST-API-Format — direkt mit transform_data verarbeitbar. Workflow-Datei, Projekt-Key, Anzahl, Datum-Bereich, Completion-Rate, Backflow, Issue-Typen und Seed konfigurierbar.</a:t>
             </a:r>
           </a:p>
         </p:txBody>
@@ -12777,7 +11252,7 @@
                   <a:srgbClr val="2C3E50"/>
                 </a:solidFill>
               </a:rPr>
-              <a:t>Sprachauswahl</a:t>
+              <a:t>Flow-Antipattern</a:t>
             </a:r>
           </a:p>
         </p:txBody>
@@ -12811,7 +11286,7 @@
                   <a:srgbClr val="2C3E50"/>
                 </a:solidFill>
               </a:rPr>
-              <a:t>Launcher: DE/EN/RO/PT/FR (5 Sprachen); build_reports und transform_data: DE/EN; letzte Wahl persistent in ~/.situation_report/prefs.json</a:t>
+              <a:t>Vier simulierbare Muster (Triangle, Flat Triangle, Cluster of Dots, Batch Transfers) — Radiobuttons in der GUI oder --pattern auf der CLI. Basiert auf Vacanti/Singh-Antipatterns zur Flow-Überwachung.</a:t>
             </a:r>
           </a:p>
         </p:txBody>
@@ -12931,7 +11406,7 @@
                   <a:srgbClr val="2C3E50"/>
                 </a:solidFill>
               </a:rPr>
-              <a:t>PDF-Manuals</a:t>
+              <a:t>Lognormale Cycle-Time</a:t>
             </a:r>
           </a:p>
         </p:txBody>
@@ -12965,7 +11440,7 @@
                   <a:srgbClr val="2C3E50"/>
                 </a:solidFill>
               </a:rPr>
-              <a:t>Launcher-Handbuch in 5 Sprachen (DE, EN, RO, PT, FR); build_reports und transform_data je DE + EN; generiert mit ReportLab</a:t>
+              <a:t>Mittlere Cycle-Time und Standardabweichung direkt einstellbar (--mean-cycle-days, --std-cycle-days); GUI mit Eingabefeld + Schieberegler. Lognormal-Verteilung ergibt realistische Rechtsschiefe.</a:t>
             </a:r>
           </a:p>
         </p:txBody>
@@ -13085,7 +11560,7 @@
                   <a:srgbClr val="2C3E50"/>
                 </a:solidFill>
               </a:rPr>
-              <a:t>Manual-Link in GUI</a:t>
+              <a:t>PI-Zyklus</a:t>
             </a:r>
           </a:p>
         </p:txBody>
@@ -13119,7 +11594,7 @@
                   <a:srgbClr val="2C3E50"/>
                 </a:solidFill>
               </a:rPr>
-              <a:t>Hilfe-Menü / (?)-Button öffnet das sprachpassende PDF direkt auf GitHub Pages</a:t>
+              <a:t>Konfigurierbare PI-Länge in Wochen (Standard 12) für Cluster- und Batch-Muster — Lieferungen werden auf die letzten 2 Wochen vor PI-Ende konzentriert (Beta(2, 0.5)-Verteilung).</a:t>
             </a:r>
           </a:p>
         </p:txBody>
@@ -13239,7 +11714,7 @@
                   <a:srgbClr val="2C3E50"/>
                 </a:solidFill>
               </a:rPr>
-              <a:t>GitHub Pages Doku</a:t>
+              <a:t>CLI + GUI</a:t>
             </a:r>
           </a:p>
         </p:txBody>
@@ -13273,7 +11748,7 @@
                   <a:srgbClr val="2C3E50"/>
                 </a:solidFill>
               </a:rPr>
-              <a:t>MkDocs-Site mit DE/EN-Doku für alle Module; Architektur nach C4-Modell</a:t>
+              <a:t>Alle Parameter über GUI (Schieberegler, Radiobuttons, Dateidialoge) oder Kommandozeile (python -m testdata_generator --pattern ...) steuerbar. 5 Sprachen (DE/EN/RO/PT/FR).</a:t>
             </a:r>
           </a:p>
         </p:txBody>
@@ -13286,314 +11761,6 @@
         </p:nvSpPr>
         <p:spPr>
           <a:xfrm>
-            <a:off x="274320" y="4617719"/>
-            <a:ext cx="2926080" cy="658368"/>
-          </a:xfrm>
-          <a:prstGeom prst="rect">
-            <a:avLst/>
-          </a:prstGeom>
-          <a:solidFill>
-            <a:srgbClr val="FFFFFF"/>
-          </a:solidFill>
-          <a:ln>
-            <a:noFill/>
-          </a:ln>
-        </p:spPr>
-        <p:style>
-          <a:lnRef idx="1">
-            <a:schemeClr val="accent1"/>
-          </a:lnRef>
-          <a:fillRef idx="3">
-            <a:schemeClr val="accent1"/>
-          </a:fillRef>
-          <a:effectRef idx="2">
-            <a:schemeClr val="accent1"/>
-          </a:effectRef>
-          <a:fontRef idx="minor">
-            <a:schemeClr val="lt1"/>
-          </a:fontRef>
-        </p:style>
-        <p:txBody>
-          <a:bodyPr rtlCol="0" anchor="ctr"/>
-          <a:lstStyle/>
-          <a:p>
-            <a:pPr algn="ctr"/>
-          </a:p>
-        </p:txBody>
-      </p:sp>
-      <p:sp>
-        <p:nvSpPr>
-          <p:cNvPr id="29" name="Rectangle 28"/>
-          <p:cNvSpPr/>
-          <p:nvPr/>
-        </p:nvSpPr>
-        <p:spPr>
-          <a:xfrm>
-            <a:off x="3291840" y="4617719"/>
-            <a:ext cx="8595360" cy="658368"/>
-          </a:xfrm>
-          <a:prstGeom prst="rect">
-            <a:avLst/>
-          </a:prstGeom>
-          <a:solidFill>
-            <a:srgbClr val="FFFFFF"/>
-          </a:solidFill>
-          <a:ln>
-            <a:noFill/>
-          </a:ln>
-        </p:spPr>
-        <p:style>
-          <a:lnRef idx="1">
-            <a:schemeClr val="accent1"/>
-          </a:lnRef>
-          <a:fillRef idx="3">
-            <a:schemeClr val="accent1"/>
-          </a:fillRef>
-          <a:effectRef idx="2">
-            <a:schemeClr val="accent1"/>
-          </a:effectRef>
-          <a:fontRef idx="minor">
-            <a:schemeClr val="lt1"/>
-          </a:fontRef>
-        </p:style>
-        <p:txBody>
-          <a:bodyPr rtlCol="0" anchor="ctr"/>
-          <a:lstStyle/>
-          <a:p>
-            <a:pPr algn="ctr"/>
-          </a:p>
-        </p:txBody>
-      </p:sp>
-      <p:sp>
-        <p:nvSpPr>
-          <p:cNvPr id="30" name="TextBox 29"/>
-          <p:cNvSpPr txBox="1"/>
-          <p:nvPr/>
-        </p:nvSpPr>
-        <p:spPr>
-          <a:xfrm>
-            <a:off x="347472" y="4654295"/>
-            <a:ext cx="2788920" cy="603503"/>
-          </a:xfrm>
-          <a:prstGeom prst="rect">
-            <a:avLst/>
-          </a:prstGeom>
-          <a:noFill/>
-        </p:spPr>
-        <p:txBody>
-          <a:bodyPr wrap="square">
-            <a:spAutoFit/>
-          </a:bodyPr>
-          <a:lstStyle/>
-          <a:p>
-            <a:pPr algn="l"/>
-            <a:r>
-              <a:rPr sz="900" b="1">
-                <a:solidFill>
-                  <a:srgbClr val="2C3E50"/>
-                </a:solidFill>
-              </a:rPr>
-              <a:t>CI/CD</a:t>
-            </a:r>
-          </a:p>
-        </p:txBody>
-      </p:sp>
-      <p:sp>
-        <p:nvSpPr>
-          <p:cNvPr id="31" name="TextBox 30"/>
-          <p:cNvSpPr txBox="1"/>
-          <p:nvPr/>
-        </p:nvSpPr>
-        <p:spPr>
-          <a:xfrm>
-            <a:off x="3364992" y="4654295"/>
-            <a:ext cx="8412480" cy="603503"/>
-          </a:xfrm>
-          <a:prstGeom prst="rect">
-            <a:avLst/>
-          </a:prstGeom>
-          <a:noFill/>
-        </p:spPr>
-        <p:txBody>
-          <a:bodyPr wrap="square">
-            <a:spAutoFit/>
-          </a:bodyPr>
-          <a:lstStyle/>
-          <a:p>
-            <a:pPr algn="l"/>
-            <a:r>
-              <a:rPr sz="900" b="0">
-                <a:solidFill>
-                  <a:srgbClr val="2C3E50"/>
-                </a:solidFill>
-              </a:rPr>
-              <a:t>GitHub Actions für automatisches Docs-Deployment und Release-Erstellung bei v*-Tags</a:t>
-            </a:r>
-          </a:p>
-        </p:txBody>
-      </p:sp>
-      <p:sp>
-        <p:nvSpPr>
-          <p:cNvPr id="32" name="Rectangle 31"/>
-          <p:cNvSpPr/>
-          <p:nvPr/>
-        </p:nvSpPr>
-        <p:spPr>
-          <a:xfrm>
-            <a:off x="274320" y="5276087"/>
-            <a:ext cx="2926080" cy="658368"/>
-          </a:xfrm>
-          <a:prstGeom prst="rect">
-            <a:avLst/>
-          </a:prstGeom>
-          <a:solidFill>
-            <a:srgbClr val="ECF0F1"/>
-          </a:solidFill>
-          <a:ln>
-            <a:noFill/>
-          </a:ln>
-        </p:spPr>
-        <p:style>
-          <a:lnRef idx="1">
-            <a:schemeClr val="accent1"/>
-          </a:lnRef>
-          <a:fillRef idx="3">
-            <a:schemeClr val="accent1"/>
-          </a:fillRef>
-          <a:effectRef idx="2">
-            <a:schemeClr val="accent1"/>
-          </a:effectRef>
-          <a:fontRef idx="minor">
-            <a:schemeClr val="lt1"/>
-          </a:fontRef>
-        </p:style>
-        <p:txBody>
-          <a:bodyPr rtlCol="0" anchor="ctr"/>
-          <a:lstStyle/>
-          <a:p>
-            <a:pPr algn="ctr"/>
-          </a:p>
-        </p:txBody>
-      </p:sp>
-      <p:sp>
-        <p:nvSpPr>
-          <p:cNvPr id="33" name="Rectangle 32"/>
-          <p:cNvSpPr/>
-          <p:nvPr/>
-        </p:nvSpPr>
-        <p:spPr>
-          <a:xfrm>
-            <a:off x="3291840" y="5276087"/>
-            <a:ext cx="8595360" cy="658368"/>
-          </a:xfrm>
-          <a:prstGeom prst="rect">
-            <a:avLst/>
-          </a:prstGeom>
-          <a:solidFill>
-            <a:srgbClr val="ECF0F1"/>
-          </a:solidFill>
-          <a:ln>
-            <a:noFill/>
-          </a:ln>
-        </p:spPr>
-        <p:style>
-          <a:lnRef idx="1">
-            <a:schemeClr val="accent1"/>
-          </a:lnRef>
-          <a:fillRef idx="3">
-            <a:schemeClr val="accent1"/>
-          </a:fillRef>
-          <a:effectRef idx="2">
-            <a:schemeClr val="accent1"/>
-          </a:effectRef>
-          <a:fontRef idx="minor">
-            <a:schemeClr val="lt1"/>
-          </a:fontRef>
-        </p:style>
-        <p:txBody>
-          <a:bodyPr rtlCol="0" anchor="ctr"/>
-          <a:lstStyle/>
-          <a:p>
-            <a:pPr algn="ctr"/>
-          </a:p>
-        </p:txBody>
-      </p:sp>
-      <p:sp>
-        <p:nvSpPr>
-          <p:cNvPr id="34" name="TextBox 33"/>
-          <p:cNvSpPr txBox="1"/>
-          <p:nvPr/>
-        </p:nvSpPr>
-        <p:spPr>
-          <a:xfrm>
-            <a:off x="347472" y="5312663"/>
-            <a:ext cx="2788920" cy="603503"/>
-          </a:xfrm>
-          <a:prstGeom prst="rect">
-            <a:avLst/>
-          </a:prstGeom>
-          <a:noFill/>
-        </p:spPr>
-        <p:txBody>
-          <a:bodyPr wrap="square">
-            <a:spAutoFit/>
-          </a:bodyPr>
-          <a:lstStyle/>
-          <a:p>
-            <a:pPr algn="l"/>
-            <a:r>
-              <a:rPr sz="900" b="1">
-                <a:solidFill>
-                  <a:srgbClr val="2C3E50"/>
-                </a:solidFill>
-              </a:rPr>
-              <a:t>Tests</a:t>
-            </a:r>
-          </a:p>
-        </p:txBody>
-      </p:sp>
-      <p:sp>
-        <p:nvSpPr>
-          <p:cNvPr id="35" name="TextBox 34"/>
-          <p:cNvSpPr txBox="1"/>
-          <p:nvPr/>
-        </p:nvSpPr>
-        <p:spPr>
-          <a:xfrm>
-            <a:off x="3364992" y="5312663"/>
-            <a:ext cx="8412480" cy="603503"/>
-          </a:xfrm>
-          <a:prstGeom prst="rect">
-            <a:avLst/>
-          </a:prstGeom>
-          <a:noFill/>
-        </p:spPr>
-        <p:txBody>
-          <a:bodyPr wrap="square">
-            <a:spAutoFit/>
-          </a:bodyPr>
-          <a:lstStyle/>
-          <a:p>
-            <a:pPr algn="l"/>
-            <a:r>
-              <a:rPr sz="900" b="0">
-                <a:solidFill>
-                  <a:srgbClr val="2C3E50"/>
-                </a:solidFill>
-              </a:rPr>
-              <a:t>Unit- und Acceptance-Tests für alle Module; aktuell 628 Tests</a:t>
-            </a:r>
-          </a:p>
-        </p:txBody>
-      </p:sp>
-      <p:sp>
-        <p:nvSpPr>
-          <p:cNvPr id="36" name="Rectangle 35"/>
-          <p:cNvSpPr/>
-          <p:nvPr/>
-        </p:nvSpPr>
-        <p:spPr>
-          <a:xfrm>
             <a:off x="0" y="6720840"/>
             <a:ext cx="12188952" cy="137160"/>
           </a:xfrm>
@@ -13601,7 +11768,7 @@
             <a:avLst/>
           </a:prstGeom>
           <a:solidFill>
-            <a:srgbClr val="27AE60"/>
+            <a:srgbClr val="2980B9"/>
           </a:solidFill>
           <a:ln>
             <a:noFill/>
@@ -13719,7 +11886,7 @@
                   <a:srgbClr val="FFFFFF"/>
                 </a:solidFill>
               </a:rPr>
-              <a:t>testdata_generator</a:t>
+              <a:t>Infrastruktur &amp; Dokumentation</a:t>
             </a:r>
           </a:p>
         </p:txBody>
@@ -13993,7 +12160,7 @@
                   <a:srgbClr val="2C3E50"/>
                 </a:solidFill>
               </a:rPr>
-              <a:t>Synthetische Testdaten</a:t>
+              <a:t>Versionierung</a:t>
             </a:r>
           </a:p>
         </p:txBody>
@@ -14027,7 +12194,7 @@
                   <a:srgbClr val="2C3E50"/>
                 </a:solidFill>
               </a:rPr>
-              <a:t>Erzeugt Jira-JSON-Exporte mit realistischem Workflow-Verlauf — direkt mit transform_data verarbeitbar</a:t>
+              <a:t>SemVer ab v0.2.0; zentrale version.py wird von allen GUIs und den Manuals gelesen; aktuell v0.99</a:t>
             </a:r>
           </a:p>
         </p:txBody>
@@ -14147,7 +12314,7 @@
                   <a:srgbClr val="2C3E50"/>
                 </a:solidFill>
               </a:rPr>
-              <a:t>Konfigurierbar</a:t>
+              <a:t>Sprachauswahl</a:t>
             </a:r>
           </a:p>
         </p:txBody>
@@ -14181,7 +12348,7 @@
                   <a:srgbClr val="2C3E50"/>
                 </a:solidFill>
               </a:rPr>
-              <a:t>Projekt-Key, Issue-Anzahl, Zeitraum, Completion-Rate, Backflow-Wahrscheinlichkeit und Seed — via GUI oder CLI</a:t>
+              <a:t>Launcher: DE/EN/RO/PT/FR (5 Sprachen); build_reports und transform_data: DE/EN; letzte Wahl persistent in ~/.situation_report/prefs.json</a:t>
             </a:r>
           </a:p>
         </p:txBody>
@@ -14301,7 +12468,7 @@
                   <a:srgbClr val="2C3E50"/>
                 </a:solidFill>
               </a:rPr>
-              <a:t>Workflow-Datei</a:t>
+              <a:t>PDF-Manuals</a:t>
             </a:r>
           </a:p>
         </p:txBody>
@@ -14335,7 +12502,7 @@
                   <a:srgbClr val="2C3E50"/>
                 </a:solidFill>
               </a:rPr>
-              <a:t>Stages und Übergänge aus bestehender workflow.txt — kompatibel mit transform_data-Format</a:t>
+              <a:t>Launcher-Handbuch in 5 Sprachen (DE, EN, RO, PT, FR); build_reports und transform_data je DE + EN; generiert mit ReportLab</a:t>
             </a:r>
           </a:p>
         </p:txBody>
@@ -14455,7 +12622,7 @@
                   <a:srgbClr val="2C3E50"/>
                 </a:solidFill>
               </a:rPr>
-              <a:t>Reproduzierbar</a:t>
+              <a:t>Manual-Link in GUI</a:t>
             </a:r>
           </a:p>
         </p:txBody>
@@ -14489,7 +12656,7 @@
                   <a:srgbClr val="2C3E50"/>
                 </a:solidFill>
               </a:rPr>
-              <a:t>Seed-Parameter garantiert identische Ausgabe — stabile, reproduzierbare Tests</a:t>
+              <a:t>Hilfe-Menü / (?)-Button öffnet das sprachpassende PDF direkt auf GitHub Pages</a:t>
             </a:r>
           </a:p>
         </p:txBody>
@@ -14609,7 +12776,7 @@
                   <a:srgbClr val="2C3E50"/>
                 </a:solidFill>
               </a:rPr>
-              <a:t>Issue-Typen</a:t>
+              <a:t>GitHub Pages Doku</a:t>
             </a:r>
           </a:p>
         </p:txBody>
@@ -14643,7 +12810,7 @@
                   <a:srgbClr val="2C3E50"/>
                 </a:solidFill>
               </a:rPr>
-              <a:t>Gewichtete Verteilung konfigurierbar (z. B. 70 % Story, 20 % Bug, 10 % Task)</a:t>
+              <a:t>MkDocs-Site mit DE/EN-Doku für alle Module; Architektur nach C4-Modell</a:t>
             </a:r>
           </a:p>
         </p:txBody>
@@ -14763,7 +12930,7 @@
                   <a:srgbClr val="2C3E50"/>
                 </a:solidFill>
               </a:rPr>
-              <a:t>GUI</a:t>
+              <a:t>CI/CD</a:t>
             </a:r>
           </a:p>
         </p:txBody>
@@ -14797,7 +12964,7 @@
                   <a:srgbClr val="2C3E50"/>
                 </a:solidFill>
               </a:rPr>
-              <a:t>tkinter-Oberfläche mit allen Parametern; Ladebalken nach 3 Sekunden</a:t>
+              <a:t>GitHub Actions für automatisches Docs-Deployment und Release-Erstellung bei v*-Tags</a:t>
             </a:r>
           </a:p>
         </p:txBody>
@@ -14917,7 +13084,7 @@
                   <a:srgbClr val="2C3E50"/>
                 </a:solidFill>
               </a:rPr>
-              <a:t>CLI</a:t>
+              <a:t>Tests</a:t>
             </a:r>
           </a:p>
         </p:txBody>
@@ -14951,7 +13118,7 @@
                   <a:srgbClr val="2C3E50"/>
                 </a:solidFill>
               </a:rPr>
-              <a:t>python -m testdata_generator; alle Parameter als Kommandozeilenargumente</a:t>
+              <a:t>Unit- und Acceptance-Tests für alle Module; aktuell 542 Tests</a:t>
             </a:r>
           </a:p>
         </p:txBody>
@@ -14964,160 +13131,6 @@
         </p:nvSpPr>
         <p:spPr>
           <a:xfrm>
-            <a:off x="274320" y="5934455"/>
-            <a:ext cx="2926080" cy="658368"/>
-          </a:xfrm>
-          <a:prstGeom prst="rect">
-            <a:avLst/>
-          </a:prstGeom>
-          <a:solidFill>
-            <a:srgbClr val="FFFFFF"/>
-          </a:solidFill>
-          <a:ln>
-            <a:noFill/>
-          </a:ln>
-        </p:spPr>
-        <p:style>
-          <a:lnRef idx="1">
-            <a:schemeClr val="accent1"/>
-          </a:lnRef>
-          <a:fillRef idx="3">
-            <a:schemeClr val="accent1"/>
-          </a:fillRef>
-          <a:effectRef idx="2">
-            <a:schemeClr val="accent1"/>
-          </a:effectRef>
-          <a:fontRef idx="minor">
-            <a:schemeClr val="lt1"/>
-          </a:fontRef>
-        </p:style>
-        <p:txBody>
-          <a:bodyPr rtlCol="0" anchor="ctr"/>
-          <a:lstStyle/>
-          <a:p>
-            <a:pPr algn="ctr"/>
-          </a:p>
-        </p:txBody>
-      </p:sp>
-      <p:sp>
-        <p:nvSpPr>
-          <p:cNvPr id="37" name="Rectangle 36"/>
-          <p:cNvSpPr/>
-          <p:nvPr/>
-        </p:nvSpPr>
-        <p:spPr>
-          <a:xfrm>
-            <a:off x="3291840" y="5934455"/>
-            <a:ext cx="8595360" cy="658368"/>
-          </a:xfrm>
-          <a:prstGeom prst="rect">
-            <a:avLst/>
-          </a:prstGeom>
-          <a:solidFill>
-            <a:srgbClr val="FFFFFF"/>
-          </a:solidFill>
-          <a:ln>
-            <a:noFill/>
-          </a:ln>
-        </p:spPr>
-        <p:style>
-          <a:lnRef idx="1">
-            <a:schemeClr val="accent1"/>
-          </a:lnRef>
-          <a:fillRef idx="3">
-            <a:schemeClr val="accent1"/>
-          </a:fillRef>
-          <a:effectRef idx="2">
-            <a:schemeClr val="accent1"/>
-          </a:effectRef>
-          <a:fontRef idx="minor">
-            <a:schemeClr val="lt1"/>
-          </a:fontRef>
-        </p:style>
-        <p:txBody>
-          <a:bodyPr rtlCol="0" anchor="ctr"/>
-          <a:lstStyle/>
-          <a:p>
-            <a:pPr algn="ctr"/>
-          </a:p>
-        </p:txBody>
-      </p:sp>
-      <p:sp>
-        <p:nvSpPr>
-          <p:cNvPr id="38" name="TextBox 37"/>
-          <p:cNvSpPr txBox="1"/>
-          <p:nvPr/>
-        </p:nvSpPr>
-        <p:spPr>
-          <a:xfrm>
-            <a:off x="347472" y="5971031"/>
-            <a:ext cx="2788920" cy="603503"/>
-          </a:xfrm>
-          <a:prstGeom prst="rect">
-            <a:avLst/>
-          </a:prstGeom>
-          <a:noFill/>
-        </p:spPr>
-        <p:txBody>
-          <a:bodyPr wrap="square">
-            <a:spAutoFit/>
-          </a:bodyPr>
-          <a:lstStyle/>
-          <a:p>
-            <a:pPr algn="l"/>
-            <a:r>
-              <a:rPr sz="900" b="1">
-                <a:solidFill>
-                  <a:srgbClr val="2C3E50"/>
-                </a:solidFill>
-              </a:rPr>
-              <a:t>Doppelklick-Starter</a:t>
-            </a:r>
-          </a:p>
-        </p:txBody>
-      </p:sp>
-      <p:sp>
-        <p:nvSpPr>
-          <p:cNvPr id="39" name="TextBox 38"/>
-          <p:cNvSpPr txBox="1"/>
-          <p:nvPr/>
-        </p:nvSpPr>
-        <p:spPr>
-          <a:xfrm>
-            <a:off x="3364992" y="5971031"/>
-            <a:ext cx="8412480" cy="603503"/>
-          </a:xfrm>
-          <a:prstGeom prst="rect">
-            <a:avLst/>
-          </a:prstGeom>
-          <a:noFill/>
-        </p:spPr>
-        <p:txBody>
-          <a:bodyPr wrap="square">
-            <a:spAutoFit/>
-          </a:bodyPr>
-          <a:lstStyle/>
-          <a:p>
-            <a:pPr algn="l"/>
-            <a:r>
-              <a:rPr sz="900" b="0">
-                <a:solidFill>
-                  <a:srgbClr val="2C3E50"/>
-                </a:solidFill>
-              </a:rPr>
-              <a:t>testdata_generator_gui.pyw startet die GUI ohne Konsolenfenster</a:t>
-            </a:r>
-          </a:p>
-        </p:txBody>
-      </p:sp>
-      <p:sp>
-        <p:nvSpPr>
-          <p:cNvPr id="40" name="Rectangle 39"/>
-          <p:cNvSpPr/>
-          <p:nvPr/>
-        </p:nvSpPr>
-        <p:spPr>
-          <a:xfrm>
             <a:off x="0" y="6720840"/>
             <a:ext cx="12188952" cy="137160"/>
           </a:xfrm>
@@ -15125,7 +13138,7 @@
             <a:avLst/>
           </a:prstGeom>
           <a:solidFill>
-            <a:srgbClr val="2980B9"/>
+            <a:srgbClr val="27AE60"/>
           </a:solidFill>
           <a:ln>
             <a:noFill/>

</xml_diff>

<commit_message>
fix: Versionsnummer 0.99 -> 0.9.9 korrigiert
Co-Authored-By: Claude Sonnet 4.6 <noreply@anthropic.com>
</commit_message>
<xml_diff>
--- a/docs/situation_report_features.pptx
+++ b/docs/situation_report_features.pptx
@@ -3245,7 +3245,7 @@
                   <a:srgbClr val="ECF0F1"/>
                 </a:solidFill>
               </a:rPr>
-              <a:t>Feature-Übersicht — v0.99 | Stand Mai 2026</a:t>
+              <a:t>Feature-Übersicht — v0.9.9 | Stand Mai 2026</a:t>
             </a:r>
           </a:p>
         </p:txBody>
@@ -12194,7 +12194,7 @@
                   <a:srgbClr val="2C3E50"/>
                 </a:solidFill>
               </a:rPr>
-              <a:t>SemVer ab v0.2.0; zentrale version.py wird von allen GUIs und den Manuals gelesen; aktuell v0.99</a:t>
+              <a:t>SemVer ab v0.2.0; zentrale version.py wird von allen GUIs und den Manuals gelesen; aktuell v0.9.9</a:t>
             </a:r>
           </a:p>
         </p:txBody>

</xml_diff>